<commit_message>
Fix Red Team findings: correct slide 5 TF-IDF claim, reconcile model count, update README Quick Start
- Slide 5: replaced fabricated "TF-IDF" claim with actual "regex-based keyword extraction"
- TASKS.md: updated model count from 53 to 80 (matches latest H2O AutoML run)
- README: Quick Start now points to streamlit run app/streamlit_app.py

Co-Authored-By: Claude Opus 4.6 (1M context) <noreply@anthropic.com>
</commit_message>
<xml_diff>
--- a/ppt/GRIFFIN_BigData_Presentation.pptx
+++ b/ppt/GRIFFIN_BigData_Presentation.pptx
@@ -5,21 +5,21 @@
     <p:sldMasterId id="2147483648" r:id="rId1"/>
   </p:sldMasterIdLst>
   <p:sldIdLst>
-    <p:sldId id="256" r:id="rId2"/>
-    <p:sldId id="257" r:id="rId3"/>
-    <p:sldId id="258" r:id="rId4"/>
-    <p:sldId id="259" r:id="rId5"/>
-    <p:sldId id="260" r:id="rId6"/>
-    <p:sldId id="261" r:id="rId7"/>
-    <p:sldId id="262" r:id="rId8"/>
-    <p:sldId id="263" r:id="rId9"/>
-    <p:sldId id="264" r:id="rId10"/>
-    <p:sldId id="265" r:id="rId11"/>
-    <p:sldId id="266" r:id="rId12"/>
-    <p:sldId id="267" r:id="rId13"/>
-    <p:sldId id="268" r:id="rId14"/>
+    <p:sldId id="256" r:id="rId7"/>
+    <p:sldId id="257" r:id="rId8"/>
+    <p:sldId id="258" r:id="rId9"/>
+    <p:sldId id="259" r:id="rId10"/>
+    <p:sldId id="260" r:id="rId11"/>
+    <p:sldId id="261" r:id="rId12"/>
+    <p:sldId id="262" r:id="rId13"/>
+    <p:sldId id="263" r:id="rId14"/>
+    <p:sldId id="264" r:id="rId15"/>
+    <p:sldId id="265" r:id="rId16"/>
+    <p:sldId id="266" r:id="rId17"/>
+    <p:sldId id="267" r:id="rId18"/>
+    <p:sldId id="268" r:id="rId19"/>
   </p:sldIdLst>
-  <p:sldSz cx="12192000" cy="6858000"/>
+  <p:sldSz cx="12191695" cy="6858000" type="screen4x3"/>
   <p:notesSz cx="6858000" cy="9144000"/>
   <p:defaultTextStyle>
     <a:defPPr>
@@ -116,22 +116,6 @@
       </a:defRPr>
     </a:lvl9pPr>
   </p:defaultTextStyle>
-  <p:extLst>
-    <p:ext uri="{EFAFB233-063F-42B5-8137-9DF3F51BA10A}">
-      <p15:sldGuideLst xmlns:p15="http://schemas.microsoft.com/office/powerpoint/2012/main">
-        <p15:guide id="1" orient="horz" pos="2160">
-          <p15:clr>
-            <a:srgbClr val="A4A3A4"/>
-          </p15:clr>
-        </p15:guide>
-        <p15:guide id="2" pos="2880">
-          <p15:clr>
-            <a:srgbClr val="A4A3A4"/>
-          </p15:clr>
-        </p15:guide>
-      </p15:sldGuideLst>
-    </p:ext>
-  </p:extLst>
 </p:presentation>
 </file>
 
@@ -173,9 +157,10 @@
           <a:lstStyle/>
           <a:p>
             <a:r>
-              <a:rPr lang="en-US"/>
+              <a:rPr lang="en-US" smtClean="0"/>
               <a:t>Click to edit Master title style</a:t>
             </a:r>
+            <a:endParaRPr lang="en-US"/>
           </a:p>
         </p:txBody>
       </p:sp>
@@ -291,9 +276,10 @@
           </a:lstStyle>
           <a:p>
             <a:r>
-              <a:rPr lang="en-US"/>
+              <a:rPr lang="en-US" smtClean="0"/>
               <a:t>Click to edit Master subtitle style</a:t>
             </a:r>
+            <a:endParaRPr lang="en-US"/>
           </a:p>
         </p:txBody>
       </p:sp>
@@ -314,7 +300,7 @@
           <a:p>
             <a:fld id="{5BCAD085-E8A6-8845-BD4E-CB4CCA059FC4}" type="datetimeFigureOut">
               <a:rPr lang="en-US" smtClean="0"/>
-              <a:t>4/12/2026</a:t>
+              <a:t>1/27/13</a:t>
             </a:fld>
             <a:endParaRPr lang="en-US"/>
           </a:p>
@@ -408,9 +394,10 @@
           <a:lstStyle/>
           <a:p>
             <a:r>
-              <a:rPr lang="en-US"/>
+              <a:rPr lang="en-US" smtClean="0"/>
               <a:t>Click to edit Master title style</a:t>
             </a:r>
+            <a:endParaRPr lang="en-US"/>
           </a:p>
         </p:txBody>
       </p:sp>
@@ -431,37 +418,38 @@
           <a:p>
             <a:pPr lvl="0"/>
             <a:r>
-              <a:rPr lang="en-US"/>
+              <a:rPr lang="en-US" smtClean="0"/>
               <a:t>Click to edit Master text styles</a:t>
             </a:r>
           </a:p>
           <a:p>
             <a:pPr lvl="1"/>
             <a:r>
-              <a:rPr lang="en-US"/>
+              <a:rPr lang="en-US" smtClean="0"/>
               <a:t>Second level</a:t>
             </a:r>
           </a:p>
           <a:p>
             <a:pPr lvl="2"/>
             <a:r>
-              <a:rPr lang="en-US"/>
+              <a:rPr lang="en-US" smtClean="0"/>
               <a:t>Third level</a:t>
             </a:r>
           </a:p>
           <a:p>
             <a:pPr lvl="3"/>
             <a:r>
-              <a:rPr lang="en-US"/>
+              <a:rPr lang="en-US" smtClean="0"/>
               <a:t>Fourth level</a:t>
             </a:r>
           </a:p>
           <a:p>
             <a:pPr lvl="4"/>
             <a:r>
-              <a:rPr lang="en-US"/>
+              <a:rPr lang="en-US" smtClean="0"/>
               <a:t>Fifth level</a:t>
             </a:r>
+            <a:endParaRPr lang="en-US"/>
           </a:p>
         </p:txBody>
       </p:sp>
@@ -482,7 +470,7 @@
           <a:p>
             <a:fld id="{5BCAD085-E8A6-8845-BD4E-CB4CCA059FC4}" type="datetimeFigureOut">
               <a:rPr lang="en-US" smtClean="0"/>
-              <a:t>4/12/2026</a:t>
+              <a:t>1/27/13</a:t>
             </a:fld>
             <a:endParaRPr lang="en-US"/>
           </a:p>
@@ -581,9 +569,10 @@
           <a:lstStyle/>
           <a:p>
             <a:r>
-              <a:rPr lang="en-US"/>
+              <a:rPr lang="en-US" smtClean="0"/>
               <a:t>Click to edit Master title style</a:t>
             </a:r>
+            <a:endParaRPr lang="en-US"/>
           </a:p>
         </p:txBody>
       </p:sp>
@@ -609,37 +598,38 @@
           <a:p>
             <a:pPr lvl="0"/>
             <a:r>
-              <a:rPr lang="en-US"/>
+              <a:rPr lang="en-US" smtClean="0"/>
               <a:t>Click to edit Master text styles</a:t>
             </a:r>
           </a:p>
           <a:p>
             <a:pPr lvl="1"/>
             <a:r>
-              <a:rPr lang="en-US"/>
+              <a:rPr lang="en-US" smtClean="0"/>
               <a:t>Second level</a:t>
             </a:r>
           </a:p>
           <a:p>
             <a:pPr lvl="2"/>
             <a:r>
-              <a:rPr lang="en-US"/>
+              <a:rPr lang="en-US" smtClean="0"/>
               <a:t>Third level</a:t>
             </a:r>
           </a:p>
           <a:p>
             <a:pPr lvl="3"/>
             <a:r>
-              <a:rPr lang="en-US"/>
+              <a:rPr lang="en-US" smtClean="0"/>
               <a:t>Fourth level</a:t>
             </a:r>
           </a:p>
           <a:p>
             <a:pPr lvl="4"/>
             <a:r>
-              <a:rPr lang="en-US"/>
+              <a:rPr lang="en-US" smtClean="0"/>
               <a:t>Fifth level</a:t>
             </a:r>
+            <a:endParaRPr lang="en-US"/>
           </a:p>
         </p:txBody>
       </p:sp>
@@ -660,7 +650,7 @@
           <a:p>
             <a:fld id="{5BCAD085-E8A6-8845-BD4E-CB4CCA059FC4}" type="datetimeFigureOut">
               <a:rPr lang="en-US" smtClean="0"/>
-              <a:t>4/12/2026</a:t>
+              <a:t>1/27/13</a:t>
             </a:fld>
             <a:endParaRPr lang="en-US"/>
           </a:p>
@@ -754,9 +744,10 @@
           <a:lstStyle/>
           <a:p>
             <a:r>
-              <a:rPr lang="en-US"/>
+              <a:rPr lang="en-US" smtClean="0"/>
               <a:t>Click to edit Master title style</a:t>
             </a:r>
+            <a:endParaRPr lang="en-US"/>
           </a:p>
         </p:txBody>
       </p:sp>
@@ -777,37 +768,38 @@
           <a:p>
             <a:pPr lvl="0"/>
             <a:r>
-              <a:rPr lang="en-US"/>
+              <a:rPr lang="en-US" smtClean="0"/>
               <a:t>Click to edit Master text styles</a:t>
             </a:r>
           </a:p>
           <a:p>
             <a:pPr lvl="1"/>
             <a:r>
-              <a:rPr lang="en-US"/>
+              <a:rPr lang="en-US" smtClean="0"/>
               <a:t>Second level</a:t>
             </a:r>
           </a:p>
           <a:p>
             <a:pPr lvl="2"/>
             <a:r>
-              <a:rPr lang="en-US"/>
+              <a:rPr lang="en-US" smtClean="0"/>
               <a:t>Third level</a:t>
             </a:r>
           </a:p>
           <a:p>
             <a:pPr lvl="3"/>
             <a:r>
-              <a:rPr lang="en-US"/>
+              <a:rPr lang="en-US" smtClean="0"/>
               <a:t>Fourth level</a:t>
             </a:r>
           </a:p>
           <a:p>
             <a:pPr lvl="4"/>
             <a:r>
-              <a:rPr lang="en-US"/>
+              <a:rPr lang="en-US" smtClean="0"/>
               <a:t>Fifth level</a:t>
             </a:r>
+            <a:endParaRPr lang="en-US"/>
           </a:p>
         </p:txBody>
       </p:sp>
@@ -828,7 +820,7 @@
           <a:p>
             <a:fld id="{5BCAD085-E8A6-8845-BD4E-CB4CCA059FC4}" type="datetimeFigureOut">
               <a:rPr lang="en-US" smtClean="0"/>
-              <a:t>4/12/2026</a:t>
+              <a:t>1/27/13</a:t>
             </a:fld>
             <a:endParaRPr lang="en-US"/>
           </a:p>
@@ -931,9 +923,10 @@
           </a:lstStyle>
           <a:p>
             <a:r>
-              <a:rPr lang="en-US"/>
+              <a:rPr lang="en-US" smtClean="0"/>
               <a:t>Click to edit Master title style</a:t>
             </a:r>
+            <a:endParaRPr lang="en-US"/>
           </a:p>
         </p:txBody>
       </p:sp>
@@ -1050,7 +1043,7 @@
           <a:p>
             <a:pPr lvl="0"/>
             <a:r>
-              <a:rPr lang="en-US"/>
+              <a:rPr lang="en-US" smtClean="0"/>
               <a:t>Click to edit Master text styles</a:t>
             </a:r>
           </a:p>
@@ -1073,7 +1066,7 @@
           <a:p>
             <a:fld id="{5BCAD085-E8A6-8845-BD4E-CB4CCA059FC4}" type="datetimeFigureOut">
               <a:rPr lang="en-US" smtClean="0"/>
-              <a:t>4/12/2026</a:t>
+              <a:t>1/27/13</a:t>
             </a:fld>
             <a:endParaRPr lang="en-US"/>
           </a:p>
@@ -1167,9 +1160,10 @@
           <a:lstStyle/>
           <a:p>
             <a:r>
-              <a:rPr lang="en-US"/>
+              <a:rPr lang="en-US" smtClean="0"/>
               <a:t>Click to edit Master title style</a:t>
             </a:r>
+            <a:endParaRPr lang="en-US"/>
           </a:p>
         </p:txBody>
       </p:sp>
@@ -1223,37 +1217,38 @@
           <a:p>
             <a:pPr lvl="0"/>
             <a:r>
-              <a:rPr lang="en-US"/>
+              <a:rPr lang="en-US" smtClean="0"/>
               <a:t>Click to edit Master text styles</a:t>
             </a:r>
           </a:p>
           <a:p>
             <a:pPr lvl="1"/>
             <a:r>
-              <a:rPr lang="en-US"/>
+              <a:rPr lang="en-US" smtClean="0"/>
               <a:t>Second level</a:t>
             </a:r>
           </a:p>
           <a:p>
             <a:pPr lvl="2"/>
             <a:r>
-              <a:rPr lang="en-US"/>
+              <a:rPr lang="en-US" smtClean="0"/>
               <a:t>Third level</a:t>
             </a:r>
           </a:p>
           <a:p>
             <a:pPr lvl="3"/>
             <a:r>
-              <a:rPr lang="en-US"/>
+              <a:rPr lang="en-US" smtClean="0"/>
               <a:t>Fourth level</a:t>
             </a:r>
           </a:p>
           <a:p>
             <a:pPr lvl="4"/>
             <a:r>
-              <a:rPr lang="en-US"/>
+              <a:rPr lang="en-US" smtClean="0"/>
               <a:t>Fifth level</a:t>
             </a:r>
+            <a:endParaRPr lang="en-US"/>
           </a:p>
         </p:txBody>
       </p:sp>
@@ -1307,37 +1302,38 @@
           <a:p>
             <a:pPr lvl="0"/>
             <a:r>
-              <a:rPr lang="en-US"/>
+              <a:rPr lang="en-US" smtClean="0"/>
               <a:t>Click to edit Master text styles</a:t>
             </a:r>
           </a:p>
           <a:p>
             <a:pPr lvl="1"/>
             <a:r>
-              <a:rPr lang="en-US"/>
+              <a:rPr lang="en-US" smtClean="0"/>
               <a:t>Second level</a:t>
             </a:r>
           </a:p>
           <a:p>
             <a:pPr lvl="2"/>
             <a:r>
-              <a:rPr lang="en-US"/>
+              <a:rPr lang="en-US" smtClean="0"/>
               <a:t>Third level</a:t>
             </a:r>
           </a:p>
           <a:p>
             <a:pPr lvl="3"/>
             <a:r>
-              <a:rPr lang="en-US"/>
+              <a:rPr lang="en-US" smtClean="0"/>
               <a:t>Fourth level</a:t>
             </a:r>
           </a:p>
           <a:p>
             <a:pPr lvl="4"/>
             <a:r>
-              <a:rPr lang="en-US"/>
+              <a:rPr lang="en-US" smtClean="0"/>
               <a:t>Fifth level</a:t>
             </a:r>
+            <a:endParaRPr lang="en-US"/>
           </a:p>
         </p:txBody>
       </p:sp>
@@ -1358,7 +1354,7 @@
           <a:p>
             <a:fld id="{5BCAD085-E8A6-8845-BD4E-CB4CCA059FC4}" type="datetimeFigureOut">
               <a:rPr lang="en-US" smtClean="0"/>
-              <a:t>4/12/2026</a:t>
+              <a:t>1/27/13</a:t>
             </a:fld>
             <a:endParaRPr lang="en-US"/>
           </a:p>
@@ -1456,9 +1452,10 @@
           </a:lstStyle>
           <a:p>
             <a:r>
-              <a:rPr lang="en-US"/>
+              <a:rPr lang="en-US" smtClean="0"/>
               <a:t>Click to edit Master title style</a:t>
             </a:r>
+            <a:endParaRPr lang="en-US"/>
           </a:p>
         </p:txBody>
       </p:sp>
@@ -1521,7 +1518,7 @@
           <a:p>
             <a:pPr lvl="0"/>
             <a:r>
-              <a:rPr lang="en-US"/>
+              <a:rPr lang="en-US" smtClean="0"/>
               <a:t>Click to edit Master text styles</a:t>
             </a:r>
           </a:p>
@@ -1577,37 +1574,38 @@
           <a:p>
             <a:pPr lvl="0"/>
             <a:r>
-              <a:rPr lang="en-US"/>
+              <a:rPr lang="en-US" smtClean="0"/>
               <a:t>Click to edit Master text styles</a:t>
             </a:r>
           </a:p>
           <a:p>
             <a:pPr lvl="1"/>
             <a:r>
-              <a:rPr lang="en-US"/>
+              <a:rPr lang="en-US" smtClean="0"/>
               <a:t>Second level</a:t>
             </a:r>
           </a:p>
           <a:p>
             <a:pPr lvl="2"/>
             <a:r>
-              <a:rPr lang="en-US"/>
+              <a:rPr lang="en-US" smtClean="0"/>
               <a:t>Third level</a:t>
             </a:r>
           </a:p>
           <a:p>
             <a:pPr lvl="3"/>
             <a:r>
-              <a:rPr lang="en-US"/>
+              <a:rPr lang="en-US" smtClean="0"/>
               <a:t>Fourth level</a:t>
             </a:r>
           </a:p>
           <a:p>
             <a:pPr lvl="4"/>
             <a:r>
-              <a:rPr lang="en-US"/>
+              <a:rPr lang="en-US" smtClean="0"/>
               <a:t>Fifth level</a:t>
             </a:r>
+            <a:endParaRPr lang="en-US"/>
           </a:p>
         </p:txBody>
       </p:sp>
@@ -1670,7 +1668,7 @@
           <a:p>
             <a:pPr lvl="0"/>
             <a:r>
-              <a:rPr lang="en-US"/>
+              <a:rPr lang="en-US" smtClean="0"/>
               <a:t>Click to edit Master text styles</a:t>
             </a:r>
           </a:p>
@@ -1726,37 +1724,38 @@
           <a:p>
             <a:pPr lvl="0"/>
             <a:r>
-              <a:rPr lang="en-US"/>
+              <a:rPr lang="en-US" smtClean="0"/>
               <a:t>Click to edit Master text styles</a:t>
             </a:r>
           </a:p>
           <a:p>
             <a:pPr lvl="1"/>
             <a:r>
-              <a:rPr lang="en-US"/>
+              <a:rPr lang="en-US" smtClean="0"/>
               <a:t>Second level</a:t>
             </a:r>
           </a:p>
           <a:p>
             <a:pPr lvl="2"/>
             <a:r>
-              <a:rPr lang="en-US"/>
+              <a:rPr lang="en-US" smtClean="0"/>
               <a:t>Third level</a:t>
             </a:r>
           </a:p>
           <a:p>
             <a:pPr lvl="3"/>
             <a:r>
-              <a:rPr lang="en-US"/>
+              <a:rPr lang="en-US" smtClean="0"/>
               <a:t>Fourth level</a:t>
             </a:r>
           </a:p>
           <a:p>
             <a:pPr lvl="4"/>
             <a:r>
-              <a:rPr lang="en-US"/>
+              <a:rPr lang="en-US" smtClean="0"/>
               <a:t>Fifth level</a:t>
             </a:r>
+            <a:endParaRPr lang="en-US"/>
           </a:p>
         </p:txBody>
       </p:sp>
@@ -1777,7 +1776,7 @@
           <a:p>
             <a:fld id="{5BCAD085-E8A6-8845-BD4E-CB4CCA059FC4}" type="datetimeFigureOut">
               <a:rPr lang="en-US" smtClean="0"/>
-              <a:t>4/12/2026</a:t>
+              <a:t>1/27/13</a:t>
             </a:fld>
             <a:endParaRPr lang="en-US"/>
           </a:p>
@@ -1871,9 +1870,10 @@
           <a:lstStyle/>
           <a:p>
             <a:r>
-              <a:rPr lang="en-US"/>
+              <a:rPr lang="en-US" smtClean="0"/>
               <a:t>Click to edit Master title style</a:t>
             </a:r>
+            <a:endParaRPr lang="en-US"/>
           </a:p>
         </p:txBody>
       </p:sp>
@@ -1894,7 +1894,7 @@
           <a:p>
             <a:fld id="{5BCAD085-E8A6-8845-BD4E-CB4CCA059FC4}" type="datetimeFigureOut">
               <a:rPr lang="en-US" smtClean="0"/>
-              <a:t>4/12/2026</a:t>
+              <a:t>1/27/13</a:t>
             </a:fld>
             <a:endParaRPr lang="en-US"/>
           </a:p>
@@ -1989,7 +1989,7 @@
           <a:p>
             <a:fld id="{5BCAD085-E8A6-8845-BD4E-CB4CCA059FC4}" type="datetimeFigureOut">
               <a:rPr lang="en-US" smtClean="0"/>
-              <a:t>4/12/2026</a:t>
+              <a:t>1/27/13</a:t>
             </a:fld>
             <a:endParaRPr lang="en-US"/>
           </a:p>
@@ -2092,9 +2092,10 @@
           </a:lstStyle>
           <a:p>
             <a:r>
-              <a:rPr lang="en-US"/>
+              <a:rPr lang="en-US" smtClean="0"/>
               <a:t>Click to edit Master title style</a:t>
             </a:r>
+            <a:endParaRPr lang="en-US"/>
           </a:p>
         </p:txBody>
       </p:sp>
@@ -2148,37 +2149,38 @@
           <a:p>
             <a:pPr lvl="0"/>
             <a:r>
-              <a:rPr lang="en-US"/>
+              <a:rPr lang="en-US" smtClean="0"/>
               <a:t>Click to edit Master text styles</a:t>
             </a:r>
           </a:p>
           <a:p>
             <a:pPr lvl="1"/>
             <a:r>
-              <a:rPr lang="en-US"/>
+              <a:rPr lang="en-US" smtClean="0"/>
               <a:t>Second level</a:t>
             </a:r>
           </a:p>
           <a:p>
             <a:pPr lvl="2"/>
             <a:r>
-              <a:rPr lang="en-US"/>
+              <a:rPr lang="en-US" smtClean="0"/>
               <a:t>Third level</a:t>
             </a:r>
           </a:p>
           <a:p>
             <a:pPr lvl="3"/>
             <a:r>
-              <a:rPr lang="en-US"/>
+              <a:rPr lang="en-US" smtClean="0"/>
               <a:t>Fourth level</a:t>
             </a:r>
           </a:p>
           <a:p>
             <a:pPr lvl="4"/>
             <a:r>
-              <a:rPr lang="en-US"/>
+              <a:rPr lang="en-US" smtClean="0"/>
               <a:t>Fifth level</a:t>
             </a:r>
+            <a:endParaRPr lang="en-US"/>
           </a:p>
         </p:txBody>
       </p:sp>
@@ -2241,7 +2243,7 @@
           <a:p>
             <a:pPr lvl="0"/>
             <a:r>
-              <a:rPr lang="en-US"/>
+              <a:rPr lang="en-US" smtClean="0"/>
               <a:t>Click to edit Master text styles</a:t>
             </a:r>
           </a:p>
@@ -2264,7 +2266,7 @@
           <a:p>
             <a:fld id="{5BCAD085-E8A6-8845-BD4E-CB4CCA059FC4}" type="datetimeFigureOut">
               <a:rPr lang="en-US" smtClean="0"/>
-              <a:t>4/12/2026</a:t>
+              <a:t>1/27/13</a:t>
             </a:fld>
             <a:endParaRPr lang="en-US"/>
           </a:p>
@@ -2367,9 +2369,10 @@
           </a:lstStyle>
           <a:p>
             <a:r>
-              <a:rPr lang="en-US"/>
+              <a:rPr lang="en-US" smtClean="0"/>
               <a:t>Click to edit Master title style</a:t>
             </a:r>
+            <a:endParaRPr lang="en-US"/>
           </a:p>
         </p:txBody>
       </p:sp>
@@ -2493,7 +2496,7 @@
           <a:p>
             <a:pPr lvl="0"/>
             <a:r>
-              <a:rPr lang="en-US"/>
+              <a:rPr lang="en-US" smtClean="0"/>
               <a:t>Click to edit Master text styles</a:t>
             </a:r>
           </a:p>
@@ -2516,7 +2519,7 @@
           <a:p>
             <a:fld id="{5BCAD085-E8A6-8845-BD4E-CB4CCA059FC4}" type="datetimeFigureOut">
               <a:rPr lang="en-US" smtClean="0"/>
-              <a:t>4/12/2026</a:t>
+              <a:t>1/27/13</a:t>
             </a:fld>
             <a:endParaRPr lang="en-US"/>
           </a:p>
@@ -2625,9 +2628,10 @@
           <a:lstStyle/>
           <a:p>
             <a:r>
-              <a:rPr lang="en-US"/>
+              <a:rPr lang="en-US" smtClean="0"/>
               <a:t>Click to edit Master title style</a:t>
             </a:r>
+            <a:endParaRPr lang="en-US"/>
           </a:p>
         </p:txBody>
       </p:sp>
@@ -2658,37 +2662,38 @@
           <a:p>
             <a:pPr lvl="0"/>
             <a:r>
-              <a:rPr lang="en-US"/>
+              <a:rPr lang="en-US" smtClean="0"/>
               <a:t>Click to edit Master text styles</a:t>
             </a:r>
           </a:p>
           <a:p>
             <a:pPr lvl="1"/>
             <a:r>
-              <a:rPr lang="en-US"/>
+              <a:rPr lang="en-US" smtClean="0"/>
               <a:t>Second level</a:t>
             </a:r>
           </a:p>
           <a:p>
             <a:pPr lvl="2"/>
             <a:r>
-              <a:rPr lang="en-US"/>
+              <a:rPr lang="en-US" smtClean="0"/>
               <a:t>Third level</a:t>
             </a:r>
           </a:p>
           <a:p>
             <a:pPr lvl="3"/>
             <a:r>
-              <a:rPr lang="en-US"/>
+              <a:rPr lang="en-US" smtClean="0"/>
               <a:t>Fourth level</a:t>
             </a:r>
           </a:p>
           <a:p>
             <a:pPr lvl="4"/>
             <a:r>
-              <a:rPr lang="en-US"/>
+              <a:rPr lang="en-US" smtClean="0"/>
               <a:t>Fifth level</a:t>
             </a:r>
+            <a:endParaRPr lang="en-US"/>
           </a:p>
         </p:txBody>
       </p:sp>
@@ -2727,7 +2732,7 @@
           <a:p>
             <a:fld id="{5BCAD085-E8A6-8845-BD4E-CB4CCA059FC4}" type="datetimeFigureOut">
               <a:rPr lang="en-US" smtClean="0"/>
-              <a:t>4/12/2026</a:t>
+              <a:t>1/27/13</a:t>
             </a:fld>
             <a:endParaRPr lang="en-US"/>
           </a:p>
@@ -3086,7 +3091,7 @@
 </file>
 
 <file path=ppt/slides/slide1.xml><?xml version="1.0" encoding="utf-8"?>
-<p:sld xmlns:a="http://schemas.openxmlformats.org/drawingml/2006/main" xmlns:r="http://schemas.openxmlformats.org/officeDocument/2006/relationships" xmlns:p="http://schemas.openxmlformats.org/presentationml/2006/main">
+<p:sld xmlns:a="http://schemas.openxmlformats.org/drawingml/2006/main" xmlns:p="http://schemas.openxmlformats.org/presentationml/2006/main" xmlns:r="http://schemas.openxmlformats.org/officeDocument/2006/relationships">
   <p:cSld>
     <p:bg>
       <p:bgPr>
@@ -3102,14 +3107,7 @@
         <p:cNvGrpSpPr/>
         <p:nvPr/>
       </p:nvGrpSpPr>
-      <p:grpSpPr>
-        <a:xfrm>
-          <a:off x="0" y="0"/>
-          <a:ext cx="0" cy="0"/>
-          <a:chOff x="0" y="0"/>
-          <a:chExt cx="0" cy="0"/>
-        </a:xfrm>
-      </p:grpSpPr>
+      <p:grpSpPr/>
       <p:sp>
         <p:nvSpPr>
           <p:cNvPr id="2" name="Rectangle 1"/>
@@ -3150,7 +3148,6 @@
           <a:lstStyle/>
           <a:p>
             <a:pPr algn="ctr"/>
-            <a:endParaRPr/>
           </a:p>
         </p:txBody>
       </p:sp>
@@ -3249,7 +3246,6 @@
           <a:lstStyle/>
           <a:p>
             <a:pPr algn="ctr"/>
-            <a:endParaRPr/>
           </a:p>
         </p:txBody>
       </p:sp>
@@ -3352,7 +3348,6 @@
           <a:lstStyle/>
           <a:p>
             <a:pPr algn="ctr"/>
-            <a:endParaRPr/>
           </a:p>
         </p:txBody>
       </p:sp>
@@ -3456,7 +3451,7 @@
 </file>
 
 <file path=ppt/slides/slide10.xml><?xml version="1.0" encoding="utf-8"?>
-<p:sld xmlns:a="http://schemas.openxmlformats.org/drawingml/2006/main" xmlns:r="http://schemas.openxmlformats.org/officeDocument/2006/relationships" xmlns:p="http://schemas.openxmlformats.org/presentationml/2006/main">
+<p:sld xmlns:a="http://schemas.openxmlformats.org/drawingml/2006/main" xmlns:p="http://schemas.openxmlformats.org/presentationml/2006/main" xmlns:r="http://schemas.openxmlformats.org/officeDocument/2006/relationships">
   <p:cSld>
     <p:bg>
       <p:bgPr>
@@ -3472,14 +3467,7 @@
         <p:cNvGrpSpPr/>
         <p:nvPr/>
       </p:nvGrpSpPr>
-      <p:grpSpPr>
-        <a:xfrm>
-          <a:off x="0" y="0"/>
-          <a:ext cx="0" cy="0"/>
-          <a:chOff x="0" y="0"/>
-          <a:chExt cx="0" cy="0"/>
-        </a:xfrm>
-      </p:grpSpPr>
+      <p:grpSpPr/>
       <p:sp>
         <p:nvSpPr>
           <p:cNvPr id="2" name="TextBox 1"/>
@@ -3556,7 +3544,6 @@
           <a:lstStyle/>
           <a:p>
             <a:pPr algn="ctr"/>
-            <a:endParaRPr/>
           </a:p>
         </p:txBody>
       </p:sp>
@@ -3604,7 +3591,6 @@
           <a:lstStyle/>
           <a:p>
             <a:pPr algn="ctr"/>
-            <a:endParaRPr/>
           </a:p>
         </p:txBody>
       </p:sp>
@@ -3712,7 +3698,6 @@
                 <a:latin typeface="Calibri"/>
               </a:defRPr>
             </a:pPr>
-            <a:endParaRPr/>
           </a:p>
           <a:p>
             <a:pPr algn="l">
@@ -3805,7 +3790,6 @@
                 <a:latin typeface="Calibri"/>
               </a:defRPr>
             </a:pPr>
-            <a:endParaRPr/>
           </a:p>
           <a:p>
             <a:pPr algn="l">
@@ -3929,7 +3913,6 @@
           <a:lstStyle/>
           <a:p>
             <a:pPr algn="ctr"/>
-            <a:endParaRPr/>
           </a:p>
         </p:txBody>
       </p:sp>
@@ -4018,7 +4001,6 @@
                 <a:latin typeface="Calibri"/>
               </a:defRPr>
             </a:pPr>
-            <a:endParaRPr/>
           </a:p>
           <a:p>
             <a:pPr algn="l">
@@ -4092,7 +4074,6 @@
                 <a:latin typeface="Calibri"/>
               </a:defRPr>
             </a:pPr>
-            <a:endParaRPr/>
           </a:p>
           <a:p>
             <a:pPr algn="l">
@@ -4185,7 +4166,6 @@
                 <a:latin typeface="Calibri"/>
               </a:defRPr>
             </a:pPr>
-            <a:endParaRPr/>
           </a:p>
           <a:p>
             <a:pPr algn="l">
@@ -4271,7 +4251,6 @@
           <a:lstStyle/>
           <a:p>
             <a:pPr algn="ctr"/>
-            <a:endParaRPr/>
           </a:p>
         </p:txBody>
       </p:sp>
@@ -4360,7 +4339,6 @@
                 <a:latin typeface="Calibri"/>
               </a:defRPr>
             </a:pPr>
-            <a:endParaRPr/>
           </a:p>
           <a:p>
             <a:pPr algn="l">
@@ -4434,7 +4412,6 @@
                 <a:latin typeface="Calibri"/>
               </a:defRPr>
             </a:pPr>
-            <a:endParaRPr/>
           </a:p>
           <a:p>
             <a:pPr algn="l">
@@ -4527,7 +4504,6 @@
                 <a:latin typeface="Calibri"/>
               </a:defRPr>
             </a:pPr>
-            <a:endParaRPr/>
           </a:p>
           <a:p>
             <a:pPr algn="l">
@@ -4650,7 +4626,7 @@
 </file>
 
 <file path=ppt/slides/slide11.xml><?xml version="1.0" encoding="utf-8"?>
-<p:sld xmlns:a="http://schemas.openxmlformats.org/drawingml/2006/main" xmlns:r="http://schemas.openxmlformats.org/officeDocument/2006/relationships" xmlns:p="http://schemas.openxmlformats.org/presentationml/2006/main">
+<p:sld xmlns:a="http://schemas.openxmlformats.org/drawingml/2006/main" xmlns:p="http://schemas.openxmlformats.org/presentationml/2006/main" xmlns:r="http://schemas.openxmlformats.org/officeDocument/2006/relationships">
   <p:cSld>
     <p:bg>
       <p:bgPr>
@@ -4666,14 +4642,7 @@
         <p:cNvGrpSpPr/>
         <p:nvPr/>
       </p:nvGrpSpPr>
-      <p:grpSpPr>
-        <a:xfrm>
-          <a:off x="0" y="0"/>
-          <a:ext cx="0" cy="0"/>
-          <a:chOff x="0" y="0"/>
-          <a:chExt cx="0" cy="0"/>
-        </a:xfrm>
-      </p:grpSpPr>
+      <p:grpSpPr/>
       <p:sp>
         <p:nvSpPr>
           <p:cNvPr id="2" name="TextBox 1"/>
@@ -4750,7 +4719,6 @@
           <a:lstStyle/>
           <a:p>
             <a:pPr algn="ctr"/>
-            <a:endParaRPr/>
           </a:p>
         </p:txBody>
       </p:sp>
@@ -4798,7 +4766,6 @@
           <a:lstStyle/>
           <a:p>
             <a:pPr algn="ctr"/>
-            <a:endParaRPr/>
           </a:p>
         </p:txBody>
       </p:sp>
@@ -4906,7 +4873,6 @@
                 <a:latin typeface="Calibri"/>
               </a:defRPr>
             </a:pPr>
-            <a:endParaRPr/>
           </a:p>
           <a:p>
             <a:pPr algn="l">
@@ -4961,7 +4927,6 @@
                 <a:latin typeface="Calibri"/>
               </a:defRPr>
             </a:pPr>
-            <a:endParaRPr/>
           </a:p>
           <a:p>
             <a:pPr algn="l">
@@ -4997,7 +4962,6 @@
                 <a:latin typeface="Calibri"/>
               </a:defRPr>
             </a:pPr>
-            <a:endParaRPr/>
           </a:p>
           <a:p>
             <a:pPr algn="l">
@@ -5083,7 +5047,6 @@
           <a:lstStyle/>
           <a:p>
             <a:pPr algn="ctr"/>
-            <a:endParaRPr/>
           </a:p>
         </p:txBody>
       </p:sp>
@@ -5172,7 +5135,6 @@
                 <a:latin typeface="Calibri"/>
               </a:defRPr>
             </a:pPr>
-            <a:endParaRPr/>
           </a:p>
           <a:p>
             <a:pPr algn="l">
@@ -5246,7 +5208,6 @@
                 <a:latin typeface="Calibri"/>
               </a:defRPr>
             </a:pPr>
-            <a:endParaRPr/>
           </a:p>
           <a:p>
             <a:pPr algn="l">
@@ -5320,7 +5281,6 @@
                 <a:latin typeface="Calibri"/>
               </a:defRPr>
             </a:pPr>
-            <a:endParaRPr/>
           </a:p>
           <a:p>
             <a:pPr algn="l">
@@ -5356,7 +5316,6 @@
                 <a:latin typeface="Calibri"/>
               </a:defRPr>
             </a:pPr>
-            <a:endParaRPr/>
           </a:p>
           <a:p>
             <a:pPr algn="l">
@@ -5442,7 +5401,6 @@
           <a:lstStyle/>
           <a:p>
             <a:pPr algn="ctr"/>
-            <a:endParaRPr/>
           </a:p>
         </p:txBody>
       </p:sp>
@@ -5563,7 +5521,7 @@
 </file>
 
 <file path=ppt/slides/slide12.xml><?xml version="1.0" encoding="utf-8"?>
-<p:sld xmlns:a="http://schemas.openxmlformats.org/drawingml/2006/main" xmlns:r="http://schemas.openxmlformats.org/officeDocument/2006/relationships" xmlns:p="http://schemas.openxmlformats.org/presentationml/2006/main">
+<p:sld xmlns:a="http://schemas.openxmlformats.org/drawingml/2006/main" xmlns:p="http://schemas.openxmlformats.org/presentationml/2006/main" xmlns:r="http://schemas.openxmlformats.org/officeDocument/2006/relationships">
   <p:cSld>
     <p:bg>
       <p:bgPr>
@@ -5579,14 +5537,7 @@
         <p:cNvGrpSpPr/>
         <p:nvPr/>
       </p:nvGrpSpPr>
-      <p:grpSpPr>
-        <a:xfrm>
-          <a:off x="0" y="0"/>
-          <a:ext cx="0" cy="0"/>
-          <a:chOff x="0" y="0"/>
-          <a:chExt cx="0" cy="0"/>
-        </a:xfrm>
-      </p:grpSpPr>
+      <p:grpSpPr/>
       <p:sp>
         <p:nvSpPr>
           <p:cNvPr id="2" name="TextBox 1"/>
@@ -5663,7 +5614,6 @@
           <a:lstStyle/>
           <a:p>
             <a:pPr algn="ctr"/>
-            <a:endParaRPr/>
           </a:p>
         </p:txBody>
       </p:sp>
@@ -5711,7 +5661,6 @@
           <a:lstStyle/>
           <a:p>
             <a:pPr algn="ctr"/>
-            <a:endParaRPr/>
           </a:p>
         </p:txBody>
       </p:sp>
@@ -5839,7 +5788,6 @@
           <a:lstStyle/>
           <a:p>
             <a:pPr algn="ctr"/>
-            <a:endParaRPr/>
           </a:p>
         </p:txBody>
       </p:sp>
@@ -5967,7 +5915,6 @@
           <a:lstStyle/>
           <a:p>
             <a:pPr algn="ctr"/>
-            <a:endParaRPr/>
           </a:p>
         </p:txBody>
       </p:sp>
@@ -6095,7 +6042,6 @@
           <a:lstStyle/>
           <a:p>
             <a:pPr algn="ctr"/>
-            <a:endParaRPr/>
           </a:p>
         </p:txBody>
       </p:sp>
@@ -6223,7 +6169,6 @@
           <a:lstStyle/>
           <a:p>
             <a:pPr algn="ctr"/>
-            <a:endParaRPr/>
           </a:p>
         </p:txBody>
       </p:sp>
@@ -6359,7 +6304,6 @@
           <a:lstStyle/>
           <a:p>
             <a:pPr algn="ctr"/>
-            <a:endParaRPr/>
           </a:p>
         </p:txBody>
       </p:sp>
@@ -6524,7 +6468,7 @@
 </file>
 
 <file path=ppt/slides/slide13.xml><?xml version="1.0" encoding="utf-8"?>
-<p:sld xmlns:a="http://schemas.openxmlformats.org/drawingml/2006/main" xmlns:r="http://schemas.openxmlformats.org/officeDocument/2006/relationships" xmlns:p="http://schemas.openxmlformats.org/presentationml/2006/main">
+<p:sld xmlns:a="http://schemas.openxmlformats.org/drawingml/2006/main" xmlns:p="http://schemas.openxmlformats.org/presentationml/2006/main" xmlns:r="http://schemas.openxmlformats.org/officeDocument/2006/relationships">
   <p:cSld>
     <p:bg>
       <p:bgPr>
@@ -6540,14 +6484,7 @@
         <p:cNvGrpSpPr/>
         <p:nvPr/>
       </p:nvGrpSpPr>
-      <p:grpSpPr>
-        <a:xfrm>
-          <a:off x="0" y="0"/>
-          <a:ext cx="0" cy="0"/>
-          <a:chOff x="0" y="0"/>
-          <a:chExt cx="0" cy="0"/>
-        </a:xfrm>
-      </p:grpSpPr>
+      <p:grpSpPr/>
       <p:sp>
         <p:nvSpPr>
           <p:cNvPr id="2" name="TextBox 1"/>
@@ -6624,7 +6561,6 @@
           <a:lstStyle/>
           <a:p>
             <a:pPr algn="ctr"/>
-            <a:endParaRPr/>
           </a:p>
         </p:txBody>
       </p:sp>
@@ -6672,7 +6608,6 @@
           <a:lstStyle/>
           <a:p>
             <a:pPr algn="ctr"/>
-            <a:endParaRPr/>
           </a:p>
         </p:txBody>
       </p:sp>
@@ -6818,7 +6753,6 @@
                 <a:latin typeface="Calibri"/>
               </a:defRPr>
             </a:pPr>
-            <a:endParaRPr/>
           </a:p>
           <a:p>
             <a:pPr algn="l">
@@ -6911,7 +6845,6 @@
                 <a:latin typeface="Calibri"/>
               </a:defRPr>
             </a:pPr>
-            <a:endParaRPr/>
           </a:p>
           <a:p>
             <a:pPr algn="l">
@@ -6997,7 +6930,6 @@
           <a:lstStyle/>
           <a:p>
             <a:pPr algn="ctr"/>
-            <a:endParaRPr/>
           </a:p>
         </p:txBody>
       </p:sp>
@@ -7143,7 +7075,6 @@
                 <a:latin typeface="Calibri"/>
               </a:defRPr>
             </a:pPr>
-            <a:endParaRPr/>
           </a:p>
           <a:p>
             <a:pPr algn="l">
@@ -7267,7 +7198,6 @@
           <a:lstStyle/>
           <a:p>
             <a:pPr algn="ctr"/>
-            <a:endParaRPr/>
           </a:p>
         </p:txBody>
       </p:sp>
@@ -7413,7 +7343,6 @@
                 <a:latin typeface="Calibri"/>
               </a:defRPr>
             </a:pPr>
-            <a:endParaRPr/>
           </a:p>
           <a:p>
             <a:pPr algn="l">
@@ -7569,7 +7498,6 @@
           <a:lstStyle/>
           <a:p>
             <a:pPr algn="ctr"/>
-            <a:endParaRPr/>
           </a:p>
         </p:txBody>
       </p:sp>
@@ -7654,7 +7582,7 @@
 </file>
 
 <file path=ppt/slides/slide2.xml><?xml version="1.0" encoding="utf-8"?>
-<p:sld xmlns:a="http://schemas.openxmlformats.org/drawingml/2006/main" xmlns:r="http://schemas.openxmlformats.org/officeDocument/2006/relationships" xmlns:p="http://schemas.openxmlformats.org/presentationml/2006/main">
+<p:sld xmlns:a="http://schemas.openxmlformats.org/drawingml/2006/main" xmlns:p="http://schemas.openxmlformats.org/presentationml/2006/main" xmlns:r="http://schemas.openxmlformats.org/officeDocument/2006/relationships">
   <p:cSld>
     <p:bg>
       <p:bgPr>
@@ -7670,14 +7598,7 @@
         <p:cNvGrpSpPr/>
         <p:nvPr/>
       </p:nvGrpSpPr>
-      <p:grpSpPr>
-        <a:xfrm>
-          <a:off x="0" y="0"/>
-          <a:ext cx="0" cy="0"/>
-          <a:chOff x="0" y="0"/>
-          <a:chExt cx="0" cy="0"/>
-        </a:xfrm>
-      </p:grpSpPr>
+      <p:grpSpPr/>
       <p:sp>
         <p:nvSpPr>
           <p:cNvPr id="2" name="TextBox 1"/>
@@ -7754,7 +7675,6 @@
           <a:lstStyle/>
           <a:p>
             <a:pPr algn="ctr"/>
-            <a:endParaRPr/>
           </a:p>
         </p:txBody>
       </p:sp>
@@ -7802,7 +7722,6 @@
           <a:lstStyle/>
           <a:p>
             <a:pPr algn="ctr"/>
-            <a:endParaRPr/>
           </a:p>
         </p:txBody>
       </p:sp>
@@ -7891,7 +7810,6 @@
                 <a:latin typeface="Calibri"/>
               </a:defRPr>
             </a:pPr>
-            <a:endParaRPr/>
           </a:p>
           <a:p>
             <a:pPr algn="l">
@@ -7958,7 +7876,6 @@
           <a:lstStyle/>
           <a:p>
             <a:pPr algn="ctr"/>
-            <a:endParaRPr/>
           </a:p>
         </p:txBody>
       </p:sp>
@@ -8047,7 +7964,6 @@
                 <a:latin typeface="Calibri"/>
               </a:defRPr>
             </a:pPr>
-            <a:endParaRPr/>
           </a:p>
           <a:p>
             <a:pPr algn="l">
@@ -8102,7 +8018,6 @@
                 <a:latin typeface="Calibri"/>
               </a:defRPr>
             </a:pPr>
-            <a:endParaRPr/>
           </a:p>
           <a:p>
             <a:pPr algn="l">
@@ -8188,7 +8103,6 @@
           <a:lstStyle/>
           <a:p>
             <a:pPr algn="ctr"/>
-            <a:endParaRPr/>
           </a:p>
         </p:txBody>
       </p:sp>
@@ -8277,7 +8191,6 @@
                 <a:latin typeface="Calibri"/>
               </a:defRPr>
             </a:pPr>
-            <a:endParaRPr/>
           </a:p>
           <a:p>
             <a:pPr algn="l">
@@ -8370,7 +8283,6 @@
                 <a:latin typeface="Calibri"/>
               </a:defRPr>
             </a:pPr>
-            <a:endParaRPr/>
           </a:p>
           <a:p>
             <a:pPr algn="l">
@@ -8474,7 +8386,7 @@
 </file>
 
 <file path=ppt/slides/slide3.xml><?xml version="1.0" encoding="utf-8"?>
-<p:sld xmlns:a="http://schemas.openxmlformats.org/drawingml/2006/main" xmlns:r="http://schemas.openxmlformats.org/officeDocument/2006/relationships" xmlns:p="http://schemas.openxmlformats.org/presentationml/2006/main">
+<p:sld xmlns:a="http://schemas.openxmlformats.org/drawingml/2006/main" xmlns:p="http://schemas.openxmlformats.org/presentationml/2006/main" xmlns:r="http://schemas.openxmlformats.org/officeDocument/2006/relationships">
   <p:cSld>
     <p:bg>
       <p:bgPr>
@@ -8490,14 +8402,7 @@
         <p:cNvGrpSpPr/>
         <p:nvPr/>
       </p:nvGrpSpPr>
-      <p:grpSpPr>
-        <a:xfrm>
-          <a:off x="0" y="0"/>
-          <a:ext cx="0" cy="0"/>
-          <a:chOff x="0" y="0"/>
-          <a:chExt cx="0" cy="0"/>
-        </a:xfrm>
-      </p:grpSpPr>
+      <p:grpSpPr/>
       <p:sp>
         <p:nvSpPr>
           <p:cNvPr id="2" name="TextBox 1"/>
@@ -8574,7 +8479,6 @@
           <a:lstStyle/>
           <a:p>
             <a:pPr algn="ctr"/>
-            <a:endParaRPr/>
           </a:p>
         </p:txBody>
       </p:sp>
@@ -8622,7 +8526,6 @@
           <a:lstStyle/>
           <a:p>
             <a:pPr algn="ctr"/>
-            <a:endParaRPr/>
           </a:p>
         </p:txBody>
       </p:sp>
@@ -8668,7 +8571,6 @@
           <a:lstStyle/>
           <a:p>
             <a:pPr algn="ctr"/>
-            <a:endParaRPr/>
           </a:p>
         </p:txBody>
       </p:sp>
@@ -8952,7 +8854,6 @@
           <a:lstStyle/>
           <a:p>
             <a:pPr algn="ctr"/>
-            <a:endParaRPr/>
           </a:p>
         </p:txBody>
       </p:sp>
@@ -8998,7 +8899,6 @@
           <a:lstStyle/>
           <a:p>
             <a:pPr algn="ctr"/>
-            <a:endParaRPr/>
           </a:p>
         </p:txBody>
       </p:sp>
@@ -9282,7 +9182,6 @@
           <a:lstStyle/>
           <a:p>
             <a:pPr algn="ctr"/>
-            <a:endParaRPr/>
           </a:p>
         </p:txBody>
       </p:sp>
@@ -9328,7 +9227,6 @@
           <a:lstStyle/>
           <a:p>
             <a:pPr algn="ctr"/>
-            <a:endParaRPr/>
           </a:p>
         </p:txBody>
       </p:sp>
@@ -9608,7 +9506,6 @@
           <a:lstStyle/>
           <a:p>
             <a:pPr algn="ctr"/>
-            <a:endParaRPr/>
           </a:p>
         </p:txBody>
       </p:sp>
@@ -9729,7 +9626,7 @@
 </file>
 
 <file path=ppt/slides/slide4.xml><?xml version="1.0" encoding="utf-8"?>
-<p:sld xmlns:a="http://schemas.openxmlformats.org/drawingml/2006/main" xmlns:r="http://schemas.openxmlformats.org/officeDocument/2006/relationships" xmlns:p="http://schemas.openxmlformats.org/presentationml/2006/main">
+<p:sld xmlns:a="http://schemas.openxmlformats.org/drawingml/2006/main" xmlns:p="http://schemas.openxmlformats.org/presentationml/2006/main" xmlns:r="http://schemas.openxmlformats.org/officeDocument/2006/relationships">
   <p:cSld>
     <p:bg>
       <p:bgPr>
@@ -9745,14 +9642,7 @@
         <p:cNvGrpSpPr/>
         <p:nvPr/>
       </p:nvGrpSpPr>
-      <p:grpSpPr>
-        <a:xfrm>
-          <a:off x="0" y="0"/>
-          <a:ext cx="0" cy="0"/>
-          <a:chOff x="0" y="0"/>
-          <a:chExt cx="0" cy="0"/>
-        </a:xfrm>
-      </p:grpSpPr>
+      <p:grpSpPr/>
       <p:sp>
         <p:nvSpPr>
           <p:cNvPr id="2" name="TextBox 1"/>
@@ -9829,7 +9719,6 @@
           <a:lstStyle/>
           <a:p>
             <a:pPr algn="ctr"/>
-            <a:endParaRPr/>
           </a:p>
         </p:txBody>
       </p:sp>
@@ -9875,7 +9764,6 @@
           <a:lstStyle/>
           <a:p>
             <a:pPr algn="ctr"/>
-            <a:endParaRPr/>
           </a:p>
         </p:txBody>
       </p:sp>
@@ -9971,7 +9859,6 @@
           <a:lstStyle/>
           <a:p>
             <a:pPr algn="ctr"/>
-            <a:endParaRPr/>
           </a:p>
         </p:txBody>
       </p:sp>
@@ -10112,7 +9999,6 @@
           <a:lstStyle/>
           <a:p>
             <a:pPr algn="ctr"/>
-            <a:endParaRPr/>
           </a:p>
         </p:txBody>
       </p:sp>
@@ -10158,7 +10044,6 @@
           <a:lstStyle/>
           <a:p>
             <a:pPr algn="ctr"/>
-            <a:endParaRPr/>
           </a:p>
         </p:txBody>
       </p:sp>
@@ -10254,7 +10139,6 @@
           <a:lstStyle/>
           <a:p>
             <a:pPr algn="ctr"/>
-            <a:endParaRPr/>
           </a:p>
         </p:txBody>
       </p:sp>
@@ -10376,7 +10260,6 @@
           <a:lstStyle/>
           <a:p>
             <a:pPr algn="ctr"/>
-            <a:endParaRPr/>
           </a:p>
         </p:txBody>
       </p:sp>
@@ -10422,7 +10305,6 @@
           <a:lstStyle/>
           <a:p>
             <a:pPr algn="ctr"/>
-            <a:endParaRPr/>
           </a:p>
         </p:txBody>
       </p:sp>
@@ -10518,7 +10400,6 @@
           <a:lstStyle/>
           <a:p>
             <a:pPr algn="ctr"/>
-            <a:endParaRPr/>
           </a:p>
         </p:txBody>
       </p:sp>
@@ -10640,7 +10521,6 @@
           <a:lstStyle/>
           <a:p>
             <a:pPr algn="ctr"/>
-            <a:endParaRPr/>
           </a:p>
         </p:txBody>
       </p:sp>
@@ -10686,7 +10566,6 @@
           <a:lstStyle/>
           <a:p>
             <a:pPr algn="ctr"/>
-            <a:endParaRPr/>
           </a:p>
         </p:txBody>
       </p:sp>
@@ -10782,7 +10661,6 @@
           <a:lstStyle/>
           <a:p>
             <a:pPr algn="ctr"/>
-            <a:endParaRPr/>
           </a:p>
         </p:txBody>
       </p:sp>
@@ -10919,7 +10797,6 @@
           <a:lstStyle/>
           <a:p>
             <a:pPr algn="ctr"/>
-            <a:endParaRPr/>
           </a:p>
         </p:txBody>
       </p:sp>
@@ -10965,7 +10842,6 @@
           <a:lstStyle/>
           <a:p>
             <a:pPr algn="ctr"/>
-            <a:endParaRPr/>
           </a:p>
         </p:txBody>
       </p:sp>
@@ -11061,7 +10937,6 @@
           <a:lstStyle/>
           <a:p>
             <a:pPr algn="ctr"/>
-            <a:endParaRPr/>
           </a:p>
         </p:txBody>
       </p:sp>
@@ -11183,7 +11058,6 @@
           <a:lstStyle/>
           <a:p>
             <a:pPr algn="ctr"/>
-            <a:endParaRPr/>
           </a:p>
         </p:txBody>
       </p:sp>
@@ -11229,7 +11103,6 @@
           <a:lstStyle/>
           <a:p>
             <a:pPr algn="ctr"/>
-            <a:endParaRPr/>
           </a:p>
         </p:txBody>
       </p:sp>
@@ -11325,7 +11198,6 @@
           <a:lstStyle/>
           <a:p>
             <a:pPr algn="ctr"/>
-            <a:endParaRPr/>
           </a:p>
         </p:txBody>
       </p:sp>
@@ -11451,7 +11323,6 @@
           <a:lstStyle/>
           <a:p>
             <a:pPr algn="ctr"/>
-            <a:endParaRPr/>
           </a:p>
         </p:txBody>
       </p:sp>
@@ -11608,7 +11479,7 @@
 </file>
 
 <file path=ppt/slides/slide5.xml><?xml version="1.0" encoding="utf-8"?>
-<p:sld xmlns:a="http://schemas.openxmlformats.org/drawingml/2006/main" xmlns:r="http://schemas.openxmlformats.org/officeDocument/2006/relationships" xmlns:p="http://schemas.openxmlformats.org/presentationml/2006/main">
+<p:sld xmlns:a="http://schemas.openxmlformats.org/drawingml/2006/main" xmlns:p="http://schemas.openxmlformats.org/presentationml/2006/main" xmlns:r="http://schemas.openxmlformats.org/officeDocument/2006/relationships">
   <p:cSld>
     <p:bg>
       <p:bgPr>
@@ -11624,14 +11495,7 @@
         <p:cNvGrpSpPr/>
         <p:nvPr/>
       </p:nvGrpSpPr>
-      <p:grpSpPr>
-        <a:xfrm>
-          <a:off x="0" y="0"/>
-          <a:ext cx="0" cy="0"/>
-          <a:chOff x="0" y="0"/>
-          <a:chExt cx="0" cy="0"/>
-        </a:xfrm>
-      </p:grpSpPr>
+      <p:grpSpPr/>
       <p:sp>
         <p:nvSpPr>
           <p:cNvPr id="2" name="TextBox 1"/>
@@ -11708,7 +11572,6 @@
           <a:lstStyle/>
           <a:p>
             <a:pPr algn="ctr"/>
-            <a:endParaRPr/>
           </a:p>
         </p:txBody>
       </p:sp>
@@ -11756,7 +11619,6 @@
           <a:lstStyle/>
           <a:p>
             <a:pPr algn="ctr"/>
-            <a:endParaRPr/>
           </a:p>
         </p:txBody>
       </p:sp>
@@ -11845,7 +11707,6 @@
                 <a:latin typeface="Calibri"/>
               </a:defRPr>
             </a:pPr>
-            <a:endParaRPr/>
           </a:p>
           <a:p>
             <a:pPr algn="l">
@@ -11863,7 +11724,7 @@
               </a:defRPr>
             </a:pPr>
             <a:r>
-              <a:t>• TF-IDF text vectorization</a:t>
+              <a:t>• Regex-based keyword frequency extraction</a:t>
             </a:r>
           </a:p>
           <a:p>
@@ -11882,7 +11743,7 @@
               </a:defRPr>
             </a:pPr>
             <a:r>
-              <a:t>• Keyword frequency extraction</a:t>
+              <a:t>• Document length metrics</a:t>
             </a:r>
           </a:p>
           <a:p>
@@ -11901,7 +11762,7 @@
               </a:defRPr>
             </a:pPr>
             <a:r>
-              <a:t>• Document length metrics</a:t>
+              <a:t>• Domain-specific term detection</a:t>
             </a:r>
           </a:p>
           <a:p>
@@ -11919,9 +11780,6 @@
                 <a:latin typeface="Calibri"/>
               </a:defRPr>
             </a:pPr>
-            <a:r>
-              <a:t>• Domain-specific term detection</a:t>
-            </a:r>
           </a:p>
           <a:p>
             <a:pPr algn="l">
@@ -11938,25 +11796,8 @@
                 <a:latin typeface="Calibri"/>
               </a:defRPr>
             </a:pPr>
-            <a:endParaRPr/>
-          </a:p>
-          <a:p>
-            <a:pPr algn="l">
-              <a:spcBef>
-                <a:spcPts val="200"/>
-              </a:spcBef>
-              <a:spcAft>
-                <a:spcPts val="100"/>
-              </a:spcAft>
-              <a:defRPr sz="1300" b="0">
-                <a:solidFill>
-                  <a:srgbClr val="2D2D2D"/>
-                </a:solidFill>
-                <a:latin typeface="Calibri"/>
-              </a:defRPr>
-            </a:pPr>
-            <a:r>
-              <a:t>Tools: pandas, scikit-learn</a:t>
+            <a:r>
+              <a:t>Tools: pandas, regex</a:t>
             </a:r>
           </a:p>
         </p:txBody>
@@ -12005,7 +11846,6 @@
           <a:lstStyle/>
           <a:p>
             <a:pPr algn="ctr"/>
-            <a:endParaRPr/>
           </a:p>
         </p:txBody>
       </p:sp>
@@ -12094,7 +11934,6 @@
                 <a:latin typeface="Calibri"/>
               </a:defRPr>
             </a:pPr>
-            <a:endParaRPr/>
           </a:p>
           <a:p>
             <a:pPr algn="l">
@@ -12206,7 +12045,6 @@
                 <a:latin typeface="Calibri"/>
               </a:defRPr>
             </a:pPr>
-            <a:endParaRPr/>
           </a:p>
           <a:p>
             <a:pPr algn="l">
@@ -12273,7 +12111,6 @@
           <a:lstStyle/>
           <a:p>
             <a:pPr algn="ctr"/>
-            <a:endParaRPr/>
           </a:p>
         </p:txBody>
       </p:sp>
@@ -12362,7 +12199,6 @@
                 <a:latin typeface="Calibri"/>
               </a:defRPr>
             </a:pPr>
-            <a:endParaRPr/>
           </a:p>
           <a:p>
             <a:pPr algn="l">
@@ -12417,7 +12253,6 @@
                 <a:latin typeface="Calibri"/>
               </a:defRPr>
             </a:pPr>
-            <a:endParaRPr/>
           </a:p>
           <a:p>
             <a:pPr algn="l">
@@ -12491,7 +12326,6 @@
                 <a:latin typeface="Calibri"/>
               </a:defRPr>
             </a:pPr>
-            <a:endParaRPr/>
           </a:p>
           <a:p>
             <a:pPr algn="l">
@@ -12595,7 +12429,7 @@
 </file>
 
 <file path=ppt/slides/slide6.xml><?xml version="1.0" encoding="utf-8"?>
-<p:sld xmlns:a="http://schemas.openxmlformats.org/drawingml/2006/main" xmlns:r="http://schemas.openxmlformats.org/officeDocument/2006/relationships" xmlns:p="http://schemas.openxmlformats.org/presentationml/2006/main">
+<p:sld xmlns:a="http://schemas.openxmlformats.org/drawingml/2006/main" xmlns:p="http://schemas.openxmlformats.org/presentationml/2006/main" xmlns:r="http://schemas.openxmlformats.org/officeDocument/2006/relationships">
   <p:cSld>
     <p:bg>
       <p:bgPr>
@@ -12611,14 +12445,7 @@
         <p:cNvGrpSpPr/>
         <p:nvPr/>
       </p:nvGrpSpPr>
-      <p:grpSpPr>
-        <a:xfrm>
-          <a:off x="0" y="0"/>
-          <a:ext cx="0" cy="0"/>
-          <a:chOff x="0" y="0"/>
-          <a:chExt cx="0" cy="0"/>
-        </a:xfrm>
-      </p:grpSpPr>
+      <p:grpSpPr/>
       <p:sp>
         <p:nvSpPr>
           <p:cNvPr id="2" name="TextBox 1"/>
@@ -12695,7 +12522,6 @@
           <a:lstStyle/>
           <a:p>
             <a:pPr algn="ctr"/>
-            <a:endParaRPr/>
           </a:p>
         </p:txBody>
       </p:sp>
@@ -12743,7 +12569,6 @@
           <a:lstStyle/>
           <a:p>
             <a:pPr algn="ctr"/>
-            <a:endParaRPr/>
           </a:p>
         </p:txBody>
       </p:sp>
@@ -12832,7 +12657,6 @@
                 <a:latin typeface="Calibri"/>
               </a:defRPr>
             </a:pPr>
-            <a:endParaRPr/>
           </a:p>
           <a:p>
             <a:pPr algn="l">
@@ -12944,7 +12768,6 @@
                 <a:latin typeface="Calibri"/>
               </a:defRPr>
             </a:pPr>
-            <a:endParaRPr/>
           </a:p>
           <a:p>
             <a:pPr algn="l">
@@ -13049,7 +12872,6 @@
           <a:lstStyle/>
           <a:p>
             <a:pPr algn="ctr"/>
-            <a:endParaRPr/>
           </a:p>
         </p:txBody>
       </p:sp>
@@ -13157,7 +12979,6 @@
                 <a:latin typeface="Calibri"/>
               </a:defRPr>
             </a:pPr>
-            <a:endParaRPr/>
           </a:p>
           <a:p>
             <a:pPr algn="l">
@@ -13288,7 +13109,6 @@
                 <a:latin typeface="Calibri"/>
               </a:defRPr>
             </a:pPr>
-            <a:endParaRPr/>
           </a:p>
           <a:p>
             <a:pPr algn="l">
@@ -13375,7 +13195,7 @@
 </file>
 
 <file path=ppt/slides/slide7.xml><?xml version="1.0" encoding="utf-8"?>
-<p:sld xmlns:a="http://schemas.openxmlformats.org/drawingml/2006/main" xmlns:r="http://schemas.openxmlformats.org/officeDocument/2006/relationships" xmlns:p="http://schemas.openxmlformats.org/presentationml/2006/main">
+<p:sld xmlns:a="http://schemas.openxmlformats.org/drawingml/2006/main" xmlns:p="http://schemas.openxmlformats.org/presentationml/2006/main" xmlns:r="http://schemas.openxmlformats.org/officeDocument/2006/relationships">
   <p:cSld>
     <p:bg>
       <p:bgPr>
@@ -13391,14 +13211,7 @@
         <p:cNvGrpSpPr/>
         <p:nvPr/>
       </p:nvGrpSpPr>
-      <p:grpSpPr>
-        <a:xfrm>
-          <a:off x="0" y="0"/>
-          <a:ext cx="0" cy="0"/>
-          <a:chOff x="0" y="0"/>
-          <a:chExt cx="0" cy="0"/>
-        </a:xfrm>
-      </p:grpSpPr>
+      <p:grpSpPr/>
       <p:sp>
         <p:nvSpPr>
           <p:cNvPr id="2" name="TextBox 1"/>
@@ -13475,7 +13288,6 @@
           <a:lstStyle/>
           <a:p>
             <a:pPr algn="ctr"/>
-            <a:endParaRPr/>
           </a:p>
         </p:txBody>
       </p:sp>
@@ -13559,7 +13371,6 @@
           <a:lstStyle/>
           <a:p>
             <a:pPr algn="ctr"/>
-            <a:endParaRPr/>
           </a:p>
         </p:txBody>
       </p:sp>
@@ -13667,7 +13478,6 @@
                 <a:latin typeface="Calibri"/>
               </a:defRPr>
             </a:pPr>
-            <a:endParaRPr/>
           </a:p>
           <a:p>
             <a:pPr algn="l">
@@ -13760,7 +13570,6 @@
                 <a:latin typeface="Calibri"/>
               </a:defRPr>
             </a:pPr>
-            <a:endParaRPr/>
           </a:p>
           <a:p>
             <a:pPr algn="l">
@@ -13815,7 +13624,6 @@
                 <a:latin typeface="Calibri"/>
               </a:defRPr>
             </a:pPr>
-            <a:endParaRPr/>
           </a:p>
           <a:p>
             <a:pPr algn="l">
@@ -13882,7 +13690,6 @@
           <a:lstStyle/>
           <a:p>
             <a:pPr algn="ctr"/>
-            <a:endParaRPr/>
           </a:p>
         </p:txBody>
       </p:sp>
@@ -13971,7 +13778,6 @@
                 <a:latin typeface="Calibri"/>
               </a:defRPr>
             </a:pPr>
-            <a:endParaRPr/>
           </a:p>
           <a:p>
             <a:pPr algn="l">
@@ -14064,7 +13870,6 @@
                 <a:latin typeface="Calibri"/>
               </a:defRPr>
             </a:pPr>
-            <a:endParaRPr/>
           </a:p>
           <a:p>
             <a:pPr algn="l">
@@ -14207,7 +14012,6 @@
           <a:lstStyle/>
           <a:p>
             <a:pPr algn="ctr"/>
-            <a:endParaRPr/>
           </a:p>
         </p:txBody>
       </p:sp>
@@ -14353,7 +14157,6 @@
                 <a:latin typeface="Calibri"/>
               </a:defRPr>
             </a:pPr>
-            <a:endParaRPr/>
           </a:p>
           <a:p>
             <a:pPr algn="l">
@@ -14427,7 +14230,6 @@
                 <a:latin typeface="Calibri"/>
               </a:defRPr>
             </a:pPr>
-            <a:endParaRPr/>
           </a:p>
           <a:p>
             <a:pPr algn="l">
@@ -14605,7 +14407,7 @@
 </file>
 
 <file path=ppt/slides/slide8.xml><?xml version="1.0" encoding="utf-8"?>
-<p:sld xmlns:a="http://schemas.openxmlformats.org/drawingml/2006/main" xmlns:r="http://schemas.openxmlformats.org/officeDocument/2006/relationships" xmlns:p="http://schemas.openxmlformats.org/presentationml/2006/main">
+<p:sld xmlns:a="http://schemas.openxmlformats.org/drawingml/2006/main" xmlns:p="http://schemas.openxmlformats.org/presentationml/2006/main" xmlns:r="http://schemas.openxmlformats.org/officeDocument/2006/relationships">
   <p:cSld>
     <p:bg>
       <p:bgPr>
@@ -14621,14 +14423,7 @@
         <p:cNvGrpSpPr/>
         <p:nvPr/>
       </p:nvGrpSpPr>
-      <p:grpSpPr>
-        <a:xfrm>
-          <a:off x="0" y="0"/>
-          <a:ext cx="0" cy="0"/>
-          <a:chOff x="0" y="0"/>
-          <a:chExt cx="0" cy="0"/>
-        </a:xfrm>
-      </p:grpSpPr>
+      <p:grpSpPr/>
       <p:sp>
         <p:nvSpPr>
           <p:cNvPr id="2" name="TextBox 1"/>
@@ -14705,7 +14500,6 @@
           <a:lstStyle/>
           <a:p>
             <a:pPr algn="ctr"/>
-            <a:endParaRPr/>
           </a:p>
         </p:txBody>
       </p:sp>
@@ -14787,7 +14581,6 @@
           <a:lstStyle/>
           <a:p>
             <a:pPr algn="ctr"/>
-            <a:endParaRPr/>
           </a:p>
         </p:txBody>
       </p:sp>
@@ -14831,7 +14624,6 @@
           <a:lstStyle/>
           <a:p>
             <a:pPr algn="ctr"/>
-            <a:endParaRPr/>
           </a:p>
         </p:txBody>
       </p:sp>
@@ -15036,7 +14828,7 @@
 </file>
 
 <file path=ppt/slides/slide9.xml><?xml version="1.0" encoding="utf-8"?>
-<p:sld xmlns:a="http://schemas.openxmlformats.org/drawingml/2006/main" xmlns:r="http://schemas.openxmlformats.org/officeDocument/2006/relationships" xmlns:p="http://schemas.openxmlformats.org/presentationml/2006/main">
+<p:sld xmlns:a="http://schemas.openxmlformats.org/drawingml/2006/main" xmlns:p="http://schemas.openxmlformats.org/presentationml/2006/main" xmlns:r="http://schemas.openxmlformats.org/officeDocument/2006/relationships">
   <p:cSld>
     <p:bg>
       <p:bgPr>
@@ -15052,14 +14844,7 @@
         <p:cNvGrpSpPr/>
         <p:nvPr/>
       </p:nvGrpSpPr>
-      <p:grpSpPr>
-        <a:xfrm>
-          <a:off x="0" y="0"/>
-          <a:ext cx="0" cy="0"/>
-          <a:chOff x="0" y="0"/>
-          <a:chExt cx="0" cy="0"/>
-        </a:xfrm>
-      </p:grpSpPr>
+      <p:grpSpPr/>
       <p:sp>
         <p:nvSpPr>
           <p:cNvPr id="2" name="TextBox 1"/>
@@ -15136,7 +14921,6 @@
           <a:lstStyle/>
           <a:p>
             <a:pPr algn="ctr"/>
-            <a:endParaRPr/>
           </a:p>
         </p:txBody>
       </p:sp>
@@ -15192,7 +14976,7 @@
         </p:blipFill>
         <p:spPr>
           <a:xfrm>
-            <a:off x="1066647" y="1658620"/>
+            <a:off x="1066647" y="1417320"/>
             <a:ext cx="10058400" cy="2129322"/>
           </a:xfrm>
           <a:prstGeom prst="rect">
@@ -15208,7 +14992,7 @@
         </p:nvSpPr>
         <p:spPr>
           <a:xfrm>
-            <a:off x="5441797" y="1646321"/>
+            <a:off x="3352647" y="1097280"/>
             <a:ext cx="2286000" cy="320040"/>
           </a:xfrm>
           <a:prstGeom prst="rect">
@@ -15231,7 +15015,6 @@
               </a:defRPr>
             </a:pPr>
             <a:r>
-              <a:rPr dirty="0"/>
               <a:t>Starting Confidence: 55%</a:t>
             </a:r>
           </a:p>
@@ -15245,7 +15028,7 @@
         </p:nvSpPr>
         <p:spPr>
           <a:xfrm>
-            <a:off x="7213447" y="1303220"/>
+            <a:off x="7010247" y="1097280"/>
             <a:ext cx="2286000" cy="320040"/>
           </a:xfrm>
           <a:prstGeom prst="rect">
@@ -15268,7 +15051,6 @@
               </a:defRPr>
             </a:pPr>
             <a:r>
-              <a:rPr dirty="0"/>
               <a:t>Final Confidence: 71%</a:t>
             </a:r>
           </a:p>
@@ -15282,8 +15064,8 @@
         </p:nvSpPr>
         <p:spPr>
           <a:xfrm>
-            <a:off x="1130147" y="3429000"/>
-            <a:ext cx="10820553" cy="2743200"/>
+            <a:off x="548640" y="3866682"/>
+            <a:ext cx="11094415" cy="2743200"/>
           </a:xfrm>
           <a:prstGeom prst="roundRect">
             <a:avLst>
@@ -15316,7 +15098,6 @@
           <a:lstStyle/>
           <a:p>
             <a:pPr algn="ctr"/>
-            <a:endParaRPr/>
           </a:p>
         </p:txBody>
       </p:sp>
@@ -15328,7 +15109,7 @@
         </p:nvSpPr>
         <p:spPr>
           <a:xfrm>
-            <a:off x="1130147" y="3566160"/>
+            <a:off x="548640" y="4003842"/>
             <a:ext cx="63500" cy="2468880"/>
           </a:xfrm>
           <a:prstGeom prst="rect">
@@ -15360,7 +15141,6 @@
           <a:lstStyle/>
           <a:p>
             <a:pPr algn="ctr"/>
-            <a:endParaRPr/>
           </a:p>
         </p:txBody>
       </p:sp>
@@ -15372,7 +15152,7 @@
         </p:nvSpPr>
         <p:spPr>
           <a:xfrm>
-            <a:off x="1450187" y="3566160"/>
+            <a:off x="868680" y="4003842"/>
             <a:ext cx="10637215" cy="320040"/>
           </a:xfrm>
           <a:prstGeom prst="rect">
@@ -15408,8 +15188,8 @@
         </p:nvSpPr>
         <p:spPr>
           <a:xfrm>
-            <a:off x="1450187" y="3886200"/>
-            <a:ext cx="10545775" cy="1738938"/>
+            <a:off x="868680" y="4323882"/>
+            <a:ext cx="10545775" cy="2148840"/>
           </a:xfrm>
           <a:prstGeom prst="rect">
             <a:avLst/>
@@ -15434,13 +15214,14 @@
               </a:defRPr>
             </a:pPr>
             <a:r>
-              <a:rPr dirty="0"/>
               <a:t>Think of this as a debate between features arguing FOR and AGAINST classifying this position as ‘Administrative Services.’</a:t>
             </a:r>
-            <a:endParaRPr lang="en-US" dirty="0"/>
-          </a:p>
-          <a:p>
-            <a:pPr algn="l">
+          </a:p>
+          <a:p>
+            <a:pPr algn="l">
+              <a:spcBef>
+                <a:spcPts val="400"/>
+              </a:spcBef>
               <a:spcAft>
                 <a:spcPts val="600"/>
               </a:spcAft>
@@ -15452,10 +15233,8 @@
               </a:defRPr>
             </a:pPr>
             <a:r>
-              <a:rPr lang="en-US" dirty="0"/>
-              <a:t>Starting Confidence: Generally based on the class representation in its training.</a:t>
-            </a:r>
-            <a:endParaRPr dirty="0"/>
+              <a:t>Red features argue IN FAVOR — healthcare_keywords = 0 (no healthcare terms supports Admin), supervises_staff = 1 (supervision duties are common in Admin roles). These push the confidence UP from 55% toward 71%.</a:t>
+            </a:r>
           </a:p>
           <a:p>
             <a:pPr algn="l">
@@ -15473,24 +15252,7 @@
               </a:defRPr>
             </a:pPr>
             <a:r>
-              <a:rPr dirty="0"/>
-              <a:t>Red features argue IN FAVOR — </a:t>
-            </a:r>
-            <a:r>
-              <a:rPr dirty="0" err="1"/>
-              <a:t>healthcare_keywords</a:t>
-            </a:r>
-            <a:r>
-              <a:rPr dirty="0"/>
-              <a:t> = 0 (no healthcare terms supports Admin), </a:t>
-            </a:r>
-            <a:r>
-              <a:rPr dirty="0" err="1"/>
-              <a:t>supervises_staff</a:t>
-            </a:r>
-            <a:r>
-              <a:rPr dirty="0"/>
-              <a:t> = 1 (supervision duties are common in Admin roles). These push the confidence UP from 55% toward 71%.</a:t>
+              <a:t>Blue features argue AGAINST — finance_keywords and receives_supervision suggest this could be Financial Services instead. These push the confidence DOWN.</a:t>
             </a:r>
           </a:p>
           <a:p>
@@ -15499,7 +15261,7 @@
                 <a:spcPts val="400"/>
               </a:spcBef>
               <a:spcAft>
-                <a:spcPts val="600"/>
+                <a:spcPts val="400"/>
               </a:spcAft>
               <a:defRPr sz="1100" b="0">
                 <a:solidFill>
@@ -15509,43 +15271,6 @@
               </a:defRPr>
             </a:pPr>
             <a:r>
-              <a:rPr dirty="0"/>
-              <a:t>Blue features argue AGAINST — </a:t>
-            </a:r>
-            <a:r>
-              <a:rPr dirty="0" err="1"/>
-              <a:t>finance_keywords</a:t>
-            </a:r>
-            <a:r>
-              <a:rPr dirty="0"/>
-              <a:t> and </a:t>
-            </a:r>
-            <a:r>
-              <a:rPr dirty="0" err="1"/>
-              <a:t>receives_supervision</a:t>
-            </a:r>
-            <a:r>
-              <a:rPr dirty="0"/>
-              <a:t> suggest this could be Financial Services instead. These push the confidence DOWN.</a:t>
-            </a:r>
-          </a:p>
-          <a:p>
-            <a:pPr algn="l">
-              <a:spcBef>
-                <a:spcPts val="400"/>
-              </a:spcBef>
-              <a:spcAft>
-                <a:spcPts val="400"/>
-              </a:spcAft>
-              <a:defRPr sz="1100" b="0">
-                <a:solidFill>
-                  <a:srgbClr val="2D2D2D"/>
-                </a:solidFill>
-                <a:latin typeface="Calibri"/>
-              </a:defRPr>
-            </a:pPr>
-            <a:r>
-              <a:rPr dirty="0"/>
               <a:t>The final verdict: 71% confidence in Administrative Services — the ‘for’ arguments outweigh the ‘against.’ This is explainable AI: every classification traces back to specific, auditable features.</a:t>
             </a:r>
           </a:p>

</xml_diff>

<commit_message>
Add demo screenshots, NB5 with saved outputs, updated PPTX with demo slides
- 6 live app screenshots in ppt/Demo_Photos/
- PPTX now 15 slides with demo walkthrough (slides 12-13)
- NB5 re-run with all outputs saved (SHAP plots, leaderboard, confusion matrix)
- QUICK_START.md updated with prominent run instructions

Co-Authored-By: Claude Opus 4.6 (1M context) <noreply@anthropic.com>
</commit_message>
<xml_diff>
--- a/ppt/GRIFFIN_BigData_Presentation.pptx
+++ b/ppt/GRIFFIN_BigData_Presentation.pptx
@@ -18,6 +18,8 @@
     <p:sldId id="266" r:id="rId17"/>
     <p:sldId id="267" r:id="rId18"/>
     <p:sldId id="268" r:id="rId19"/>
+    <p:sldId id="269" r:id="rId20"/>
+    <p:sldId id="270" r:id="rId21"/>
   </p:sldIdLst>
   <p:sldSz cx="12191695" cy="6858000" type="screen4x3"/>
   <p:notesSz cx="6858000" cy="9144000"/>
@@ -3437,7 +3439,7 @@
               </a:defRPr>
             </a:pPr>
             <a:r>
-              <a:t>1 / 13</a:t>
+              <a:t>1 / 15</a:t>
             </a:r>
           </a:p>
         </p:txBody>
@@ -4612,7 +4614,7 @@
               </a:defRPr>
             </a:pPr>
             <a:r>
-              <a:t>10 / 13</a:t>
+              <a:t>10 / 15</a:t>
             </a:r>
           </a:p>
         </p:txBody>
@@ -5507,7 +5509,7 @@
               </a:defRPr>
             </a:pPr>
             <a:r>
-              <a:t>11 / 13</a:t>
+              <a:t>11 / 15</a:t>
             </a:r>
           </a:p>
         </p:txBody>
@@ -5569,7 +5571,7 @@
               </a:defRPr>
             </a:pPr>
             <a:r>
-              <a:t>Ethical Reflection</a:t>
+              <a:t>Live Demo — Classification in Action</a:t>
             </a:r>
           </a:p>
         </p:txBody>
@@ -5583,7 +5585,7 @@
         <p:spPr>
           <a:xfrm>
             <a:off x="548640" y="868680"/>
-            <a:ext cx="2743200" cy="25400"/>
+            <a:ext cx="5029200" cy="25400"/>
           </a:xfrm>
           <a:prstGeom prst="rect">
             <a:avLst/>
@@ -5626,7 +5628,7 @@
         <p:spPr>
           <a:xfrm>
             <a:off x="563727" y="1143000"/>
-            <a:ext cx="3474720" cy="2011680"/>
+            <a:ext cx="3474720" cy="4114800"/>
           </a:xfrm>
           <a:prstGeom prst="roundRect">
             <a:avLst>
@@ -5634,9 +5636,9 @@
             </a:avLst>
           </a:prstGeom>
           <a:solidFill>
-            <a:srgbClr val="F5F3EE"/>
+            <a:srgbClr val="FFFFFF"/>
           </a:solidFill>
-          <a:ln w="12700">
+          <a:ln w="19050">
             <a:solidFill>
               <a:srgbClr val="E0DBD0"/>
             </a:solidFill>
@@ -5664,16 +5666,40 @@
           </a:p>
         </p:txBody>
       </p:sp>
-      <p:sp>
-        <p:nvSpPr>
-          <p:cNvPr id="5" name="TextBox 4"/>
+      <p:pic>
+        <p:nvPicPr>
+          <p:cNvPr id="5" name="Picture 4" descr="Picture 1 Prompt.png"/>
+          <p:cNvPicPr>
+            <a:picLocks noChangeAspect="1"/>
+          </p:cNvPicPr>
+          <p:nvPr/>
+        </p:nvPicPr>
+        <p:blipFill>
+          <a:blip r:embed="rId2"/>
+          <a:stretch>
+            <a:fillRect/>
+          </a:stretch>
+        </p:blipFill>
+        <p:spPr>
+          <a:xfrm>
+            <a:off x="655167" y="1234440"/>
+            <a:ext cx="3291840" cy="3931920"/>
+          </a:xfrm>
+          <a:prstGeom prst="rect">
+            <a:avLst/>
+          </a:prstGeom>
+        </p:spPr>
+      </p:pic>
+      <p:sp>
+        <p:nvSpPr>
+          <p:cNvPr id="6" name="TextBox 5"/>
           <p:cNvSpPr txBox="1"/>
           <p:nvPr/>
         </p:nvSpPr>
         <p:spPr>
           <a:xfrm>
-            <a:off x="746607" y="1280160"/>
-            <a:ext cx="3108960" cy="365760"/>
+            <a:off x="563727" y="5330952"/>
+            <a:ext cx="3474720" cy="548640"/>
           </a:xfrm>
           <a:prstGeom prst="rect">
             <a:avLst/>
@@ -5686,60 +5712,16 @@
           </a:bodyPr>
           <a:lstStyle/>
           <a:p>
-            <a:pPr algn="l">
-              <a:defRPr sz="1200" b="1">
-                <a:solidFill>
-                  <a:srgbClr val="115740"/>
-                </a:solidFill>
-                <a:latin typeface="Calibri"/>
-              </a:defRPr>
-            </a:pPr>
-            <a:r>
-              <a:t>1. PUBLIC DATA ETHICS</a:t>
-            </a:r>
-          </a:p>
-        </p:txBody>
-      </p:sp>
-      <p:sp>
-        <p:nvSpPr>
-          <p:cNvPr id="6" name="TextBox 5"/>
-          <p:cNvSpPr txBox="1"/>
-          <p:nvPr/>
-        </p:nvSpPr>
-        <p:spPr>
-          <a:xfrm>
-            <a:off x="746607" y="1645920"/>
-            <a:ext cx="3108960" cy="1371600"/>
-          </a:xfrm>
-          <a:prstGeom prst="rect">
-            <a:avLst/>
-          </a:prstGeom>
-          <a:noFill/>
-        </p:spPr>
-        <p:txBody>
-          <a:bodyPr wrap="square">
-            <a:spAutoFit/>
-          </a:bodyPr>
-          <a:lstStyle/>
-          <a:p>
-            <a:pPr algn="l">
-              <a:defRPr sz="1100" b="0">
-                <a:solidFill>
-                  <a:srgbClr val="2D2D2D"/>
-                </a:solidFill>
-                <a:latin typeface="Calibri"/>
-              </a:defRPr>
-            </a:pPr>
-            <a:r>
-              <a:t>Rate-limited scraping (1.5s delays) of public</a:t>
-            </a:r>
-            <a:br/>
-            <a:r>
-              <a:t>government DHRM data. Cached locally so each</a:t>
-            </a:r>
-            <a:br/>
-            <a:r>
-              <a:t>URL fetched at most once.</a:t>
+            <a:pPr algn="ctr">
+              <a:defRPr sz="1400" b="0">
+                <a:solidFill>
+                  <a:srgbClr val="5A5A5A"/>
+                </a:solidFill>
+                <a:latin typeface="Calibri"/>
+              </a:defRPr>
+            </a:pPr>
+            <a:r>
+              <a:t>Step 1: Paste position description</a:t>
             </a:r>
           </a:p>
         </p:txBody>
@@ -5753,7 +5735,7 @@
         <p:spPr>
           <a:xfrm>
             <a:off x="4358487" y="1143000"/>
-            <a:ext cx="3474720" cy="2011680"/>
+            <a:ext cx="3474720" cy="4114800"/>
           </a:xfrm>
           <a:prstGeom prst="roundRect">
             <a:avLst>
@@ -5761,9 +5743,9 @@
             </a:avLst>
           </a:prstGeom>
           <a:solidFill>
-            <a:srgbClr val="F5F3EE"/>
+            <a:srgbClr val="FFFFFF"/>
           </a:solidFill>
-          <a:ln w="12700">
+          <a:ln w="19050">
             <a:solidFill>
               <a:srgbClr val="E0DBD0"/>
             </a:solidFill>
@@ -5791,16 +5773,40 @@
           </a:p>
         </p:txBody>
       </p:sp>
-      <p:sp>
-        <p:nvSpPr>
-          <p:cNvPr id="8" name="TextBox 7"/>
+      <p:pic>
+        <p:nvPicPr>
+          <p:cNvPr id="8" name="Picture 7" descr="Picture 2 - Top Result with Recommendation.png"/>
+          <p:cNvPicPr>
+            <a:picLocks noChangeAspect="1"/>
+          </p:cNvPicPr>
+          <p:nvPr/>
+        </p:nvPicPr>
+        <p:blipFill>
+          <a:blip r:embed="rId3"/>
+          <a:stretch>
+            <a:fillRect/>
+          </a:stretch>
+        </p:blipFill>
+        <p:spPr>
+          <a:xfrm>
+            <a:off x="4449927" y="1234440"/>
+            <a:ext cx="3291840" cy="3931920"/>
+          </a:xfrm>
+          <a:prstGeom prst="rect">
+            <a:avLst/>
+          </a:prstGeom>
+        </p:spPr>
+      </p:pic>
+      <p:sp>
+        <p:nvSpPr>
+          <p:cNvPr id="9" name="TextBox 8"/>
           <p:cNvSpPr txBox="1"/>
           <p:nvPr/>
         </p:nvSpPr>
         <p:spPr>
           <a:xfrm>
-            <a:off x="4541367" y="1280160"/>
-            <a:ext cx="3108960" cy="365760"/>
+            <a:off x="4358487" y="5330952"/>
+            <a:ext cx="3474720" cy="548640"/>
           </a:xfrm>
           <a:prstGeom prst="rect">
             <a:avLst/>
@@ -5813,60 +5819,16 @@
           </a:bodyPr>
           <a:lstStyle/>
           <a:p>
-            <a:pPr algn="l">
-              <a:defRPr sz="1200" b="1">
-                <a:solidFill>
-                  <a:srgbClr val="C99700"/>
-                </a:solidFill>
-                <a:latin typeface="Calibri"/>
-              </a:defRPr>
-            </a:pPr>
-            <a:r>
-              <a:t>2. CLASSIFICATION BIAS</a:t>
-            </a:r>
-          </a:p>
-        </p:txBody>
-      </p:sp>
-      <p:sp>
-        <p:nvSpPr>
-          <p:cNvPr id="9" name="TextBox 8"/>
-          <p:cNvSpPr txBox="1"/>
-          <p:nvPr/>
-        </p:nvSpPr>
-        <p:spPr>
-          <a:xfrm>
-            <a:off x="4541367" y="1645920"/>
-            <a:ext cx="3108960" cy="1371600"/>
-          </a:xfrm>
-          <a:prstGeom prst="rect">
-            <a:avLst/>
-          </a:prstGeom>
-          <a:noFill/>
-        </p:spPr>
-        <p:txBody>
-          <a:bodyPr wrap="square">
-            <a:spAutoFit/>
-          </a:bodyPr>
-          <a:lstStyle/>
-          <a:p>
-            <a:pPr algn="l">
-              <a:defRPr sz="1100" b="0">
-                <a:solidFill>
-                  <a:srgbClr val="2D2D2D"/>
-                </a:solidFill>
-                <a:latin typeface="Calibri"/>
-              </a:defRPr>
-            </a:pPr>
-            <a:r>
-              <a:t>103 PDs with heavy class imbalance acknowledged.</a:t>
-            </a:r>
-            <a:br/>
-            <a:r>
-              <a:t>Stratified CV preserves proportions.</a:t>
-            </a:r>
-            <a:br/>
-            <a:r>
-              <a:t>Model framed as advisory, not deterministic.</a:t>
+            <a:pPr algn="ctr">
+              <a:defRPr sz="1400" b="0">
+                <a:solidFill>
+                  <a:srgbClr val="5A5A5A"/>
+                </a:solidFill>
+                <a:latin typeface="Calibri"/>
+              </a:defRPr>
+            </a:pPr>
+            <a:r>
+              <a:t>Step 2: AI classifies with ranked matches and confidence</a:t>
             </a:r>
           </a:p>
         </p:txBody>
@@ -5880,7 +5842,7 @@
         <p:spPr>
           <a:xfrm>
             <a:off x="8153247" y="1143000"/>
-            <a:ext cx="3474720" cy="2011680"/>
+            <a:ext cx="3474720" cy="4114800"/>
           </a:xfrm>
           <a:prstGeom prst="roundRect">
             <a:avLst>
@@ -5888,9 +5850,9 @@
             </a:avLst>
           </a:prstGeom>
           <a:solidFill>
-            <a:srgbClr val="F5F3EE"/>
+            <a:srgbClr val="FFFFFF"/>
           </a:solidFill>
-          <a:ln w="12700">
+          <a:ln w="19050">
             <a:solidFill>
               <a:srgbClr val="E0DBD0"/>
             </a:solidFill>
@@ -5918,16 +5880,40 @@
           </a:p>
         </p:txBody>
       </p:sp>
-      <p:sp>
-        <p:nvSpPr>
-          <p:cNvPr id="11" name="TextBox 10"/>
+      <p:pic>
+        <p:nvPicPr>
+          <p:cNvPr id="11" name="Picture 10" descr="Picture 3 - Second and third.png"/>
+          <p:cNvPicPr>
+            <a:picLocks noChangeAspect="1"/>
+          </p:cNvPicPr>
+          <p:nvPr/>
+        </p:nvPicPr>
+        <p:blipFill>
+          <a:blip r:embed="rId4"/>
+          <a:stretch>
+            <a:fillRect/>
+          </a:stretch>
+        </p:blipFill>
+        <p:spPr>
+          <a:xfrm>
+            <a:off x="8244687" y="1234440"/>
+            <a:ext cx="3291840" cy="3931920"/>
+          </a:xfrm>
+          <a:prstGeom prst="rect">
+            <a:avLst/>
+          </a:prstGeom>
+        </p:spPr>
+      </p:pic>
+      <p:sp>
+        <p:nvSpPr>
+          <p:cNvPr id="12" name="TextBox 11"/>
           <p:cNvSpPr txBox="1"/>
           <p:nvPr/>
         </p:nvSpPr>
         <p:spPr>
           <a:xfrm>
-            <a:off x="8336127" y="1280160"/>
-            <a:ext cx="3108960" cy="365760"/>
+            <a:off x="8153247" y="5330952"/>
+            <a:ext cx="3474720" cy="548640"/>
           </a:xfrm>
           <a:prstGeom prst="rect">
             <a:avLst/>
@@ -5940,30 +5926,30 @@
           </a:bodyPr>
           <a:lstStyle/>
           <a:p>
-            <a:pPr algn="l">
-              <a:defRPr sz="1200" b="1">
-                <a:solidFill>
-                  <a:srgbClr val="115740"/>
-                </a:solidFill>
-                <a:latin typeface="Calibri"/>
-              </a:defRPr>
-            </a:pPr>
-            <a:r>
-              <a:t>3. HUMAN-IN-THE-LOOP</a:t>
-            </a:r>
-          </a:p>
-        </p:txBody>
-      </p:sp>
-      <p:sp>
-        <p:nvSpPr>
-          <p:cNvPr id="12" name="TextBox 11"/>
+            <a:pPr algn="ctr">
+              <a:defRPr sz="1400" b="0">
+                <a:solidFill>
+                  <a:srgbClr val="5A5A5A"/>
+                </a:solidFill>
+                <a:latin typeface="Calibri"/>
+              </a:defRPr>
+            </a:pPr>
+            <a:r>
+              <a:t>Step 3: Alternative roles for human review</a:t>
+            </a:r>
+          </a:p>
+        </p:txBody>
+      </p:sp>
+      <p:sp>
+        <p:nvSpPr>
+          <p:cNvPr id="13" name="TextBox 12"/>
           <p:cNvSpPr txBox="1"/>
           <p:nvPr/>
         </p:nvSpPr>
         <p:spPr>
           <a:xfrm>
-            <a:off x="8336127" y="1645920"/>
-            <a:ext cx="3108960" cy="1371600"/>
+            <a:off x="11094415" y="6446520"/>
+            <a:ext cx="914400" cy="274320"/>
           </a:xfrm>
           <a:prstGeom prst="rect">
             <a:avLst/>
@@ -5976,475 +5962,6 @@
           </a:bodyPr>
           <a:lstStyle/>
           <a:p>
-            <a:pPr algn="l">
-              <a:defRPr sz="1100" b="0">
-                <a:solidFill>
-                  <a:srgbClr val="2D2D2D"/>
-                </a:solidFill>
-                <a:latin typeface="Calibri"/>
-              </a:defRPr>
-            </a:pPr>
-            <a:r>
-              <a:t>AI recommends, HR decides. Never auto-submits.</a:t>
-            </a:r>
-            <a:br/>
-            <a:r>
-              <a:t>Confidence scores + reasoning narratives</a:t>
-            </a:r>
-            <a:br/>
-            <a:r>
-              <a:t>enable informed professional judgment.</a:t>
-            </a:r>
-          </a:p>
-        </p:txBody>
-      </p:sp>
-      <p:sp>
-        <p:nvSpPr>
-          <p:cNvPr id="13" name="Rounded Rectangle 12"/>
-          <p:cNvSpPr/>
-          <p:nvPr/>
-        </p:nvSpPr>
-        <p:spPr>
-          <a:xfrm>
-            <a:off x="563727" y="3337560"/>
-            <a:ext cx="3474720" cy="2011680"/>
-          </a:xfrm>
-          <a:prstGeom prst="roundRect">
-            <a:avLst>
-              <a:gd name="adj" fmla="val 5000"/>
-            </a:avLst>
-          </a:prstGeom>
-          <a:solidFill>
-            <a:srgbClr val="F5F3EE"/>
-          </a:solidFill>
-          <a:ln w="12700">
-            <a:solidFill>
-              <a:srgbClr val="E0DBD0"/>
-            </a:solidFill>
-          </a:ln>
-        </p:spPr>
-        <p:style>
-          <a:lnRef idx="1">
-            <a:schemeClr val="accent1"/>
-          </a:lnRef>
-          <a:fillRef idx="3">
-            <a:schemeClr val="accent1"/>
-          </a:fillRef>
-          <a:effectRef idx="2">
-            <a:schemeClr val="accent1"/>
-          </a:effectRef>
-          <a:fontRef idx="minor">
-            <a:schemeClr val="lt1"/>
-          </a:fontRef>
-        </p:style>
-        <p:txBody>
-          <a:bodyPr rtlCol="0" anchor="ctr"/>
-          <a:lstStyle/>
-          <a:p>
-            <a:pPr algn="ctr"/>
-          </a:p>
-        </p:txBody>
-      </p:sp>
-      <p:sp>
-        <p:nvSpPr>
-          <p:cNvPr id="14" name="TextBox 13"/>
-          <p:cNvSpPr txBox="1"/>
-          <p:nvPr/>
-        </p:nvSpPr>
-        <p:spPr>
-          <a:xfrm>
-            <a:off x="746607" y="3474720"/>
-            <a:ext cx="3108960" cy="365760"/>
-          </a:xfrm>
-          <a:prstGeom prst="rect">
-            <a:avLst/>
-          </a:prstGeom>
-          <a:noFill/>
-        </p:spPr>
-        <p:txBody>
-          <a:bodyPr wrap="square">
-            <a:spAutoFit/>
-          </a:bodyPr>
-          <a:lstStyle/>
-          <a:p>
-            <a:pPr algn="l">
-              <a:defRPr sz="1200" b="1">
-                <a:solidFill>
-                  <a:srgbClr val="1A7A5A"/>
-                </a:solidFill>
-                <a:latin typeface="Calibri"/>
-              </a:defRPr>
-            </a:pPr>
-            <a:r>
-              <a:t>4. LLM TRANSPARENCY</a:t>
-            </a:r>
-          </a:p>
-        </p:txBody>
-      </p:sp>
-      <p:sp>
-        <p:nvSpPr>
-          <p:cNvPr id="15" name="TextBox 14"/>
-          <p:cNvSpPr txBox="1"/>
-          <p:nvPr/>
-        </p:nvSpPr>
-        <p:spPr>
-          <a:xfrm>
-            <a:off x="746607" y="3840480"/>
-            <a:ext cx="3108960" cy="1371600"/>
-          </a:xfrm>
-          <a:prstGeom prst="rect">
-            <a:avLst/>
-          </a:prstGeom>
-          <a:noFill/>
-        </p:spPr>
-        <p:txBody>
-          <a:bodyPr wrap="square">
-            <a:spAutoFit/>
-          </a:bodyPr>
-          <a:lstStyle/>
-          <a:p>
-            <a:pPr algn="l">
-              <a:defRPr sz="1100" b="0">
-                <a:solidFill>
-                  <a:srgbClr val="2D2D2D"/>
-                </a:solidFill>
-                <a:latin typeface="Calibri"/>
-              </a:defRPr>
-            </a:pPr>
-            <a:r>
-              <a:t>Step-by-step reasoning narratives, not black-box.</a:t>
-            </a:r>
-            <a:br/>
-            <a:r>
-              <a:t>Auditable 8-component agent pipeline.</a:t>
-            </a:r>
-            <a:br/>
-            <a:r>
-              <a:t>Every classification is explainable.</a:t>
-            </a:r>
-          </a:p>
-        </p:txBody>
-      </p:sp>
-      <p:sp>
-        <p:nvSpPr>
-          <p:cNvPr id="16" name="Rounded Rectangle 15"/>
-          <p:cNvSpPr/>
-          <p:nvPr/>
-        </p:nvSpPr>
-        <p:spPr>
-          <a:xfrm>
-            <a:off x="4358487" y="3337560"/>
-            <a:ext cx="3474720" cy="2011680"/>
-          </a:xfrm>
-          <a:prstGeom prst="roundRect">
-            <a:avLst>
-              <a:gd name="adj" fmla="val 5000"/>
-            </a:avLst>
-          </a:prstGeom>
-          <a:solidFill>
-            <a:srgbClr val="F5F3EE"/>
-          </a:solidFill>
-          <a:ln w="12700">
-            <a:solidFill>
-              <a:srgbClr val="E0DBD0"/>
-            </a:solidFill>
-          </a:ln>
-        </p:spPr>
-        <p:style>
-          <a:lnRef idx="1">
-            <a:schemeClr val="accent1"/>
-          </a:lnRef>
-          <a:fillRef idx="3">
-            <a:schemeClr val="accent1"/>
-          </a:fillRef>
-          <a:effectRef idx="2">
-            <a:schemeClr val="accent1"/>
-          </a:effectRef>
-          <a:fontRef idx="minor">
-            <a:schemeClr val="lt1"/>
-          </a:fontRef>
-        </p:style>
-        <p:txBody>
-          <a:bodyPr rtlCol="0" anchor="ctr"/>
-          <a:lstStyle/>
-          <a:p>
-            <a:pPr algn="ctr"/>
-          </a:p>
-        </p:txBody>
-      </p:sp>
-      <p:sp>
-        <p:nvSpPr>
-          <p:cNvPr id="17" name="TextBox 16"/>
-          <p:cNvSpPr txBox="1"/>
-          <p:nvPr/>
-        </p:nvSpPr>
-        <p:spPr>
-          <a:xfrm>
-            <a:off x="4541367" y="3474720"/>
-            <a:ext cx="3108960" cy="365760"/>
-          </a:xfrm>
-          <a:prstGeom prst="rect">
-            <a:avLst/>
-          </a:prstGeom>
-          <a:noFill/>
-        </p:spPr>
-        <p:txBody>
-          <a:bodyPr wrap="square">
-            <a:spAutoFit/>
-          </a:bodyPr>
-          <a:lstStyle/>
-          <a:p>
-            <a:pPr algn="l">
-              <a:defRPr sz="1200" b="1">
-                <a:solidFill>
-                  <a:srgbClr val="C99700"/>
-                </a:solidFill>
-                <a:latin typeface="Calibri"/>
-              </a:defRPr>
-            </a:pPr>
-            <a:r>
-              <a:t>5. DATA PRIVACY</a:t>
-            </a:r>
-          </a:p>
-        </p:txBody>
-      </p:sp>
-      <p:sp>
-        <p:nvSpPr>
-          <p:cNvPr id="18" name="TextBox 17"/>
-          <p:cNvSpPr txBox="1"/>
-          <p:nvPr/>
-        </p:nvSpPr>
-        <p:spPr>
-          <a:xfrm>
-            <a:off x="4541367" y="3840480"/>
-            <a:ext cx="3108960" cy="1371600"/>
-          </a:xfrm>
-          <a:prstGeom prst="rect">
-            <a:avLst/>
-          </a:prstGeom>
-          <a:noFill/>
-        </p:spPr>
-        <p:txBody>
-          <a:bodyPr wrap="square">
-            <a:spAutoFit/>
-          </a:bodyPr>
-          <a:lstStyle/>
-          <a:p>
-            <a:pPr algn="l">
-              <a:defRPr sz="1100" b="0">
-                <a:solidFill>
-                  <a:srgbClr val="2D2D2D"/>
-                </a:solidFill>
-                <a:latin typeface="Calibri"/>
-              </a:defRPr>
-            </a:pPr>
-            <a:r>
-              <a:t>Censoring pipeline removes all PII, JP codes,</a:t>
-            </a:r>
-            <a:br/>
-            <a:r>
-              <a:t>comp grades, salary data before ML training.</a:t>
-            </a:r>
-            <a:br/>
-            <a:r>
-              <a:t>No personally identifiable information in pipeline.</a:t>
-            </a:r>
-            <a:br/>
-            <a:r>
-              <a:t>Since we do not have current PDs, future training</a:t>
-            </a:r>
-            <a:br/>
-            <a:r>
-              <a:t>data MUST be sanitized before being provided.</a:t>
-            </a:r>
-          </a:p>
-        </p:txBody>
-      </p:sp>
-      <p:sp>
-        <p:nvSpPr>
-          <p:cNvPr id="19" name="Rounded Rectangle 18"/>
-          <p:cNvSpPr/>
-          <p:nvPr/>
-        </p:nvSpPr>
-        <p:spPr>
-          <a:xfrm>
-            <a:off x="8153247" y="3337560"/>
-            <a:ext cx="3474720" cy="2011680"/>
-          </a:xfrm>
-          <a:prstGeom prst="roundRect">
-            <a:avLst>
-              <a:gd name="adj" fmla="val 5000"/>
-            </a:avLst>
-          </a:prstGeom>
-          <a:solidFill>
-            <a:srgbClr val="F5F3EE"/>
-          </a:solidFill>
-          <a:ln w="12700">
-            <a:solidFill>
-              <a:srgbClr val="E0DBD0"/>
-            </a:solidFill>
-          </a:ln>
-        </p:spPr>
-        <p:style>
-          <a:lnRef idx="1">
-            <a:schemeClr val="accent1"/>
-          </a:lnRef>
-          <a:fillRef idx="3">
-            <a:schemeClr val="accent1"/>
-          </a:fillRef>
-          <a:effectRef idx="2">
-            <a:schemeClr val="accent1"/>
-          </a:effectRef>
-          <a:fontRef idx="minor">
-            <a:schemeClr val="lt1"/>
-          </a:fontRef>
-        </p:style>
-        <p:txBody>
-          <a:bodyPr rtlCol="0" anchor="ctr"/>
-          <a:lstStyle/>
-          <a:p>
-            <a:pPr algn="ctr"/>
-          </a:p>
-        </p:txBody>
-      </p:sp>
-      <p:sp>
-        <p:nvSpPr>
-          <p:cNvPr id="20" name="TextBox 19"/>
-          <p:cNvSpPr txBox="1"/>
-          <p:nvPr/>
-        </p:nvSpPr>
-        <p:spPr>
-          <a:xfrm>
-            <a:off x="8336127" y="3474720"/>
-            <a:ext cx="3108960" cy="365760"/>
-          </a:xfrm>
-          <a:prstGeom prst="rect">
-            <a:avLst/>
-          </a:prstGeom>
-          <a:noFill/>
-        </p:spPr>
-        <p:txBody>
-          <a:bodyPr wrap="square">
-            <a:spAutoFit/>
-          </a:bodyPr>
-          <a:lstStyle/>
-          <a:p>
-            <a:pPr algn="l">
-              <a:defRPr sz="1200" b="1">
-                <a:solidFill>
-                  <a:srgbClr val="115740"/>
-                </a:solidFill>
-                <a:latin typeface="Calibri"/>
-              </a:defRPr>
-            </a:pPr>
-            <a:r>
-              <a:t>6. API SECURITY</a:t>
-            </a:r>
-          </a:p>
-        </p:txBody>
-      </p:sp>
-      <p:sp>
-        <p:nvSpPr>
-          <p:cNvPr id="21" name="TextBox 20"/>
-          <p:cNvSpPr txBox="1"/>
-          <p:nvPr/>
-        </p:nvSpPr>
-        <p:spPr>
-          <a:xfrm>
-            <a:off x="8336127" y="3840480"/>
-            <a:ext cx="3108960" cy="1371600"/>
-          </a:xfrm>
-          <a:prstGeom prst="rect">
-            <a:avLst/>
-          </a:prstGeom>
-          <a:noFill/>
-        </p:spPr>
-        <p:txBody>
-          <a:bodyPr wrap="square">
-            <a:spAutoFit/>
-          </a:bodyPr>
-          <a:lstStyle/>
-          <a:p>
-            <a:pPr algn="l">
-              <a:defRPr sz="1100" b="0">
-                <a:solidFill>
-                  <a:srgbClr val="2D2D2D"/>
-                </a:solidFill>
-                <a:latin typeface="Calibri"/>
-              </a:defRPr>
-            </a:pPr>
-            <a:r>
-              <a:t>.env excluded from git via .gitignore.</a:t>
-            </a:r>
-            <a:br/>
-            <a:r>
-              <a:t>Credentials loaded via python-dotenv.</a:t>
-            </a:r>
-            <a:br/>
-            <a:r>
-              <a:t>No API keys hardcoded in source files.</a:t>
-            </a:r>
-          </a:p>
-        </p:txBody>
-      </p:sp>
-      <p:sp>
-        <p:nvSpPr>
-          <p:cNvPr id="22" name="TextBox 21"/>
-          <p:cNvSpPr txBox="1"/>
-          <p:nvPr/>
-        </p:nvSpPr>
-        <p:spPr>
-          <a:xfrm>
-            <a:off x="548640" y="5623560"/>
-            <a:ext cx="11094415" cy="457200"/>
-          </a:xfrm>
-          <a:prstGeom prst="rect">
-            <a:avLst/>
-          </a:prstGeom>
-          <a:noFill/>
-        </p:spPr>
-        <p:txBody>
-          <a:bodyPr wrap="square">
-            <a:spAutoFit/>
-          </a:bodyPr>
-          <a:lstStyle/>
-          <a:p>
-            <a:pPr algn="ctr">
-              <a:defRPr sz="1400" b="1">
-                <a:solidFill>
-                  <a:srgbClr val="C99700"/>
-                </a:solidFill>
-                <a:latin typeface="Calibri"/>
-              </a:defRPr>
-            </a:pPr>
-            <a:r>
-              <a:t>Ethics integrated as engineering decisions — not a separate compliance exercise</a:t>
-            </a:r>
-          </a:p>
-        </p:txBody>
-      </p:sp>
-      <p:sp>
-        <p:nvSpPr>
-          <p:cNvPr id="23" name="TextBox 22"/>
-          <p:cNvSpPr txBox="1"/>
-          <p:nvPr/>
-        </p:nvSpPr>
-        <p:spPr>
-          <a:xfrm>
-            <a:off x="11094415" y="6446520"/>
-            <a:ext cx="914400" cy="274320"/>
-          </a:xfrm>
-          <a:prstGeom prst="rect">
-            <a:avLst/>
-          </a:prstGeom>
-          <a:noFill/>
-        </p:spPr>
-        <p:txBody>
-          <a:bodyPr wrap="square">
-            <a:spAutoFit/>
-          </a:bodyPr>
-          <a:lstStyle/>
-          <a:p>
             <a:pPr algn="r">
               <a:defRPr sz="1000" b="0">
                 <a:solidFill>
@@ -6454,7 +5971,7 @@
               </a:defRPr>
             </a:pPr>
             <a:r>
-              <a:t>12 / 13</a:t>
+              <a:t>12 / 15</a:t>
             </a:r>
           </a:p>
         </p:txBody>
@@ -6516,6 +6033,1415 @@
               </a:defRPr>
             </a:pPr>
             <a:r>
+              <a:t>Live Demo — Multi-Position Classification</a:t>
+            </a:r>
+          </a:p>
+        </p:txBody>
+      </p:sp>
+      <p:sp>
+        <p:nvSpPr>
+          <p:cNvPr id="3" name="Rectangle 2"/>
+          <p:cNvSpPr/>
+          <p:nvPr/>
+        </p:nvSpPr>
+        <p:spPr>
+          <a:xfrm>
+            <a:off x="548640" y="868680"/>
+            <a:ext cx="5486400" cy="25400"/>
+          </a:xfrm>
+          <a:prstGeom prst="rect">
+            <a:avLst/>
+          </a:prstGeom>
+          <a:solidFill>
+            <a:srgbClr val="C99700"/>
+          </a:solidFill>
+          <a:ln>
+            <a:noFill/>
+          </a:ln>
+        </p:spPr>
+        <p:style>
+          <a:lnRef idx="1">
+            <a:schemeClr val="accent1"/>
+          </a:lnRef>
+          <a:fillRef idx="3">
+            <a:schemeClr val="accent1"/>
+          </a:fillRef>
+          <a:effectRef idx="2">
+            <a:schemeClr val="accent1"/>
+          </a:effectRef>
+          <a:fontRef idx="minor">
+            <a:schemeClr val="lt1"/>
+          </a:fontRef>
+        </p:style>
+        <p:txBody>
+          <a:bodyPr rtlCol="0" anchor="ctr"/>
+          <a:lstStyle/>
+          <a:p>
+            <a:pPr algn="ctr"/>
+          </a:p>
+        </p:txBody>
+      </p:sp>
+      <p:sp>
+        <p:nvSpPr>
+          <p:cNvPr id="4" name="Rounded Rectangle 3"/>
+          <p:cNvSpPr/>
+          <p:nvPr/>
+        </p:nvSpPr>
+        <p:spPr>
+          <a:xfrm>
+            <a:off x="609447" y="1143000"/>
+            <a:ext cx="5303520" cy="3474720"/>
+          </a:xfrm>
+          <a:prstGeom prst="roundRect">
+            <a:avLst>
+              <a:gd name="adj" fmla="val 5000"/>
+            </a:avLst>
+          </a:prstGeom>
+          <a:solidFill>
+            <a:srgbClr val="FFFFFF"/>
+          </a:solidFill>
+          <a:ln w="19050">
+            <a:solidFill>
+              <a:srgbClr val="E0DBD0"/>
+            </a:solidFill>
+          </a:ln>
+        </p:spPr>
+        <p:style>
+          <a:lnRef idx="1">
+            <a:schemeClr val="accent1"/>
+          </a:lnRef>
+          <a:fillRef idx="3">
+            <a:schemeClr val="accent1"/>
+          </a:fillRef>
+          <a:effectRef idx="2">
+            <a:schemeClr val="accent1"/>
+          </a:effectRef>
+          <a:fontRef idx="minor">
+            <a:schemeClr val="lt1"/>
+          </a:fontRef>
+        </p:style>
+        <p:txBody>
+          <a:bodyPr rtlCol="0" anchor="ctr"/>
+          <a:lstStyle/>
+          <a:p>
+            <a:pPr algn="ctr"/>
+          </a:p>
+        </p:txBody>
+      </p:sp>
+      <p:pic>
+        <p:nvPicPr>
+          <p:cNvPr id="5" name="Picture 4" descr="Picture 4 - Role 2 - Top Result.png"/>
+          <p:cNvPicPr>
+            <a:picLocks noChangeAspect="1"/>
+          </p:cNvPicPr>
+          <p:nvPr/>
+        </p:nvPicPr>
+        <p:blipFill>
+          <a:blip r:embed="rId2"/>
+          <a:stretch>
+            <a:fillRect/>
+          </a:stretch>
+        </p:blipFill>
+        <p:spPr>
+          <a:xfrm>
+            <a:off x="700887" y="1234440"/>
+            <a:ext cx="5120640" cy="3291840"/>
+          </a:xfrm>
+          <a:prstGeom prst="rect">
+            <a:avLst/>
+          </a:prstGeom>
+        </p:spPr>
+      </p:pic>
+      <p:sp>
+        <p:nvSpPr>
+          <p:cNvPr id="6" name="TextBox 5"/>
+          <p:cNvSpPr txBox="1"/>
+          <p:nvPr/>
+        </p:nvSpPr>
+        <p:spPr>
+          <a:xfrm>
+            <a:off x="609447" y="4663440"/>
+            <a:ext cx="5303520" cy="365760"/>
+          </a:xfrm>
+          <a:prstGeom prst="rect">
+            <a:avLst/>
+          </a:prstGeom>
+          <a:noFill/>
+        </p:spPr>
+        <p:txBody>
+          <a:bodyPr wrap="square">
+            <a:spAutoFit/>
+          </a:bodyPr>
+          <a:lstStyle/>
+          <a:p>
+            <a:pPr algn="ctr">
+              <a:defRPr sz="1400" b="0">
+                <a:solidFill>
+                  <a:srgbClr val="5A5A5A"/>
+                </a:solidFill>
+                <a:latin typeface="Calibri"/>
+              </a:defRPr>
+            </a:pPr>
+            <a:r>
+              <a:t>Second position: different career group identified</a:t>
+            </a:r>
+          </a:p>
+        </p:txBody>
+      </p:sp>
+      <p:sp>
+        <p:nvSpPr>
+          <p:cNvPr id="7" name="Rounded Rectangle 6"/>
+          <p:cNvSpPr/>
+          <p:nvPr/>
+        </p:nvSpPr>
+        <p:spPr>
+          <a:xfrm>
+            <a:off x="6278727" y="1143000"/>
+            <a:ext cx="5303520" cy="3474720"/>
+          </a:xfrm>
+          <a:prstGeom prst="roundRect">
+            <a:avLst>
+              <a:gd name="adj" fmla="val 5000"/>
+            </a:avLst>
+          </a:prstGeom>
+          <a:solidFill>
+            <a:srgbClr val="FFFFFF"/>
+          </a:solidFill>
+          <a:ln w="19050">
+            <a:solidFill>
+              <a:srgbClr val="E0DBD0"/>
+            </a:solidFill>
+          </a:ln>
+        </p:spPr>
+        <p:style>
+          <a:lnRef idx="1">
+            <a:schemeClr val="accent1"/>
+          </a:lnRef>
+          <a:fillRef idx="3">
+            <a:schemeClr val="accent1"/>
+          </a:fillRef>
+          <a:effectRef idx="2">
+            <a:schemeClr val="accent1"/>
+          </a:effectRef>
+          <a:fontRef idx="minor">
+            <a:schemeClr val="lt1"/>
+          </a:fontRef>
+        </p:style>
+        <p:txBody>
+          <a:bodyPr rtlCol="0" anchor="ctr"/>
+          <a:lstStyle/>
+          <a:p>
+            <a:pPr algn="ctr"/>
+          </a:p>
+        </p:txBody>
+      </p:sp>
+      <p:pic>
+        <p:nvPicPr>
+          <p:cNvPr id="8" name="Picture 7" descr="Picture 5 - Role 2 second and third.png"/>
+          <p:cNvPicPr>
+            <a:picLocks noChangeAspect="1"/>
+          </p:cNvPicPr>
+          <p:nvPr/>
+        </p:nvPicPr>
+        <p:blipFill>
+          <a:blip r:embed="rId3"/>
+          <a:stretch>
+            <a:fillRect/>
+          </a:stretch>
+        </p:blipFill>
+        <p:spPr>
+          <a:xfrm>
+            <a:off x="6370167" y="1234440"/>
+            <a:ext cx="5120640" cy="3291840"/>
+          </a:xfrm>
+          <a:prstGeom prst="rect">
+            <a:avLst/>
+          </a:prstGeom>
+        </p:spPr>
+      </p:pic>
+      <p:sp>
+        <p:nvSpPr>
+          <p:cNvPr id="9" name="TextBox 8"/>
+          <p:cNvSpPr txBox="1"/>
+          <p:nvPr/>
+        </p:nvSpPr>
+        <p:spPr>
+          <a:xfrm>
+            <a:off x="6278727" y="4663440"/>
+            <a:ext cx="5303520" cy="365760"/>
+          </a:xfrm>
+          <a:prstGeom prst="rect">
+            <a:avLst/>
+          </a:prstGeom>
+          <a:noFill/>
+        </p:spPr>
+        <p:txBody>
+          <a:bodyPr wrap="square">
+            <a:spAutoFit/>
+          </a:bodyPr>
+          <a:lstStyle/>
+          <a:p>
+            <a:pPr algn="ctr">
+              <a:defRPr sz="1400" b="0">
+                <a:solidFill>
+                  <a:srgbClr val="5A5A5A"/>
+                </a:solidFill>
+                <a:latin typeface="Calibri"/>
+              </a:defRPr>
+            </a:pPr>
+            <a:r>
+              <a:t>Ranked alternatives with confidence scores</a:t>
+            </a:r>
+          </a:p>
+        </p:txBody>
+      </p:sp>
+      <p:sp>
+        <p:nvSpPr>
+          <p:cNvPr id="10" name="Rounded Rectangle 9"/>
+          <p:cNvSpPr/>
+          <p:nvPr/>
+        </p:nvSpPr>
+        <p:spPr>
+          <a:xfrm>
+            <a:off x="3352647" y="4983480"/>
+            <a:ext cx="5486400" cy="1371600"/>
+          </a:xfrm>
+          <a:prstGeom prst="roundRect">
+            <a:avLst>
+              <a:gd name="adj" fmla="val 5000"/>
+            </a:avLst>
+          </a:prstGeom>
+          <a:solidFill>
+            <a:srgbClr val="FFFFFF"/>
+          </a:solidFill>
+          <a:ln w="19050">
+            <a:solidFill>
+              <a:srgbClr val="E0DBD0"/>
+            </a:solidFill>
+          </a:ln>
+        </p:spPr>
+        <p:style>
+          <a:lnRef idx="1">
+            <a:schemeClr val="accent1"/>
+          </a:lnRef>
+          <a:fillRef idx="3">
+            <a:schemeClr val="accent1"/>
+          </a:fillRef>
+          <a:effectRef idx="2">
+            <a:schemeClr val="accent1"/>
+          </a:effectRef>
+          <a:fontRef idx="minor">
+            <a:schemeClr val="lt1"/>
+          </a:fontRef>
+        </p:style>
+        <p:txBody>
+          <a:bodyPr rtlCol="0" anchor="ctr"/>
+          <a:lstStyle/>
+          <a:p>
+            <a:pPr algn="ctr"/>
+          </a:p>
+        </p:txBody>
+      </p:sp>
+      <p:pic>
+        <p:nvPicPr>
+          <p:cNvPr id="11" name="Picture 10" descr="Picture 6 Closing.png"/>
+          <p:cNvPicPr>
+            <a:picLocks noChangeAspect="1"/>
+          </p:cNvPicPr>
+          <p:nvPr/>
+        </p:nvPicPr>
+        <p:blipFill>
+          <a:blip r:embed="rId4"/>
+          <a:stretch>
+            <a:fillRect/>
+          </a:stretch>
+        </p:blipFill>
+        <p:spPr>
+          <a:xfrm>
+            <a:off x="3444087" y="5074920"/>
+            <a:ext cx="5303520" cy="1188720"/>
+          </a:xfrm>
+          <a:prstGeom prst="rect">
+            <a:avLst/>
+          </a:prstGeom>
+        </p:spPr>
+      </p:pic>
+      <p:sp>
+        <p:nvSpPr>
+          <p:cNvPr id="12" name="TextBox 11"/>
+          <p:cNvSpPr txBox="1"/>
+          <p:nvPr/>
+        </p:nvSpPr>
+        <p:spPr>
+          <a:xfrm>
+            <a:off x="3352647" y="6400800"/>
+            <a:ext cx="5486400" cy="365760"/>
+          </a:xfrm>
+          <a:prstGeom prst="rect">
+            <a:avLst/>
+          </a:prstGeom>
+          <a:noFill/>
+        </p:spPr>
+        <p:txBody>
+          <a:bodyPr wrap="square">
+            <a:spAutoFit/>
+          </a:bodyPr>
+          <a:lstStyle/>
+          <a:p>
+            <a:pPr algn="ctr">
+              <a:defRPr sz="1400" b="0">
+                <a:solidFill>
+                  <a:srgbClr val="5A5A5A"/>
+                </a:solidFill>
+                <a:latin typeface="Calibri"/>
+              </a:defRPr>
+            </a:pPr>
+            <a:r>
+              <a:t>Dual-Method Classification: ML + AI transparency</a:t>
+            </a:r>
+          </a:p>
+        </p:txBody>
+      </p:sp>
+      <p:sp>
+        <p:nvSpPr>
+          <p:cNvPr id="13" name="TextBox 12"/>
+          <p:cNvSpPr txBox="1"/>
+          <p:nvPr/>
+        </p:nvSpPr>
+        <p:spPr>
+          <a:xfrm>
+            <a:off x="11094415" y="6446520"/>
+            <a:ext cx="914400" cy="274320"/>
+          </a:xfrm>
+          <a:prstGeom prst="rect">
+            <a:avLst/>
+          </a:prstGeom>
+          <a:noFill/>
+        </p:spPr>
+        <p:txBody>
+          <a:bodyPr wrap="square">
+            <a:spAutoFit/>
+          </a:bodyPr>
+          <a:lstStyle/>
+          <a:p>
+            <a:pPr algn="r">
+              <a:defRPr sz="1000" b="0">
+                <a:solidFill>
+                  <a:srgbClr val="5A5A5A"/>
+                </a:solidFill>
+                <a:latin typeface="Calibri"/>
+              </a:defRPr>
+            </a:pPr>
+            <a:r>
+              <a:t>13 / 15</a:t>
+            </a:r>
+          </a:p>
+        </p:txBody>
+      </p:sp>
+    </p:spTree>
+  </p:cSld>
+  <p:clrMapOvr>
+    <a:masterClrMapping/>
+  </p:clrMapOvr>
+</p:sld>
+</file>
+
+<file path=ppt/slides/slide14.xml><?xml version="1.0" encoding="utf-8"?>
+<p:sld xmlns:a="http://schemas.openxmlformats.org/drawingml/2006/main" xmlns:p="http://schemas.openxmlformats.org/presentationml/2006/main" xmlns:r="http://schemas.openxmlformats.org/officeDocument/2006/relationships">
+  <p:cSld>
+    <p:bg>
+      <p:bgPr>
+        <a:solidFill>
+          <a:srgbClr val="FFFFFF"/>
+        </a:solidFill>
+        <a:effectLst/>
+      </p:bgPr>
+    </p:bg>
+    <p:spTree>
+      <p:nvGrpSpPr>
+        <p:cNvPr id="1" name=""/>
+        <p:cNvGrpSpPr/>
+        <p:nvPr/>
+      </p:nvGrpSpPr>
+      <p:grpSpPr/>
+      <p:sp>
+        <p:nvSpPr>
+          <p:cNvPr id="2" name="TextBox 1"/>
+          <p:cNvSpPr txBox="1"/>
+          <p:nvPr/>
+        </p:nvSpPr>
+        <p:spPr>
+          <a:xfrm>
+            <a:off x="548640" y="274320"/>
+            <a:ext cx="11094415" cy="640080"/>
+          </a:xfrm>
+          <a:prstGeom prst="rect">
+            <a:avLst/>
+          </a:prstGeom>
+          <a:noFill/>
+        </p:spPr>
+        <p:txBody>
+          <a:bodyPr wrap="square">
+            <a:spAutoFit/>
+          </a:bodyPr>
+          <a:lstStyle/>
+          <a:p>
+            <a:pPr algn="l">
+              <a:defRPr sz="3200" b="1">
+                <a:solidFill>
+                  <a:srgbClr val="115740"/>
+                </a:solidFill>
+                <a:latin typeface="Calibri"/>
+              </a:defRPr>
+            </a:pPr>
+            <a:r>
+              <a:t>Ethical Reflection</a:t>
+            </a:r>
+          </a:p>
+        </p:txBody>
+      </p:sp>
+      <p:sp>
+        <p:nvSpPr>
+          <p:cNvPr id="3" name="Rectangle 2"/>
+          <p:cNvSpPr/>
+          <p:nvPr/>
+        </p:nvSpPr>
+        <p:spPr>
+          <a:xfrm>
+            <a:off x="548640" y="868680"/>
+            <a:ext cx="2743200" cy="25400"/>
+          </a:xfrm>
+          <a:prstGeom prst="rect">
+            <a:avLst/>
+          </a:prstGeom>
+          <a:solidFill>
+            <a:srgbClr val="C99700"/>
+          </a:solidFill>
+          <a:ln>
+            <a:noFill/>
+          </a:ln>
+        </p:spPr>
+        <p:style>
+          <a:lnRef idx="1">
+            <a:schemeClr val="accent1"/>
+          </a:lnRef>
+          <a:fillRef idx="3">
+            <a:schemeClr val="accent1"/>
+          </a:fillRef>
+          <a:effectRef idx="2">
+            <a:schemeClr val="accent1"/>
+          </a:effectRef>
+          <a:fontRef idx="minor">
+            <a:schemeClr val="lt1"/>
+          </a:fontRef>
+        </p:style>
+        <p:txBody>
+          <a:bodyPr rtlCol="0" anchor="ctr"/>
+          <a:lstStyle/>
+          <a:p>
+            <a:pPr algn="ctr"/>
+          </a:p>
+        </p:txBody>
+      </p:sp>
+      <p:sp>
+        <p:nvSpPr>
+          <p:cNvPr id="4" name="Rounded Rectangle 3"/>
+          <p:cNvSpPr/>
+          <p:nvPr/>
+        </p:nvSpPr>
+        <p:spPr>
+          <a:xfrm>
+            <a:off x="563727" y="1143000"/>
+            <a:ext cx="3474720" cy="2011680"/>
+          </a:xfrm>
+          <a:prstGeom prst="roundRect">
+            <a:avLst>
+              <a:gd name="adj" fmla="val 5000"/>
+            </a:avLst>
+          </a:prstGeom>
+          <a:solidFill>
+            <a:srgbClr val="F5F3EE"/>
+          </a:solidFill>
+          <a:ln w="12700">
+            <a:solidFill>
+              <a:srgbClr val="E0DBD0"/>
+            </a:solidFill>
+          </a:ln>
+        </p:spPr>
+        <p:style>
+          <a:lnRef idx="1">
+            <a:schemeClr val="accent1"/>
+          </a:lnRef>
+          <a:fillRef idx="3">
+            <a:schemeClr val="accent1"/>
+          </a:fillRef>
+          <a:effectRef idx="2">
+            <a:schemeClr val="accent1"/>
+          </a:effectRef>
+          <a:fontRef idx="minor">
+            <a:schemeClr val="lt1"/>
+          </a:fontRef>
+        </p:style>
+        <p:txBody>
+          <a:bodyPr rtlCol="0" anchor="ctr"/>
+          <a:lstStyle/>
+          <a:p>
+            <a:pPr algn="ctr"/>
+          </a:p>
+        </p:txBody>
+      </p:sp>
+      <p:sp>
+        <p:nvSpPr>
+          <p:cNvPr id="5" name="TextBox 4"/>
+          <p:cNvSpPr txBox="1"/>
+          <p:nvPr/>
+        </p:nvSpPr>
+        <p:spPr>
+          <a:xfrm>
+            <a:off x="746607" y="1280160"/>
+            <a:ext cx="3108960" cy="365760"/>
+          </a:xfrm>
+          <a:prstGeom prst="rect">
+            <a:avLst/>
+          </a:prstGeom>
+          <a:noFill/>
+        </p:spPr>
+        <p:txBody>
+          <a:bodyPr wrap="square">
+            <a:spAutoFit/>
+          </a:bodyPr>
+          <a:lstStyle/>
+          <a:p>
+            <a:pPr algn="l">
+              <a:defRPr sz="1200" b="1">
+                <a:solidFill>
+                  <a:srgbClr val="115740"/>
+                </a:solidFill>
+                <a:latin typeface="Calibri"/>
+              </a:defRPr>
+            </a:pPr>
+            <a:r>
+              <a:t>1. PUBLIC DATA ETHICS</a:t>
+            </a:r>
+          </a:p>
+        </p:txBody>
+      </p:sp>
+      <p:sp>
+        <p:nvSpPr>
+          <p:cNvPr id="6" name="TextBox 5"/>
+          <p:cNvSpPr txBox="1"/>
+          <p:nvPr/>
+        </p:nvSpPr>
+        <p:spPr>
+          <a:xfrm>
+            <a:off x="746607" y="1645920"/>
+            <a:ext cx="3108960" cy="1371600"/>
+          </a:xfrm>
+          <a:prstGeom prst="rect">
+            <a:avLst/>
+          </a:prstGeom>
+          <a:noFill/>
+        </p:spPr>
+        <p:txBody>
+          <a:bodyPr wrap="square">
+            <a:spAutoFit/>
+          </a:bodyPr>
+          <a:lstStyle/>
+          <a:p>
+            <a:pPr algn="l">
+              <a:defRPr sz="1100" b="0">
+                <a:solidFill>
+                  <a:srgbClr val="2D2D2D"/>
+                </a:solidFill>
+                <a:latin typeface="Calibri"/>
+              </a:defRPr>
+            </a:pPr>
+            <a:r>
+              <a:t>Rate-limited scraping (1.5s delays) of public</a:t>
+            </a:r>
+            <a:br/>
+            <a:r>
+              <a:t>government DHRM data. Cached locally so each</a:t>
+            </a:r>
+            <a:br/>
+            <a:r>
+              <a:t>URL fetched at most once.</a:t>
+            </a:r>
+          </a:p>
+        </p:txBody>
+      </p:sp>
+      <p:sp>
+        <p:nvSpPr>
+          <p:cNvPr id="7" name="Rounded Rectangle 6"/>
+          <p:cNvSpPr/>
+          <p:nvPr/>
+        </p:nvSpPr>
+        <p:spPr>
+          <a:xfrm>
+            <a:off x="4358487" y="1143000"/>
+            <a:ext cx="3474720" cy="2011680"/>
+          </a:xfrm>
+          <a:prstGeom prst="roundRect">
+            <a:avLst>
+              <a:gd name="adj" fmla="val 5000"/>
+            </a:avLst>
+          </a:prstGeom>
+          <a:solidFill>
+            <a:srgbClr val="F5F3EE"/>
+          </a:solidFill>
+          <a:ln w="12700">
+            <a:solidFill>
+              <a:srgbClr val="E0DBD0"/>
+            </a:solidFill>
+          </a:ln>
+        </p:spPr>
+        <p:style>
+          <a:lnRef idx="1">
+            <a:schemeClr val="accent1"/>
+          </a:lnRef>
+          <a:fillRef idx="3">
+            <a:schemeClr val="accent1"/>
+          </a:fillRef>
+          <a:effectRef idx="2">
+            <a:schemeClr val="accent1"/>
+          </a:effectRef>
+          <a:fontRef idx="minor">
+            <a:schemeClr val="lt1"/>
+          </a:fontRef>
+        </p:style>
+        <p:txBody>
+          <a:bodyPr rtlCol="0" anchor="ctr"/>
+          <a:lstStyle/>
+          <a:p>
+            <a:pPr algn="ctr"/>
+          </a:p>
+        </p:txBody>
+      </p:sp>
+      <p:sp>
+        <p:nvSpPr>
+          <p:cNvPr id="8" name="TextBox 7"/>
+          <p:cNvSpPr txBox="1"/>
+          <p:nvPr/>
+        </p:nvSpPr>
+        <p:spPr>
+          <a:xfrm>
+            <a:off x="4541367" y="1280160"/>
+            <a:ext cx="3108960" cy="365760"/>
+          </a:xfrm>
+          <a:prstGeom prst="rect">
+            <a:avLst/>
+          </a:prstGeom>
+          <a:noFill/>
+        </p:spPr>
+        <p:txBody>
+          <a:bodyPr wrap="square">
+            <a:spAutoFit/>
+          </a:bodyPr>
+          <a:lstStyle/>
+          <a:p>
+            <a:pPr algn="l">
+              <a:defRPr sz="1200" b="1">
+                <a:solidFill>
+                  <a:srgbClr val="C99700"/>
+                </a:solidFill>
+                <a:latin typeface="Calibri"/>
+              </a:defRPr>
+            </a:pPr>
+            <a:r>
+              <a:t>2. CLASSIFICATION BIAS</a:t>
+            </a:r>
+          </a:p>
+        </p:txBody>
+      </p:sp>
+      <p:sp>
+        <p:nvSpPr>
+          <p:cNvPr id="9" name="TextBox 8"/>
+          <p:cNvSpPr txBox="1"/>
+          <p:nvPr/>
+        </p:nvSpPr>
+        <p:spPr>
+          <a:xfrm>
+            <a:off x="4541367" y="1645920"/>
+            <a:ext cx="3108960" cy="1371600"/>
+          </a:xfrm>
+          <a:prstGeom prst="rect">
+            <a:avLst/>
+          </a:prstGeom>
+          <a:noFill/>
+        </p:spPr>
+        <p:txBody>
+          <a:bodyPr wrap="square">
+            <a:spAutoFit/>
+          </a:bodyPr>
+          <a:lstStyle/>
+          <a:p>
+            <a:pPr algn="l">
+              <a:defRPr sz="1100" b="0">
+                <a:solidFill>
+                  <a:srgbClr val="2D2D2D"/>
+                </a:solidFill>
+                <a:latin typeface="Calibri"/>
+              </a:defRPr>
+            </a:pPr>
+            <a:r>
+              <a:t>103 PDs with heavy class imbalance acknowledged.</a:t>
+            </a:r>
+            <a:br/>
+            <a:r>
+              <a:t>Stratified CV preserves proportions.</a:t>
+            </a:r>
+            <a:br/>
+            <a:r>
+              <a:t>Model framed as advisory, not deterministic.</a:t>
+            </a:r>
+          </a:p>
+        </p:txBody>
+      </p:sp>
+      <p:sp>
+        <p:nvSpPr>
+          <p:cNvPr id="10" name="Rounded Rectangle 9"/>
+          <p:cNvSpPr/>
+          <p:nvPr/>
+        </p:nvSpPr>
+        <p:spPr>
+          <a:xfrm>
+            <a:off x="8153247" y="1143000"/>
+            <a:ext cx="3474720" cy="2011680"/>
+          </a:xfrm>
+          <a:prstGeom prst="roundRect">
+            <a:avLst>
+              <a:gd name="adj" fmla="val 5000"/>
+            </a:avLst>
+          </a:prstGeom>
+          <a:solidFill>
+            <a:srgbClr val="F5F3EE"/>
+          </a:solidFill>
+          <a:ln w="12700">
+            <a:solidFill>
+              <a:srgbClr val="E0DBD0"/>
+            </a:solidFill>
+          </a:ln>
+        </p:spPr>
+        <p:style>
+          <a:lnRef idx="1">
+            <a:schemeClr val="accent1"/>
+          </a:lnRef>
+          <a:fillRef idx="3">
+            <a:schemeClr val="accent1"/>
+          </a:fillRef>
+          <a:effectRef idx="2">
+            <a:schemeClr val="accent1"/>
+          </a:effectRef>
+          <a:fontRef idx="minor">
+            <a:schemeClr val="lt1"/>
+          </a:fontRef>
+        </p:style>
+        <p:txBody>
+          <a:bodyPr rtlCol="0" anchor="ctr"/>
+          <a:lstStyle/>
+          <a:p>
+            <a:pPr algn="ctr"/>
+          </a:p>
+        </p:txBody>
+      </p:sp>
+      <p:sp>
+        <p:nvSpPr>
+          <p:cNvPr id="11" name="TextBox 10"/>
+          <p:cNvSpPr txBox="1"/>
+          <p:nvPr/>
+        </p:nvSpPr>
+        <p:spPr>
+          <a:xfrm>
+            <a:off x="8336127" y="1280160"/>
+            <a:ext cx="3108960" cy="365760"/>
+          </a:xfrm>
+          <a:prstGeom prst="rect">
+            <a:avLst/>
+          </a:prstGeom>
+          <a:noFill/>
+        </p:spPr>
+        <p:txBody>
+          <a:bodyPr wrap="square">
+            <a:spAutoFit/>
+          </a:bodyPr>
+          <a:lstStyle/>
+          <a:p>
+            <a:pPr algn="l">
+              <a:defRPr sz="1200" b="1">
+                <a:solidFill>
+                  <a:srgbClr val="115740"/>
+                </a:solidFill>
+                <a:latin typeface="Calibri"/>
+              </a:defRPr>
+            </a:pPr>
+            <a:r>
+              <a:t>3. HUMAN-IN-THE-LOOP</a:t>
+            </a:r>
+          </a:p>
+        </p:txBody>
+      </p:sp>
+      <p:sp>
+        <p:nvSpPr>
+          <p:cNvPr id="12" name="TextBox 11"/>
+          <p:cNvSpPr txBox="1"/>
+          <p:nvPr/>
+        </p:nvSpPr>
+        <p:spPr>
+          <a:xfrm>
+            <a:off x="8336127" y="1645920"/>
+            <a:ext cx="3108960" cy="1371600"/>
+          </a:xfrm>
+          <a:prstGeom prst="rect">
+            <a:avLst/>
+          </a:prstGeom>
+          <a:noFill/>
+        </p:spPr>
+        <p:txBody>
+          <a:bodyPr wrap="square">
+            <a:spAutoFit/>
+          </a:bodyPr>
+          <a:lstStyle/>
+          <a:p>
+            <a:pPr algn="l">
+              <a:defRPr sz="1100" b="0">
+                <a:solidFill>
+                  <a:srgbClr val="2D2D2D"/>
+                </a:solidFill>
+                <a:latin typeface="Calibri"/>
+              </a:defRPr>
+            </a:pPr>
+            <a:r>
+              <a:t>AI recommends, HR decides. Never auto-submits.</a:t>
+            </a:r>
+            <a:br/>
+            <a:r>
+              <a:t>Confidence scores + reasoning narratives</a:t>
+            </a:r>
+            <a:br/>
+            <a:r>
+              <a:t>enable informed professional judgment.</a:t>
+            </a:r>
+          </a:p>
+        </p:txBody>
+      </p:sp>
+      <p:sp>
+        <p:nvSpPr>
+          <p:cNvPr id="13" name="Rounded Rectangle 12"/>
+          <p:cNvSpPr/>
+          <p:nvPr/>
+        </p:nvSpPr>
+        <p:spPr>
+          <a:xfrm>
+            <a:off x="563727" y="3337560"/>
+            <a:ext cx="3474720" cy="2011680"/>
+          </a:xfrm>
+          <a:prstGeom prst="roundRect">
+            <a:avLst>
+              <a:gd name="adj" fmla="val 5000"/>
+            </a:avLst>
+          </a:prstGeom>
+          <a:solidFill>
+            <a:srgbClr val="F5F3EE"/>
+          </a:solidFill>
+          <a:ln w="12700">
+            <a:solidFill>
+              <a:srgbClr val="E0DBD0"/>
+            </a:solidFill>
+          </a:ln>
+        </p:spPr>
+        <p:style>
+          <a:lnRef idx="1">
+            <a:schemeClr val="accent1"/>
+          </a:lnRef>
+          <a:fillRef idx="3">
+            <a:schemeClr val="accent1"/>
+          </a:fillRef>
+          <a:effectRef idx="2">
+            <a:schemeClr val="accent1"/>
+          </a:effectRef>
+          <a:fontRef idx="minor">
+            <a:schemeClr val="lt1"/>
+          </a:fontRef>
+        </p:style>
+        <p:txBody>
+          <a:bodyPr rtlCol="0" anchor="ctr"/>
+          <a:lstStyle/>
+          <a:p>
+            <a:pPr algn="ctr"/>
+          </a:p>
+        </p:txBody>
+      </p:sp>
+      <p:sp>
+        <p:nvSpPr>
+          <p:cNvPr id="14" name="TextBox 13"/>
+          <p:cNvSpPr txBox="1"/>
+          <p:nvPr/>
+        </p:nvSpPr>
+        <p:spPr>
+          <a:xfrm>
+            <a:off x="746607" y="3474720"/>
+            <a:ext cx="3108960" cy="365760"/>
+          </a:xfrm>
+          <a:prstGeom prst="rect">
+            <a:avLst/>
+          </a:prstGeom>
+          <a:noFill/>
+        </p:spPr>
+        <p:txBody>
+          <a:bodyPr wrap="square">
+            <a:spAutoFit/>
+          </a:bodyPr>
+          <a:lstStyle/>
+          <a:p>
+            <a:pPr algn="l">
+              <a:defRPr sz="1200" b="1">
+                <a:solidFill>
+                  <a:srgbClr val="1A7A5A"/>
+                </a:solidFill>
+                <a:latin typeface="Calibri"/>
+              </a:defRPr>
+            </a:pPr>
+            <a:r>
+              <a:t>4. LLM TRANSPARENCY</a:t>
+            </a:r>
+          </a:p>
+        </p:txBody>
+      </p:sp>
+      <p:sp>
+        <p:nvSpPr>
+          <p:cNvPr id="15" name="TextBox 14"/>
+          <p:cNvSpPr txBox="1"/>
+          <p:nvPr/>
+        </p:nvSpPr>
+        <p:spPr>
+          <a:xfrm>
+            <a:off x="746607" y="3840480"/>
+            <a:ext cx="3108960" cy="1371600"/>
+          </a:xfrm>
+          <a:prstGeom prst="rect">
+            <a:avLst/>
+          </a:prstGeom>
+          <a:noFill/>
+        </p:spPr>
+        <p:txBody>
+          <a:bodyPr wrap="square">
+            <a:spAutoFit/>
+          </a:bodyPr>
+          <a:lstStyle/>
+          <a:p>
+            <a:pPr algn="l">
+              <a:defRPr sz="1100" b="0">
+                <a:solidFill>
+                  <a:srgbClr val="2D2D2D"/>
+                </a:solidFill>
+                <a:latin typeface="Calibri"/>
+              </a:defRPr>
+            </a:pPr>
+            <a:r>
+              <a:t>Step-by-step reasoning narratives, not black-box.</a:t>
+            </a:r>
+            <a:br/>
+            <a:r>
+              <a:t>Auditable 8-component agent pipeline.</a:t>
+            </a:r>
+            <a:br/>
+            <a:r>
+              <a:t>Every classification is explainable.</a:t>
+            </a:r>
+          </a:p>
+        </p:txBody>
+      </p:sp>
+      <p:sp>
+        <p:nvSpPr>
+          <p:cNvPr id="16" name="Rounded Rectangle 15"/>
+          <p:cNvSpPr/>
+          <p:nvPr/>
+        </p:nvSpPr>
+        <p:spPr>
+          <a:xfrm>
+            <a:off x="4358487" y="3337560"/>
+            <a:ext cx="3474720" cy="2011680"/>
+          </a:xfrm>
+          <a:prstGeom prst="roundRect">
+            <a:avLst>
+              <a:gd name="adj" fmla="val 5000"/>
+            </a:avLst>
+          </a:prstGeom>
+          <a:solidFill>
+            <a:srgbClr val="F5F3EE"/>
+          </a:solidFill>
+          <a:ln w="12700">
+            <a:solidFill>
+              <a:srgbClr val="E0DBD0"/>
+            </a:solidFill>
+          </a:ln>
+        </p:spPr>
+        <p:style>
+          <a:lnRef idx="1">
+            <a:schemeClr val="accent1"/>
+          </a:lnRef>
+          <a:fillRef idx="3">
+            <a:schemeClr val="accent1"/>
+          </a:fillRef>
+          <a:effectRef idx="2">
+            <a:schemeClr val="accent1"/>
+          </a:effectRef>
+          <a:fontRef idx="minor">
+            <a:schemeClr val="lt1"/>
+          </a:fontRef>
+        </p:style>
+        <p:txBody>
+          <a:bodyPr rtlCol="0" anchor="ctr"/>
+          <a:lstStyle/>
+          <a:p>
+            <a:pPr algn="ctr"/>
+          </a:p>
+        </p:txBody>
+      </p:sp>
+      <p:sp>
+        <p:nvSpPr>
+          <p:cNvPr id="17" name="TextBox 16"/>
+          <p:cNvSpPr txBox="1"/>
+          <p:nvPr/>
+        </p:nvSpPr>
+        <p:spPr>
+          <a:xfrm>
+            <a:off x="4541367" y="3474720"/>
+            <a:ext cx="3108960" cy="365760"/>
+          </a:xfrm>
+          <a:prstGeom prst="rect">
+            <a:avLst/>
+          </a:prstGeom>
+          <a:noFill/>
+        </p:spPr>
+        <p:txBody>
+          <a:bodyPr wrap="square">
+            <a:spAutoFit/>
+          </a:bodyPr>
+          <a:lstStyle/>
+          <a:p>
+            <a:pPr algn="l">
+              <a:defRPr sz="1200" b="1">
+                <a:solidFill>
+                  <a:srgbClr val="C99700"/>
+                </a:solidFill>
+                <a:latin typeface="Calibri"/>
+              </a:defRPr>
+            </a:pPr>
+            <a:r>
+              <a:t>5. DATA PRIVACY</a:t>
+            </a:r>
+          </a:p>
+        </p:txBody>
+      </p:sp>
+      <p:sp>
+        <p:nvSpPr>
+          <p:cNvPr id="18" name="TextBox 17"/>
+          <p:cNvSpPr txBox="1"/>
+          <p:nvPr/>
+        </p:nvSpPr>
+        <p:spPr>
+          <a:xfrm>
+            <a:off x="4541367" y="3840480"/>
+            <a:ext cx="3108960" cy="1371600"/>
+          </a:xfrm>
+          <a:prstGeom prst="rect">
+            <a:avLst/>
+          </a:prstGeom>
+          <a:noFill/>
+        </p:spPr>
+        <p:txBody>
+          <a:bodyPr wrap="square">
+            <a:spAutoFit/>
+          </a:bodyPr>
+          <a:lstStyle/>
+          <a:p>
+            <a:pPr algn="l">
+              <a:defRPr sz="1100" b="0">
+                <a:solidFill>
+                  <a:srgbClr val="2D2D2D"/>
+                </a:solidFill>
+                <a:latin typeface="Calibri"/>
+              </a:defRPr>
+            </a:pPr>
+            <a:r>
+              <a:t>Censoring pipeline removes all PII, JP codes,</a:t>
+            </a:r>
+            <a:br/>
+            <a:r>
+              <a:t>comp grades, salary data before ML training.</a:t>
+            </a:r>
+            <a:br/>
+            <a:r>
+              <a:t>No personally identifiable information in pipeline.</a:t>
+            </a:r>
+            <a:br/>
+            <a:r>
+              <a:t>Since we do not have current PDs, future training</a:t>
+            </a:r>
+            <a:br/>
+            <a:r>
+              <a:t>data MUST be sanitized before being provided.</a:t>
+            </a:r>
+          </a:p>
+        </p:txBody>
+      </p:sp>
+      <p:sp>
+        <p:nvSpPr>
+          <p:cNvPr id="19" name="Rounded Rectangle 18"/>
+          <p:cNvSpPr/>
+          <p:nvPr/>
+        </p:nvSpPr>
+        <p:spPr>
+          <a:xfrm>
+            <a:off x="8153247" y="3337560"/>
+            <a:ext cx="3474720" cy="2011680"/>
+          </a:xfrm>
+          <a:prstGeom prst="roundRect">
+            <a:avLst>
+              <a:gd name="adj" fmla="val 5000"/>
+            </a:avLst>
+          </a:prstGeom>
+          <a:solidFill>
+            <a:srgbClr val="F5F3EE"/>
+          </a:solidFill>
+          <a:ln w="12700">
+            <a:solidFill>
+              <a:srgbClr val="E0DBD0"/>
+            </a:solidFill>
+          </a:ln>
+        </p:spPr>
+        <p:style>
+          <a:lnRef idx="1">
+            <a:schemeClr val="accent1"/>
+          </a:lnRef>
+          <a:fillRef idx="3">
+            <a:schemeClr val="accent1"/>
+          </a:fillRef>
+          <a:effectRef idx="2">
+            <a:schemeClr val="accent1"/>
+          </a:effectRef>
+          <a:fontRef idx="minor">
+            <a:schemeClr val="lt1"/>
+          </a:fontRef>
+        </p:style>
+        <p:txBody>
+          <a:bodyPr rtlCol="0" anchor="ctr"/>
+          <a:lstStyle/>
+          <a:p>
+            <a:pPr algn="ctr"/>
+          </a:p>
+        </p:txBody>
+      </p:sp>
+      <p:sp>
+        <p:nvSpPr>
+          <p:cNvPr id="20" name="TextBox 19"/>
+          <p:cNvSpPr txBox="1"/>
+          <p:nvPr/>
+        </p:nvSpPr>
+        <p:spPr>
+          <a:xfrm>
+            <a:off x="8336127" y="3474720"/>
+            <a:ext cx="3108960" cy="365760"/>
+          </a:xfrm>
+          <a:prstGeom prst="rect">
+            <a:avLst/>
+          </a:prstGeom>
+          <a:noFill/>
+        </p:spPr>
+        <p:txBody>
+          <a:bodyPr wrap="square">
+            <a:spAutoFit/>
+          </a:bodyPr>
+          <a:lstStyle/>
+          <a:p>
+            <a:pPr algn="l">
+              <a:defRPr sz="1200" b="1">
+                <a:solidFill>
+                  <a:srgbClr val="115740"/>
+                </a:solidFill>
+                <a:latin typeface="Calibri"/>
+              </a:defRPr>
+            </a:pPr>
+            <a:r>
+              <a:t>6. API SECURITY</a:t>
+            </a:r>
+          </a:p>
+        </p:txBody>
+      </p:sp>
+      <p:sp>
+        <p:nvSpPr>
+          <p:cNvPr id="21" name="TextBox 20"/>
+          <p:cNvSpPr txBox="1"/>
+          <p:nvPr/>
+        </p:nvSpPr>
+        <p:spPr>
+          <a:xfrm>
+            <a:off x="8336127" y="3840480"/>
+            <a:ext cx="3108960" cy="1371600"/>
+          </a:xfrm>
+          <a:prstGeom prst="rect">
+            <a:avLst/>
+          </a:prstGeom>
+          <a:noFill/>
+        </p:spPr>
+        <p:txBody>
+          <a:bodyPr wrap="square">
+            <a:spAutoFit/>
+          </a:bodyPr>
+          <a:lstStyle/>
+          <a:p>
+            <a:pPr algn="l">
+              <a:defRPr sz="1100" b="0">
+                <a:solidFill>
+                  <a:srgbClr val="2D2D2D"/>
+                </a:solidFill>
+                <a:latin typeface="Calibri"/>
+              </a:defRPr>
+            </a:pPr>
+            <a:r>
+              <a:t>.env excluded from git via .gitignore.</a:t>
+            </a:r>
+            <a:br/>
+            <a:r>
+              <a:t>Credentials loaded via python-dotenv.</a:t>
+            </a:r>
+            <a:br/>
+            <a:r>
+              <a:t>No API keys hardcoded in source files.</a:t>
+            </a:r>
+          </a:p>
+        </p:txBody>
+      </p:sp>
+      <p:sp>
+        <p:nvSpPr>
+          <p:cNvPr id="22" name="TextBox 21"/>
+          <p:cNvSpPr txBox="1"/>
+          <p:nvPr/>
+        </p:nvSpPr>
+        <p:spPr>
+          <a:xfrm>
+            <a:off x="548640" y="5623560"/>
+            <a:ext cx="11094415" cy="457200"/>
+          </a:xfrm>
+          <a:prstGeom prst="rect">
+            <a:avLst/>
+          </a:prstGeom>
+          <a:noFill/>
+        </p:spPr>
+        <p:txBody>
+          <a:bodyPr wrap="square">
+            <a:spAutoFit/>
+          </a:bodyPr>
+          <a:lstStyle/>
+          <a:p>
+            <a:pPr algn="ctr">
+              <a:defRPr sz="1400" b="1">
+                <a:solidFill>
+                  <a:srgbClr val="C99700"/>
+                </a:solidFill>
+                <a:latin typeface="Calibri"/>
+              </a:defRPr>
+            </a:pPr>
+            <a:r>
+              <a:t>Ethics integrated as engineering decisions — not a separate compliance exercise</a:t>
+            </a:r>
+          </a:p>
+        </p:txBody>
+      </p:sp>
+      <p:sp>
+        <p:nvSpPr>
+          <p:cNvPr id="23" name="TextBox 22"/>
+          <p:cNvSpPr txBox="1"/>
+          <p:nvPr/>
+        </p:nvSpPr>
+        <p:spPr>
+          <a:xfrm>
+            <a:off x="11094415" y="6446520"/>
+            <a:ext cx="914400" cy="274320"/>
+          </a:xfrm>
+          <a:prstGeom prst="rect">
+            <a:avLst/>
+          </a:prstGeom>
+          <a:noFill/>
+        </p:spPr>
+        <p:txBody>
+          <a:bodyPr wrap="square">
+            <a:spAutoFit/>
+          </a:bodyPr>
+          <a:lstStyle/>
+          <a:p>
+            <a:pPr algn="r">
+              <a:defRPr sz="1000" b="0">
+                <a:solidFill>
+                  <a:srgbClr val="5A5A5A"/>
+                </a:solidFill>
+                <a:latin typeface="Calibri"/>
+              </a:defRPr>
+            </a:pPr>
+            <a:r>
+              <a:t>14 / 15</a:t>
+            </a:r>
+          </a:p>
+        </p:txBody>
+      </p:sp>
+    </p:spTree>
+  </p:cSld>
+  <p:clrMapOvr>
+    <a:masterClrMapping/>
+  </p:clrMapOvr>
+</p:sld>
+</file>
+
+<file path=ppt/slides/slide15.xml><?xml version="1.0" encoding="utf-8"?>
+<p:sld xmlns:a="http://schemas.openxmlformats.org/drawingml/2006/main" xmlns:p="http://schemas.openxmlformats.org/presentationml/2006/main" xmlns:r="http://schemas.openxmlformats.org/officeDocument/2006/relationships">
+  <p:cSld>
+    <p:bg>
+      <p:bgPr>
+        <a:solidFill>
+          <a:srgbClr val="FFFFFF"/>
+        </a:solidFill>
+        <a:effectLst/>
+      </p:bgPr>
+    </p:bg>
+    <p:spTree>
+      <p:nvGrpSpPr>
+        <p:cNvPr id="1" name=""/>
+        <p:cNvGrpSpPr/>
+        <p:nvPr/>
+      </p:nvGrpSpPr>
+      <p:grpSpPr/>
+      <p:sp>
+        <p:nvSpPr>
+          <p:cNvPr id="2" name="TextBox 1"/>
+          <p:cNvSpPr txBox="1"/>
+          <p:nvPr/>
+        </p:nvSpPr>
+        <p:spPr>
+          <a:xfrm>
+            <a:off x="548640" y="274320"/>
+            <a:ext cx="11094415" cy="640080"/>
+          </a:xfrm>
+          <a:prstGeom prst="rect">
+            <a:avLst/>
+          </a:prstGeom>
+          <a:noFill/>
+        </p:spPr>
+        <p:txBody>
+          <a:bodyPr wrap="square">
+            <a:spAutoFit/>
+          </a:bodyPr>
+          <a:lstStyle/>
+          <a:p>
+            <a:pPr algn="l">
+              <a:defRPr sz="3200" b="1">
+                <a:solidFill>
+                  <a:srgbClr val="115740"/>
+                </a:solidFill>
+                <a:latin typeface="Calibri"/>
+              </a:defRPr>
+            </a:pPr>
+            <a:r>
               <a:t>Next Steps</a:t>
             </a:r>
           </a:p>
@@ -7568,7 +8494,7 @@
               </a:defRPr>
             </a:pPr>
             <a:r>
-              <a:t>13 / 13</a:t>
+              <a:t>15 / 15</a:t>
             </a:r>
           </a:p>
         </p:txBody>
@@ -8372,7 +9298,7 @@
               </a:defRPr>
             </a:pPr>
             <a:r>
-              <a:t>2 / 13</a:t>
+              <a:t>2 / 15</a:t>
             </a:r>
           </a:p>
         </p:txBody>
@@ -9612,7 +10538,7 @@
               </a:defRPr>
             </a:pPr>
             <a:r>
-              <a:t>3 / 13</a:t>
+              <a:t>3 / 15</a:t>
             </a:r>
           </a:p>
         </p:txBody>
@@ -11465,7 +12391,7 @@
               </a:defRPr>
             </a:pPr>
             <a:r>
-              <a:t>4 / 13</a:t>
+              <a:t>4 / 15</a:t>
             </a:r>
           </a:p>
         </p:txBody>
@@ -12415,7 +13341,7 @@
               </a:defRPr>
             </a:pPr>
             <a:r>
-              <a:t>5 / 13</a:t>
+              <a:t>5 / 15</a:t>
             </a:r>
           </a:p>
         </p:txBody>
@@ -13181,7 +14107,7 @@
               </a:defRPr>
             </a:pPr>
             <a:r>
-              <a:t>6 / 13</a:t>
+              <a:t>6 / 15</a:t>
             </a:r>
           </a:p>
         </p:txBody>
@@ -14393,7 +15319,7 @@
               </a:defRPr>
             </a:pPr>
             <a:r>
-              <a:t>7 / 13</a:t>
+              <a:t>7 / 15</a:t>
             </a:r>
           </a:p>
         </p:txBody>
@@ -14814,7 +15740,7 @@
               </a:defRPr>
             </a:pPr>
             <a:r>
-              <a:t>8 / 13</a:t>
+              <a:t>8 / 15</a:t>
             </a:r>
           </a:p>
         </p:txBody>
@@ -15307,7 +16233,7 @@
               </a:defRPr>
             </a:pPr>
             <a:r>
-              <a:t>9 / 13</a:t>
+              <a:t>9 / 15</a:t>
             </a:r>
           </a:p>
         </p:txBody>

</xml_diff>

<commit_message>
Add required CareerOneStop API attribution (U.S. DOL/ETA)
Federal data source requires attribution and non-endorsement disclaimer.
Added to: Streamlit app footer, slide deck, poster references, README.

Co-Authored-By: Claude Opus 4.6 (1M context) <noreply@anthropic.com>
</commit_message>
<xml_diff>
--- a/ppt/GRIFFIN_BigData_Presentation.pptx
+++ b/ppt/GRIFFIN_BigData_Presentation.pptx
@@ -20,6 +20,7 @@
     <p:sldId id="268" r:id="rId19"/>
     <p:sldId id="269" r:id="rId20"/>
     <p:sldId id="270" r:id="rId21"/>
+    <p:sldId id="271" r:id="rId22"/>
   </p:sldIdLst>
   <p:sldSz cx="12191695" cy="6858000" type="screen4x3"/>
   <p:notesSz cx="6858000" cy="9144000"/>
@@ -3439,7 +3440,7 @@
               </a:defRPr>
             </a:pPr>
             <a:r>
-              <a:t>1 / 15</a:t>
+              <a:t>1 / 16</a:t>
             </a:r>
           </a:p>
         </p:txBody>
@@ -4614,7 +4615,7 @@
               </a:defRPr>
             </a:pPr>
             <a:r>
-              <a:t>10 / 15</a:t>
+              <a:t>10 / 16</a:t>
             </a:r>
           </a:p>
         </p:txBody>
@@ -5509,7 +5510,7 @@
               </a:defRPr>
             </a:pPr>
             <a:r>
-              <a:t>11 / 15</a:t>
+              <a:t>11 / 16</a:t>
             </a:r>
           </a:p>
         </p:txBody>
@@ -5571,7 +5572,7 @@
               </a:defRPr>
             </a:pPr>
             <a:r>
-              <a:t>Live Demo — Classification in Action</a:t>
+              <a:t>Live Demo — Entering a Position Description</a:t>
             </a:r>
           </a:p>
         </p:txBody>
@@ -5627,8 +5628,8 @@
         </p:nvSpPr>
         <p:spPr>
           <a:xfrm>
-            <a:off x="563727" y="1143000"/>
-            <a:ext cx="3474720" cy="4114800"/>
+            <a:off x="746607" y="1051560"/>
+            <a:ext cx="5212080" cy="4044106"/>
           </a:xfrm>
           <a:prstGeom prst="roundRect">
             <a:avLst>
@@ -5682,8 +5683,8 @@
         </p:blipFill>
         <p:spPr>
           <a:xfrm>
-            <a:off x="655167" y="1234440"/>
-            <a:ext cx="3291840" cy="3931920"/>
+            <a:off x="838047" y="1143000"/>
+            <a:ext cx="5029200" cy="3861226"/>
           </a:xfrm>
           <a:prstGeom prst="rect">
             <a:avLst/>
@@ -5698,8 +5699,8 @@
         </p:nvSpPr>
         <p:spPr>
           <a:xfrm>
-            <a:off x="563727" y="5330952"/>
-            <a:ext cx="3474720" cy="548640"/>
+            <a:off x="746607" y="5113954"/>
+            <a:ext cx="5212080" cy="548640"/>
           </a:xfrm>
           <a:prstGeom prst="rect">
             <a:avLst/>
@@ -5713,7 +5714,7 @@
           <a:lstStyle/>
           <a:p>
             <a:pPr algn="ctr">
-              <a:defRPr sz="1400" b="0">
+              <a:defRPr sz="1300" b="0">
                 <a:solidFill>
                   <a:srgbClr val="5A5A5A"/>
                 </a:solidFill>
@@ -5721,7 +5722,7 @@
               </a:defRPr>
             </a:pPr>
             <a:r>
-              <a:t>Step 1: Paste position description</a:t>
+              <a:t>Step 1: Paste position description and select classification mode</a:t>
             </a:r>
           </a:p>
         </p:txBody>
@@ -5734,8 +5735,8 @@
         </p:nvSpPr>
         <p:spPr>
           <a:xfrm>
-            <a:off x="4358487" y="1143000"/>
-            <a:ext cx="3474720" cy="4114800"/>
+            <a:off x="6233007" y="1051560"/>
+            <a:ext cx="5212080" cy="4127275"/>
           </a:xfrm>
           <a:prstGeom prst="roundRect">
             <a:avLst>
@@ -5789,8 +5790,8 @@
         </p:blipFill>
         <p:spPr>
           <a:xfrm>
-            <a:off x="4449927" y="1234440"/>
-            <a:ext cx="3291840" cy="3931920"/>
+            <a:off x="6324447" y="1143000"/>
+            <a:ext cx="5029200" cy="3944395"/>
           </a:xfrm>
           <a:prstGeom prst="rect">
             <a:avLst/>
@@ -5805,8 +5806,8 @@
         </p:nvSpPr>
         <p:spPr>
           <a:xfrm>
-            <a:off x="4358487" y="5330952"/>
-            <a:ext cx="3474720" cy="548640"/>
+            <a:off x="6233007" y="5197123"/>
+            <a:ext cx="5212080" cy="548640"/>
           </a:xfrm>
           <a:prstGeom prst="rect">
             <a:avLst/>
@@ -5820,7 +5821,7 @@
           <a:lstStyle/>
           <a:p>
             <a:pPr algn="ctr">
-              <a:defRPr sz="1400" b="0">
+              <a:defRPr sz="1300" b="0">
                 <a:solidFill>
                   <a:srgbClr val="5A5A5A"/>
                 </a:solidFill>
@@ -5828,92 +5829,21 @@
               </a:defRPr>
             </a:pPr>
             <a:r>
-              <a:t>Step 2: AI classifies with ranked matches and confidence</a:t>
-            </a:r>
-          </a:p>
-        </p:txBody>
-      </p:sp>
-      <p:sp>
-        <p:nvSpPr>
-          <p:cNvPr id="10" name="Rounded Rectangle 9"/>
-          <p:cNvSpPr/>
-          <p:nvPr/>
-        </p:nvSpPr>
-        <p:spPr>
-          <a:xfrm>
-            <a:off x="8153247" y="1143000"/>
-            <a:ext cx="3474720" cy="4114800"/>
-          </a:xfrm>
-          <a:prstGeom prst="roundRect">
-            <a:avLst>
-              <a:gd name="adj" fmla="val 5000"/>
-            </a:avLst>
-          </a:prstGeom>
-          <a:solidFill>
-            <a:srgbClr val="FFFFFF"/>
-          </a:solidFill>
-          <a:ln w="19050">
-            <a:solidFill>
-              <a:srgbClr val="E0DBD0"/>
-            </a:solidFill>
-          </a:ln>
-        </p:spPr>
-        <p:style>
-          <a:lnRef idx="1">
-            <a:schemeClr val="accent1"/>
-          </a:lnRef>
-          <a:fillRef idx="3">
-            <a:schemeClr val="accent1"/>
-          </a:fillRef>
-          <a:effectRef idx="2">
-            <a:schemeClr val="accent1"/>
-          </a:effectRef>
-          <a:fontRef idx="minor">
-            <a:schemeClr val="lt1"/>
-          </a:fontRef>
-        </p:style>
-        <p:txBody>
-          <a:bodyPr rtlCol="0" anchor="ctr"/>
-          <a:lstStyle/>
-          <a:p>
-            <a:pPr algn="ctr"/>
-          </a:p>
-        </p:txBody>
-      </p:sp>
-      <p:pic>
-        <p:nvPicPr>
-          <p:cNvPr id="11" name="Picture 10" descr="Picture 3 - Second and third.png"/>
-          <p:cNvPicPr>
-            <a:picLocks noChangeAspect="1"/>
-          </p:cNvPicPr>
-          <p:nvPr/>
-        </p:nvPicPr>
-        <p:blipFill>
-          <a:blip r:embed="rId4"/>
-          <a:stretch>
-            <a:fillRect/>
-          </a:stretch>
-        </p:blipFill>
-        <p:spPr>
-          <a:xfrm>
-            <a:off x="8244687" y="1234440"/>
-            <a:ext cx="3291840" cy="3931920"/>
-          </a:xfrm>
-          <a:prstGeom prst="rect">
-            <a:avLst/>
-          </a:prstGeom>
-        </p:spPr>
-      </p:pic>
-      <p:sp>
-        <p:nvSpPr>
-          <p:cNvPr id="12" name="TextBox 11"/>
+              <a:t>Step 2: Top-ranked match with AI confidence and reasoning</a:t>
+            </a:r>
+          </a:p>
+        </p:txBody>
+      </p:sp>
+      <p:sp>
+        <p:nvSpPr>
+          <p:cNvPr id="10" name="TextBox 9"/>
           <p:cNvSpPr txBox="1"/>
           <p:nvPr/>
         </p:nvSpPr>
         <p:spPr>
           <a:xfrm>
-            <a:off x="8153247" y="5330952"/>
-            <a:ext cx="3474720" cy="548640"/>
+            <a:off x="11094415" y="6446520"/>
+            <a:ext cx="914400" cy="274320"/>
           </a:xfrm>
           <a:prstGeom prst="rect">
             <a:avLst/>
@@ -5926,42 +5856,6 @@
           </a:bodyPr>
           <a:lstStyle/>
           <a:p>
-            <a:pPr algn="ctr">
-              <a:defRPr sz="1400" b="0">
-                <a:solidFill>
-                  <a:srgbClr val="5A5A5A"/>
-                </a:solidFill>
-                <a:latin typeface="Calibri"/>
-              </a:defRPr>
-            </a:pPr>
-            <a:r>
-              <a:t>Step 3: Alternative roles for human review</a:t>
-            </a:r>
-          </a:p>
-        </p:txBody>
-      </p:sp>
-      <p:sp>
-        <p:nvSpPr>
-          <p:cNvPr id="13" name="TextBox 12"/>
-          <p:cNvSpPr txBox="1"/>
-          <p:nvPr/>
-        </p:nvSpPr>
-        <p:spPr>
-          <a:xfrm>
-            <a:off x="11094415" y="6446520"/>
-            <a:ext cx="914400" cy="274320"/>
-          </a:xfrm>
-          <a:prstGeom prst="rect">
-            <a:avLst/>
-          </a:prstGeom>
-          <a:noFill/>
-        </p:spPr>
-        <p:txBody>
-          <a:bodyPr wrap="square">
-            <a:spAutoFit/>
-          </a:bodyPr>
-          <a:lstStyle/>
-          <a:p>
             <a:pPr algn="r">
               <a:defRPr sz="1000" b="0">
                 <a:solidFill>
@@ -5971,7 +5865,7 @@
               </a:defRPr>
             </a:pPr>
             <a:r>
-              <a:t>12 / 15</a:t>
+              <a:t>12 / 16</a:t>
             </a:r>
           </a:p>
         </p:txBody>
@@ -6033,7 +5927,7 @@
               </a:defRPr>
             </a:pPr>
             <a:r>
-              <a:t>Live Demo — Multi-Position Classification</a:t>
+              <a:t>Live Demo — Ranked Alternatives</a:t>
             </a:r>
           </a:p>
         </p:txBody>
@@ -6047,7 +5941,7 @@
         <p:spPr>
           <a:xfrm>
             <a:off x="548640" y="868680"/>
-            <a:ext cx="5486400" cy="25400"/>
+            <a:ext cx="4572000" cy="25400"/>
           </a:xfrm>
           <a:prstGeom prst="rect">
             <a:avLst/>
@@ -6089,8 +5983,8 @@
         </p:nvSpPr>
         <p:spPr>
           <a:xfrm>
-            <a:off x="609447" y="1143000"/>
-            <a:ext cx="5303520" cy="3474720"/>
+            <a:off x="746607" y="1051560"/>
+            <a:ext cx="5212080" cy="3109677"/>
           </a:xfrm>
           <a:prstGeom prst="roundRect">
             <a:avLst>
@@ -6130,7 +6024,7 @@
       </p:sp>
       <p:pic>
         <p:nvPicPr>
-          <p:cNvPr id="5" name="Picture 4" descr="Picture 4 - Role 2 - Top Result.png"/>
+          <p:cNvPr id="5" name="Picture 4" descr="Picture 3 - Second and third.png"/>
           <p:cNvPicPr>
             <a:picLocks noChangeAspect="1"/>
           </p:cNvPicPr>
@@ -6144,8 +6038,8 @@
         </p:blipFill>
         <p:spPr>
           <a:xfrm>
-            <a:off x="700887" y="1234440"/>
-            <a:ext cx="5120640" cy="3291840"/>
+            <a:off x="838047" y="1143000"/>
+            <a:ext cx="5029200" cy="2926797"/>
           </a:xfrm>
           <a:prstGeom prst="rect">
             <a:avLst/>
@@ -6160,8 +6054,8 @@
         </p:nvSpPr>
         <p:spPr>
           <a:xfrm>
-            <a:off x="609447" y="4663440"/>
-            <a:ext cx="5303520" cy="365760"/>
+            <a:off x="746607" y="4179525"/>
+            <a:ext cx="5212080" cy="548640"/>
           </a:xfrm>
           <a:prstGeom prst="rect">
             <a:avLst/>
@@ -6175,7 +6069,7 @@
           <a:lstStyle/>
           <a:p>
             <a:pPr algn="ctr">
-              <a:defRPr sz="1400" b="0">
+              <a:defRPr sz="1300" b="0">
                 <a:solidFill>
                   <a:srgbClr val="5A5A5A"/>
                 </a:solidFill>
@@ -6183,7 +6077,7 @@
               </a:defRPr>
             </a:pPr>
             <a:r>
-              <a:t>Second position: different career group identified</a:t>
+              <a:t>Alternative roles ranked by confidence for human review</a:t>
             </a:r>
           </a:p>
         </p:txBody>
@@ -6196,8 +6090,8 @@
         </p:nvSpPr>
         <p:spPr>
           <a:xfrm>
-            <a:off x="6278727" y="1143000"/>
-            <a:ext cx="5303520" cy="3474720"/>
+            <a:off x="6233007" y="1051560"/>
+            <a:ext cx="5212080" cy="4309495"/>
           </a:xfrm>
           <a:prstGeom prst="roundRect">
             <a:avLst>
@@ -6237,7 +6131,7 @@
       </p:sp>
       <p:pic>
         <p:nvPicPr>
-          <p:cNvPr id="8" name="Picture 7" descr="Picture 5 - Role 2 second and third.png"/>
+          <p:cNvPr id="8" name="Picture 7" descr="Picture 4 - Role 2 - Top Result.png"/>
           <p:cNvPicPr>
             <a:picLocks noChangeAspect="1"/>
           </p:cNvPicPr>
@@ -6251,8 +6145,8 @@
         </p:blipFill>
         <p:spPr>
           <a:xfrm>
-            <a:off x="6370167" y="1234440"/>
-            <a:ext cx="5120640" cy="3291840"/>
+            <a:off x="6324447" y="1143000"/>
+            <a:ext cx="5029200" cy="4126615"/>
           </a:xfrm>
           <a:prstGeom prst="rect">
             <a:avLst/>
@@ -6267,8 +6161,8 @@
         </p:nvSpPr>
         <p:spPr>
           <a:xfrm>
-            <a:off x="6278727" y="4663440"/>
-            <a:ext cx="5303520" cy="365760"/>
+            <a:off x="6233007" y="5379343"/>
+            <a:ext cx="5212080" cy="548640"/>
           </a:xfrm>
           <a:prstGeom prst="rect">
             <a:avLst/>
@@ -6282,7 +6176,7 @@
           <a:lstStyle/>
           <a:p>
             <a:pPr algn="ctr">
-              <a:defRPr sz="1400" b="0">
+              <a:defRPr sz="1300" b="0">
                 <a:solidFill>
                   <a:srgbClr val="5A5A5A"/>
                 </a:solidFill>
@@ -6290,92 +6184,21 @@
               </a:defRPr>
             </a:pPr>
             <a:r>
-              <a:t>Ranked alternatives with confidence scores</a:t>
-            </a:r>
-          </a:p>
-        </p:txBody>
-      </p:sp>
-      <p:sp>
-        <p:nvSpPr>
-          <p:cNvPr id="10" name="Rounded Rectangle 9"/>
-          <p:cNvSpPr/>
-          <p:nvPr/>
-        </p:nvSpPr>
-        <p:spPr>
-          <a:xfrm>
-            <a:off x="3352647" y="4983480"/>
-            <a:ext cx="5486400" cy="1371600"/>
-          </a:xfrm>
-          <a:prstGeom prst="roundRect">
-            <a:avLst>
-              <a:gd name="adj" fmla="val 5000"/>
-            </a:avLst>
-          </a:prstGeom>
-          <a:solidFill>
-            <a:srgbClr val="FFFFFF"/>
-          </a:solidFill>
-          <a:ln w="19050">
-            <a:solidFill>
-              <a:srgbClr val="E0DBD0"/>
-            </a:solidFill>
-          </a:ln>
-        </p:spPr>
-        <p:style>
-          <a:lnRef idx="1">
-            <a:schemeClr val="accent1"/>
-          </a:lnRef>
-          <a:fillRef idx="3">
-            <a:schemeClr val="accent1"/>
-          </a:fillRef>
-          <a:effectRef idx="2">
-            <a:schemeClr val="accent1"/>
-          </a:effectRef>
-          <a:fontRef idx="minor">
-            <a:schemeClr val="lt1"/>
-          </a:fontRef>
-        </p:style>
-        <p:txBody>
-          <a:bodyPr rtlCol="0" anchor="ctr"/>
-          <a:lstStyle/>
-          <a:p>
-            <a:pPr algn="ctr"/>
-          </a:p>
-        </p:txBody>
-      </p:sp>
-      <p:pic>
-        <p:nvPicPr>
-          <p:cNvPr id="11" name="Picture 10" descr="Picture 6 Closing.png"/>
-          <p:cNvPicPr>
-            <a:picLocks noChangeAspect="1"/>
-          </p:cNvPicPr>
-          <p:nvPr/>
-        </p:nvPicPr>
-        <p:blipFill>
-          <a:blip r:embed="rId4"/>
-          <a:stretch>
-            <a:fillRect/>
-          </a:stretch>
-        </p:blipFill>
-        <p:spPr>
-          <a:xfrm>
-            <a:off x="3444087" y="5074920"/>
-            <a:ext cx="5303520" cy="1188720"/>
-          </a:xfrm>
-          <a:prstGeom prst="rect">
-            <a:avLst/>
-          </a:prstGeom>
-        </p:spPr>
-      </p:pic>
-      <p:sp>
-        <p:nvSpPr>
-          <p:cNvPr id="12" name="TextBox 11"/>
+              <a:t>Second position: different career group identified</a:t>
+            </a:r>
+          </a:p>
+        </p:txBody>
+      </p:sp>
+      <p:sp>
+        <p:nvSpPr>
+          <p:cNvPr id="10" name="TextBox 9"/>
           <p:cNvSpPr txBox="1"/>
           <p:nvPr/>
         </p:nvSpPr>
         <p:spPr>
           <a:xfrm>
-            <a:off x="3352647" y="6400800"/>
-            <a:ext cx="5486400" cy="365760"/>
+            <a:off x="11094415" y="6446520"/>
+            <a:ext cx="914400" cy="274320"/>
           </a:xfrm>
           <a:prstGeom prst="rect">
             <a:avLst/>
@@ -6388,42 +6211,6 @@
           </a:bodyPr>
           <a:lstStyle/>
           <a:p>
-            <a:pPr algn="ctr">
-              <a:defRPr sz="1400" b="0">
-                <a:solidFill>
-                  <a:srgbClr val="5A5A5A"/>
-                </a:solidFill>
-                <a:latin typeface="Calibri"/>
-              </a:defRPr>
-            </a:pPr>
-            <a:r>
-              <a:t>Dual-Method Classification: ML + AI transparency</a:t>
-            </a:r>
-          </a:p>
-        </p:txBody>
-      </p:sp>
-      <p:sp>
-        <p:nvSpPr>
-          <p:cNvPr id="13" name="TextBox 12"/>
-          <p:cNvSpPr txBox="1"/>
-          <p:nvPr/>
-        </p:nvSpPr>
-        <p:spPr>
-          <a:xfrm>
-            <a:off x="11094415" y="6446520"/>
-            <a:ext cx="914400" cy="274320"/>
-          </a:xfrm>
-          <a:prstGeom prst="rect">
-            <a:avLst/>
-          </a:prstGeom>
-          <a:noFill/>
-        </p:spPr>
-        <p:txBody>
-          <a:bodyPr wrap="square">
-            <a:spAutoFit/>
-          </a:bodyPr>
-          <a:lstStyle/>
-          <a:p>
             <a:pPr algn="r">
               <a:defRPr sz="1000" b="0">
                 <a:solidFill>
@@ -6433,7 +6220,7 @@
               </a:defRPr>
             </a:pPr>
             <a:r>
-              <a:t>13 / 15</a:t>
+              <a:t>13 / 16</a:t>
             </a:r>
           </a:p>
         </p:txBody>
@@ -6495,7 +6282,7 @@
               </a:defRPr>
             </a:pPr>
             <a:r>
-              <a:t>Ethical Reflection</a:t>
+              <a:t>Live Demo — Multi-Position &amp; Methodology</a:t>
             </a:r>
           </a:p>
         </p:txBody>
@@ -6509,7 +6296,7 @@
         <p:spPr>
           <a:xfrm>
             <a:off x="548640" y="868680"/>
-            <a:ext cx="2743200" cy="25400"/>
+            <a:ext cx="5486400" cy="25400"/>
           </a:xfrm>
           <a:prstGeom prst="rect">
             <a:avLst/>
@@ -6551,8 +6338,8 @@
         </p:nvSpPr>
         <p:spPr>
           <a:xfrm>
-            <a:off x="563727" y="1143000"/>
-            <a:ext cx="3474720" cy="2011680"/>
+            <a:off x="746607" y="1051560"/>
+            <a:ext cx="5212080" cy="2967732"/>
           </a:xfrm>
           <a:prstGeom prst="roundRect">
             <a:avLst>
@@ -6560,9 +6347,9 @@
             </a:avLst>
           </a:prstGeom>
           <a:solidFill>
-            <a:srgbClr val="F5F3EE"/>
+            <a:srgbClr val="FFFFFF"/>
           </a:solidFill>
-          <a:ln w="12700">
+          <a:ln w="19050">
             <a:solidFill>
               <a:srgbClr val="E0DBD0"/>
             </a:solidFill>
@@ -6590,16 +6377,40 @@
           </a:p>
         </p:txBody>
       </p:sp>
-      <p:sp>
-        <p:nvSpPr>
-          <p:cNvPr id="5" name="TextBox 4"/>
+      <p:pic>
+        <p:nvPicPr>
+          <p:cNvPr id="5" name="Picture 4" descr="Picture 5 - Role 2 second and third.png"/>
+          <p:cNvPicPr>
+            <a:picLocks noChangeAspect="1"/>
+          </p:cNvPicPr>
+          <p:nvPr/>
+        </p:nvPicPr>
+        <p:blipFill>
+          <a:blip r:embed="rId2"/>
+          <a:stretch>
+            <a:fillRect/>
+          </a:stretch>
+        </p:blipFill>
+        <p:spPr>
+          <a:xfrm>
+            <a:off x="838047" y="1143000"/>
+            <a:ext cx="5029200" cy="2784852"/>
+          </a:xfrm>
+          <a:prstGeom prst="rect">
+            <a:avLst/>
+          </a:prstGeom>
+        </p:spPr>
+      </p:pic>
+      <p:sp>
+        <p:nvSpPr>
+          <p:cNvPr id="6" name="TextBox 5"/>
           <p:cNvSpPr txBox="1"/>
           <p:nvPr/>
         </p:nvSpPr>
         <p:spPr>
           <a:xfrm>
-            <a:off x="746607" y="1280160"/>
-            <a:ext cx="3108960" cy="365760"/>
+            <a:off x="746607" y="4037580"/>
+            <a:ext cx="5212080" cy="548640"/>
           </a:xfrm>
           <a:prstGeom prst="rect">
             <a:avLst/>
@@ -6612,60 +6423,16 @@
           </a:bodyPr>
           <a:lstStyle/>
           <a:p>
-            <a:pPr algn="l">
-              <a:defRPr sz="1200" b="1">
-                <a:solidFill>
-                  <a:srgbClr val="115740"/>
-                </a:solidFill>
-                <a:latin typeface="Calibri"/>
-              </a:defRPr>
-            </a:pPr>
-            <a:r>
-              <a:t>1. PUBLIC DATA ETHICS</a:t>
-            </a:r>
-          </a:p>
-        </p:txBody>
-      </p:sp>
-      <p:sp>
-        <p:nvSpPr>
-          <p:cNvPr id="6" name="TextBox 5"/>
-          <p:cNvSpPr txBox="1"/>
-          <p:nvPr/>
-        </p:nvSpPr>
-        <p:spPr>
-          <a:xfrm>
-            <a:off x="746607" y="1645920"/>
-            <a:ext cx="3108960" cy="1371600"/>
-          </a:xfrm>
-          <a:prstGeom prst="rect">
-            <a:avLst/>
-          </a:prstGeom>
-          <a:noFill/>
-        </p:spPr>
-        <p:txBody>
-          <a:bodyPr wrap="square">
-            <a:spAutoFit/>
-          </a:bodyPr>
-          <a:lstStyle/>
-          <a:p>
-            <a:pPr algn="l">
-              <a:defRPr sz="1100" b="0">
-                <a:solidFill>
-                  <a:srgbClr val="2D2D2D"/>
-                </a:solidFill>
-                <a:latin typeface="Calibri"/>
-              </a:defRPr>
-            </a:pPr>
-            <a:r>
-              <a:t>Rate-limited scraping (1.5s delays) of public</a:t>
-            </a:r>
-            <a:br/>
-            <a:r>
-              <a:t>government DHRM data. Cached locally so each</a:t>
-            </a:r>
-            <a:br/>
-            <a:r>
-              <a:t>URL fetched at most once.</a:t>
+            <a:pPr algn="ctr">
+              <a:defRPr sz="1300" b="0">
+                <a:solidFill>
+                  <a:srgbClr val="5A5A5A"/>
+                </a:solidFill>
+                <a:latin typeface="Calibri"/>
+              </a:defRPr>
+            </a:pPr>
+            <a:r>
+              <a:t>Ranked alternatives for second position</a:t>
             </a:r>
           </a:p>
         </p:txBody>
@@ -6678,8 +6445,8 @@
         </p:nvSpPr>
         <p:spPr>
           <a:xfrm>
-            <a:off x="4358487" y="1143000"/>
-            <a:ext cx="3474720" cy="2011680"/>
+            <a:off x="6233007" y="1051560"/>
+            <a:ext cx="5212080" cy="2510069"/>
           </a:xfrm>
           <a:prstGeom prst="roundRect">
             <a:avLst>
@@ -6687,9 +6454,9 @@
             </a:avLst>
           </a:prstGeom>
           <a:solidFill>
-            <a:srgbClr val="F5F3EE"/>
+            <a:srgbClr val="FFFFFF"/>
           </a:solidFill>
-          <a:ln w="12700">
+          <a:ln w="19050">
             <a:solidFill>
               <a:srgbClr val="E0DBD0"/>
             </a:solidFill>
@@ -6717,16 +6484,40 @@
           </a:p>
         </p:txBody>
       </p:sp>
-      <p:sp>
-        <p:nvSpPr>
-          <p:cNvPr id="8" name="TextBox 7"/>
+      <p:pic>
+        <p:nvPicPr>
+          <p:cNvPr id="8" name="Picture 7" descr="Picture 6 Closing.png"/>
+          <p:cNvPicPr>
+            <a:picLocks noChangeAspect="1"/>
+          </p:cNvPicPr>
+          <p:nvPr/>
+        </p:nvPicPr>
+        <p:blipFill>
+          <a:blip r:embed="rId3"/>
+          <a:stretch>
+            <a:fillRect/>
+          </a:stretch>
+        </p:blipFill>
+        <p:spPr>
+          <a:xfrm>
+            <a:off x="6324447" y="1143000"/>
+            <a:ext cx="5029200" cy="2327189"/>
+          </a:xfrm>
+          <a:prstGeom prst="rect">
+            <a:avLst/>
+          </a:prstGeom>
+        </p:spPr>
+      </p:pic>
+      <p:sp>
+        <p:nvSpPr>
+          <p:cNvPr id="9" name="TextBox 8"/>
           <p:cNvSpPr txBox="1"/>
           <p:nvPr/>
         </p:nvSpPr>
         <p:spPr>
           <a:xfrm>
-            <a:off x="4541367" y="1280160"/>
-            <a:ext cx="3108960" cy="365760"/>
+            <a:off x="6233007" y="3579917"/>
+            <a:ext cx="5212080" cy="548640"/>
           </a:xfrm>
           <a:prstGeom prst="rect">
             <a:avLst/>
@@ -6739,30 +6530,30 @@
           </a:bodyPr>
           <a:lstStyle/>
           <a:p>
-            <a:pPr algn="l">
-              <a:defRPr sz="1200" b="1">
-                <a:solidFill>
-                  <a:srgbClr val="C99700"/>
-                </a:solidFill>
-                <a:latin typeface="Calibri"/>
-              </a:defRPr>
-            </a:pPr>
-            <a:r>
-              <a:t>2. CLASSIFICATION BIAS</a:t>
-            </a:r>
-          </a:p>
-        </p:txBody>
-      </p:sp>
-      <p:sp>
-        <p:nvSpPr>
-          <p:cNvPr id="9" name="TextBox 8"/>
+            <a:pPr algn="ctr">
+              <a:defRPr sz="1300" b="0">
+                <a:solidFill>
+                  <a:srgbClr val="5A5A5A"/>
+                </a:solidFill>
+                <a:latin typeface="Calibri"/>
+              </a:defRPr>
+            </a:pPr>
+            <a:r>
+              <a:t>Dual-Method Classification: ML + AI transparency</a:t>
+            </a:r>
+          </a:p>
+        </p:txBody>
+      </p:sp>
+      <p:sp>
+        <p:nvSpPr>
+          <p:cNvPr id="10" name="TextBox 9"/>
           <p:cNvSpPr txBox="1"/>
           <p:nvPr/>
         </p:nvSpPr>
         <p:spPr>
           <a:xfrm>
-            <a:off x="4541367" y="1645920"/>
-            <a:ext cx="3108960" cy="1371600"/>
+            <a:off x="11094415" y="6446520"/>
+            <a:ext cx="914400" cy="274320"/>
           </a:xfrm>
           <a:prstGeom prst="rect">
             <a:avLst/>
@@ -6775,602 +6566,6 @@
           </a:bodyPr>
           <a:lstStyle/>
           <a:p>
-            <a:pPr algn="l">
-              <a:defRPr sz="1100" b="0">
-                <a:solidFill>
-                  <a:srgbClr val="2D2D2D"/>
-                </a:solidFill>
-                <a:latin typeface="Calibri"/>
-              </a:defRPr>
-            </a:pPr>
-            <a:r>
-              <a:t>103 PDs with heavy class imbalance acknowledged.</a:t>
-            </a:r>
-            <a:br/>
-            <a:r>
-              <a:t>Stratified CV preserves proportions.</a:t>
-            </a:r>
-            <a:br/>
-            <a:r>
-              <a:t>Model framed as advisory, not deterministic.</a:t>
-            </a:r>
-          </a:p>
-        </p:txBody>
-      </p:sp>
-      <p:sp>
-        <p:nvSpPr>
-          <p:cNvPr id="10" name="Rounded Rectangle 9"/>
-          <p:cNvSpPr/>
-          <p:nvPr/>
-        </p:nvSpPr>
-        <p:spPr>
-          <a:xfrm>
-            <a:off x="8153247" y="1143000"/>
-            <a:ext cx="3474720" cy="2011680"/>
-          </a:xfrm>
-          <a:prstGeom prst="roundRect">
-            <a:avLst>
-              <a:gd name="adj" fmla="val 5000"/>
-            </a:avLst>
-          </a:prstGeom>
-          <a:solidFill>
-            <a:srgbClr val="F5F3EE"/>
-          </a:solidFill>
-          <a:ln w="12700">
-            <a:solidFill>
-              <a:srgbClr val="E0DBD0"/>
-            </a:solidFill>
-          </a:ln>
-        </p:spPr>
-        <p:style>
-          <a:lnRef idx="1">
-            <a:schemeClr val="accent1"/>
-          </a:lnRef>
-          <a:fillRef idx="3">
-            <a:schemeClr val="accent1"/>
-          </a:fillRef>
-          <a:effectRef idx="2">
-            <a:schemeClr val="accent1"/>
-          </a:effectRef>
-          <a:fontRef idx="minor">
-            <a:schemeClr val="lt1"/>
-          </a:fontRef>
-        </p:style>
-        <p:txBody>
-          <a:bodyPr rtlCol="0" anchor="ctr"/>
-          <a:lstStyle/>
-          <a:p>
-            <a:pPr algn="ctr"/>
-          </a:p>
-        </p:txBody>
-      </p:sp>
-      <p:sp>
-        <p:nvSpPr>
-          <p:cNvPr id="11" name="TextBox 10"/>
-          <p:cNvSpPr txBox="1"/>
-          <p:nvPr/>
-        </p:nvSpPr>
-        <p:spPr>
-          <a:xfrm>
-            <a:off x="8336127" y="1280160"/>
-            <a:ext cx="3108960" cy="365760"/>
-          </a:xfrm>
-          <a:prstGeom prst="rect">
-            <a:avLst/>
-          </a:prstGeom>
-          <a:noFill/>
-        </p:spPr>
-        <p:txBody>
-          <a:bodyPr wrap="square">
-            <a:spAutoFit/>
-          </a:bodyPr>
-          <a:lstStyle/>
-          <a:p>
-            <a:pPr algn="l">
-              <a:defRPr sz="1200" b="1">
-                <a:solidFill>
-                  <a:srgbClr val="115740"/>
-                </a:solidFill>
-                <a:latin typeface="Calibri"/>
-              </a:defRPr>
-            </a:pPr>
-            <a:r>
-              <a:t>3. HUMAN-IN-THE-LOOP</a:t>
-            </a:r>
-          </a:p>
-        </p:txBody>
-      </p:sp>
-      <p:sp>
-        <p:nvSpPr>
-          <p:cNvPr id="12" name="TextBox 11"/>
-          <p:cNvSpPr txBox="1"/>
-          <p:nvPr/>
-        </p:nvSpPr>
-        <p:spPr>
-          <a:xfrm>
-            <a:off x="8336127" y="1645920"/>
-            <a:ext cx="3108960" cy="1371600"/>
-          </a:xfrm>
-          <a:prstGeom prst="rect">
-            <a:avLst/>
-          </a:prstGeom>
-          <a:noFill/>
-        </p:spPr>
-        <p:txBody>
-          <a:bodyPr wrap="square">
-            <a:spAutoFit/>
-          </a:bodyPr>
-          <a:lstStyle/>
-          <a:p>
-            <a:pPr algn="l">
-              <a:defRPr sz="1100" b="0">
-                <a:solidFill>
-                  <a:srgbClr val="2D2D2D"/>
-                </a:solidFill>
-                <a:latin typeface="Calibri"/>
-              </a:defRPr>
-            </a:pPr>
-            <a:r>
-              <a:t>AI recommends, HR decides. Never auto-submits.</a:t>
-            </a:r>
-            <a:br/>
-            <a:r>
-              <a:t>Confidence scores + reasoning narratives</a:t>
-            </a:r>
-            <a:br/>
-            <a:r>
-              <a:t>enable informed professional judgment.</a:t>
-            </a:r>
-          </a:p>
-        </p:txBody>
-      </p:sp>
-      <p:sp>
-        <p:nvSpPr>
-          <p:cNvPr id="13" name="Rounded Rectangle 12"/>
-          <p:cNvSpPr/>
-          <p:nvPr/>
-        </p:nvSpPr>
-        <p:spPr>
-          <a:xfrm>
-            <a:off x="563727" y="3337560"/>
-            <a:ext cx="3474720" cy="2011680"/>
-          </a:xfrm>
-          <a:prstGeom prst="roundRect">
-            <a:avLst>
-              <a:gd name="adj" fmla="val 5000"/>
-            </a:avLst>
-          </a:prstGeom>
-          <a:solidFill>
-            <a:srgbClr val="F5F3EE"/>
-          </a:solidFill>
-          <a:ln w="12700">
-            <a:solidFill>
-              <a:srgbClr val="E0DBD0"/>
-            </a:solidFill>
-          </a:ln>
-        </p:spPr>
-        <p:style>
-          <a:lnRef idx="1">
-            <a:schemeClr val="accent1"/>
-          </a:lnRef>
-          <a:fillRef idx="3">
-            <a:schemeClr val="accent1"/>
-          </a:fillRef>
-          <a:effectRef idx="2">
-            <a:schemeClr val="accent1"/>
-          </a:effectRef>
-          <a:fontRef idx="minor">
-            <a:schemeClr val="lt1"/>
-          </a:fontRef>
-        </p:style>
-        <p:txBody>
-          <a:bodyPr rtlCol="0" anchor="ctr"/>
-          <a:lstStyle/>
-          <a:p>
-            <a:pPr algn="ctr"/>
-          </a:p>
-        </p:txBody>
-      </p:sp>
-      <p:sp>
-        <p:nvSpPr>
-          <p:cNvPr id="14" name="TextBox 13"/>
-          <p:cNvSpPr txBox="1"/>
-          <p:nvPr/>
-        </p:nvSpPr>
-        <p:spPr>
-          <a:xfrm>
-            <a:off x="746607" y="3474720"/>
-            <a:ext cx="3108960" cy="365760"/>
-          </a:xfrm>
-          <a:prstGeom prst="rect">
-            <a:avLst/>
-          </a:prstGeom>
-          <a:noFill/>
-        </p:spPr>
-        <p:txBody>
-          <a:bodyPr wrap="square">
-            <a:spAutoFit/>
-          </a:bodyPr>
-          <a:lstStyle/>
-          <a:p>
-            <a:pPr algn="l">
-              <a:defRPr sz="1200" b="1">
-                <a:solidFill>
-                  <a:srgbClr val="1A7A5A"/>
-                </a:solidFill>
-                <a:latin typeface="Calibri"/>
-              </a:defRPr>
-            </a:pPr>
-            <a:r>
-              <a:t>4. LLM TRANSPARENCY</a:t>
-            </a:r>
-          </a:p>
-        </p:txBody>
-      </p:sp>
-      <p:sp>
-        <p:nvSpPr>
-          <p:cNvPr id="15" name="TextBox 14"/>
-          <p:cNvSpPr txBox="1"/>
-          <p:nvPr/>
-        </p:nvSpPr>
-        <p:spPr>
-          <a:xfrm>
-            <a:off x="746607" y="3840480"/>
-            <a:ext cx="3108960" cy="1371600"/>
-          </a:xfrm>
-          <a:prstGeom prst="rect">
-            <a:avLst/>
-          </a:prstGeom>
-          <a:noFill/>
-        </p:spPr>
-        <p:txBody>
-          <a:bodyPr wrap="square">
-            <a:spAutoFit/>
-          </a:bodyPr>
-          <a:lstStyle/>
-          <a:p>
-            <a:pPr algn="l">
-              <a:defRPr sz="1100" b="0">
-                <a:solidFill>
-                  <a:srgbClr val="2D2D2D"/>
-                </a:solidFill>
-                <a:latin typeface="Calibri"/>
-              </a:defRPr>
-            </a:pPr>
-            <a:r>
-              <a:t>Step-by-step reasoning narratives, not black-box.</a:t>
-            </a:r>
-            <a:br/>
-            <a:r>
-              <a:t>Auditable 8-component agent pipeline.</a:t>
-            </a:r>
-            <a:br/>
-            <a:r>
-              <a:t>Every classification is explainable.</a:t>
-            </a:r>
-          </a:p>
-        </p:txBody>
-      </p:sp>
-      <p:sp>
-        <p:nvSpPr>
-          <p:cNvPr id="16" name="Rounded Rectangle 15"/>
-          <p:cNvSpPr/>
-          <p:nvPr/>
-        </p:nvSpPr>
-        <p:spPr>
-          <a:xfrm>
-            <a:off x="4358487" y="3337560"/>
-            <a:ext cx="3474720" cy="2011680"/>
-          </a:xfrm>
-          <a:prstGeom prst="roundRect">
-            <a:avLst>
-              <a:gd name="adj" fmla="val 5000"/>
-            </a:avLst>
-          </a:prstGeom>
-          <a:solidFill>
-            <a:srgbClr val="F5F3EE"/>
-          </a:solidFill>
-          <a:ln w="12700">
-            <a:solidFill>
-              <a:srgbClr val="E0DBD0"/>
-            </a:solidFill>
-          </a:ln>
-        </p:spPr>
-        <p:style>
-          <a:lnRef idx="1">
-            <a:schemeClr val="accent1"/>
-          </a:lnRef>
-          <a:fillRef idx="3">
-            <a:schemeClr val="accent1"/>
-          </a:fillRef>
-          <a:effectRef idx="2">
-            <a:schemeClr val="accent1"/>
-          </a:effectRef>
-          <a:fontRef idx="minor">
-            <a:schemeClr val="lt1"/>
-          </a:fontRef>
-        </p:style>
-        <p:txBody>
-          <a:bodyPr rtlCol="0" anchor="ctr"/>
-          <a:lstStyle/>
-          <a:p>
-            <a:pPr algn="ctr"/>
-          </a:p>
-        </p:txBody>
-      </p:sp>
-      <p:sp>
-        <p:nvSpPr>
-          <p:cNvPr id="17" name="TextBox 16"/>
-          <p:cNvSpPr txBox="1"/>
-          <p:nvPr/>
-        </p:nvSpPr>
-        <p:spPr>
-          <a:xfrm>
-            <a:off x="4541367" y="3474720"/>
-            <a:ext cx="3108960" cy="365760"/>
-          </a:xfrm>
-          <a:prstGeom prst="rect">
-            <a:avLst/>
-          </a:prstGeom>
-          <a:noFill/>
-        </p:spPr>
-        <p:txBody>
-          <a:bodyPr wrap="square">
-            <a:spAutoFit/>
-          </a:bodyPr>
-          <a:lstStyle/>
-          <a:p>
-            <a:pPr algn="l">
-              <a:defRPr sz="1200" b="1">
-                <a:solidFill>
-                  <a:srgbClr val="C99700"/>
-                </a:solidFill>
-                <a:latin typeface="Calibri"/>
-              </a:defRPr>
-            </a:pPr>
-            <a:r>
-              <a:t>5. DATA PRIVACY</a:t>
-            </a:r>
-          </a:p>
-        </p:txBody>
-      </p:sp>
-      <p:sp>
-        <p:nvSpPr>
-          <p:cNvPr id="18" name="TextBox 17"/>
-          <p:cNvSpPr txBox="1"/>
-          <p:nvPr/>
-        </p:nvSpPr>
-        <p:spPr>
-          <a:xfrm>
-            <a:off x="4541367" y="3840480"/>
-            <a:ext cx="3108960" cy="1371600"/>
-          </a:xfrm>
-          <a:prstGeom prst="rect">
-            <a:avLst/>
-          </a:prstGeom>
-          <a:noFill/>
-        </p:spPr>
-        <p:txBody>
-          <a:bodyPr wrap="square">
-            <a:spAutoFit/>
-          </a:bodyPr>
-          <a:lstStyle/>
-          <a:p>
-            <a:pPr algn="l">
-              <a:defRPr sz="1100" b="0">
-                <a:solidFill>
-                  <a:srgbClr val="2D2D2D"/>
-                </a:solidFill>
-                <a:latin typeface="Calibri"/>
-              </a:defRPr>
-            </a:pPr>
-            <a:r>
-              <a:t>Censoring pipeline removes all PII, JP codes,</a:t>
-            </a:r>
-            <a:br/>
-            <a:r>
-              <a:t>comp grades, salary data before ML training.</a:t>
-            </a:r>
-            <a:br/>
-            <a:r>
-              <a:t>No personally identifiable information in pipeline.</a:t>
-            </a:r>
-            <a:br/>
-            <a:r>
-              <a:t>Since we do not have current PDs, future training</a:t>
-            </a:r>
-            <a:br/>
-            <a:r>
-              <a:t>data MUST be sanitized before being provided.</a:t>
-            </a:r>
-          </a:p>
-        </p:txBody>
-      </p:sp>
-      <p:sp>
-        <p:nvSpPr>
-          <p:cNvPr id="19" name="Rounded Rectangle 18"/>
-          <p:cNvSpPr/>
-          <p:nvPr/>
-        </p:nvSpPr>
-        <p:spPr>
-          <a:xfrm>
-            <a:off x="8153247" y="3337560"/>
-            <a:ext cx="3474720" cy="2011680"/>
-          </a:xfrm>
-          <a:prstGeom prst="roundRect">
-            <a:avLst>
-              <a:gd name="adj" fmla="val 5000"/>
-            </a:avLst>
-          </a:prstGeom>
-          <a:solidFill>
-            <a:srgbClr val="F5F3EE"/>
-          </a:solidFill>
-          <a:ln w="12700">
-            <a:solidFill>
-              <a:srgbClr val="E0DBD0"/>
-            </a:solidFill>
-          </a:ln>
-        </p:spPr>
-        <p:style>
-          <a:lnRef idx="1">
-            <a:schemeClr val="accent1"/>
-          </a:lnRef>
-          <a:fillRef idx="3">
-            <a:schemeClr val="accent1"/>
-          </a:fillRef>
-          <a:effectRef idx="2">
-            <a:schemeClr val="accent1"/>
-          </a:effectRef>
-          <a:fontRef idx="minor">
-            <a:schemeClr val="lt1"/>
-          </a:fontRef>
-        </p:style>
-        <p:txBody>
-          <a:bodyPr rtlCol="0" anchor="ctr"/>
-          <a:lstStyle/>
-          <a:p>
-            <a:pPr algn="ctr"/>
-          </a:p>
-        </p:txBody>
-      </p:sp>
-      <p:sp>
-        <p:nvSpPr>
-          <p:cNvPr id="20" name="TextBox 19"/>
-          <p:cNvSpPr txBox="1"/>
-          <p:nvPr/>
-        </p:nvSpPr>
-        <p:spPr>
-          <a:xfrm>
-            <a:off x="8336127" y="3474720"/>
-            <a:ext cx="3108960" cy="365760"/>
-          </a:xfrm>
-          <a:prstGeom prst="rect">
-            <a:avLst/>
-          </a:prstGeom>
-          <a:noFill/>
-        </p:spPr>
-        <p:txBody>
-          <a:bodyPr wrap="square">
-            <a:spAutoFit/>
-          </a:bodyPr>
-          <a:lstStyle/>
-          <a:p>
-            <a:pPr algn="l">
-              <a:defRPr sz="1200" b="1">
-                <a:solidFill>
-                  <a:srgbClr val="115740"/>
-                </a:solidFill>
-                <a:latin typeface="Calibri"/>
-              </a:defRPr>
-            </a:pPr>
-            <a:r>
-              <a:t>6. API SECURITY</a:t>
-            </a:r>
-          </a:p>
-        </p:txBody>
-      </p:sp>
-      <p:sp>
-        <p:nvSpPr>
-          <p:cNvPr id="21" name="TextBox 20"/>
-          <p:cNvSpPr txBox="1"/>
-          <p:nvPr/>
-        </p:nvSpPr>
-        <p:spPr>
-          <a:xfrm>
-            <a:off x="8336127" y="3840480"/>
-            <a:ext cx="3108960" cy="1371600"/>
-          </a:xfrm>
-          <a:prstGeom prst="rect">
-            <a:avLst/>
-          </a:prstGeom>
-          <a:noFill/>
-        </p:spPr>
-        <p:txBody>
-          <a:bodyPr wrap="square">
-            <a:spAutoFit/>
-          </a:bodyPr>
-          <a:lstStyle/>
-          <a:p>
-            <a:pPr algn="l">
-              <a:defRPr sz="1100" b="0">
-                <a:solidFill>
-                  <a:srgbClr val="2D2D2D"/>
-                </a:solidFill>
-                <a:latin typeface="Calibri"/>
-              </a:defRPr>
-            </a:pPr>
-            <a:r>
-              <a:t>.env excluded from git via .gitignore.</a:t>
-            </a:r>
-            <a:br/>
-            <a:r>
-              <a:t>Credentials loaded via python-dotenv.</a:t>
-            </a:r>
-            <a:br/>
-            <a:r>
-              <a:t>No API keys hardcoded in source files.</a:t>
-            </a:r>
-          </a:p>
-        </p:txBody>
-      </p:sp>
-      <p:sp>
-        <p:nvSpPr>
-          <p:cNvPr id="22" name="TextBox 21"/>
-          <p:cNvSpPr txBox="1"/>
-          <p:nvPr/>
-        </p:nvSpPr>
-        <p:spPr>
-          <a:xfrm>
-            <a:off x="548640" y="5623560"/>
-            <a:ext cx="11094415" cy="457200"/>
-          </a:xfrm>
-          <a:prstGeom prst="rect">
-            <a:avLst/>
-          </a:prstGeom>
-          <a:noFill/>
-        </p:spPr>
-        <p:txBody>
-          <a:bodyPr wrap="square">
-            <a:spAutoFit/>
-          </a:bodyPr>
-          <a:lstStyle/>
-          <a:p>
-            <a:pPr algn="ctr">
-              <a:defRPr sz="1400" b="1">
-                <a:solidFill>
-                  <a:srgbClr val="C99700"/>
-                </a:solidFill>
-                <a:latin typeface="Calibri"/>
-              </a:defRPr>
-            </a:pPr>
-            <a:r>
-              <a:t>Ethics integrated as engineering decisions — not a separate compliance exercise</a:t>
-            </a:r>
-          </a:p>
-        </p:txBody>
-      </p:sp>
-      <p:sp>
-        <p:nvSpPr>
-          <p:cNvPr id="23" name="TextBox 22"/>
-          <p:cNvSpPr txBox="1"/>
-          <p:nvPr/>
-        </p:nvSpPr>
-        <p:spPr>
-          <a:xfrm>
-            <a:off x="11094415" y="6446520"/>
-            <a:ext cx="914400" cy="274320"/>
-          </a:xfrm>
-          <a:prstGeom prst="rect">
-            <a:avLst/>
-          </a:prstGeom>
-          <a:noFill/>
-        </p:spPr>
-        <p:txBody>
-          <a:bodyPr wrap="square">
-            <a:spAutoFit/>
-          </a:bodyPr>
-          <a:lstStyle/>
-          <a:p>
             <a:pPr algn="r">
               <a:defRPr sz="1000" b="0">
                 <a:solidFill>
@@ -7380,7 +6575,7 @@
               </a:defRPr>
             </a:pPr>
             <a:r>
-              <a:t>14 / 15</a:t>
+              <a:t>14 / 16</a:t>
             </a:r>
           </a:p>
         </p:txBody>
@@ -7442,6 +6637,953 @@
               </a:defRPr>
             </a:pPr>
             <a:r>
+              <a:t>Ethical Reflection</a:t>
+            </a:r>
+          </a:p>
+        </p:txBody>
+      </p:sp>
+      <p:sp>
+        <p:nvSpPr>
+          <p:cNvPr id="3" name="Rectangle 2"/>
+          <p:cNvSpPr/>
+          <p:nvPr/>
+        </p:nvSpPr>
+        <p:spPr>
+          <a:xfrm>
+            <a:off x="548640" y="868680"/>
+            <a:ext cx="2743200" cy="25400"/>
+          </a:xfrm>
+          <a:prstGeom prst="rect">
+            <a:avLst/>
+          </a:prstGeom>
+          <a:solidFill>
+            <a:srgbClr val="C99700"/>
+          </a:solidFill>
+          <a:ln>
+            <a:noFill/>
+          </a:ln>
+        </p:spPr>
+        <p:style>
+          <a:lnRef idx="1">
+            <a:schemeClr val="accent1"/>
+          </a:lnRef>
+          <a:fillRef idx="3">
+            <a:schemeClr val="accent1"/>
+          </a:fillRef>
+          <a:effectRef idx="2">
+            <a:schemeClr val="accent1"/>
+          </a:effectRef>
+          <a:fontRef idx="minor">
+            <a:schemeClr val="lt1"/>
+          </a:fontRef>
+        </p:style>
+        <p:txBody>
+          <a:bodyPr rtlCol="0" anchor="ctr"/>
+          <a:lstStyle/>
+          <a:p>
+            <a:pPr algn="ctr"/>
+          </a:p>
+        </p:txBody>
+      </p:sp>
+      <p:sp>
+        <p:nvSpPr>
+          <p:cNvPr id="4" name="Rounded Rectangle 3"/>
+          <p:cNvSpPr/>
+          <p:nvPr/>
+        </p:nvSpPr>
+        <p:spPr>
+          <a:xfrm>
+            <a:off x="563727" y="1143000"/>
+            <a:ext cx="3474720" cy="2011680"/>
+          </a:xfrm>
+          <a:prstGeom prst="roundRect">
+            <a:avLst>
+              <a:gd name="adj" fmla="val 5000"/>
+            </a:avLst>
+          </a:prstGeom>
+          <a:solidFill>
+            <a:srgbClr val="F5F3EE"/>
+          </a:solidFill>
+          <a:ln w="12700">
+            <a:solidFill>
+              <a:srgbClr val="E0DBD0"/>
+            </a:solidFill>
+          </a:ln>
+        </p:spPr>
+        <p:style>
+          <a:lnRef idx="1">
+            <a:schemeClr val="accent1"/>
+          </a:lnRef>
+          <a:fillRef idx="3">
+            <a:schemeClr val="accent1"/>
+          </a:fillRef>
+          <a:effectRef idx="2">
+            <a:schemeClr val="accent1"/>
+          </a:effectRef>
+          <a:fontRef idx="minor">
+            <a:schemeClr val="lt1"/>
+          </a:fontRef>
+        </p:style>
+        <p:txBody>
+          <a:bodyPr rtlCol="0" anchor="ctr"/>
+          <a:lstStyle/>
+          <a:p>
+            <a:pPr algn="ctr"/>
+          </a:p>
+        </p:txBody>
+      </p:sp>
+      <p:sp>
+        <p:nvSpPr>
+          <p:cNvPr id="5" name="TextBox 4"/>
+          <p:cNvSpPr txBox="1"/>
+          <p:nvPr/>
+        </p:nvSpPr>
+        <p:spPr>
+          <a:xfrm>
+            <a:off x="746607" y="1280160"/>
+            <a:ext cx="3108960" cy="365760"/>
+          </a:xfrm>
+          <a:prstGeom prst="rect">
+            <a:avLst/>
+          </a:prstGeom>
+          <a:noFill/>
+        </p:spPr>
+        <p:txBody>
+          <a:bodyPr wrap="square">
+            <a:spAutoFit/>
+          </a:bodyPr>
+          <a:lstStyle/>
+          <a:p>
+            <a:pPr algn="l">
+              <a:defRPr sz="1200" b="1">
+                <a:solidFill>
+                  <a:srgbClr val="115740"/>
+                </a:solidFill>
+                <a:latin typeface="Calibri"/>
+              </a:defRPr>
+            </a:pPr>
+            <a:r>
+              <a:t>1. PUBLIC DATA ETHICS</a:t>
+            </a:r>
+          </a:p>
+        </p:txBody>
+      </p:sp>
+      <p:sp>
+        <p:nvSpPr>
+          <p:cNvPr id="6" name="TextBox 5"/>
+          <p:cNvSpPr txBox="1"/>
+          <p:nvPr/>
+        </p:nvSpPr>
+        <p:spPr>
+          <a:xfrm>
+            <a:off x="746607" y="1645920"/>
+            <a:ext cx="3108960" cy="1371600"/>
+          </a:xfrm>
+          <a:prstGeom prst="rect">
+            <a:avLst/>
+          </a:prstGeom>
+          <a:noFill/>
+        </p:spPr>
+        <p:txBody>
+          <a:bodyPr wrap="square">
+            <a:spAutoFit/>
+          </a:bodyPr>
+          <a:lstStyle/>
+          <a:p>
+            <a:pPr algn="l">
+              <a:defRPr sz="1100" b="0">
+                <a:solidFill>
+                  <a:srgbClr val="2D2D2D"/>
+                </a:solidFill>
+                <a:latin typeface="Calibri"/>
+              </a:defRPr>
+            </a:pPr>
+            <a:r>
+              <a:t>Rate-limited scraping (1.5s delays) of public</a:t>
+            </a:r>
+            <a:br/>
+            <a:r>
+              <a:t>government DHRM data. Cached locally so each</a:t>
+            </a:r>
+            <a:br/>
+            <a:r>
+              <a:t>URL fetched at most once.</a:t>
+            </a:r>
+          </a:p>
+        </p:txBody>
+      </p:sp>
+      <p:sp>
+        <p:nvSpPr>
+          <p:cNvPr id="7" name="Rounded Rectangle 6"/>
+          <p:cNvSpPr/>
+          <p:nvPr/>
+        </p:nvSpPr>
+        <p:spPr>
+          <a:xfrm>
+            <a:off x="4358487" y="1143000"/>
+            <a:ext cx="3474720" cy="2011680"/>
+          </a:xfrm>
+          <a:prstGeom prst="roundRect">
+            <a:avLst>
+              <a:gd name="adj" fmla="val 5000"/>
+            </a:avLst>
+          </a:prstGeom>
+          <a:solidFill>
+            <a:srgbClr val="F5F3EE"/>
+          </a:solidFill>
+          <a:ln w="12700">
+            <a:solidFill>
+              <a:srgbClr val="E0DBD0"/>
+            </a:solidFill>
+          </a:ln>
+        </p:spPr>
+        <p:style>
+          <a:lnRef idx="1">
+            <a:schemeClr val="accent1"/>
+          </a:lnRef>
+          <a:fillRef idx="3">
+            <a:schemeClr val="accent1"/>
+          </a:fillRef>
+          <a:effectRef idx="2">
+            <a:schemeClr val="accent1"/>
+          </a:effectRef>
+          <a:fontRef idx="minor">
+            <a:schemeClr val="lt1"/>
+          </a:fontRef>
+        </p:style>
+        <p:txBody>
+          <a:bodyPr rtlCol="0" anchor="ctr"/>
+          <a:lstStyle/>
+          <a:p>
+            <a:pPr algn="ctr"/>
+          </a:p>
+        </p:txBody>
+      </p:sp>
+      <p:sp>
+        <p:nvSpPr>
+          <p:cNvPr id="8" name="TextBox 7"/>
+          <p:cNvSpPr txBox="1"/>
+          <p:nvPr/>
+        </p:nvSpPr>
+        <p:spPr>
+          <a:xfrm>
+            <a:off x="4541367" y="1280160"/>
+            <a:ext cx="3108960" cy="365760"/>
+          </a:xfrm>
+          <a:prstGeom prst="rect">
+            <a:avLst/>
+          </a:prstGeom>
+          <a:noFill/>
+        </p:spPr>
+        <p:txBody>
+          <a:bodyPr wrap="square">
+            <a:spAutoFit/>
+          </a:bodyPr>
+          <a:lstStyle/>
+          <a:p>
+            <a:pPr algn="l">
+              <a:defRPr sz="1200" b="1">
+                <a:solidFill>
+                  <a:srgbClr val="C99700"/>
+                </a:solidFill>
+                <a:latin typeface="Calibri"/>
+              </a:defRPr>
+            </a:pPr>
+            <a:r>
+              <a:t>2. CLASSIFICATION BIAS</a:t>
+            </a:r>
+          </a:p>
+        </p:txBody>
+      </p:sp>
+      <p:sp>
+        <p:nvSpPr>
+          <p:cNvPr id="9" name="TextBox 8"/>
+          <p:cNvSpPr txBox="1"/>
+          <p:nvPr/>
+        </p:nvSpPr>
+        <p:spPr>
+          <a:xfrm>
+            <a:off x="4541367" y="1645920"/>
+            <a:ext cx="3108960" cy="1371600"/>
+          </a:xfrm>
+          <a:prstGeom prst="rect">
+            <a:avLst/>
+          </a:prstGeom>
+          <a:noFill/>
+        </p:spPr>
+        <p:txBody>
+          <a:bodyPr wrap="square">
+            <a:spAutoFit/>
+          </a:bodyPr>
+          <a:lstStyle/>
+          <a:p>
+            <a:pPr algn="l">
+              <a:defRPr sz="1100" b="0">
+                <a:solidFill>
+                  <a:srgbClr val="2D2D2D"/>
+                </a:solidFill>
+                <a:latin typeface="Calibri"/>
+              </a:defRPr>
+            </a:pPr>
+            <a:r>
+              <a:t>103 PDs with heavy class imbalance acknowledged.</a:t>
+            </a:r>
+            <a:br/>
+            <a:r>
+              <a:t>Stratified CV preserves proportions.</a:t>
+            </a:r>
+            <a:br/>
+            <a:r>
+              <a:t>Model framed as advisory, not deterministic.</a:t>
+            </a:r>
+          </a:p>
+        </p:txBody>
+      </p:sp>
+      <p:sp>
+        <p:nvSpPr>
+          <p:cNvPr id="10" name="Rounded Rectangle 9"/>
+          <p:cNvSpPr/>
+          <p:nvPr/>
+        </p:nvSpPr>
+        <p:spPr>
+          <a:xfrm>
+            <a:off x="8153247" y="1143000"/>
+            <a:ext cx="3474720" cy="2011680"/>
+          </a:xfrm>
+          <a:prstGeom prst="roundRect">
+            <a:avLst>
+              <a:gd name="adj" fmla="val 5000"/>
+            </a:avLst>
+          </a:prstGeom>
+          <a:solidFill>
+            <a:srgbClr val="F5F3EE"/>
+          </a:solidFill>
+          <a:ln w="12700">
+            <a:solidFill>
+              <a:srgbClr val="E0DBD0"/>
+            </a:solidFill>
+          </a:ln>
+        </p:spPr>
+        <p:style>
+          <a:lnRef idx="1">
+            <a:schemeClr val="accent1"/>
+          </a:lnRef>
+          <a:fillRef idx="3">
+            <a:schemeClr val="accent1"/>
+          </a:fillRef>
+          <a:effectRef idx="2">
+            <a:schemeClr val="accent1"/>
+          </a:effectRef>
+          <a:fontRef idx="minor">
+            <a:schemeClr val="lt1"/>
+          </a:fontRef>
+        </p:style>
+        <p:txBody>
+          <a:bodyPr rtlCol="0" anchor="ctr"/>
+          <a:lstStyle/>
+          <a:p>
+            <a:pPr algn="ctr"/>
+          </a:p>
+        </p:txBody>
+      </p:sp>
+      <p:sp>
+        <p:nvSpPr>
+          <p:cNvPr id="11" name="TextBox 10"/>
+          <p:cNvSpPr txBox="1"/>
+          <p:nvPr/>
+        </p:nvSpPr>
+        <p:spPr>
+          <a:xfrm>
+            <a:off x="8336127" y="1280160"/>
+            <a:ext cx="3108960" cy="365760"/>
+          </a:xfrm>
+          <a:prstGeom prst="rect">
+            <a:avLst/>
+          </a:prstGeom>
+          <a:noFill/>
+        </p:spPr>
+        <p:txBody>
+          <a:bodyPr wrap="square">
+            <a:spAutoFit/>
+          </a:bodyPr>
+          <a:lstStyle/>
+          <a:p>
+            <a:pPr algn="l">
+              <a:defRPr sz="1200" b="1">
+                <a:solidFill>
+                  <a:srgbClr val="115740"/>
+                </a:solidFill>
+                <a:latin typeface="Calibri"/>
+              </a:defRPr>
+            </a:pPr>
+            <a:r>
+              <a:t>3. HUMAN-IN-THE-LOOP</a:t>
+            </a:r>
+          </a:p>
+        </p:txBody>
+      </p:sp>
+      <p:sp>
+        <p:nvSpPr>
+          <p:cNvPr id="12" name="TextBox 11"/>
+          <p:cNvSpPr txBox="1"/>
+          <p:nvPr/>
+        </p:nvSpPr>
+        <p:spPr>
+          <a:xfrm>
+            <a:off x="8336127" y="1645920"/>
+            <a:ext cx="3108960" cy="1371600"/>
+          </a:xfrm>
+          <a:prstGeom prst="rect">
+            <a:avLst/>
+          </a:prstGeom>
+          <a:noFill/>
+        </p:spPr>
+        <p:txBody>
+          <a:bodyPr wrap="square">
+            <a:spAutoFit/>
+          </a:bodyPr>
+          <a:lstStyle/>
+          <a:p>
+            <a:pPr algn="l">
+              <a:defRPr sz="1100" b="0">
+                <a:solidFill>
+                  <a:srgbClr val="2D2D2D"/>
+                </a:solidFill>
+                <a:latin typeface="Calibri"/>
+              </a:defRPr>
+            </a:pPr>
+            <a:r>
+              <a:t>AI recommends, HR decides. Never auto-submits.</a:t>
+            </a:r>
+            <a:br/>
+            <a:r>
+              <a:t>Confidence scores + reasoning narratives</a:t>
+            </a:r>
+            <a:br/>
+            <a:r>
+              <a:t>enable informed professional judgment.</a:t>
+            </a:r>
+          </a:p>
+        </p:txBody>
+      </p:sp>
+      <p:sp>
+        <p:nvSpPr>
+          <p:cNvPr id="13" name="Rounded Rectangle 12"/>
+          <p:cNvSpPr/>
+          <p:nvPr/>
+        </p:nvSpPr>
+        <p:spPr>
+          <a:xfrm>
+            <a:off x="563727" y="3337560"/>
+            <a:ext cx="3474720" cy="2011680"/>
+          </a:xfrm>
+          <a:prstGeom prst="roundRect">
+            <a:avLst>
+              <a:gd name="adj" fmla="val 5000"/>
+            </a:avLst>
+          </a:prstGeom>
+          <a:solidFill>
+            <a:srgbClr val="F5F3EE"/>
+          </a:solidFill>
+          <a:ln w="12700">
+            <a:solidFill>
+              <a:srgbClr val="E0DBD0"/>
+            </a:solidFill>
+          </a:ln>
+        </p:spPr>
+        <p:style>
+          <a:lnRef idx="1">
+            <a:schemeClr val="accent1"/>
+          </a:lnRef>
+          <a:fillRef idx="3">
+            <a:schemeClr val="accent1"/>
+          </a:fillRef>
+          <a:effectRef idx="2">
+            <a:schemeClr val="accent1"/>
+          </a:effectRef>
+          <a:fontRef idx="minor">
+            <a:schemeClr val="lt1"/>
+          </a:fontRef>
+        </p:style>
+        <p:txBody>
+          <a:bodyPr rtlCol="0" anchor="ctr"/>
+          <a:lstStyle/>
+          <a:p>
+            <a:pPr algn="ctr"/>
+          </a:p>
+        </p:txBody>
+      </p:sp>
+      <p:sp>
+        <p:nvSpPr>
+          <p:cNvPr id="14" name="TextBox 13"/>
+          <p:cNvSpPr txBox="1"/>
+          <p:nvPr/>
+        </p:nvSpPr>
+        <p:spPr>
+          <a:xfrm>
+            <a:off x="746607" y="3474720"/>
+            <a:ext cx="3108960" cy="365760"/>
+          </a:xfrm>
+          <a:prstGeom prst="rect">
+            <a:avLst/>
+          </a:prstGeom>
+          <a:noFill/>
+        </p:spPr>
+        <p:txBody>
+          <a:bodyPr wrap="square">
+            <a:spAutoFit/>
+          </a:bodyPr>
+          <a:lstStyle/>
+          <a:p>
+            <a:pPr algn="l">
+              <a:defRPr sz="1200" b="1">
+                <a:solidFill>
+                  <a:srgbClr val="1A7A5A"/>
+                </a:solidFill>
+                <a:latin typeface="Calibri"/>
+              </a:defRPr>
+            </a:pPr>
+            <a:r>
+              <a:t>4. LLM TRANSPARENCY</a:t>
+            </a:r>
+          </a:p>
+        </p:txBody>
+      </p:sp>
+      <p:sp>
+        <p:nvSpPr>
+          <p:cNvPr id="15" name="TextBox 14"/>
+          <p:cNvSpPr txBox="1"/>
+          <p:nvPr/>
+        </p:nvSpPr>
+        <p:spPr>
+          <a:xfrm>
+            <a:off x="746607" y="3840480"/>
+            <a:ext cx="3108960" cy="1371600"/>
+          </a:xfrm>
+          <a:prstGeom prst="rect">
+            <a:avLst/>
+          </a:prstGeom>
+          <a:noFill/>
+        </p:spPr>
+        <p:txBody>
+          <a:bodyPr wrap="square">
+            <a:spAutoFit/>
+          </a:bodyPr>
+          <a:lstStyle/>
+          <a:p>
+            <a:pPr algn="l">
+              <a:defRPr sz="1100" b="0">
+                <a:solidFill>
+                  <a:srgbClr val="2D2D2D"/>
+                </a:solidFill>
+                <a:latin typeface="Calibri"/>
+              </a:defRPr>
+            </a:pPr>
+            <a:r>
+              <a:t>Step-by-step reasoning narratives, not black-box.</a:t>
+            </a:r>
+            <a:br/>
+            <a:r>
+              <a:t>Auditable 8-component agent pipeline.</a:t>
+            </a:r>
+            <a:br/>
+            <a:r>
+              <a:t>Every classification is explainable.</a:t>
+            </a:r>
+          </a:p>
+        </p:txBody>
+      </p:sp>
+      <p:sp>
+        <p:nvSpPr>
+          <p:cNvPr id="16" name="Rounded Rectangle 15"/>
+          <p:cNvSpPr/>
+          <p:nvPr/>
+        </p:nvSpPr>
+        <p:spPr>
+          <a:xfrm>
+            <a:off x="4358487" y="3337560"/>
+            <a:ext cx="3474720" cy="2011680"/>
+          </a:xfrm>
+          <a:prstGeom prst="roundRect">
+            <a:avLst>
+              <a:gd name="adj" fmla="val 5000"/>
+            </a:avLst>
+          </a:prstGeom>
+          <a:solidFill>
+            <a:srgbClr val="F5F3EE"/>
+          </a:solidFill>
+          <a:ln w="12700">
+            <a:solidFill>
+              <a:srgbClr val="E0DBD0"/>
+            </a:solidFill>
+          </a:ln>
+        </p:spPr>
+        <p:style>
+          <a:lnRef idx="1">
+            <a:schemeClr val="accent1"/>
+          </a:lnRef>
+          <a:fillRef idx="3">
+            <a:schemeClr val="accent1"/>
+          </a:fillRef>
+          <a:effectRef idx="2">
+            <a:schemeClr val="accent1"/>
+          </a:effectRef>
+          <a:fontRef idx="minor">
+            <a:schemeClr val="lt1"/>
+          </a:fontRef>
+        </p:style>
+        <p:txBody>
+          <a:bodyPr rtlCol="0" anchor="ctr"/>
+          <a:lstStyle/>
+          <a:p>
+            <a:pPr algn="ctr"/>
+          </a:p>
+        </p:txBody>
+      </p:sp>
+      <p:sp>
+        <p:nvSpPr>
+          <p:cNvPr id="17" name="TextBox 16"/>
+          <p:cNvSpPr txBox="1"/>
+          <p:nvPr/>
+        </p:nvSpPr>
+        <p:spPr>
+          <a:xfrm>
+            <a:off x="4541367" y="3474720"/>
+            <a:ext cx="3108960" cy="365760"/>
+          </a:xfrm>
+          <a:prstGeom prst="rect">
+            <a:avLst/>
+          </a:prstGeom>
+          <a:noFill/>
+        </p:spPr>
+        <p:txBody>
+          <a:bodyPr wrap="square">
+            <a:spAutoFit/>
+          </a:bodyPr>
+          <a:lstStyle/>
+          <a:p>
+            <a:pPr algn="l">
+              <a:defRPr sz="1200" b="1">
+                <a:solidFill>
+                  <a:srgbClr val="C99700"/>
+                </a:solidFill>
+                <a:latin typeface="Calibri"/>
+              </a:defRPr>
+            </a:pPr>
+            <a:r>
+              <a:t>5. DATA PRIVACY</a:t>
+            </a:r>
+          </a:p>
+        </p:txBody>
+      </p:sp>
+      <p:sp>
+        <p:nvSpPr>
+          <p:cNvPr id="18" name="TextBox 17"/>
+          <p:cNvSpPr txBox="1"/>
+          <p:nvPr/>
+        </p:nvSpPr>
+        <p:spPr>
+          <a:xfrm>
+            <a:off x="4541367" y="3840480"/>
+            <a:ext cx="3108960" cy="1371600"/>
+          </a:xfrm>
+          <a:prstGeom prst="rect">
+            <a:avLst/>
+          </a:prstGeom>
+          <a:noFill/>
+        </p:spPr>
+        <p:txBody>
+          <a:bodyPr wrap="square">
+            <a:spAutoFit/>
+          </a:bodyPr>
+          <a:lstStyle/>
+          <a:p>
+            <a:pPr algn="l">
+              <a:defRPr sz="1100" b="0">
+                <a:solidFill>
+                  <a:srgbClr val="2D2D2D"/>
+                </a:solidFill>
+                <a:latin typeface="Calibri"/>
+              </a:defRPr>
+            </a:pPr>
+            <a:r>
+              <a:t>Censoring pipeline removes all PII, JP codes,</a:t>
+            </a:r>
+            <a:br/>
+            <a:r>
+              <a:t>comp grades, salary data before ML training.</a:t>
+            </a:r>
+            <a:br/>
+            <a:r>
+              <a:t>No personally identifiable information in pipeline.</a:t>
+            </a:r>
+            <a:br/>
+            <a:r>
+              <a:t>Since we do not have current PDs, future training</a:t>
+            </a:r>
+            <a:br/>
+            <a:r>
+              <a:t>data MUST be sanitized before being provided.</a:t>
+            </a:r>
+          </a:p>
+        </p:txBody>
+      </p:sp>
+      <p:sp>
+        <p:nvSpPr>
+          <p:cNvPr id="19" name="Rounded Rectangle 18"/>
+          <p:cNvSpPr/>
+          <p:nvPr/>
+        </p:nvSpPr>
+        <p:spPr>
+          <a:xfrm>
+            <a:off x="8153247" y="3337560"/>
+            <a:ext cx="3474720" cy="2011680"/>
+          </a:xfrm>
+          <a:prstGeom prst="roundRect">
+            <a:avLst>
+              <a:gd name="adj" fmla="val 5000"/>
+            </a:avLst>
+          </a:prstGeom>
+          <a:solidFill>
+            <a:srgbClr val="F5F3EE"/>
+          </a:solidFill>
+          <a:ln w="12700">
+            <a:solidFill>
+              <a:srgbClr val="E0DBD0"/>
+            </a:solidFill>
+          </a:ln>
+        </p:spPr>
+        <p:style>
+          <a:lnRef idx="1">
+            <a:schemeClr val="accent1"/>
+          </a:lnRef>
+          <a:fillRef idx="3">
+            <a:schemeClr val="accent1"/>
+          </a:fillRef>
+          <a:effectRef idx="2">
+            <a:schemeClr val="accent1"/>
+          </a:effectRef>
+          <a:fontRef idx="minor">
+            <a:schemeClr val="lt1"/>
+          </a:fontRef>
+        </p:style>
+        <p:txBody>
+          <a:bodyPr rtlCol="0" anchor="ctr"/>
+          <a:lstStyle/>
+          <a:p>
+            <a:pPr algn="ctr"/>
+          </a:p>
+        </p:txBody>
+      </p:sp>
+      <p:sp>
+        <p:nvSpPr>
+          <p:cNvPr id="20" name="TextBox 19"/>
+          <p:cNvSpPr txBox="1"/>
+          <p:nvPr/>
+        </p:nvSpPr>
+        <p:spPr>
+          <a:xfrm>
+            <a:off x="8336127" y="3474720"/>
+            <a:ext cx="3108960" cy="365760"/>
+          </a:xfrm>
+          <a:prstGeom prst="rect">
+            <a:avLst/>
+          </a:prstGeom>
+          <a:noFill/>
+        </p:spPr>
+        <p:txBody>
+          <a:bodyPr wrap="square">
+            <a:spAutoFit/>
+          </a:bodyPr>
+          <a:lstStyle/>
+          <a:p>
+            <a:pPr algn="l">
+              <a:defRPr sz="1200" b="1">
+                <a:solidFill>
+                  <a:srgbClr val="115740"/>
+                </a:solidFill>
+                <a:latin typeface="Calibri"/>
+              </a:defRPr>
+            </a:pPr>
+            <a:r>
+              <a:t>6. API SECURITY</a:t>
+            </a:r>
+          </a:p>
+        </p:txBody>
+      </p:sp>
+      <p:sp>
+        <p:nvSpPr>
+          <p:cNvPr id="21" name="TextBox 20"/>
+          <p:cNvSpPr txBox="1"/>
+          <p:nvPr/>
+        </p:nvSpPr>
+        <p:spPr>
+          <a:xfrm>
+            <a:off x="8336127" y="3840480"/>
+            <a:ext cx="3108960" cy="1371600"/>
+          </a:xfrm>
+          <a:prstGeom prst="rect">
+            <a:avLst/>
+          </a:prstGeom>
+          <a:noFill/>
+        </p:spPr>
+        <p:txBody>
+          <a:bodyPr wrap="square">
+            <a:spAutoFit/>
+          </a:bodyPr>
+          <a:lstStyle/>
+          <a:p>
+            <a:pPr algn="l">
+              <a:defRPr sz="1100" b="0">
+                <a:solidFill>
+                  <a:srgbClr val="2D2D2D"/>
+                </a:solidFill>
+                <a:latin typeface="Calibri"/>
+              </a:defRPr>
+            </a:pPr>
+            <a:r>
+              <a:t>.env excluded from git via .gitignore.</a:t>
+            </a:r>
+            <a:br/>
+            <a:r>
+              <a:t>Credentials loaded via python-dotenv.</a:t>
+            </a:r>
+            <a:br/>
+            <a:r>
+              <a:t>No API keys hardcoded in source files.</a:t>
+            </a:r>
+          </a:p>
+        </p:txBody>
+      </p:sp>
+      <p:sp>
+        <p:nvSpPr>
+          <p:cNvPr id="22" name="TextBox 21"/>
+          <p:cNvSpPr txBox="1"/>
+          <p:nvPr/>
+        </p:nvSpPr>
+        <p:spPr>
+          <a:xfrm>
+            <a:off x="548640" y="5623560"/>
+            <a:ext cx="11094415" cy="457200"/>
+          </a:xfrm>
+          <a:prstGeom prst="rect">
+            <a:avLst/>
+          </a:prstGeom>
+          <a:noFill/>
+        </p:spPr>
+        <p:txBody>
+          <a:bodyPr wrap="square">
+            <a:spAutoFit/>
+          </a:bodyPr>
+          <a:lstStyle/>
+          <a:p>
+            <a:pPr algn="ctr">
+              <a:defRPr sz="1400" b="1">
+                <a:solidFill>
+                  <a:srgbClr val="C99700"/>
+                </a:solidFill>
+                <a:latin typeface="Calibri"/>
+              </a:defRPr>
+            </a:pPr>
+            <a:r>
+              <a:t>Ethics integrated as engineering decisions — not a separate compliance exercise</a:t>
+            </a:r>
+          </a:p>
+        </p:txBody>
+      </p:sp>
+      <p:sp>
+        <p:nvSpPr>
+          <p:cNvPr id="23" name="TextBox 22"/>
+          <p:cNvSpPr txBox="1"/>
+          <p:nvPr/>
+        </p:nvSpPr>
+        <p:spPr>
+          <a:xfrm>
+            <a:off x="11094415" y="6446520"/>
+            <a:ext cx="914400" cy="274320"/>
+          </a:xfrm>
+          <a:prstGeom prst="rect">
+            <a:avLst/>
+          </a:prstGeom>
+          <a:noFill/>
+        </p:spPr>
+        <p:txBody>
+          <a:bodyPr wrap="square">
+            <a:spAutoFit/>
+          </a:bodyPr>
+          <a:lstStyle/>
+          <a:p>
+            <a:pPr algn="r">
+              <a:defRPr sz="1000" b="0">
+                <a:solidFill>
+                  <a:srgbClr val="5A5A5A"/>
+                </a:solidFill>
+                <a:latin typeface="Calibri"/>
+              </a:defRPr>
+            </a:pPr>
+            <a:r>
+              <a:t>15 / 16</a:t>
+            </a:r>
+          </a:p>
+        </p:txBody>
+      </p:sp>
+    </p:spTree>
+  </p:cSld>
+  <p:clrMapOvr>
+    <a:masterClrMapping/>
+  </p:clrMapOvr>
+</p:sld>
+</file>
+
+<file path=ppt/slides/slide16.xml><?xml version="1.0" encoding="utf-8"?>
+<p:sld xmlns:a="http://schemas.openxmlformats.org/drawingml/2006/main" xmlns:p="http://schemas.openxmlformats.org/presentationml/2006/main" xmlns:r="http://schemas.openxmlformats.org/officeDocument/2006/relationships">
+  <p:cSld>
+    <p:bg>
+      <p:bgPr>
+        <a:solidFill>
+          <a:srgbClr val="FFFFFF"/>
+        </a:solidFill>
+        <a:effectLst/>
+      </p:bgPr>
+    </p:bg>
+    <p:spTree>
+      <p:nvGrpSpPr>
+        <p:cNvPr id="1" name=""/>
+        <p:cNvGrpSpPr/>
+        <p:nvPr/>
+      </p:nvGrpSpPr>
+      <p:grpSpPr/>
+      <p:sp>
+        <p:nvSpPr>
+          <p:cNvPr id="2" name="TextBox 1"/>
+          <p:cNvSpPr txBox="1"/>
+          <p:nvPr/>
+        </p:nvSpPr>
+        <p:spPr>
+          <a:xfrm>
+            <a:off x="548640" y="274320"/>
+            <a:ext cx="11094415" cy="640080"/>
+          </a:xfrm>
+          <a:prstGeom prst="rect">
+            <a:avLst/>
+          </a:prstGeom>
+          <a:noFill/>
+        </p:spPr>
+        <p:txBody>
+          <a:bodyPr wrap="square">
+            <a:spAutoFit/>
+          </a:bodyPr>
+          <a:lstStyle/>
+          <a:p>
+            <a:pPr algn="l">
+              <a:defRPr sz="3200" b="1">
+                <a:solidFill>
+                  <a:srgbClr val="115740"/>
+                </a:solidFill>
+                <a:latin typeface="Calibri"/>
+              </a:defRPr>
+            </a:pPr>
+            <a:r>
               <a:t>Next Steps</a:t>
             </a:r>
           </a:p>
@@ -8471,8 +8613,8 @@
         </p:nvSpPr>
         <p:spPr>
           <a:xfrm>
-            <a:off x="11094415" y="6446520"/>
-            <a:ext cx="914400" cy="274320"/>
+            <a:off x="548640" y="6263640"/>
+            <a:ext cx="11094415" cy="274320"/>
           </a:xfrm>
           <a:prstGeom prst="rect">
             <a:avLst/>
@@ -8485,6 +8627,42 @@
           </a:bodyPr>
           <a:lstStyle/>
           <a:p>
+            <a:pPr algn="ctr">
+              <a:defRPr sz="900" b="0">
+                <a:solidFill>
+                  <a:srgbClr val="999999"/>
+                </a:solidFill>
+                <a:latin typeface="Calibri"/>
+              </a:defRPr>
+            </a:pPr>
+            <a:r>
+              <a:t>Salary data: CareerOneStop, U.S. DOL/ETA (careeronestop.org)</a:t>
+            </a:r>
+          </a:p>
+        </p:txBody>
+      </p:sp>
+      <p:sp>
+        <p:nvSpPr>
+          <p:cNvPr id="17" name="TextBox 16"/>
+          <p:cNvSpPr txBox="1"/>
+          <p:nvPr/>
+        </p:nvSpPr>
+        <p:spPr>
+          <a:xfrm>
+            <a:off x="11094415" y="6446520"/>
+            <a:ext cx="914400" cy="274320"/>
+          </a:xfrm>
+          <a:prstGeom prst="rect">
+            <a:avLst/>
+          </a:prstGeom>
+          <a:noFill/>
+        </p:spPr>
+        <p:txBody>
+          <a:bodyPr wrap="square">
+            <a:spAutoFit/>
+          </a:bodyPr>
+          <a:lstStyle/>
+          <a:p>
             <a:pPr algn="r">
               <a:defRPr sz="1000" b="0">
                 <a:solidFill>
@@ -8494,7 +8672,7 @@
               </a:defRPr>
             </a:pPr>
             <a:r>
-              <a:t>15 / 15</a:t>
+              <a:t>16 / 16</a:t>
             </a:r>
           </a:p>
         </p:txBody>
@@ -9298,7 +9476,7 @@
               </a:defRPr>
             </a:pPr>
             <a:r>
-              <a:t>2 / 15</a:t>
+              <a:t>2 / 16</a:t>
             </a:r>
           </a:p>
         </p:txBody>
@@ -10538,7 +10716,7 @@
               </a:defRPr>
             </a:pPr>
             <a:r>
-              <a:t>3 / 15</a:t>
+              <a:t>3 / 16</a:t>
             </a:r>
           </a:p>
         </p:txBody>
@@ -12391,7 +12569,7 @@
               </a:defRPr>
             </a:pPr>
             <a:r>
-              <a:t>4 / 15</a:t>
+              <a:t>4 / 16</a:t>
             </a:r>
           </a:p>
         </p:txBody>
@@ -13341,7 +13519,7 @@
               </a:defRPr>
             </a:pPr>
             <a:r>
-              <a:t>5 / 15</a:t>
+              <a:t>5 / 16</a:t>
             </a:r>
           </a:p>
         </p:txBody>
@@ -14107,7 +14285,7 @@
               </a:defRPr>
             </a:pPr>
             <a:r>
-              <a:t>6 / 15</a:t>
+              <a:t>6 / 16</a:t>
             </a:r>
           </a:p>
         </p:txBody>
@@ -15319,7 +15497,7 @@
               </a:defRPr>
             </a:pPr>
             <a:r>
-              <a:t>7 / 15</a:t>
+              <a:t>7 / 16</a:t>
             </a:r>
           </a:p>
         </p:txBody>
@@ -15740,7 +15918,7 @@
               </a:defRPr>
             </a:pPr>
             <a:r>
-              <a:t>8 / 15</a:t>
+              <a:t>8 / 16</a:t>
             </a:r>
           </a:p>
         </p:txBody>
@@ -16233,7 +16411,7 @@
               </a:defRPr>
             </a:pPr>
             <a:r>
-              <a:t>9 / 15</a:t>
+              <a:t>9 / 16</a:t>
             </a:r>
           </a:p>
         </p:txBody>

</xml_diff>

<commit_message>
Add dedicated References & Data Sources slide (slide 17)
Clean DOL attribution off slide 16 footer, consolidated all references
and required attributions into dedicated final slide.

Co-Authored-By: Claude Opus 4.6 (1M context) <noreply@anthropic.com>
</commit_message>
<xml_diff>
--- a/ppt/GRIFFIN_BigData_Presentation.pptx
+++ b/ppt/GRIFFIN_BigData_Presentation.pptx
@@ -21,6 +21,7 @@
     <p:sldId id="269" r:id="rId20"/>
     <p:sldId id="270" r:id="rId21"/>
     <p:sldId id="271" r:id="rId22"/>
+    <p:sldId id="272" r:id="rId23"/>
   </p:sldIdLst>
   <p:sldSz cx="12191695" cy="6858000" type="screen4x3"/>
   <p:notesSz cx="6858000" cy="9144000"/>
@@ -3440,7 +3441,7 @@
               </a:defRPr>
             </a:pPr>
             <a:r>
-              <a:t>1 / 16</a:t>
+              <a:t>1 / 17</a:t>
             </a:r>
           </a:p>
         </p:txBody>
@@ -4615,7 +4616,7 @@
               </a:defRPr>
             </a:pPr>
             <a:r>
-              <a:t>10 / 16</a:t>
+              <a:t>10 / 17</a:t>
             </a:r>
           </a:p>
         </p:txBody>
@@ -5510,7 +5511,7 @@
               </a:defRPr>
             </a:pPr>
             <a:r>
-              <a:t>11 / 16</a:t>
+              <a:t>11 / 17</a:t>
             </a:r>
           </a:p>
         </p:txBody>
@@ -5865,7 +5866,7 @@
               </a:defRPr>
             </a:pPr>
             <a:r>
-              <a:t>12 / 16</a:t>
+              <a:t>12 / 17</a:t>
             </a:r>
           </a:p>
         </p:txBody>
@@ -6220,7 +6221,7 @@
               </a:defRPr>
             </a:pPr>
             <a:r>
-              <a:t>13 / 16</a:t>
+              <a:t>13 / 17</a:t>
             </a:r>
           </a:p>
         </p:txBody>
@@ -6575,7 +6576,7 @@
               </a:defRPr>
             </a:pPr>
             <a:r>
-              <a:t>14 / 16</a:t>
+              <a:t>14 / 17</a:t>
             </a:r>
           </a:p>
         </p:txBody>
@@ -7522,7 +7523,7 @@
               </a:defRPr>
             </a:pPr>
             <a:r>
-              <a:t>15 / 16</a:t>
+              <a:t>15 / 17</a:t>
             </a:r>
           </a:p>
         </p:txBody>
@@ -8613,8 +8614,8 @@
         </p:nvSpPr>
         <p:spPr>
           <a:xfrm>
-            <a:off x="548640" y="6263640"/>
-            <a:ext cx="11094415" cy="274320"/>
+            <a:off x="11094415" y="6446520"/>
+            <a:ext cx="914400" cy="274320"/>
           </a:xfrm>
           <a:prstGeom prst="rect">
             <a:avLst/>
@@ -8627,30 +8628,56 @@
           </a:bodyPr>
           <a:lstStyle/>
           <a:p>
-            <a:pPr algn="ctr">
-              <a:defRPr sz="900" b="0">
-                <a:solidFill>
-                  <a:srgbClr val="999999"/>
-                </a:solidFill>
-                <a:latin typeface="Calibri"/>
-              </a:defRPr>
-            </a:pPr>
-            <a:r>
-              <a:t>Salary data: CareerOneStop, U.S. DOL/ETA (careeronestop.org)</a:t>
-            </a:r>
-          </a:p>
-        </p:txBody>
-      </p:sp>
-      <p:sp>
-        <p:nvSpPr>
-          <p:cNvPr id="17" name="TextBox 16"/>
+            <a:pPr algn="r">
+              <a:defRPr sz="1000" b="0">
+                <a:solidFill>
+                  <a:srgbClr val="5A5A5A"/>
+                </a:solidFill>
+                <a:latin typeface="Calibri"/>
+              </a:defRPr>
+            </a:pPr>
+            <a:r>
+              <a:t>16 / 17</a:t>
+            </a:r>
+          </a:p>
+        </p:txBody>
+      </p:sp>
+    </p:spTree>
+  </p:cSld>
+  <p:clrMapOvr>
+    <a:masterClrMapping/>
+  </p:clrMapOvr>
+</p:sld>
+</file>
+
+<file path=ppt/slides/slide17.xml><?xml version="1.0" encoding="utf-8"?>
+<p:sld xmlns:a="http://schemas.openxmlformats.org/drawingml/2006/main" xmlns:p="http://schemas.openxmlformats.org/presentationml/2006/main" xmlns:r="http://schemas.openxmlformats.org/officeDocument/2006/relationships">
+  <p:cSld>
+    <p:bg>
+      <p:bgPr>
+        <a:solidFill>
+          <a:srgbClr val="FFFFFF"/>
+        </a:solidFill>
+        <a:effectLst/>
+      </p:bgPr>
+    </p:bg>
+    <p:spTree>
+      <p:nvGrpSpPr>
+        <p:cNvPr id="1" name=""/>
+        <p:cNvGrpSpPr/>
+        <p:nvPr/>
+      </p:nvGrpSpPr>
+      <p:grpSpPr/>
+      <p:sp>
+        <p:nvSpPr>
+          <p:cNvPr id="2" name="TextBox 1"/>
           <p:cNvSpPr txBox="1"/>
           <p:nvPr/>
         </p:nvSpPr>
         <p:spPr>
           <a:xfrm>
-            <a:off x="11094415" y="6446520"/>
-            <a:ext cx="914400" cy="274320"/>
+            <a:off x="548640" y="274320"/>
+            <a:ext cx="11094415" cy="640080"/>
           </a:xfrm>
           <a:prstGeom prst="rect">
             <a:avLst/>
@@ -8663,6 +8690,845 @@
           </a:bodyPr>
           <a:lstStyle/>
           <a:p>
+            <a:pPr algn="l">
+              <a:defRPr sz="3200" b="1">
+                <a:solidFill>
+                  <a:srgbClr val="115740"/>
+                </a:solidFill>
+                <a:latin typeface="Calibri"/>
+              </a:defRPr>
+            </a:pPr>
+            <a:r>
+              <a:t>References &amp; Data Sources</a:t>
+            </a:r>
+          </a:p>
+        </p:txBody>
+      </p:sp>
+      <p:sp>
+        <p:nvSpPr>
+          <p:cNvPr id="3" name="Rectangle 2"/>
+          <p:cNvSpPr/>
+          <p:nvPr/>
+        </p:nvSpPr>
+        <p:spPr>
+          <a:xfrm>
+            <a:off x="548640" y="868680"/>
+            <a:ext cx="4114800" cy="25400"/>
+          </a:xfrm>
+          <a:prstGeom prst="rect">
+            <a:avLst/>
+          </a:prstGeom>
+          <a:solidFill>
+            <a:srgbClr val="C99700"/>
+          </a:solidFill>
+          <a:ln>
+            <a:noFill/>
+          </a:ln>
+        </p:spPr>
+        <p:style>
+          <a:lnRef idx="1">
+            <a:schemeClr val="accent1"/>
+          </a:lnRef>
+          <a:fillRef idx="3">
+            <a:schemeClr val="accent1"/>
+          </a:fillRef>
+          <a:effectRef idx="2">
+            <a:schemeClr val="accent1"/>
+          </a:effectRef>
+          <a:fontRef idx="minor">
+            <a:schemeClr val="lt1"/>
+          </a:fontRef>
+        </p:style>
+        <p:txBody>
+          <a:bodyPr rtlCol="0" anchor="ctr"/>
+          <a:lstStyle/>
+          <a:p>
+            <a:pPr algn="ctr"/>
+          </a:p>
+        </p:txBody>
+      </p:sp>
+      <p:sp>
+        <p:nvSpPr>
+          <p:cNvPr id="4" name="Rounded Rectangle 3"/>
+          <p:cNvSpPr/>
+          <p:nvPr/>
+        </p:nvSpPr>
+        <p:spPr>
+          <a:xfrm>
+            <a:off x="731520" y="1188720"/>
+            <a:ext cx="5303520" cy="2194560"/>
+          </a:xfrm>
+          <a:prstGeom prst="roundRect">
+            <a:avLst>
+              <a:gd name="adj" fmla="val 5000"/>
+            </a:avLst>
+          </a:prstGeom>
+          <a:solidFill>
+            <a:srgbClr val="F5F3EE"/>
+          </a:solidFill>
+          <a:ln w="19050">
+            <a:solidFill>
+              <a:srgbClr val="E0DBD0"/>
+            </a:solidFill>
+          </a:ln>
+        </p:spPr>
+        <p:style>
+          <a:lnRef idx="1">
+            <a:schemeClr val="accent1"/>
+          </a:lnRef>
+          <a:fillRef idx="3">
+            <a:schemeClr val="accent1"/>
+          </a:fillRef>
+          <a:effectRef idx="2">
+            <a:schemeClr val="accent1"/>
+          </a:effectRef>
+          <a:fontRef idx="minor">
+            <a:schemeClr val="lt1"/>
+          </a:fontRef>
+        </p:style>
+        <p:txBody>
+          <a:bodyPr rtlCol="0" anchor="ctr"/>
+          <a:lstStyle/>
+          <a:p>
+            <a:pPr algn="ctr"/>
+          </a:p>
+        </p:txBody>
+      </p:sp>
+      <p:sp>
+        <p:nvSpPr>
+          <p:cNvPr id="5" name="TextBox 4"/>
+          <p:cNvSpPr txBox="1"/>
+          <p:nvPr/>
+        </p:nvSpPr>
+        <p:spPr>
+          <a:xfrm>
+            <a:off x="960120" y="1325880"/>
+            <a:ext cx="4846320" cy="1920240"/>
+          </a:xfrm>
+          <a:prstGeom prst="rect">
+            <a:avLst/>
+          </a:prstGeom>
+          <a:noFill/>
+        </p:spPr>
+        <p:txBody>
+          <a:bodyPr wrap="square">
+            <a:spAutoFit/>
+          </a:bodyPr>
+          <a:lstStyle/>
+          <a:p>
+            <a:pPr algn="l">
+              <a:defRPr sz="1400" b="1">
+                <a:solidFill>
+                  <a:srgbClr val="115740"/>
+                </a:solidFill>
+                <a:latin typeface="Calibri"/>
+              </a:defRPr>
+            </a:pPr>
+            <a:r>
+              <a:t>DATA SOURCES</a:t>
+            </a:r>
+          </a:p>
+          <a:p>
+            <a:pPr algn="l">
+              <a:spcBef>
+                <a:spcPts val="200"/>
+              </a:spcBef>
+              <a:spcAft>
+                <a:spcPts val="200"/>
+              </a:spcAft>
+              <a:defRPr sz="600" b="0">
+                <a:solidFill>
+                  <a:srgbClr val="2D2D2D"/>
+                </a:solidFill>
+                <a:latin typeface="Calibri"/>
+              </a:defRPr>
+            </a:pPr>
+          </a:p>
+          <a:p>
+            <a:pPr algn="l">
+              <a:spcBef>
+                <a:spcPts val="400"/>
+              </a:spcBef>
+              <a:spcAft>
+                <a:spcPts val="0"/>
+              </a:spcAft>
+              <a:defRPr sz="1300" b="1">
+                <a:solidFill>
+                  <a:srgbClr val="2D2D2D"/>
+                </a:solidFill>
+                <a:latin typeface="Calibri"/>
+              </a:defRPr>
+            </a:pPr>
+            <a:r>
+              <a:t>Virginia DHRM  —  dhrm.virginia.gov</a:t>
+            </a:r>
+          </a:p>
+          <a:p>
+            <a:pPr algn="l">
+              <a:spcBef>
+                <a:spcPts val="0"/>
+              </a:spcBef>
+              <a:spcAft>
+                <a:spcPts val="400"/>
+              </a:spcAft>
+              <a:defRPr sz="1200" b="0">
+                <a:solidFill>
+                  <a:srgbClr val="5A5A5A"/>
+                </a:solidFill>
+                <a:latin typeface="Calibri"/>
+              </a:defRPr>
+            </a:pPr>
+            <a:r>
+              <a:t>56 career group pages, public government data</a:t>
+            </a:r>
+          </a:p>
+          <a:p>
+            <a:pPr algn="l">
+              <a:spcBef>
+                <a:spcPts val="400"/>
+              </a:spcBef>
+              <a:spcAft>
+                <a:spcPts val="0"/>
+              </a:spcAft>
+              <a:defRPr sz="1300" b="1">
+                <a:solidFill>
+                  <a:srgbClr val="2D2D2D"/>
+                </a:solidFill>
+                <a:latin typeface="Calibri"/>
+              </a:defRPr>
+            </a:pPr>
+            <a:r>
+              <a:t>William &amp; Mary Workday  —  williammary.wd12.myworkdayjobs.com</a:t>
+            </a:r>
+          </a:p>
+          <a:p>
+            <a:pPr algn="l">
+              <a:spcBef>
+                <a:spcPts val="0"/>
+              </a:spcBef>
+              <a:spcAft>
+                <a:spcPts val="400"/>
+              </a:spcAft>
+              <a:defRPr sz="1200" b="0">
+                <a:solidFill>
+                  <a:srgbClr val="5A5A5A"/>
+                </a:solidFill>
+                <a:latin typeface="Calibri"/>
+              </a:defRPr>
+            </a:pPr>
+            <a:r>
+              <a:t>150 public job postings, no authentication required</a:t>
+            </a:r>
+          </a:p>
+          <a:p>
+            <a:pPr algn="l">
+              <a:spcBef>
+                <a:spcPts val="400"/>
+              </a:spcBef>
+              <a:spcAft>
+                <a:spcPts val="0"/>
+              </a:spcAft>
+              <a:defRPr sz="1300" b="1">
+                <a:solidFill>
+                  <a:srgbClr val="2D2D2D"/>
+                </a:solidFill>
+                <a:latin typeface="Calibri"/>
+              </a:defRPr>
+            </a:pPr>
+            <a:r>
+              <a:t>CareerOneStop API  —  careeronestop.org</a:t>
+            </a:r>
+          </a:p>
+          <a:p>
+            <a:pPr algn="l">
+              <a:spcBef>
+                <a:spcPts val="0"/>
+              </a:spcBef>
+              <a:spcAft>
+                <a:spcPts val="200"/>
+              </a:spcAft>
+              <a:defRPr sz="1200" b="0">
+                <a:solidFill>
+                  <a:srgbClr val="5A5A5A"/>
+                </a:solidFill>
+                <a:latin typeface="Calibri"/>
+              </a:defRPr>
+            </a:pPr>
+            <a:r>
+              <a:t>U.S. DOL/ETA salary benchmarks</a:t>
+            </a:r>
+          </a:p>
+        </p:txBody>
+      </p:sp>
+      <p:sp>
+        <p:nvSpPr>
+          <p:cNvPr id="6" name="Rounded Rectangle 5"/>
+          <p:cNvSpPr/>
+          <p:nvPr/>
+        </p:nvSpPr>
+        <p:spPr>
+          <a:xfrm>
+            <a:off x="6400800" y="1188720"/>
+            <a:ext cx="5303520" cy="2194560"/>
+          </a:xfrm>
+          <a:prstGeom prst="roundRect">
+            <a:avLst>
+              <a:gd name="adj" fmla="val 5000"/>
+            </a:avLst>
+          </a:prstGeom>
+          <a:solidFill>
+            <a:srgbClr val="F5F3EE"/>
+          </a:solidFill>
+          <a:ln w="19050">
+            <a:solidFill>
+              <a:srgbClr val="E0DBD0"/>
+            </a:solidFill>
+          </a:ln>
+        </p:spPr>
+        <p:style>
+          <a:lnRef idx="1">
+            <a:schemeClr val="accent1"/>
+          </a:lnRef>
+          <a:fillRef idx="3">
+            <a:schemeClr val="accent1"/>
+          </a:fillRef>
+          <a:effectRef idx="2">
+            <a:schemeClr val="accent1"/>
+          </a:effectRef>
+          <a:fontRef idx="minor">
+            <a:schemeClr val="lt1"/>
+          </a:fontRef>
+        </p:style>
+        <p:txBody>
+          <a:bodyPr rtlCol="0" anchor="ctr"/>
+          <a:lstStyle/>
+          <a:p>
+            <a:pPr algn="ctr"/>
+          </a:p>
+        </p:txBody>
+      </p:sp>
+      <p:sp>
+        <p:nvSpPr>
+          <p:cNvPr id="7" name="TextBox 6"/>
+          <p:cNvSpPr txBox="1"/>
+          <p:nvPr/>
+        </p:nvSpPr>
+        <p:spPr>
+          <a:xfrm>
+            <a:off x="6629400" y="1325880"/>
+            <a:ext cx="4846320" cy="1920240"/>
+          </a:xfrm>
+          <a:prstGeom prst="rect">
+            <a:avLst/>
+          </a:prstGeom>
+          <a:noFill/>
+        </p:spPr>
+        <p:txBody>
+          <a:bodyPr wrap="square">
+            <a:spAutoFit/>
+          </a:bodyPr>
+          <a:lstStyle/>
+          <a:p>
+            <a:pPr algn="l">
+              <a:defRPr sz="1400" b="1">
+                <a:solidFill>
+                  <a:srgbClr val="115740"/>
+                </a:solidFill>
+                <a:latin typeface="Calibri"/>
+              </a:defRPr>
+            </a:pPr>
+            <a:r>
+              <a:t>TECHNOLOGIES</a:t>
+            </a:r>
+          </a:p>
+          <a:p>
+            <a:pPr algn="l">
+              <a:spcBef>
+                <a:spcPts val="200"/>
+              </a:spcBef>
+              <a:spcAft>
+                <a:spcPts val="200"/>
+              </a:spcAft>
+              <a:defRPr sz="600" b="0">
+                <a:solidFill>
+                  <a:srgbClr val="2D2D2D"/>
+                </a:solidFill>
+                <a:latin typeface="Calibri"/>
+              </a:defRPr>
+            </a:pPr>
+          </a:p>
+          <a:p>
+            <a:pPr algn="l">
+              <a:spcBef>
+                <a:spcPts val="200"/>
+              </a:spcBef>
+              <a:spcAft>
+                <a:spcPts val="0"/>
+              </a:spcAft>
+              <a:defRPr sz="1300" b="1">
+                <a:solidFill>
+                  <a:srgbClr val="2D2D2D"/>
+                </a:solidFill>
+                <a:latin typeface="Calibri"/>
+              </a:defRPr>
+            </a:pPr>
+            <a:r>
+              <a:t>H2O AutoML  —  docs.h2o.ai</a:t>
+            </a:r>
+          </a:p>
+          <a:p>
+            <a:pPr algn="l">
+              <a:spcBef>
+                <a:spcPts val="0"/>
+              </a:spcBef>
+              <a:spcAft>
+                <a:spcPts val="100"/>
+              </a:spcAft>
+              <a:defRPr sz="1200" b="0">
+                <a:solidFill>
+                  <a:srgbClr val="5A5A5A"/>
+                </a:solidFill>
+                <a:latin typeface="Calibri"/>
+              </a:defRPr>
+            </a:pPr>
+            <a:r>
+              <a:t>Automated machine learning</a:t>
+            </a:r>
+          </a:p>
+          <a:p>
+            <a:pPr algn="l">
+              <a:spcBef>
+                <a:spcPts val="400"/>
+              </a:spcBef>
+              <a:spcAft>
+                <a:spcPts val="0"/>
+              </a:spcAft>
+              <a:defRPr sz="1300" b="1">
+                <a:solidFill>
+                  <a:srgbClr val="2D2D2D"/>
+                </a:solidFill>
+                <a:latin typeface="Calibri"/>
+              </a:defRPr>
+            </a:pPr>
+            <a:r>
+              <a:t>LangChain  —  python.langchain.com</a:t>
+            </a:r>
+          </a:p>
+          <a:p>
+            <a:pPr algn="l">
+              <a:spcBef>
+                <a:spcPts val="0"/>
+              </a:spcBef>
+              <a:spcAft>
+                <a:spcPts val="100"/>
+              </a:spcAft>
+              <a:defRPr sz="1200" b="0">
+                <a:solidFill>
+                  <a:srgbClr val="5A5A5A"/>
+                </a:solidFill>
+                <a:latin typeface="Calibri"/>
+              </a:defRPr>
+            </a:pPr>
+            <a:r>
+              <a:t>Multi-agent orchestration</a:t>
+            </a:r>
+          </a:p>
+          <a:p>
+            <a:pPr algn="l">
+              <a:spcBef>
+                <a:spcPts val="400"/>
+              </a:spcBef>
+              <a:spcAft>
+                <a:spcPts val="0"/>
+              </a:spcAft>
+              <a:defRPr sz="1300" b="1">
+                <a:solidFill>
+                  <a:srgbClr val="2D2D2D"/>
+                </a:solidFill>
+                <a:latin typeface="Calibri"/>
+              </a:defRPr>
+            </a:pPr>
+            <a:r>
+              <a:t>Google Gemini API  —  ai.google.dev</a:t>
+            </a:r>
+          </a:p>
+          <a:p>
+            <a:pPr algn="l">
+              <a:spcBef>
+                <a:spcPts val="0"/>
+              </a:spcBef>
+              <a:spcAft>
+                <a:spcPts val="100"/>
+              </a:spcAft>
+              <a:defRPr sz="1200" b="0">
+                <a:solidFill>
+                  <a:srgbClr val="5A5A5A"/>
+                </a:solidFill>
+                <a:latin typeface="Calibri"/>
+              </a:defRPr>
+            </a:pPr>
+            <a:r>
+              <a:t>LLM classification</a:t>
+            </a:r>
+          </a:p>
+          <a:p>
+            <a:pPr algn="l">
+              <a:spcBef>
+                <a:spcPts val="400"/>
+              </a:spcBef>
+              <a:spcAft>
+                <a:spcPts val="0"/>
+              </a:spcAft>
+              <a:defRPr sz="1300" b="1">
+                <a:solidFill>
+                  <a:srgbClr val="2D2D2D"/>
+                </a:solidFill>
+                <a:latin typeface="Calibri"/>
+              </a:defRPr>
+            </a:pPr>
+            <a:r>
+              <a:t>SHAP  —  shap.readthedocs.io</a:t>
+            </a:r>
+          </a:p>
+          <a:p>
+            <a:pPr algn="l">
+              <a:spcBef>
+                <a:spcPts val="0"/>
+              </a:spcBef>
+              <a:spcAft>
+                <a:spcPts val="100"/>
+              </a:spcAft>
+              <a:defRPr sz="1200" b="0">
+                <a:solidFill>
+                  <a:srgbClr val="5A5A5A"/>
+                </a:solidFill>
+                <a:latin typeface="Calibri"/>
+              </a:defRPr>
+            </a:pPr>
+            <a:r>
+              <a:t>ML explainability</a:t>
+            </a:r>
+          </a:p>
+          <a:p>
+            <a:pPr algn="l">
+              <a:spcBef>
+                <a:spcPts val="400"/>
+              </a:spcBef>
+              <a:spcAft>
+                <a:spcPts val="0"/>
+              </a:spcAft>
+              <a:defRPr sz="1300" b="1">
+                <a:solidFill>
+                  <a:srgbClr val="2D2D2D"/>
+                </a:solidFill>
+                <a:latin typeface="Calibri"/>
+              </a:defRPr>
+            </a:pPr>
+            <a:r>
+              <a:t>Streamlit  —  streamlit.io</a:t>
+            </a:r>
+          </a:p>
+          <a:p>
+            <a:pPr algn="l">
+              <a:spcBef>
+                <a:spcPts val="0"/>
+              </a:spcBef>
+              <a:spcAft>
+                <a:spcPts val="100"/>
+              </a:spcAft>
+              <a:defRPr sz="1200" b="0">
+                <a:solidFill>
+                  <a:srgbClr val="5A5A5A"/>
+                </a:solidFill>
+                <a:latin typeface="Calibri"/>
+              </a:defRPr>
+            </a:pPr>
+            <a:r>
+              <a:t>Web application framework</a:t>
+            </a:r>
+          </a:p>
+          <a:p>
+            <a:pPr algn="l">
+              <a:spcBef>
+                <a:spcPts val="400"/>
+              </a:spcBef>
+              <a:spcAft>
+                <a:spcPts val="0"/>
+              </a:spcAft>
+              <a:defRPr sz="1300" b="1">
+                <a:solidFill>
+                  <a:srgbClr val="2D2D2D"/>
+                </a:solidFill>
+                <a:latin typeface="Calibri"/>
+              </a:defRPr>
+            </a:pPr>
+            <a:r>
+              <a:t>SQLAlchemy  —  sqlalchemy.org</a:t>
+            </a:r>
+          </a:p>
+          <a:p>
+            <a:pPr algn="l">
+              <a:spcBef>
+                <a:spcPts val="0"/>
+              </a:spcBef>
+              <a:spcAft>
+                <a:spcPts val="100"/>
+              </a:spcAft>
+              <a:defRPr sz="1200" b="0">
+                <a:solidFill>
+                  <a:srgbClr val="5A5A5A"/>
+                </a:solidFill>
+                <a:latin typeface="Calibri"/>
+              </a:defRPr>
+            </a:pPr>
+            <a:r>
+              <a:t>Database ORM</a:t>
+            </a:r>
+          </a:p>
+        </p:txBody>
+      </p:sp>
+      <p:sp>
+        <p:nvSpPr>
+          <p:cNvPr id="8" name="Rounded Rectangle 7"/>
+          <p:cNvSpPr/>
+          <p:nvPr/>
+        </p:nvSpPr>
+        <p:spPr>
+          <a:xfrm>
+            <a:off x="731520" y="3657600"/>
+            <a:ext cx="10972800" cy="1188720"/>
+          </a:xfrm>
+          <a:prstGeom prst="roundRect">
+            <a:avLst>
+              <a:gd name="adj" fmla="val 5000"/>
+            </a:avLst>
+          </a:prstGeom>
+          <a:solidFill>
+            <a:srgbClr val="E8F2EE"/>
+          </a:solidFill>
+          <a:ln w="12700">
+            <a:solidFill>
+              <a:srgbClr val="115740"/>
+            </a:solidFill>
+          </a:ln>
+        </p:spPr>
+        <p:style>
+          <a:lnRef idx="1">
+            <a:schemeClr val="accent1"/>
+          </a:lnRef>
+          <a:fillRef idx="3">
+            <a:schemeClr val="accent1"/>
+          </a:fillRef>
+          <a:effectRef idx="2">
+            <a:schemeClr val="accent1"/>
+          </a:effectRef>
+          <a:fontRef idx="minor">
+            <a:schemeClr val="lt1"/>
+          </a:fontRef>
+        </p:style>
+        <p:txBody>
+          <a:bodyPr rtlCol="0" anchor="ctr"/>
+          <a:lstStyle/>
+          <a:p>
+            <a:pPr algn="ctr"/>
+          </a:p>
+        </p:txBody>
+      </p:sp>
+      <p:sp>
+        <p:nvSpPr>
+          <p:cNvPr id="9" name="TextBox 8"/>
+          <p:cNvSpPr txBox="1"/>
+          <p:nvPr/>
+        </p:nvSpPr>
+        <p:spPr>
+          <a:xfrm>
+            <a:off x="1005840" y="3794760"/>
+            <a:ext cx="10424160" cy="914400"/>
+          </a:xfrm>
+          <a:prstGeom prst="rect">
+            <a:avLst/>
+          </a:prstGeom>
+          <a:noFill/>
+        </p:spPr>
+        <p:txBody>
+          <a:bodyPr wrap="square">
+            <a:spAutoFit/>
+          </a:bodyPr>
+          <a:lstStyle/>
+          <a:p>
+            <a:pPr algn="l">
+              <a:defRPr sz="1400" b="1">
+                <a:solidFill>
+                  <a:srgbClr val="115740"/>
+                </a:solidFill>
+                <a:latin typeface="Calibri"/>
+              </a:defRPr>
+            </a:pPr>
+            <a:r>
+              <a:t>REQUIRED ATTRIBUTION</a:t>
+            </a:r>
+          </a:p>
+          <a:p>
+            <a:pPr algn="l">
+              <a:spcBef>
+                <a:spcPts val="200"/>
+              </a:spcBef>
+              <a:spcAft>
+                <a:spcPts val="200"/>
+              </a:spcAft>
+              <a:defRPr sz="400" b="0">
+                <a:solidFill>
+                  <a:srgbClr val="2D2D2D"/>
+                </a:solidFill>
+                <a:latin typeface="Calibri"/>
+              </a:defRPr>
+            </a:pPr>
+          </a:p>
+          <a:p>
+            <a:pPr algn="l">
+              <a:spcBef>
+                <a:spcPts val="400"/>
+              </a:spcBef>
+              <a:spcAft>
+                <a:spcPts val="200"/>
+              </a:spcAft>
+              <a:defRPr sz="1300" b="0">
+                <a:solidFill>
+                  <a:srgbClr val="2D2D2D"/>
+                </a:solidFill>
+                <a:latin typeface="Calibri"/>
+              </a:defRPr>
+            </a:pPr>
+            <a:r>
+              <a:t>Salary benchmarking data provided by CareerOneStop, sponsored by the U.S. Department of Labor, Employment and Training Administration (USDOL/ETA). This project does not reflect the official position of USDOL/ETA.</a:t>
+            </a:r>
+          </a:p>
+        </p:txBody>
+      </p:sp>
+      <p:sp>
+        <p:nvSpPr>
+          <p:cNvPr id="10" name="Rounded Rectangle 9"/>
+          <p:cNvSpPr/>
+          <p:nvPr/>
+        </p:nvSpPr>
+        <p:spPr>
+          <a:xfrm>
+            <a:off x="731520" y="5074920"/>
+            <a:ext cx="10972800" cy="731520"/>
+          </a:xfrm>
+          <a:prstGeom prst="roundRect">
+            <a:avLst>
+              <a:gd name="adj" fmla="val 5000"/>
+            </a:avLst>
+          </a:prstGeom>
+          <a:solidFill>
+            <a:srgbClr val="F5F3EE"/>
+          </a:solidFill>
+          <a:ln w="19050">
+            <a:solidFill>
+              <a:srgbClr val="E0DBD0"/>
+            </a:solidFill>
+          </a:ln>
+        </p:spPr>
+        <p:style>
+          <a:lnRef idx="1">
+            <a:schemeClr val="accent1"/>
+          </a:lnRef>
+          <a:fillRef idx="3">
+            <a:schemeClr val="accent1"/>
+          </a:fillRef>
+          <a:effectRef idx="2">
+            <a:schemeClr val="accent1"/>
+          </a:effectRef>
+          <a:fontRef idx="minor">
+            <a:schemeClr val="lt1"/>
+          </a:fontRef>
+        </p:style>
+        <p:txBody>
+          <a:bodyPr rtlCol="0" anchor="ctr"/>
+          <a:lstStyle/>
+          <a:p>
+            <a:pPr algn="ctr"/>
+          </a:p>
+        </p:txBody>
+      </p:sp>
+      <p:sp>
+        <p:nvSpPr>
+          <p:cNvPr id="11" name="TextBox 10"/>
+          <p:cNvSpPr txBox="1"/>
+          <p:nvPr/>
+        </p:nvSpPr>
+        <p:spPr>
+          <a:xfrm>
+            <a:off x="1005840" y="5184648"/>
+            <a:ext cx="10424160" cy="548640"/>
+          </a:xfrm>
+          <a:prstGeom prst="rect">
+            <a:avLst/>
+          </a:prstGeom>
+          <a:noFill/>
+        </p:spPr>
+        <p:txBody>
+          <a:bodyPr wrap="square">
+            <a:spAutoFit/>
+          </a:bodyPr>
+          <a:lstStyle/>
+          <a:p>
+            <a:pPr algn="l">
+              <a:defRPr sz="1400" b="1">
+                <a:solidFill>
+                  <a:srgbClr val="115740"/>
+                </a:solidFill>
+                <a:latin typeface="Calibri"/>
+              </a:defRPr>
+            </a:pPr>
+            <a:r>
+              <a:t>RESEARCH PAPER</a:t>
+            </a:r>
+          </a:p>
+          <a:p>
+            <a:pPr algn="l">
+              <a:spcBef>
+                <a:spcPts val="400"/>
+              </a:spcBef>
+              <a:spcAft>
+                <a:spcPts val="200"/>
+              </a:spcAft>
+              <a:defRPr sz="1300" b="0">
+                <a:solidFill>
+                  <a:srgbClr val="5A5A5A"/>
+                </a:solidFill>
+                <a:latin typeface="Calibri"/>
+              </a:defRPr>
+            </a:pPr>
+            <a:r>
+              <a:t>[Team will add citation]</a:t>
+            </a:r>
+          </a:p>
+        </p:txBody>
+      </p:sp>
+      <p:sp>
+        <p:nvSpPr>
+          <p:cNvPr id="12" name="TextBox 11"/>
+          <p:cNvSpPr txBox="1"/>
+          <p:nvPr/>
+        </p:nvSpPr>
+        <p:spPr>
+          <a:xfrm>
+            <a:off x="11094415" y="6446520"/>
+            <a:ext cx="914400" cy="274320"/>
+          </a:xfrm>
+          <a:prstGeom prst="rect">
+            <a:avLst/>
+          </a:prstGeom>
+          <a:noFill/>
+        </p:spPr>
+        <p:txBody>
+          <a:bodyPr wrap="square">
+            <a:spAutoFit/>
+          </a:bodyPr>
+          <a:lstStyle/>
+          <a:p>
             <a:pPr algn="r">
               <a:defRPr sz="1000" b="0">
                 <a:solidFill>
@@ -8672,7 +9538,7 @@
               </a:defRPr>
             </a:pPr>
             <a:r>
-              <a:t>16 / 16</a:t>
+              <a:t>17 / 17</a:t>
             </a:r>
           </a:p>
         </p:txBody>
@@ -9476,7 +10342,7 @@
               </a:defRPr>
             </a:pPr>
             <a:r>
-              <a:t>2 / 16</a:t>
+              <a:t>2 / 17</a:t>
             </a:r>
           </a:p>
         </p:txBody>
@@ -10716,7 +11582,7 @@
               </a:defRPr>
             </a:pPr>
             <a:r>
-              <a:t>3 / 16</a:t>
+              <a:t>3 / 17</a:t>
             </a:r>
           </a:p>
         </p:txBody>
@@ -12569,7 +13435,7 @@
               </a:defRPr>
             </a:pPr>
             <a:r>
-              <a:t>4 / 16</a:t>
+              <a:t>4 / 17</a:t>
             </a:r>
           </a:p>
         </p:txBody>
@@ -13519,7 +14385,7 @@
               </a:defRPr>
             </a:pPr>
             <a:r>
-              <a:t>5 / 16</a:t>
+              <a:t>5 / 17</a:t>
             </a:r>
           </a:p>
         </p:txBody>
@@ -14285,7 +15151,7 @@
               </a:defRPr>
             </a:pPr>
             <a:r>
-              <a:t>6 / 16</a:t>
+              <a:t>6 / 17</a:t>
             </a:r>
           </a:p>
         </p:txBody>
@@ -15497,7 +16363,7 @@
               </a:defRPr>
             </a:pPr>
             <a:r>
-              <a:t>7 / 16</a:t>
+              <a:t>7 / 17</a:t>
             </a:r>
           </a:p>
         </p:txBody>
@@ -15918,7 +16784,7 @@
               </a:defRPr>
             </a:pPr>
             <a:r>
-              <a:t>8 / 16</a:t>
+              <a:t>8 / 17</a:t>
             </a:r>
           </a:p>
         </p:txBody>
@@ -16411,7 +17277,7 @@
               </a:defRPr>
             </a:pPr>
             <a:r>
-              <a:t>9 / 16</a:t>
+              <a:t>9 / 17</a:t>
             </a:r>
           </a:p>
         </p:txBody>

</xml_diff>

<commit_message>
Final Owner-revised presentation — DO NOT REBUILD FROM SCRIPT
</commit_message>
<xml_diff>
--- a/ppt/GRIFFIN_BigData_Presentation.pptx
+++ b/ppt/GRIFFIN_BigData_Presentation.pptx
@@ -5,25 +5,25 @@
     <p:sldMasterId id="2147483648" r:id="rId1"/>
   </p:sldMasterIdLst>
   <p:sldIdLst>
-    <p:sldId id="256" r:id="rId7"/>
-    <p:sldId id="257" r:id="rId8"/>
-    <p:sldId id="258" r:id="rId9"/>
-    <p:sldId id="259" r:id="rId10"/>
-    <p:sldId id="260" r:id="rId11"/>
-    <p:sldId id="261" r:id="rId12"/>
-    <p:sldId id="262" r:id="rId13"/>
-    <p:sldId id="263" r:id="rId14"/>
-    <p:sldId id="264" r:id="rId15"/>
-    <p:sldId id="265" r:id="rId16"/>
-    <p:sldId id="266" r:id="rId17"/>
-    <p:sldId id="267" r:id="rId18"/>
-    <p:sldId id="268" r:id="rId19"/>
-    <p:sldId id="269" r:id="rId20"/>
-    <p:sldId id="270" r:id="rId21"/>
-    <p:sldId id="271" r:id="rId22"/>
-    <p:sldId id="272" r:id="rId23"/>
+    <p:sldId id="256" r:id="rId2"/>
+    <p:sldId id="257" r:id="rId3"/>
+    <p:sldId id="258" r:id="rId4"/>
+    <p:sldId id="259" r:id="rId5"/>
+    <p:sldId id="260" r:id="rId6"/>
+    <p:sldId id="261" r:id="rId7"/>
+    <p:sldId id="262" r:id="rId8"/>
+    <p:sldId id="263" r:id="rId9"/>
+    <p:sldId id="264" r:id="rId10"/>
+    <p:sldId id="265" r:id="rId11"/>
+    <p:sldId id="266" r:id="rId12"/>
+    <p:sldId id="267" r:id="rId13"/>
+    <p:sldId id="268" r:id="rId14"/>
+    <p:sldId id="269" r:id="rId15"/>
+    <p:sldId id="270" r:id="rId16"/>
+    <p:sldId id="271" r:id="rId17"/>
+    <p:sldId id="272" r:id="rId18"/>
   </p:sldIdLst>
-  <p:sldSz cx="12191695" cy="6858000" type="screen4x3"/>
+  <p:sldSz cx="12192000" cy="6858000"/>
   <p:notesSz cx="6858000" cy="9144000"/>
   <p:defaultTextStyle>
     <a:defPPr>
@@ -120,6 +120,22 @@
       </a:defRPr>
     </a:lvl9pPr>
   </p:defaultTextStyle>
+  <p:extLst>
+    <p:ext uri="{EFAFB233-063F-42B5-8137-9DF3F51BA10A}">
+      <p15:sldGuideLst xmlns:p15="http://schemas.microsoft.com/office/powerpoint/2012/main">
+        <p15:guide id="1" orient="horz" pos="2160">
+          <p15:clr>
+            <a:srgbClr val="A4A3A4"/>
+          </p15:clr>
+        </p15:guide>
+        <p15:guide id="2" pos="2880">
+          <p15:clr>
+            <a:srgbClr val="A4A3A4"/>
+          </p15:clr>
+        </p15:guide>
+      </p15:sldGuideLst>
+    </p:ext>
+  </p:extLst>
 </p:presentation>
 </file>
 
@@ -161,10 +177,9 @@
           <a:lstStyle/>
           <a:p>
             <a:r>
-              <a:rPr lang="en-US" smtClean="0"/>
+              <a:rPr lang="en-US"/>
               <a:t>Click to edit Master title style</a:t>
             </a:r>
-            <a:endParaRPr lang="en-US"/>
           </a:p>
         </p:txBody>
       </p:sp>
@@ -280,10 +295,9 @@
           </a:lstStyle>
           <a:p>
             <a:r>
-              <a:rPr lang="en-US" smtClean="0"/>
+              <a:rPr lang="en-US"/>
               <a:t>Click to edit Master subtitle style</a:t>
             </a:r>
-            <a:endParaRPr lang="en-US"/>
           </a:p>
         </p:txBody>
       </p:sp>
@@ -304,7 +318,7 @@
           <a:p>
             <a:fld id="{5BCAD085-E8A6-8845-BD4E-CB4CCA059FC4}" type="datetimeFigureOut">
               <a:rPr lang="en-US" smtClean="0"/>
-              <a:t>1/27/13</a:t>
+              <a:t>4/12/2026</a:t>
             </a:fld>
             <a:endParaRPr lang="en-US"/>
           </a:p>
@@ -398,10 +412,9 @@
           <a:lstStyle/>
           <a:p>
             <a:r>
-              <a:rPr lang="en-US" smtClean="0"/>
+              <a:rPr lang="en-US"/>
               <a:t>Click to edit Master title style</a:t>
             </a:r>
-            <a:endParaRPr lang="en-US"/>
           </a:p>
         </p:txBody>
       </p:sp>
@@ -422,38 +435,37 @@
           <a:p>
             <a:pPr lvl="0"/>
             <a:r>
-              <a:rPr lang="en-US" smtClean="0"/>
+              <a:rPr lang="en-US"/>
               <a:t>Click to edit Master text styles</a:t>
             </a:r>
           </a:p>
           <a:p>
             <a:pPr lvl="1"/>
             <a:r>
-              <a:rPr lang="en-US" smtClean="0"/>
+              <a:rPr lang="en-US"/>
               <a:t>Second level</a:t>
             </a:r>
           </a:p>
           <a:p>
             <a:pPr lvl="2"/>
             <a:r>
-              <a:rPr lang="en-US" smtClean="0"/>
+              <a:rPr lang="en-US"/>
               <a:t>Third level</a:t>
             </a:r>
           </a:p>
           <a:p>
             <a:pPr lvl="3"/>
             <a:r>
-              <a:rPr lang="en-US" smtClean="0"/>
+              <a:rPr lang="en-US"/>
               <a:t>Fourth level</a:t>
             </a:r>
           </a:p>
           <a:p>
             <a:pPr lvl="4"/>
             <a:r>
-              <a:rPr lang="en-US" smtClean="0"/>
+              <a:rPr lang="en-US"/>
               <a:t>Fifth level</a:t>
             </a:r>
-            <a:endParaRPr lang="en-US"/>
           </a:p>
         </p:txBody>
       </p:sp>
@@ -474,7 +486,7 @@
           <a:p>
             <a:fld id="{5BCAD085-E8A6-8845-BD4E-CB4CCA059FC4}" type="datetimeFigureOut">
               <a:rPr lang="en-US" smtClean="0"/>
-              <a:t>1/27/13</a:t>
+              <a:t>4/12/2026</a:t>
             </a:fld>
             <a:endParaRPr lang="en-US"/>
           </a:p>
@@ -573,10 +585,9 @@
           <a:lstStyle/>
           <a:p>
             <a:r>
-              <a:rPr lang="en-US" smtClean="0"/>
+              <a:rPr lang="en-US"/>
               <a:t>Click to edit Master title style</a:t>
             </a:r>
-            <a:endParaRPr lang="en-US"/>
           </a:p>
         </p:txBody>
       </p:sp>
@@ -602,38 +613,37 @@
           <a:p>
             <a:pPr lvl="0"/>
             <a:r>
-              <a:rPr lang="en-US" smtClean="0"/>
+              <a:rPr lang="en-US"/>
               <a:t>Click to edit Master text styles</a:t>
             </a:r>
           </a:p>
           <a:p>
             <a:pPr lvl="1"/>
             <a:r>
-              <a:rPr lang="en-US" smtClean="0"/>
+              <a:rPr lang="en-US"/>
               <a:t>Second level</a:t>
             </a:r>
           </a:p>
           <a:p>
             <a:pPr lvl="2"/>
             <a:r>
-              <a:rPr lang="en-US" smtClean="0"/>
+              <a:rPr lang="en-US"/>
               <a:t>Third level</a:t>
             </a:r>
           </a:p>
           <a:p>
             <a:pPr lvl="3"/>
             <a:r>
-              <a:rPr lang="en-US" smtClean="0"/>
+              <a:rPr lang="en-US"/>
               <a:t>Fourth level</a:t>
             </a:r>
           </a:p>
           <a:p>
             <a:pPr lvl="4"/>
             <a:r>
-              <a:rPr lang="en-US" smtClean="0"/>
+              <a:rPr lang="en-US"/>
               <a:t>Fifth level</a:t>
             </a:r>
-            <a:endParaRPr lang="en-US"/>
           </a:p>
         </p:txBody>
       </p:sp>
@@ -654,7 +664,7 @@
           <a:p>
             <a:fld id="{5BCAD085-E8A6-8845-BD4E-CB4CCA059FC4}" type="datetimeFigureOut">
               <a:rPr lang="en-US" smtClean="0"/>
-              <a:t>1/27/13</a:t>
+              <a:t>4/12/2026</a:t>
             </a:fld>
             <a:endParaRPr lang="en-US"/>
           </a:p>
@@ -748,10 +758,9 @@
           <a:lstStyle/>
           <a:p>
             <a:r>
-              <a:rPr lang="en-US" smtClean="0"/>
+              <a:rPr lang="en-US"/>
               <a:t>Click to edit Master title style</a:t>
             </a:r>
-            <a:endParaRPr lang="en-US"/>
           </a:p>
         </p:txBody>
       </p:sp>
@@ -772,38 +781,37 @@
           <a:p>
             <a:pPr lvl="0"/>
             <a:r>
-              <a:rPr lang="en-US" smtClean="0"/>
+              <a:rPr lang="en-US"/>
               <a:t>Click to edit Master text styles</a:t>
             </a:r>
           </a:p>
           <a:p>
             <a:pPr lvl="1"/>
             <a:r>
-              <a:rPr lang="en-US" smtClean="0"/>
+              <a:rPr lang="en-US"/>
               <a:t>Second level</a:t>
             </a:r>
           </a:p>
           <a:p>
             <a:pPr lvl="2"/>
             <a:r>
-              <a:rPr lang="en-US" smtClean="0"/>
+              <a:rPr lang="en-US"/>
               <a:t>Third level</a:t>
             </a:r>
           </a:p>
           <a:p>
             <a:pPr lvl="3"/>
             <a:r>
-              <a:rPr lang="en-US" smtClean="0"/>
+              <a:rPr lang="en-US"/>
               <a:t>Fourth level</a:t>
             </a:r>
           </a:p>
           <a:p>
             <a:pPr lvl="4"/>
             <a:r>
-              <a:rPr lang="en-US" smtClean="0"/>
+              <a:rPr lang="en-US"/>
               <a:t>Fifth level</a:t>
             </a:r>
-            <a:endParaRPr lang="en-US"/>
           </a:p>
         </p:txBody>
       </p:sp>
@@ -824,7 +832,7 @@
           <a:p>
             <a:fld id="{5BCAD085-E8A6-8845-BD4E-CB4CCA059FC4}" type="datetimeFigureOut">
               <a:rPr lang="en-US" smtClean="0"/>
-              <a:t>1/27/13</a:t>
+              <a:t>4/12/2026</a:t>
             </a:fld>
             <a:endParaRPr lang="en-US"/>
           </a:p>
@@ -927,10 +935,9 @@
           </a:lstStyle>
           <a:p>
             <a:r>
-              <a:rPr lang="en-US" smtClean="0"/>
+              <a:rPr lang="en-US"/>
               <a:t>Click to edit Master title style</a:t>
             </a:r>
-            <a:endParaRPr lang="en-US"/>
           </a:p>
         </p:txBody>
       </p:sp>
@@ -1047,7 +1054,7 @@
           <a:p>
             <a:pPr lvl="0"/>
             <a:r>
-              <a:rPr lang="en-US" smtClean="0"/>
+              <a:rPr lang="en-US"/>
               <a:t>Click to edit Master text styles</a:t>
             </a:r>
           </a:p>
@@ -1070,7 +1077,7 @@
           <a:p>
             <a:fld id="{5BCAD085-E8A6-8845-BD4E-CB4CCA059FC4}" type="datetimeFigureOut">
               <a:rPr lang="en-US" smtClean="0"/>
-              <a:t>1/27/13</a:t>
+              <a:t>4/12/2026</a:t>
             </a:fld>
             <a:endParaRPr lang="en-US"/>
           </a:p>
@@ -1164,10 +1171,9 @@
           <a:lstStyle/>
           <a:p>
             <a:r>
-              <a:rPr lang="en-US" smtClean="0"/>
+              <a:rPr lang="en-US"/>
               <a:t>Click to edit Master title style</a:t>
             </a:r>
-            <a:endParaRPr lang="en-US"/>
           </a:p>
         </p:txBody>
       </p:sp>
@@ -1221,38 +1227,37 @@
           <a:p>
             <a:pPr lvl="0"/>
             <a:r>
-              <a:rPr lang="en-US" smtClean="0"/>
+              <a:rPr lang="en-US"/>
               <a:t>Click to edit Master text styles</a:t>
             </a:r>
           </a:p>
           <a:p>
             <a:pPr lvl="1"/>
             <a:r>
-              <a:rPr lang="en-US" smtClean="0"/>
+              <a:rPr lang="en-US"/>
               <a:t>Second level</a:t>
             </a:r>
           </a:p>
           <a:p>
             <a:pPr lvl="2"/>
             <a:r>
-              <a:rPr lang="en-US" smtClean="0"/>
+              <a:rPr lang="en-US"/>
               <a:t>Third level</a:t>
             </a:r>
           </a:p>
           <a:p>
             <a:pPr lvl="3"/>
             <a:r>
-              <a:rPr lang="en-US" smtClean="0"/>
+              <a:rPr lang="en-US"/>
               <a:t>Fourth level</a:t>
             </a:r>
           </a:p>
           <a:p>
             <a:pPr lvl="4"/>
             <a:r>
-              <a:rPr lang="en-US" smtClean="0"/>
+              <a:rPr lang="en-US"/>
               <a:t>Fifth level</a:t>
             </a:r>
-            <a:endParaRPr lang="en-US"/>
           </a:p>
         </p:txBody>
       </p:sp>
@@ -1306,38 +1311,37 @@
           <a:p>
             <a:pPr lvl="0"/>
             <a:r>
-              <a:rPr lang="en-US" smtClean="0"/>
+              <a:rPr lang="en-US"/>
               <a:t>Click to edit Master text styles</a:t>
             </a:r>
           </a:p>
           <a:p>
             <a:pPr lvl="1"/>
             <a:r>
-              <a:rPr lang="en-US" smtClean="0"/>
+              <a:rPr lang="en-US"/>
               <a:t>Second level</a:t>
             </a:r>
           </a:p>
           <a:p>
             <a:pPr lvl="2"/>
             <a:r>
-              <a:rPr lang="en-US" smtClean="0"/>
+              <a:rPr lang="en-US"/>
               <a:t>Third level</a:t>
             </a:r>
           </a:p>
           <a:p>
             <a:pPr lvl="3"/>
             <a:r>
-              <a:rPr lang="en-US" smtClean="0"/>
+              <a:rPr lang="en-US"/>
               <a:t>Fourth level</a:t>
             </a:r>
           </a:p>
           <a:p>
             <a:pPr lvl="4"/>
             <a:r>
-              <a:rPr lang="en-US" smtClean="0"/>
+              <a:rPr lang="en-US"/>
               <a:t>Fifth level</a:t>
             </a:r>
-            <a:endParaRPr lang="en-US"/>
           </a:p>
         </p:txBody>
       </p:sp>
@@ -1358,7 +1362,7 @@
           <a:p>
             <a:fld id="{5BCAD085-E8A6-8845-BD4E-CB4CCA059FC4}" type="datetimeFigureOut">
               <a:rPr lang="en-US" smtClean="0"/>
-              <a:t>1/27/13</a:t>
+              <a:t>4/12/2026</a:t>
             </a:fld>
             <a:endParaRPr lang="en-US"/>
           </a:p>
@@ -1456,10 +1460,9 @@
           </a:lstStyle>
           <a:p>
             <a:r>
-              <a:rPr lang="en-US" smtClean="0"/>
+              <a:rPr lang="en-US"/>
               <a:t>Click to edit Master title style</a:t>
             </a:r>
-            <a:endParaRPr lang="en-US"/>
           </a:p>
         </p:txBody>
       </p:sp>
@@ -1522,7 +1525,7 @@
           <a:p>
             <a:pPr lvl="0"/>
             <a:r>
-              <a:rPr lang="en-US" smtClean="0"/>
+              <a:rPr lang="en-US"/>
               <a:t>Click to edit Master text styles</a:t>
             </a:r>
           </a:p>
@@ -1578,38 +1581,37 @@
           <a:p>
             <a:pPr lvl="0"/>
             <a:r>
-              <a:rPr lang="en-US" smtClean="0"/>
+              <a:rPr lang="en-US"/>
               <a:t>Click to edit Master text styles</a:t>
             </a:r>
           </a:p>
           <a:p>
             <a:pPr lvl="1"/>
             <a:r>
-              <a:rPr lang="en-US" smtClean="0"/>
+              <a:rPr lang="en-US"/>
               <a:t>Second level</a:t>
             </a:r>
           </a:p>
           <a:p>
             <a:pPr lvl="2"/>
             <a:r>
-              <a:rPr lang="en-US" smtClean="0"/>
+              <a:rPr lang="en-US"/>
               <a:t>Third level</a:t>
             </a:r>
           </a:p>
           <a:p>
             <a:pPr lvl="3"/>
             <a:r>
-              <a:rPr lang="en-US" smtClean="0"/>
+              <a:rPr lang="en-US"/>
               <a:t>Fourth level</a:t>
             </a:r>
           </a:p>
           <a:p>
             <a:pPr lvl="4"/>
             <a:r>
-              <a:rPr lang="en-US" smtClean="0"/>
+              <a:rPr lang="en-US"/>
               <a:t>Fifth level</a:t>
             </a:r>
-            <a:endParaRPr lang="en-US"/>
           </a:p>
         </p:txBody>
       </p:sp>
@@ -1672,7 +1674,7 @@
           <a:p>
             <a:pPr lvl="0"/>
             <a:r>
-              <a:rPr lang="en-US" smtClean="0"/>
+              <a:rPr lang="en-US"/>
               <a:t>Click to edit Master text styles</a:t>
             </a:r>
           </a:p>
@@ -1728,38 +1730,37 @@
           <a:p>
             <a:pPr lvl="0"/>
             <a:r>
-              <a:rPr lang="en-US" smtClean="0"/>
+              <a:rPr lang="en-US"/>
               <a:t>Click to edit Master text styles</a:t>
             </a:r>
           </a:p>
           <a:p>
             <a:pPr lvl="1"/>
             <a:r>
-              <a:rPr lang="en-US" smtClean="0"/>
+              <a:rPr lang="en-US"/>
               <a:t>Second level</a:t>
             </a:r>
           </a:p>
           <a:p>
             <a:pPr lvl="2"/>
             <a:r>
-              <a:rPr lang="en-US" smtClean="0"/>
+              <a:rPr lang="en-US"/>
               <a:t>Third level</a:t>
             </a:r>
           </a:p>
           <a:p>
             <a:pPr lvl="3"/>
             <a:r>
-              <a:rPr lang="en-US" smtClean="0"/>
+              <a:rPr lang="en-US"/>
               <a:t>Fourth level</a:t>
             </a:r>
           </a:p>
           <a:p>
             <a:pPr lvl="4"/>
             <a:r>
-              <a:rPr lang="en-US" smtClean="0"/>
+              <a:rPr lang="en-US"/>
               <a:t>Fifth level</a:t>
             </a:r>
-            <a:endParaRPr lang="en-US"/>
           </a:p>
         </p:txBody>
       </p:sp>
@@ -1780,7 +1781,7 @@
           <a:p>
             <a:fld id="{5BCAD085-E8A6-8845-BD4E-CB4CCA059FC4}" type="datetimeFigureOut">
               <a:rPr lang="en-US" smtClean="0"/>
-              <a:t>1/27/13</a:t>
+              <a:t>4/12/2026</a:t>
             </a:fld>
             <a:endParaRPr lang="en-US"/>
           </a:p>
@@ -1874,10 +1875,9 @@
           <a:lstStyle/>
           <a:p>
             <a:r>
-              <a:rPr lang="en-US" smtClean="0"/>
+              <a:rPr lang="en-US"/>
               <a:t>Click to edit Master title style</a:t>
             </a:r>
-            <a:endParaRPr lang="en-US"/>
           </a:p>
         </p:txBody>
       </p:sp>
@@ -1898,7 +1898,7 @@
           <a:p>
             <a:fld id="{5BCAD085-E8A6-8845-BD4E-CB4CCA059FC4}" type="datetimeFigureOut">
               <a:rPr lang="en-US" smtClean="0"/>
-              <a:t>1/27/13</a:t>
+              <a:t>4/12/2026</a:t>
             </a:fld>
             <a:endParaRPr lang="en-US"/>
           </a:p>
@@ -1993,7 +1993,7 @@
           <a:p>
             <a:fld id="{5BCAD085-E8A6-8845-BD4E-CB4CCA059FC4}" type="datetimeFigureOut">
               <a:rPr lang="en-US" smtClean="0"/>
-              <a:t>1/27/13</a:t>
+              <a:t>4/12/2026</a:t>
             </a:fld>
             <a:endParaRPr lang="en-US"/>
           </a:p>
@@ -2096,10 +2096,9 @@
           </a:lstStyle>
           <a:p>
             <a:r>
-              <a:rPr lang="en-US" smtClean="0"/>
+              <a:rPr lang="en-US"/>
               <a:t>Click to edit Master title style</a:t>
             </a:r>
-            <a:endParaRPr lang="en-US"/>
           </a:p>
         </p:txBody>
       </p:sp>
@@ -2153,38 +2152,37 @@
           <a:p>
             <a:pPr lvl="0"/>
             <a:r>
-              <a:rPr lang="en-US" smtClean="0"/>
+              <a:rPr lang="en-US"/>
               <a:t>Click to edit Master text styles</a:t>
             </a:r>
           </a:p>
           <a:p>
             <a:pPr lvl="1"/>
             <a:r>
-              <a:rPr lang="en-US" smtClean="0"/>
+              <a:rPr lang="en-US"/>
               <a:t>Second level</a:t>
             </a:r>
           </a:p>
           <a:p>
             <a:pPr lvl="2"/>
             <a:r>
-              <a:rPr lang="en-US" smtClean="0"/>
+              <a:rPr lang="en-US"/>
               <a:t>Third level</a:t>
             </a:r>
           </a:p>
           <a:p>
             <a:pPr lvl="3"/>
             <a:r>
-              <a:rPr lang="en-US" smtClean="0"/>
+              <a:rPr lang="en-US"/>
               <a:t>Fourth level</a:t>
             </a:r>
           </a:p>
           <a:p>
             <a:pPr lvl="4"/>
             <a:r>
-              <a:rPr lang="en-US" smtClean="0"/>
+              <a:rPr lang="en-US"/>
               <a:t>Fifth level</a:t>
             </a:r>
-            <a:endParaRPr lang="en-US"/>
           </a:p>
         </p:txBody>
       </p:sp>
@@ -2247,7 +2245,7 @@
           <a:p>
             <a:pPr lvl="0"/>
             <a:r>
-              <a:rPr lang="en-US" smtClean="0"/>
+              <a:rPr lang="en-US"/>
               <a:t>Click to edit Master text styles</a:t>
             </a:r>
           </a:p>
@@ -2270,7 +2268,7 @@
           <a:p>
             <a:fld id="{5BCAD085-E8A6-8845-BD4E-CB4CCA059FC4}" type="datetimeFigureOut">
               <a:rPr lang="en-US" smtClean="0"/>
-              <a:t>1/27/13</a:t>
+              <a:t>4/12/2026</a:t>
             </a:fld>
             <a:endParaRPr lang="en-US"/>
           </a:p>
@@ -2373,10 +2371,9 @@
           </a:lstStyle>
           <a:p>
             <a:r>
-              <a:rPr lang="en-US" smtClean="0"/>
+              <a:rPr lang="en-US"/>
               <a:t>Click to edit Master title style</a:t>
             </a:r>
-            <a:endParaRPr lang="en-US"/>
           </a:p>
         </p:txBody>
       </p:sp>
@@ -2500,7 +2497,7 @@
           <a:p>
             <a:pPr lvl="0"/>
             <a:r>
-              <a:rPr lang="en-US" smtClean="0"/>
+              <a:rPr lang="en-US"/>
               <a:t>Click to edit Master text styles</a:t>
             </a:r>
           </a:p>
@@ -2523,7 +2520,7 @@
           <a:p>
             <a:fld id="{5BCAD085-E8A6-8845-BD4E-CB4CCA059FC4}" type="datetimeFigureOut">
               <a:rPr lang="en-US" smtClean="0"/>
-              <a:t>1/27/13</a:t>
+              <a:t>4/12/2026</a:t>
             </a:fld>
             <a:endParaRPr lang="en-US"/>
           </a:p>
@@ -2632,10 +2629,9 @@
           <a:lstStyle/>
           <a:p>
             <a:r>
-              <a:rPr lang="en-US" smtClean="0"/>
+              <a:rPr lang="en-US"/>
               <a:t>Click to edit Master title style</a:t>
             </a:r>
-            <a:endParaRPr lang="en-US"/>
           </a:p>
         </p:txBody>
       </p:sp>
@@ -2666,38 +2662,37 @@
           <a:p>
             <a:pPr lvl="0"/>
             <a:r>
-              <a:rPr lang="en-US" smtClean="0"/>
+              <a:rPr lang="en-US"/>
               <a:t>Click to edit Master text styles</a:t>
             </a:r>
           </a:p>
           <a:p>
             <a:pPr lvl="1"/>
             <a:r>
-              <a:rPr lang="en-US" smtClean="0"/>
+              <a:rPr lang="en-US"/>
               <a:t>Second level</a:t>
             </a:r>
           </a:p>
           <a:p>
             <a:pPr lvl="2"/>
             <a:r>
-              <a:rPr lang="en-US" smtClean="0"/>
+              <a:rPr lang="en-US"/>
               <a:t>Third level</a:t>
             </a:r>
           </a:p>
           <a:p>
             <a:pPr lvl="3"/>
             <a:r>
-              <a:rPr lang="en-US" smtClean="0"/>
+              <a:rPr lang="en-US"/>
               <a:t>Fourth level</a:t>
             </a:r>
           </a:p>
           <a:p>
             <a:pPr lvl="4"/>
             <a:r>
-              <a:rPr lang="en-US" smtClean="0"/>
+              <a:rPr lang="en-US"/>
               <a:t>Fifth level</a:t>
             </a:r>
-            <a:endParaRPr lang="en-US"/>
           </a:p>
         </p:txBody>
       </p:sp>
@@ -2736,7 +2731,7 @@
           <a:p>
             <a:fld id="{5BCAD085-E8A6-8845-BD4E-CB4CCA059FC4}" type="datetimeFigureOut">
               <a:rPr lang="en-US" smtClean="0"/>
-              <a:t>1/27/13</a:t>
+              <a:t>4/12/2026</a:t>
             </a:fld>
             <a:endParaRPr lang="en-US"/>
           </a:p>
@@ -3095,7 +3090,7 @@
 </file>
 
 <file path=ppt/slides/slide1.xml><?xml version="1.0" encoding="utf-8"?>
-<p:sld xmlns:a="http://schemas.openxmlformats.org/drawingml/2006/main" xmlns:p="http://schemas.openxmlformats.org/presentationml/2006/main" xmlns:r="http://schemas.openxmlformats.org/officeDocument/2006/relationships">
+<p:sld xmlns:a="http://schemas.openxmlformats.org/drawingml/2006/main" xmlns:r="http://schemas.openxmlformats.org/officeDocument/2006/relationships" xmlns:p="http://schemas.openxmlformats.org/presentationml/2006/main">
   <p:cSld>
     <p:bg>
       <p:bgPr>
@@ -3111,7 +3106,14 @@
         <p:cNvGrpSpPr/>
         <p:nvPr/>
       </p:nvGrpSpPr>
-      <p:grpSpPr/>
+      <p:grpSpPr>
+        <a:xfrm>
+          <a:off x="0" y="0"/>
+          <a:ext cx="0" cy="0"/>
+          <a:chOff x="0" y="0"/>
+          <a:chExt cx="0" cy="0"/>
+        </a:xfrm>
+      </p:grpSpPr>
       <p:sp>
         <p:nvSpPr>
           <p:cNvPr id="2" name="Rectangle 1"/>
@@ -3152,6 +3154,7 @@
           <a:lstStyle/>
           <a:p>
             <a:pPr algn="ctr"/>
+            <a:endParaRPr/>
           </a:p>
         </p:txBody>
       </p:sp>
@@ -3186,6 +3189,7 @@
               </a:defRPr>
             </a:pPr>
             <a:r>
+              <a:rPr dirty="0"/>
               <a:t>GRIFFIN</a:t>
             </a:r>
           </a:p>
@@ -3205,6 +3209,7 @@
               </a:defRPr>
             </a:pPr>
             <a:r>
+              <a:rPr dirty="0"/>
               <a:t>HR Position Classification &amp; Pay Tool</a:t>
             </a:r>
           </a:p>
@@ -3250,6 +3255,7 @@
           <a:lstStyle/>
           <a:p>
             <a:pPr algn="ctr"/>
+            <a:endParaRPr/>
           </a:p>
         </p:txBody>
       </p:sp>
@@ -3352,6 +3358,7 @@
           <a:lstStyle/>
           <a:p>
             <a:pPr algn="ctr"/>
+            <a:endParaRPr/>
           </a:p>
         </p:txBody>
       </p:sp>
@@ -3455,7 +3462,7 @@
 </file>
 
 <file path=ppt/slides/slide10.xml><?xml version="1.0" encoding="utf-8"?>
-<p:sld xmlns:a="http://schemas.openxmlformats.org/drawingml/2006/main" xmlns:p="http://schemas.openxmlformats.org/presentationml/2006/main" xmlns:r="http://schemas.openxmlformats.org/officeDocument/2006/relationships">
+<p:sld xmlns:a="http://schemas.openxmlformats.org/drawingml/2006/main" xmlns:r="http://schemas.openxmlformats.org/officeDocument/2006/relationships" xmlns:p="http://schemas.openxmlformats.org/presentationml/2006/main">
   <p:cSld>
     <p:bg>
       <p:bgPr>
@@ -3471,7 +3478,14 @@
         <p:cNvGrpSpPr/>
         <p:nvPr/>
       </p:nvGrpSpPr>
-      <p:grpSpPr/>
+      <p:grpSpPr>
+        <a:xfrm>
+          <a:off x="0" y="0"/>
+          <a:ext cx="0" cy="0"/>
+          <a:chOff x="0" y="0"/>
+          <a:chExt cx="0" cy="0"/>
+        </a:xfrm>
+      </p:grpSpPr>
       <p:sp>
         <p:nvSpPr>
           <p:cNvPr id="2" name="TextBox 1"/>
@@ -3548,6 +3562,7 @@
           <a:lstStyle/>
           <a:p>
             <a:pPr algn="ctr"/>
+            <a:endParaRPr/>
           </a:p>
         </p:txBody>
       </p:sp>
@@ -3595,6 +3610,7 @@
           <a:lstStyle/>
           <a:p>
             <a:pPr algn="ctr"/>
+            <a:endParaRPr/>
           </a:p>
         </p:txBody>
       </p:sp>
@@ -3702,6 +3718,7 @@
                 <a:latin typeface="Calibri"/>
               </a:defRPr>
             </a:pPr>
+            <a:endParaRPr/>
           </a:p>
           <a:p>
             <a:pPr algn="l">
@@ -3794,6 +3811,7 @@
                 <a:latin typeface="Calibri"/>
               </a:defRPr>
             </a:pPr>
+            <a:endParaRPr/>
           </a:p>
           <a:p>
             <a:pPr algn="l">
@@ -3917,6 +3935,7 @@
           <a:lstStyle/>
           <a:p>
             <a:pPr algn="ctr"/>
+            <a:endParaRPr/>
           </a:p>
         </p:txBody>
       </p:sp>
@@ -4005,6 +4024,7 @@
                 <a:latin typeface="Calibri"/>
               </a:defRPr>
             </a:pPr>
+            <a:endParaRPr/>
           </a:p>
           <a:p>
             <a:pPr algn="l">
@@ -4078,6 +4098,7 @@
                 <a:latin typeface="Calibri"/>
               </a:defRPr>
             </a:pPr>
+            <a:endParaRPr/>
           </a:p>
           <a:p>
             <a:pPr algn="l">
@@ -4170,6 +4191,7 @@
                 <a:latin typeface="Calibri"/>
               </a:defRPr>
             </a:pPr>
+            <a:endParaRPr/>
           </a:p>
           <a:p>
             <a:pPr algn="l">
@@ -4255,6 +4277,7 @@
           <a:lstStyle/>
           <a:p>
             <a:pPr algn="ctr"/>
+            <a:endParaRPr/>
           </a:p>
         </p:txBody>
       </p:sp>
@@ -4343,6 +4366,7 @@
                 <a:latin typeface="Calibri"/>
               </a:defRPr>
             </a:pPr>
+            <a:endParaRPr/>
           </a:p>
           <a:p>
             <a:pPr algn="l">
@@ -4416,6 +4440,7 @@
                 <a:latin typeface="Calibri"/>
               </a:defRPr>
             </a:pPr>
+            <a:endParaRPr/>
           </a:p>
           <a:p>
             <a:pPr algn="l">
@@ -4508,6 +4533,7 @@
                 <a:latin typeface="Calibri"/>
               </a:defRPr>
             </a:pPr>
+            <a:endParaRPr/>
           </a:p>
           <a:p>
             <a:pPr algn="l">
@@ -4630,7 +4656,7 @@
 </file>
 
 <file path=ppt/slides/slide11.xml><?xml version="1.0" encoding="utf-8"?>
-<p:sld xmlns:a="http://schemas.openxmlformats.org/drawingml/2006/main" xmlns:p="http://schemas.openxmlformats.org/presentationml/2006/main" xmlns:r="http://schemas.openxmlformats.org/officeDocument/2006/relationships">
+<p:sld xmlns:a="http://schemas.openxmlformats.org/drawingml/2006/main" xmlns:r="http://schemas.openxmlformats.org/officeDocument/2006/relationships" xmlns:p="http://schemas.openxmlformats.org/presentationml/2006/main">
   <p:cSld>
     <p:bg>
       <p:bgPr>
@@ -4646,7 +4672,14 @@
         <p:cNvGrpSpPr/>
         <p:nvPr/>
       </p:nvGrpSpPr>
-      <p:grpSpPr/>
+      <p:grpSpPr>
+        <a:xfrm>
+          <a:off x="0" y="0"/>
+          <a:ext cx="0" cy="0"/>
+          <a:chOff x="0" y="0"/>
+          <a:chExt cx="0" cy="0"/>
+        </a:xfrm>
+      </p:grpSpPr>
       <p:sp>
         <p:nvSpPr>
           <p:cNvPr id="2" name="TextBox 1"/>
@@ -4723,6 +4756,7 @@
           <a:lstStyle/>
           <a:p>
             <a:pPr algn="ctr"/>
+            <a:endParaRPr/>
           </a:p>
         </p:txBody>
       </p:sp>
@@ -4770,6 +4804,7 @@
           <a:lstStyle/>
           <a:p>
             <a:pPr algn="ctr"/>
+            <a:endParaRPr/>
           </a:p>
         </p:txBody>
       </p:sp>
@@ -4877,6 +4912,7 @@
                 <a:latin typeface="Calibri"/>
               </a:defRPr>
             </a:pPr>
+            <a:endParaRPr/>
           </a:p>
           <a:p>
             <a:pPr algn="l">
@@ -4931,6 +4967,7 @@
                 <a:latin typeface="Calibri"/>
               </a:defRPr>
             </a:pPr>
+            <a:endParaRPr/>
           </a:p>
           <a:p>
             <a:pPr algn="l">
@@ -4966,6 +5003,7 @@
                 <a:latin typeface="Calibri"/>
               </a:defRPr>
             </a:pPr>
+            <a:endParaRPr/>
           </a:p>
           <a:p>
             <a:pPr algn="l">
@@ -5051,6 +5089,7 @@
           <a:lstStyle/>
           <a:p>
             <a:pPr algn="ctr"/>
+            <a:endParaRPr/>
           </a:p>
         </p:txBody>
       </p:sp>
@@ -5139,6 +5178,7 @@
                 <a:latin typeface="Calibri"/>
               </a:defRPr>
             </a:pPr>
+            <a:endParaRPr/>
           </a:p>
           <a:p>
             <a:pPr algn="l">
@@ -5212,6 +5252,7 @@
                 <a:latin typeface="Calibri"/>
               </a:defRPr>
             </a:pPr>
+            <a:endParaRPr/>
           </a:p>
           <a:p>
             <a:pPr algn="l">
@@ -5285,6 +5326,7 @@
                 <a:latin typeface="Calibri"/>
               </a:defRPr>
             </a:pPr>
+            <a:endParaRPr/>
           </a:p>
           <a:p>
             <a:pPr algn="l">
@@ -5320,6 +5362,7 @@
                 <a:latin typeface="Calibri"/>
               </a:defRPr>
             </a:pPr>
+            <a:endParaRPr/>
           </a:p>
           <a:p>
             <a:pPr algn="l">
@@ -5405,6 +5448,7 @@
           <a:lstStyle/>
           <a:p>
             <a:pPr algn="ctr"/>
+            <a:endParaRPr/>
           </a:p>
         </p:txBody>
       </p:sp>
@@ -5525,7 +5569,7 @@
 </file>
 
 <file path=ppt/slides/slide12.xml><?xml version="1.0" encoding="utf-8"?>
-<p:sld xmlns:a="http://schemas.openxmlformats.org/drawingml/2006/main" xmlns:p="http://schemas.openxmlformats.org/presentationml/2006/main" xmlns:r="http://schemas.openxmlformats.org/officeDocument/2006/relationships">
+<p:sld xmlns:a="http://schemas.openxmlformats.org/drawingml/2006/main" xmlns:r="http://schemas.openxmlformats.org/officeDocument/2006/relationships" xmlns:p="http://schemas.openxmlformats.org/presentationml/2006/main">
   <p:cSld>
     <p:bg>
       <p:bgPr>
@@ -5541,7 +5585,14 @@
         <p:cNvGrpSpPr/>
         <p:nvPr/>
       </p:nvGrpSpPr>
-      <p:grpSpPr/>
+      <p:grpSpPr>
+        <a:xfrm>
+          <a:off x="0" y="0"/>
+          <a:ext cx="0" cy="0"/>
+          <a:chOff x="0" y="0"/>
+          <a:chExt cx="0" cy="0"/>
+        </a:xfrm>
+      </p:grpSpPr>
       <p:sp>
         <p:nvSpPr>
           <p:cNvPr id="2" name="TextBox 1"/>
@@ -5618,6 +5669,7 @@
           <a:lstStyle/>
           <a:p>
             <a:pPr algn="ctr"/>
+            <a:endParaRPr/>
           </a:p>
         </p:txBody>
       </p:sp>
@@ -5665,6 +5717,7 @@
           <a:lstStyle/>
           <a:p>
             <a:pPr algn="ctr"/>
+            <a:endParaRPr/>
           </a:p>
         </p:txBody>
       </p:sp>
@@ -5772,6 +5825,7 @@
           <a:lstStyle/>
           <a:p>
             <a:pPr algn="ctr"/>
+            <a:endParaRPr/>
           </a:p>
         </p:txBody>
       </p:sp>
@@ -5880,7 +5934,7 @@
 </file>
 
 <file path=ppt/slides/slide13.xml><?xml version="1.0" encoding="utf-8"?>
-<p:sld xmlns:a="http://schemas.openxmlformats.org/drawingml/2006/main" xmlns:p="http://schemas.openxmlformats.org/presentationml/2006/main" xmlns:r="http://schemas.openxmlformats.org/officeDocument/2006/relationships">
+<p:sld xmlns:a="http://schemas.openxmlformats.org/drawingml/2006/main" xmlns:r="http://schemas.openxmlformats.org/officeDocument/2006/relationships" xmlns:p="http://schemas.openxmlformats.org/presentationml/2006/main">
   <p:cSld>
     <p:bg>
       <p:bgPr>
@@ -5896,7 +5950,14 @@
         <p:cNvGrpSpPr/>
         <p:nvPr/>
       </p:nvGrpSpPr>
-      <p:grpSpPr/>
+      <p:grpSpPr>
+        <a:xfrm>
+          <a:off x="0" y="0"/>
+          <a:ext cx="0" cy="0"/>
+          <a:chOff x="0" y="0"/>
+          <a:chExt cx="0" cy="0"/>
+        </a:xfrm>
+      </p:grpSpPr>
       <p:sp>
         <p:nvSpPr>
           <p:cNvPr id="2" name="TextBox 1"/>
@@ -5973,6 +6034,7 @@
           <a:lstStyle/>
           <a:p>
             <a:pPr algn="ctr"/>
+            <a:endParaRPr/>
           </a:p>
         </p:txBody>
       </p:sp>
@@ -6020,6 +6082,7 @@
           <a:lstStyle/>
           <a:p>
             <a:pPr algn="ctr"/>
+            <a:endParaRPr/>
           </a:p>
         </p:txBody>
       </p:sp>
@@ -6127,6 +6190,7 @@
           <a:lstStyle/>
           <a:p>
             <a:pPr algn="ctr"/>
+            <a:endParaRPr/>
           </a:p>
         </p:txBody>
       </p:sp>
@@ -6235,7 +6299,7 @@
 </file>
 
 <file path=ppt/slides/slide14.xml><?xml version="1.0" encoding="utf-8"?>
-<p:sld xmlns:a="http://schemas.openxmlformats.org/drawingml/2006/main" xmlns:p="http://schemas.openxmlformats.org/presentationml/2006/main" xmlns:r="http://schemas.openxmlformats.org/officeDocument/2006/relationships">
+<p:sld xmlns:a="http://schemas.openxmlformats.org/drawingml/2006/main" xmlns:r="http://schemas.openxmlformats.org/officeDocument/2006/relationships" xmlns:p="http://schemas.openxmlformats.org/presentationml/2006/main">
   <p:cSld>
     <p:bg>
       <p:bgPr>
@@ -6251,7 +6315,14 @@
         <p:cNvGrpSpPr/>
         <p:nvPr/>
       </p:nvGrpSpPr>
-      <p:grpSpPr/>
+      <p:grpSpPr>
+        <a:xfrm>
+          <a:off x="0" y="0"/>
+          <a:ext cx="0" cy="0"/>
+          <a:chOff x="0" y="0"/>
+          <a:chExt cx="0" cy="0"/>
+        </a:xfrm>
+      </p:grpSpPr>
       <p:sp>
         <p:nvSpPr>
           <p:cNvPr id="2" name="TextBox 1"/>
@@ -6328,6 +6399,7 @@
           <a:lstStyle/>
           <a:p>
             <a:pPr algn="ctr"/>
+            <a:endParaRPr/>
           </a:p>
         </p:txBody>
       </p:sp>
@@ -6375,6 +6447,7 @@
           <a:lstStyle/>
           <a:p>
             <a:pPr algn="ctr"/>
+            <a:endParaRPr/>
           </a:p>
         </p:txBody>
       </p:sp>
@@ -6482,6 +6555,7 @@
           <a:lstStyle/>
           <a:p>
             <a:pPr algn="ctr"/>
+            <a:endParaRPr/>
           </a:p>
         </p:txBody>
       </p:sp>
@@ -6518,7 +6592,7 @@
         <p:spPr>
           <a:xfrm>
             <a:off x="6233007" y="3579917"/>
-            <a:ext cx="5212080" cy="548640"/>
+            <a:ext cx="5212080" cy="292388"/>
           </a:xfrm>
           <a:prstGeom prst="rect">
             <a:avLst/>
@@ -6590,7 +6664,7 @@
 </file>
 
 <file path=ppt/slides/slide15.xml><?xml version="1.0" encoding="utf-8"?>
-<p:sld xmlns:a="http://schemas.openxmlformats.org/drawingml/2006/main" xmlns:p="http://schemas.openxmlformats.org/presentationml/2006/main" xmlns:r="http://schemas.openxmlformats.org/officeDocument/2006/relationships">
+<p:sld xmlns:a="http://schemas.openxmlformats.org/drawingml/2006/main" xmlns:r="http://schemas.openxmlformats.org/officeDocument/2006/relationships" xmlns:p="http://schemas.openxmlformats.org/presentationml/2006/main">
   <p:cSld>
     <p:bg>
       <p:bgPr>
@@ -6606,7 +6680,14 @@
         <p:cNvGrpSpPr/>
         <p:nvPr/>
       </p:nvGrpSpPr>
-      <p:grpSpPr/>
+      <p:grpSpPr>
+        <a:xfrm>
+          <a:off x="0" y="0"/>
+          <a:ext cx="0" cy="0"/>
+          <a:chOff x="0" y="0"/>
+          <a:chExt cx="0" cy="0"/>
+        </a:xfrm>
+      </p:grpSpPr>
       <p:sp>
         <p:nvSpPr>
           <p:cNvPr id="2" name="TextBox 1"/>
@@ -6683,6 +6764,7 @@
           <a:lstStyle/>
           <a:p>
             <a:pPr algn="ctr"/>
+            <a:endParaRPr/>
           </a:p>
         </p:txBody>
       </p:sp>
@@ -6730,6 +6812,7 @@
           <a:lstStyle/>
           <a:p>
             <a:pPr algn="ctr"/>
+            <a:endParaRPr/>
           </a:p>
         </p:txBody>
       </p:sp>
@@ -6857,6 +6940,7 @@
           <a:lstStyle/>
           <a:p>
             <a:pPr algn="ctr"/>
+            <a:endParaRPr/>
           </a:p>
         </p:txBody>
       </p:sp>
@@ -6984,6 +7068,7 @@
           <a:lstStyle/>
           <a:p>
             <a:pPr algn="ctr"/>
+            <a:endParaRPr/>
           </a:p>
         </p:txBody>
       </p:sp>
@@ -7111,6 +7196,7 @@
           <a:lstStyle/>
           <a:p>
             <a:pPr algn="ctr"/>
+            <a:endParaRPr/>
           </a:p>
         </p:txBody>
       </p:sp>
@@ -7238,6 +7324,7 @@
           <a:lstStyle/>
           <a:p>
             <a:pPr algn="ctr"/>
+            <a:endParaRPr/>
           </a:p>
         </p:txBody>
       </p:sp>
@@ -7373,6 +7460,7 @@
           <a:lstStyle/>
           <a:p>
             <a:pPr algn="ctr"/>
+            <a:endParaRPr/>
           </a:p>
         </p:txBody>
       </p:sp>
@@ -7537,7 +7625,7 @@
 </file>
 
 <file path=ppt/slides/slide16.xml><?xml version="1.0" encoding="utf-8"?>
-<p:sld xmlns:a="http://schemas.openxmlformats.org/drawingml/2006/main" xmlns:p="http://schemas.openxmlformats.org/presentationml/2006/main" xmlns:r="http://schemas.openxmlformats.org/officeDocument/2006/relationships">
+<p:sld xmlns:a="http://schemas.openxmlformats.org/drawingml/2006/main" xmlns:r="http://schemas.openxmlformats.org/officeDocument/2006/relationships" xmlns:p="http://schemas.openxmlformats.org/presentationml/2006/main">
   <p:cSld>
     <p:bg>
       <p:bgPr>
@@ -7553,7 +7641,14 @@
         <p:cNvGrpSpPr/>
         <p:nvPr/>
       </p:nvGrpSpPr>
-      <p:grpSpPr/>
+      <p:grpSpPr>
+        <a:xfrm>
+          <a:off x="0" y="0"/>
+          <a:ext cx="0" cy="0"/>
+          <a:chOff x="0" y="0"/>
+          <a:chExt cx="0" cy="0"/>
+        </a:xfrm>
+      </p:grpSpPr>
       <p:sp>
         <p:nvSpPr>
           <p:cNvPr id="2" name="TextBox 1"/>
@@ -7630,6 +7725,7 @@
           <a:lstStyle/>
           <a:p>
             <a:pPr algn="ctr"/>
+            <a:endParaRPr/>
           </a:p>
         </p:txBody>
       </p:sp>
@@ -7677,6 +7773,7 @@
           <a:lstStyle/>
           <a:p>
             <a:pPr algn="ctr"/>
+            <a:endParaRPr/>
           </a:p>
         </p:txBody>
       </p:sp>
@@ -7822,6 +7919,7 @@
                 <a:latin typeface="Calibri"/>
               </a:defRPr>
             </a:pPr>
+            <a:endParaRPr/>
           </a:p>
           <a:p>
             <a:pPr algn="l">
@@ -7914,6 +8012,7 @@
                 <a:latin typeface="Calibri"/>
               </a:defRPr>
             </a:pPr>
+            <a:endParaRPr/>
           </a:p>
           <a:p>
             <a:pPr algn="l">
@@ -7999,6 +8098,7 @@
           <a:lstStyle/>
           <a:p>
             <a:pPr algn="ctr"/>
+            <a:endParaRPr/>
           </a:p>
         </p:txBody>
       </p:sp>
@@ -8144,6 +8244,7 @@
                 <a:latin typeface="Calibri"/>
               </a:defRPr>
             </a:pPr>
+            <a:endParaRPr/>
           </a:p>
           <a:p>
             <a:pPr algn="l">
@@ -8267,6 +8368,7 @@
           <a:lstStyle/>
           <a:p>
             <a:pPr algn="ctr"/>
+            <a:endParaRPr/>
           </a:p>
         </p:txBody>
       </p:sp>
@@ -8412,6 +8514,7 @@
                 <a:latin typeface="Calibri"/>
               </a:defRPr>
             </a:pPr>
+            <a:endParaRPr/>
           </a:p>
           <a:p>
             <a:pPr algn="l">
@@ -8567,6 +8670,7 @@
           <a:lstStyle/>
           <a:p>
             <a:pPr algn="ctr"/>
+            <a:endParaRPr/>
           </a:p>
         </p:txBody>
       </p:sp>
@@ -8651,7 +8755,7 @@
 </file>
 
 <file path=ppt/slides/slide17.xml><?xml version="1.0" encoding="utf-8"?>
-<p:sld xmlns:a="http://schemas.openxmlformats.org/drawingml/2006/main" xmlns:p="http://schemas.openxmlformats.org/presentationml/2006/main" xmlns:r="http://schemas.openxmlformats.org/officeDocument/2006/relationships">
+<p:sld xmlns:a="http://schemas.openxmlformats.org/drawingml/2006/main" xmlns:r="http://schemas.openxmlformats.org/officeDocument/2006/relationships" xmlns:p="http://schemas.openxmlformats.org/presentationml/2006/main">
   <p:cSld>
     <p:bg>
       <p:bgPr>
@@ -8667,7 +8771,14 @@
         <p:cNvGrpSpPr/>
         <p:nvPr/>
       </p:nvGrpSpPr>
-      <p:grpSpPr/>
+      <p:grpSpPr>
+        <a:xfrm>
+          <a:off x="0" y="0"/>
+          <a:ext cx="0" cy="0"/>
+          <a:chOff x="0" y="0"/>
+          <a:chExt cx="0" cy="0"/>
+        </a:xfrm>
+      </p:grpSpPr>
       <p:sp>
         <p:nvSpPr>
           <p:cNvPr id="2" name="TextBox 1"/>
@@ -8744,6 +8855,7 @@
           <a:lstStyle/>
           <a:p>
             <a:pPr algn="ctr"/>
+            <a:endParaRPr/>
           </a:p>
         </p:txBody>
       </p:sp>
@@ -8791,6 +8903,7 @@
           <a:lstStyle/>
           <a:p>
             <a:pPr algn="ctr"/>
+            <a:endParaRPr/>
           </a:p>
         </p:txBody>
       </p:sp>
@@ -8843,6 +8956,7 @@
                 <a:latin typeface="Calibri"/>
               </a:defRPr>
             </a:pPr>
+            <a:endParaRPr/>
           </a:p>
           <a:p>
             <a:pPr algn="l">
@@ -9004,6 +9118,7 @@
           <a:lstStyle/>
           <a:p>
             <a:pPr algn="ctr"/>
+            <a:endParaRPr/>
           </a:p>
         </p:txBody>
       </p:sp>
@@ -9016,7 +9131,7 @@
         <p:spPr>
           <a:xfrm>
             <a:off x="6629400" y="1325880"/>
-            <a:ext cx="4846320" cy="1920240"/>
+            <a:ext cx="2965450" cy="1759456"/>
           </a:xfrm>
           <a:prstGeom prst="rect">
             <a:avLst/>
@@ -9038,6 +9153,7 @@
               </a:defRPr>
             </a:pPr>
             <a:r>
+              <a:rPr dirty="0"/>
               <a:t>TECHNOLOGIES</a:t>
             </a:r>
           </a:p>
@@ -9056,6 +9172,7 @@
                 <a:latin typeface="Calibri"/>
               </a:defRPr>
             </a:pPr>
+            <a:endParaRPr dirty="0"/>
           </a:p>
           <a:p>
             <a:pPr algn="l">
@@ -9073,8 +9190,22 @@
               </a:defRPr>
             </a:pPr>
             <a:r>
-              <a:t>H2O AutoML  —  docs.h2o.ai</a:t>
-            </a:r>
+              <a:rPr dirty="0"/>
+              <a:t>H2O </a:t>
+            </a:r>
+            <a:r>
+              <a:rPr dirty="0" err="1"/>
+              <a:t>AutoML</a:t>
+            </a:r>
+            <a:r>
+              <a:rPr dirty="0"/>
+              <a:t>  —  docs.h2o.ai</a:t>
+            </a:r>
+            <a:r>
+              <a:rPr lang="en-US" dirty="0"/>
+              <a:t>		</a:t>
+            </a:r>
+            <a:endParaRPr dirty="0"/>
           </a:p>
           <a:p>
             <a:pPr algn="l">
@@ -9092,6 +9223,7 @@
               </a:defRPr>
             </a:pPr>
             <a:r>
+              <a:rPr dirty="0"/>
               <a:t>Automated machine learning</a:t>
             </a:r>
           </a:p>
@@ -9111,7 +9243,12 @@
               </a:defRPr>
             </a:pPr>
             <a:r>
-              <a:t>LangChain  —  python.langchain.com</a:t>
+              <a:rPr dirty="0" err="1"/>
+              <a:t>LangChain</a:t>
+            </a:r>
+            <a:r>
+              <a:rPr dirty="0"/>
+              <a:t>  —  python.langchain.com</a:t>
             </a:r>
           </a:p>
           <a:p>
@@ -9130,6 +9267,7 @@
               </a:defRPr>
             </a:pPr>
             <a:r>
+              <a:rPr dirty="0"/>
               <a:t>Multi-agent orchestration</a:t>
             </a:r>
           </a:p>
@@ -9149,8 +9287,14 @@
               </a:defRPr>
             </a:pPr>
             <a:r>
-              <a:t>Google Gemini API  —  ai.google.dev</a:t>
-            </a:r>
+              <a:rPr lang="en-US" dirty="0"/>
+              <a:t>Google Gemini API  —  </a:t>
+            </a:r>
+            <a:r>
+              <a:rPr lang="en-US" dirty="0" err="1"/>
+              <a:t>ai.google.dev</a:t>
+            </a:r>
+            <a:endParaRPr lang="en-US" dirty="0"/>
           </a:p>
           <a:p>
             <a:pPr algn="l">
@@ -9168,121 +9312,8 @@
               </a:defRPr>
             </a:pPr>
             <a:r>
+              <a:rPr lang="en-US" dirty="0"/>
               <a:t>LLM classification</a:t>
-            </a:r>
-          </a:p>
-          <a:p>
-            <a:pPr algn="l">
-              <a:spcBef>
-                <a:spcPts val="400"/>
-              </a:spcBef>
-              <a:spcAft>
-                <a:spcPts val="0"/>
-              </a:spcAft>
-              <a:defRPr sz="1300" b="1">
-                <a:solidFill>
-                  <a:srgbClr val="2D2D2D"/>
-                </a:solidFill>
-                <a:latin typeface="Calibri"/>
-              </a:defRPr>
-            </a:pPr>
-            <a:r>
-              <a:t>SHAP  —  shap.readthedocs.io</a:t>
-            </a:r>
-          </a:p>
-          <a:p>
-            <a:pPr algn="l">
-              <a:spcBef>
-                <a:spcPts val="0"/>
-              </a:spcBef>
-              <a:spcAft>
-                <a:spcPts val="100"/>
-              </a:spcAft>
-              <a:defRPr sz="1200" b="0">
-                <a:solidFill>
-                  <a:srgbClr val="5A5A5A"/>
-                </a:solidFill>
-                <a:latin typeface="Calibri"/>
-              </a:defRPr>
-            </a:pPr>
-            <a:r>
-              <a:t>ML explainability</a:t>
-            </a:r>
-          </a:p>
-          <a:p>
-            <a:pPr algn="l">
-              <a:spcBef>
-                <a:spcPts val="400"/>
-              </a:spcBef>
-              <a:spcAft>
-                <a:spcPts val="0"/>
-              </a:spcAft>
-              <a:defRPr sz="1300" b="1">
-                <a:solidFill>
-                  <a:srgbClr val="2D2D2D"/>
-                </a:solidFill>
-                <a:latin typeface="Calibri"/>
-              </a:defRPr>
-            </a:pPr>
-            <a:r>
-              <a:t>Streamlit  —  streamlit.io</a:t>
-            </a:r>
-          </a:p>
-          <a:p>
-            <a:pPr algn="l">
-              <a:spcBef>
-                <a:spcPts val="0"/>
-              </a:spcBef>
-              <a:spcAft>
-                <a:spcPts val="100"/>
-              </a:spcAft>
-              <a:defRPr sz="1200" b="0">
-                <a:solidFill>
-                  <a:srgbClr val="5A5A5A"/>
-                </a:solidFill>
-                <a:latin typeface="Calibri"/>
-              </a:defRPr>
-            </a:pPr>
-            <a:r>
-              <a:t>Web application framework</a:t>
-            </a:r>
-          </a:p>
-          <a:p>
-            <a:pPr algn="l">
-              <a:spcBef>
-                <a:spcPts val="400"/>
-              </a:spcBef>
-              <a:spcAft>
-                <a:spcPts val="0"/>
-              </a:spcAft>
-              <a:defRPr sz="1300" b="1">
-                <a:solidFill>
-                  <a:srgbClr val="2D2D2D"/>
-                </a:solidFill>
-                <a:latin typeface="Calibri"/>
-              </a:defRPr>
-            </a:pPr>
-            <a:r>
-              <a:t>SQLAlchemy  —  sqlalchemy.org</a:t>
-            </a:r>
-          </a:p>
-          <a:p>
-            <a:pPr algn="l">
-              <a:spcBef>
-                <a:spcPts val="0"/>
-              </a:spcBef>
-              <a:spcAft>
-                <a:spcPts val="100"/>
-              </a:spcAft>
-              <a:defRPr sz="1200" b="0">
-                <a:solidFill>
-                  <a:srgbClr val="5A5A5A"/>
-                </a:solidFill>
-                <a:latin typeface="Calibri"/>
-              </a:defRPr>
-            </a:pPr>
-            <a:r>
-              <a:t>Database ORM</a:t>
             </a:r>
           </a:p>
         </p:txBody>
@@ -9331,6 +9362,7 @@
           <a:lstStyle/>
           <a:p>
             <a:pPr algn="ctr"/>
+            <a:endParaRPr/>
           </a:p>
         </p:txBody>
       </p:sp>
@@ -9383,6 +9415,7 @@
                 <a:latin typeface="Calibri"/>
               </a:defRPr>
             </a:pPr>
+            <a:endParaRPr/>
           </a:p>
           <a:p>
             <a:pPr algn="l">
@@ -9407,61 +9440,14 @@
       </p:sp>
       <p:sp>
         <p:nvSpPr>
-          <p:cNvPr id="10" name="Rounded Rectangle 9"/>
-          <p:cNvSpPr/>
-          <p:nvPr/>
-        </p:nvSpPr>
-        <p:spPr>
-          <a:xfrm>
-            <a:off x="731520" y="5074920"/>
-            <a:ext cx="10972800" cy="731520"/>
-          </a:xfrm>
-          <a:prstGeom prst="roundRect">
-            <a:avLst>
-              <a:gd name="adj" fmla="val 5000"/>
-            </a:avLst>
-          </a:prstGeom>
-          <a:solidFill>
-            <a:srgbClr val="F5F3EE"/>
-          </a:solidFill>
-          <a:ln w="19050">
-            <a:solidFill>
-              <a:srgbClr val="E0DBD0"/>
-            </a:solidFill>
-          </a:ln>
-        </p:spPr>
-        <p:style>
-          <a:lnRef idx="1">
-            <a:schemeClr val="accent1"/>
-          </a:lnRef>
-          <a:fillRef idx="3">
-            <a:schemeClr val="accent1"/>
-          </a:fillRef>
-          <a:effectRef idx="2">
-            <a:schemeClr val="accent1"/>
-          </a:effectRef>
-          <a:fontRef idx="minor">
-            <a:schemeClr val="lt1"/>
-          </a:fontRef>
-        </p:style>
-        <p:txBody>
-          <a:bodyPr rtlCol="0" anchor="ctr"/>
-          <a:lstStyle/>
-          <a:p>
-            <a:pPr algn="ctr"/>
-          </a:p>
-        </p:txBody>
-      </p:sp>
-      <p:sp>
-        <p:nvSpPr>
-          <p:cNvPr id="11" name="TextBox 10"/>
+          <p:cNvPr id="12" name="TextBox 11"/>
           <p:cNvSpPr txBox="1"/>
           <p:nvPr/>
         </p:nvSpPr>
         <p:spPr>
           <a:xfrm>
-            <a:off x="1005840" y="5184648"/>
-            <a:ext cx="10424160" cy="548640"/>
+            <a:off x="11094415" y="6446520"/>
+            <a:ext cx="914400" cy="274320"/>
           </a:xfrm>
           <a:prstGeom prst="rect">
             <a:avLst/>
@@ -9474,27 +9460,8 @@
           </a:bodyPr>
           <a:lstStyle/>
           <a:p>
-            <a:pPr algn="l">
-              <a:defRPr sz="1400" b="1">
-                <a:solidFill>
-                  <a:srgbClr val="115740"/>
-                </a:solidFill>
-                <a:latin typeface="Calibri"/>
-              </a:defRPr>
-            </a:pPr>
-            <a:r>
-              <a:t>RESEARCH PAPER</a:t>
-            </a:r>
-          </a:p>
-          <a:p>
-            <a:pPr algn="l">
-              <a:spcBef>
-                <a:spcPts val="400"/>
-              </a:spcBef>
-              <a:spcAft>
-                <a:spcPts val="200"/>
-              </a:spcAft>
-              <a:defRPr sz="1300" b="0">
+            <a:pPr algn="r">
+              <a:defRPr sz="1000" b="0">
                 <a:solidFill>
                   <a:srgbClr val="5A5A5A"/>
                 </a:solidFill>
@@ -9502,21 +9469,27 @@
               </a:defRPr>
             </a:pPr>
             <a:r>
-              <a:t>[Team will add citation]</a:t>
-            </a:r>
-          </a:p>
-        </p:txBody>
-      </p:sp>
-      <p:sp>
-        <p:nvSpPr>
-          <p:cNvPr id="12" name="TextBox 11"/>
+              <a:t>17 / 17</a:t>
+            </a:r>
+          </a:p>
+        </p:txBody>
+      </p:sp>
+      <p:sp>
+        <p:nvSpPr>
+          <p:cNvPr id="13" name="TextBox 12">
+            <a:extLst>
+              <a:ext uri="{FF2B5EF4-FFF2-40B4-BE49-F238E27FC236}">
+                <a16:creationId xmlns:a16="http://schemas.microsoft.com/office/drawing/2014/main" id="{9D2DCF6F-5D62-FC05-DA13-89ED6DB336AA}"/>
+              </a:ext>
+            </a:extLst>
+          </p:cNvPr>
           <p:cNvSpPr txBox="1"/>
           <p:nvPr/>
         </p:nvSpPr>
         <p:spPr>
           <a:xfrm>
-            <a:off x="11094415" y="6446520"/>
-            <a:ext cx="914400" cy="274320"/>
+            <a:off x="9391650" y="1510303"/>
+            <a:ext cx="2400300" cy="1741502"/>
           </a:xfrm>
           <a:prstGeom prst="rect">
             <a:avLst/>
@@ -9529,8 +9502,45 @@
           </a:bodyPr>
           <a:lstStyle/>
           <a:p>
-            <a:pPr algn="r">
-              <a:defRPr sz="1000" b="0">
+            <a:pPr algn="l">
+              <a:spcBef>
+                <a:spcPts val="200"/>
+              </a:spcBef>
+              <a:spcAft>
+                <a:spcPts val="200"/>
+              </a:spcAft>
+              <a:defRPr sz="600" b="0">
+                <a:solidFill>
+                  <a:srgbClr val="2D2D2D"/>
+                </a:solidFill>
+                <a:latin typeface="Calibri"/>
+              </a:defRPr>
+            </a:pPr>
+            <a:endParaRPr dirty="0"/>
+          </a:p>
+          <a:p>
+            <a:pPr>
+              <a:spcBef>
+                <a:spcPts val="400"/>
+              </a:spcBef>
+              <a:defRPr sz="1300" b="1">
+                <a:solidFill>
+                  <a:srgbClr val="2D2D2D"/>
+                </a:solidFill>
+                <a:latin typeface="Calibri"/>
+              </a:defRPr>
+            </a:pPr>
+            <a:r>
+              <a:rPr lang="en-US" dirty="0"/>
+              <a:t>SHAP  —  shap.readthedocs.io</a:t>
+            </a:r>
+          </a:p>
+          <a:p>
+            <a:pPr>
+              <a:spcAft>
+                <a:spcPts val="100"/>
+              </a:spcAft>
+              <a:defRPr sz="1200" b="0">
                 <a:solidFill>
                   <a:srgbClr val="5A5A5A"/>
                 </a:solidFill>
@@ -9538,8 +9548,102 @@
               </a:defRPr>
             </a:pPr>
             <a:r>
-              <a:t>17 / 17</a:t>
-            </a:r>
+              <a:rPr lang="en-US" dirty="0"/>
+              <a:t>ML explainability</a:t>
+            </a:r>
+          </a:p>
+          <a:p>
+            <a:pPr>
+              <a:spcBef>
+                <a:spcPts val="400"/>
+              </a:spcBef>
+              <a:defRPr sz="1300" b="1">
+                <a:solidFill>
+                  <a:srgbClr val="2D2D2D"/>
+                </a:solidFill>
+                <a:latin typeface="Calibri"/>
+              </a:defRPr>
+            </a:pPr>
+            <a:r>
+              <a:rPr lang="en-US" dirty="0" err="1"/>
+              <a:t>Streamlit</a:t>
+            </a:r>
+            <a:r>
+              <a:rPr lang="en-US" dirty="0"/>
+              <a:t>  —  streamlit.io</a:t>
+            </a:r>
+          </a:p>
+          <a:p>
+            <a:pPr>
+              <a:spcAft>
+                <a:spcPts val="100"/>
+              </a:spcAft>
+              <a:defRPr sz="1200" b="0">
+                <a:solidFill>
+                  <a:srgbClr val="5A5A5A"/>
+                </a:solidFill>
+                <a:latin typeface="Calibri"/>
+              </a:defRPr>
+            </a:pPr>
+            <a:r>
+              <a:rPr lang="en-US" dirty="0"/>
+              <a:t>Web application framework</a:t>
+            </a:r>
+          </a:p>
+          <a:p>
+            <a:pPr>
+              <a:spcBef>
+                <a:spcPts val="400"/>
+              </a:spcBef>
+              <a:defRPr sz="1300" b="1">
+                <a:solidFill>
+                  <a:srgbClr val="2D2D2D"/>
+                </a:solidFill>
+                <a:latin typeface="Calibri"/>
+              </a:defRPr>
+            </a:pPr>
+            <a:r>
+              <a:rPr lang="en-US" dirty="0" err="1"/>
+              <a:t>SQLAlchemy</a:t>
+            </a:r>
+            <a:r>
+              <a:rPr lang="en-US" dirty="0"/>
+              <a:t>  —  sqlalchemy.org</a:t>
+            </a:r>
+          </a:p>
+          <a:p>
+            <a:pPr>
+              <a:spcAft>
+                <a:spcPts val="100"/>
+              </a:spcAft>
+              <a:defRPr sz="1200" b="0">
+                <a:solidFill>
+                  <a:srgbClr val="5A5A5A"/>
+                </a:solidFill>
+                <a:latin typeface="Calibri"/>
+              </a:defRPr>
+            </a:pPr>
+            <a:r>
+              <a:rPr lang="en-US" dirty="0"/>
+              <a:t>Database ORM</a:t>
+            </a:r>
+          </a:p>
+          <a:p>
+            <a:pPr algn="l">
+              <a:spcBef>
+                <a:spcPts val="0"/>
+              </a:spcBef>
+              <a:spcAft>
+                <a:spcPts val="100"/>
+              </a:spcAft>
+              <a:defRPr sz="1200" b="0">
+                <a:solidFill>
+                  <a:srgbClr val="5A5A5A"/>
+                </a:solidFill>
+                <a:latin typeface="Calibri"/>
+              </a:defRPr>
+            </a:pPr>
+            <a:endParaRPr lang="en-US" dirty="0"/>
           </a:p>
         </p:txBody>
       </p:sp>
@@ -9552,7 +9656,7 @@
 </file>
 
 <file path=ppt/slides/slide2.xml><?xml version="1.0" encoding="utf-8"?>
-<p:sld xmlns:a="http://schemas.openxmlformats.org/drawingml/2006/main" xmlns:p="http://schemas.openxmlformats.org/presentationml/2006/main" xmlns:r="http://schemas.openxmlformats.org/officeDocument/2006/relationships">
+<p:sld xmlns:a="http://schemas.openxmlformats.org/drawingml/2006/main" xmlns:r="http://schemas.openxmlformats.org/officeDocument/2006/relationships" xmlns:p="http://schemas.openxmlformats.org/presentationml/2006/main">
   <p:cSld>
     <p:bg>
       <p:bgPr>
@@ -9568,7 +9672,14 @@
         <p:cNvGrpSpPr/>
         <p:nvPr/>
       </p:nvGrpSpPr>
-      <p:grpSpPr/>
+      <p:grpSpPr>
+        <a:xfrm>
+          <a:off x="0" y="0"/>
+          <a:ext cx="0" cy="0"/>
+          <a:chOff x="0" y="0"/>
+          <a:chExt cx="0" cy="0"/>
+        </a:xfrm>
+      </p:grpSpPr>
       <p:sp>
         <p:nvSpPr>
           <p:cNvPr id="2" name="TextBox 1"/>
@@ -9645,6 +9756,7 @@
           <a:lstStyle/>
           <a:p>
             <a:pPr algn="ctr"/>
+            <a:endParaRPr/>
           </a:p>
         </p:txBody>
       </p:sp>
@@ -9692,6 +9804,7 @@
           <a:lstStyle/>
           <a:p>
             <a:pPr algn="ctr"/>
+            <a:endParaRPr/>
           </a:p>
         </p:txBody>
       </p:sp>
@@ -9740,7 +9853,7 @@
         <p:spPr>
           <a:xfrm>
             <a:off x="792327" y="1828800"/>
-            <a:ext cx="3017520" cy="3474720"/>
+            <a:ext cx="3017520" cy="3357329"/>
           </a:xfrm>
           <a:prstGeom prst="rect">
             <a:avLst/>
@@ -9762,7 +9875,34 @@
               </a:defRPr>
             </a:pPr>
             <a:r>
-              <a:t>William &amp; Mary’s HR is under resourced and struggle to meet classification and compensation setting for current vacancies as well as periodically updating existing positions. These position descriptions must be classified against 500+ position descriptions into Virginia DHRM career groups and pay bands, translated to W&amp;M’s pay scale, and must be competitive enough to attract high quality applicants.</a:t>
+              <a:rPr b="1" dirty="0"/>
+              <a:t>William &amp; Mary’s HR is under resourced and struggle to meet classification and compensation setting for current vacancies as well as periodically updating existing positions. </a:t>
+            </a:r>
+            <a:endParaRPr lang="en-US" b="1" dirty="0"/>
+          </a:p>
+          <a:p>
+            <a:pPr algn="l">
+              <a:defRPr sz="1300" b="0">
+                <a:solidFill>
+                  <a:srgbClr val="2D2D2D"/>
+                </a:solidFill>
+                <a:latin typeface="Calibri"/>
+              </a:defRPr>
+            </a:pPr>
+            <a:endParaRPr lang="en-US" dirty="0"/>
+          </a:p>
+          <a:p>
+            <a:pPr algn="l">
+              <a:defRPr sz="1300" b="0">
+                <a:solidFill>
+                  <a:srgbClr val="2D2D2D"/>
+                </a:solidFill>
+                <a:latin typeface="Calibri"/>
+              </a:defRPr>
+            </a:pPr>
+            <a:r>
+              <a:rPr dirty="0"/>
+              <a:t>These position descriptions must be classified against 500+ position descriptions into Virginia DHRM career groups and pay bands, translated to W&amp;M’s pay scale, and must be competitive enough to attract high quality applicants.</a:t>
             </a:r>
           </a:p>
           <a:p>
@@ -9780,6 +9920,7 @@
                 <a:latin typeface="Calibri"/>
               </a:defRPr>
             </a:pPr>
+            <a:endParaRPr dirty="0"/>
           </a:p>
           <a:p>
             <a:pPr algn="l">
@@ -9797,6 +9938,7 @@
               </a:defRPr>
             </a:pPr>
             <a:r>
+              <a:rPr dirty="0"/>
               <a:t>Manual classification is time-intensive and inconsistent across reviewers.</a:t>
             </a:r>
           </a:p>
@@ -9846,6 +9988,7 @@
           <a:lstStyle/>
           <a:p>
             <a:pPr algn="ctr"/>
+            <a:endParaRPr/>
           </a:p>
         </p:txBody>
       </p:sp>
@@ -9894,7 +10037,7 @@
         <p:spPr>
           <a:xfrm>
             <a:off x="4587087" y="1828800"/>
-            <a:ext cx="3017520" cy="3474720"/>
+            <a:ext cx="3017520" cy="3349635"/>
           </a:xfrm>
           <a:prstGeom prst="rect">
             <a:avLst/>
@@ -9916,6 +10059,7 @@
               </a:defRPr>
             </a:pPr>
             <a:r>
+              <a:rPr b="1" dirty="0"/>
               <a:t>GRIFFIN — an AI-powered classification &amp; pay setting recommendation system combining:</a:t>
             </a:r>
           </a:p>
@@ -9934,6 +10078,7 @@
                 <a:latin typeface="Calibri"/>
               </a:defRPr>
             </a:pPr>
+            <a:endParaRPr dirty="0"/>
           </a:p>
           <a:p>
             <a:pPr algn="l">
@@ -9951,7 +10096,16 @@
               </a:defRPr>
             </a:pPr>
             <a:r>
-              <a:t>• Traditional ML (H2O AutoML) for pattern-based matching</a:t>
+              <a:rPr dirty="0"/>
+              <a:t>• Traditional ML (H2O </a:t>
+            </a:r>
+            <a:r>
+              <a:rPr dirty="0" err="1"/>
+              <a:t>AutoML</a:t>
+            </a:r>
+            <a:r>
+              <a:rPr dirty="0"/>
+              <a:t>) for pattern-based matching</a:t>
             </a:r>
           </a:p>
           <a:p>
@@ -9970,7 +10124,16 @@
               </a:defRPr>
             </a:pPr>
             <a:r>
-              <a:t>• Agentic AI (LangChain + Gemini) for explainable reasoning</a:t>
+              <a:rPr dirty="0"/>
+              <a:t>• Agentic AI (</a:t>
+            </a:r>
+            <a:r>
+              <a:rPr dirty="0" err="1"/>
+              <a:t>LangChain</a:t>
+            </a:r>
+            <a:r>
+              <a:rPr dirty="0"/>
+              <a:t> + Gemini) for explainable reasoning</a:t>
             </a:r>
           </a:p>
           <a:p>
@@ -9988,6 +10151,7 @@
                 <a:latin typeface="Calibri"/>
               </a:defRPr>
             </a:pPr>
+            <a:endParaRPr dirty="0"/>
           </a:p>
           <a:p>
             <a:pPr algn="l">
@@ -10005,8 +10169,10 @@
               </a:defRPr>
             </a:pPr>
             <a:r>
+              <a:rPr b="1" dirty="0"/>
               <a:t>Providing HR personnel ranked recommendations with rationale for human review.</a:t>
             </a:r>
+            <a:endParaRPr lang="en-US" b="1" dirty="0"/>
           </a:p>
           <a:p>
             <a:pPr algn="l">
@@ -10023,8 +10189,34 @@
                 <a:latin typeface="Calibri"/>
               </a:defRPr>
             </a:pPr>
-            <a:r>
-              <a:t>Multi-method approach ensures both accuracy and transparency.</a:t>
+            <a:endParaRPr dirty="0"/>
+          </a:p>
+          <a:p>
+            <a:pPr algn="l">
+              <a:spcBef>
+                <a:spcPts val="200"/>
+              </a:spcBef>
+              <a:spcAft>
+                <a:spcPts val="100"/>
+              </a:spcAft>
+              <a:defRPr sz="1300" b="0">
+                <a:solidFill>
+                  <a:srgbClr val="2D2D2D"/>
+                </a:solidFill>
+                <a:latin typeface="Calibri"/>
+              </a:defRPr>
+            </a:pPr>
+            <a:r>
+              <a:rPr dirty="0"/>
+              <a:t>Multi-method approach </a:t>
+            </a:r>
+            <a:r>
+              <a:rPr lang="en-US" dirty="0"/>
+              <a:t>provides</a:t>
+            </a:r>
+            <a:r>
+              <a:rPr dirty="0"/>
+              <a:t> both accuracy and transparency.</a:t>
             </a:r>
           </a:p>
         </p:txBody>
@@ -10073,6 +10265,7 @@
           <a:lstStyle/>
           <a:p>
             <a:pPr algn="ctr"/>
+            <a:endParaRPr/>
           </a:p>
         </p:txBody>
       </p:sp>
@@ -10143,6 +10336,7 @@
               </a:defRPr>
             </a:pPr>
             <a:r>
+              <a:rPr dirty="0"/>
               <a:t>End-to-end batch analytics pipeline:</a:t>
             </a:r>
           </a:p>
@@ -10161,6 +10355,7 @@
                 <a:latin typeface="Calibri"/>
               </a:defRPr>
             </a:pPr>
+            <a:endParaRPr dirty="0"/>
           </a:p>
           <a:p>
             <a:pPr algn="l">
@@ -10178,6 +10373,7 @@
               </a:defRPr>
             </a:pPr>
             <a:r>
+              <a:rPr dirty="0"/>
               <a:t>• 56 career groups classified</a:t>
             </a:r>
           </a:p>
@@ -10197,6 +10393,7 @@
               </a:defRPr>
             </a:pPr>
             <a:r>
+              <a:rPr dirty="0"/>
               <a:t>• 294 roles mapped</a:t>
             </a:r>
           </a:p>
@@ -10216,6 +10413,7 @@
               </a:defRPr>
             </a:pPr>
             <a:r>
+              <a:rPr dirty="0"/>
               <a:t>• 103 position descriptions processed</a:t>
             </a:r>
           </a:p>
@@ -10235,6 +10433,7 @@
               </a:defRPr>
             </a:pPr>
             <a:r>
+              <a:rPr dirty="0"/>
               <a:t>• 80 ML models trained</a:t>
             </a:r>
           </a:p>
@@ -10253,6 +10452,7 @@
                 <a:latin typeface="Calibri"/>
               </a:defRPr>
             </a:pPr>
+            <a:endParaRPr dirty="0"/>
           </a:p>
           <a:p>
             <a:pPr algn="l">
@@ -10270,7 +10470,16 @@
               </a:defRPr>
             </a:pPr>
             <a:r>
-              <a:t>Data acquisition → ML training → interactive Streamlit app</a:t>
+              <a:rPr dirty="0"/>
+              <a:t>Data acquisition → ML training → interactive </a:t>
+            </a:r>
+            <a:r>
+              <a:rPr dirty="0" err="1"/>
+              <a:t>Streamlit</a:t>
+            </a:r>
+            <a:r>
+              <a:rPr dirty="0"/>
+              <a:t> app</a:t>
             </a:r>
           </a:p>
         </p:txBody>
@@ -10356,7 +10565,7 @@
 </file>
 
 <file path=ppt/slides/slide3.xml><?xml version="1.0" encoding="utf-8"?>
-<p:sld xmlns:a="http://schemas.openxmlformats.org/drawingml/2006/main" xmlns:p="http://schemas.openxmlformats.org/presentationml/2006/main" xmlns:r="http://schemas.openxmlformats.org/officeDocument/2006/relationships">
+<p:sld xmlns:a="http://schemas.openxmlformats.org/drawingml/2006/main" xmlns:r="http://schemas.openxmlformats.org/officeDocument/2006/relationships" xmlns:p="http://schemas.openxmlformats.org/presentationml/2006/main">
   <p:cSld>
     <p:bg>
       <p:bgPr>
@@ -10372,7 +10581,14 @@
         <p:cNvGrpSpPr/>
         <p:nvPr/>
       </p:nvGrpSpPr>
-      <p:grpSpPr/>
+      <p:grpSpPr>
+        <a:xfrm>
+          <a:off x="0" y="0"/>
+          <a:ext cx="0" cy="0"/>
+          <a:chOff x="0" y="0"/>
+          <a:chExt cx="0" cy="0"/>
+        </a:xfrm>
+      </p:grpSpPr>
       <p:sp>
         <p:nvSpPr>
           <p:cNvPr id="2" name="TextBox 1"/>
@@ -10449,6 +10665,7 @@
           <a:lstStyle/>
           <a:p>
             <a:pPr algn="ctr"/>
+            <a:endParaRPr/>
           </a:p>
         </p:txBody>
       </p:sp>
@@ -10496,6 +10713,7 @@
           <a:lstStyle/>
           <a:p>
             <a:pPr algn="ctr"/>
+            <a:endParaRPr/>
           </a:p>
         </p:txBody>
       </p:sp>
@@ -10541,6 +10759,7 @@
           <a:lstStyle/>
           <a:p>
             <a:pPr algn="ctr"/>
+            <a:endParaRPr/>
           </a:p>
         </p:txBody>
       </p:sp>
@@ -10824,6 +11043,7 @@
           <a:lstStyle/>
           <a:p>
             <a:pPr algn="ctr"/>
+            <a:endParaRPr/>
           </a:p>
         </p:txBody>
       </p:sp>
@@ -10869,6 +11089,7 @@
           <a:lstStyle/>
           <a:p>
             <a:pPr algn="ctr"/>
+            <a:endParaRPr/>
           </a:p>
         </p:txBody>
       </p:sp>
@@ -11152,6 +11373,7 @@
           <a:lstStyle/>
           <a:p>
             <a:pPr algn="ctr"/>
+            <a:endParaRPr/>
           </a:p>
         </p:txBody>
       </p:sp>
@@ -11197,6 +11419,7 @@
           <a:lstStyle/>
           <a:p>
             <a:pPr algn="ctr"/>
+            <a:endParaRPr/>
           </a:p>
         </p:txBody>
       </p:sp>
@@ -11476,6 +11699,7 @@
           <a:lstStyle/>
           <a:p>
             <a:pPr algn="ctr"/>
+            <a:endParaRPr/>
           </a:p>
         </p:txBody>
       </p:sp>
@@ -11596,7 +11820,7 @@
 </file>
 
 <file path=ppt/slides/slide4.xml><?xml version="1.0" encoding="utf-8"?>
-<p:sld xmlns:a="http://schemas.openxmlformats.org/drawingml/2006/main" xmlns:p="http://schemas.openxmlformats.org/presentationml/2006/main" xmlns:r="http://schemas.openxmlformats.org/officeDocument/2006/relationships">
+<p:sld xmlns:a="http://schemas.openxmlformats.org/drawingml/2006/main" xmlns:r="http://schemas.openxmlformats.org/officeDocument/2006/relationships" xmlns:p="http://schemas.openxmlformats.org/presentationml/2006/main">
   <p:cSld>
     <p:bg>
       <p:bgPr>
@@ -11612,7 +11836,14 @@
         <p:cNvGrpSpPr/>
         <p:nvPr/>
       </p:nvGrpSpPr>
-      <p:grpSpPr/>
+      <p:grpSpPr>
+        <a:xfrm>
+          <a:off x="0" y="0"/>
+          <a:ext cx="0" cy="0"/>
+          <a:chOff x="0" y="0"/>
+          <a:chExt cx="0" cy="0"/>
+        </a:xfrm>
+      </p:grpSpPr>
       <p:sp>
         <p:nvSpPr>
           <p:cNvPr id="2" name="TextBox 1"/>
@@ -11689,6 +11920,7 @@
           <a:lstStyle/>
           <a:p>
             <a:pPr algn="ctr"/>
+            <a:endParaRPr/>
           </a:p>
         </p:txBody>
       </p:sp>
@@ -11734,6 +11966,7 @@
           <a:lstStyle/>
           <a:p>
             <a:pPr algn="ctr"/>
+            <a:endParaRPr/>
           </a:p>
         </p:txBody>
       </p:sp>
@@ -11746,7 +11979,7 @@
         <p:spPr>
           <a:xfrm>
             <a:off x="563727" y="1371600"/>
-            <a:ext cx="1691640" cy="1280160"/>
+            <a:ext cx="1691640" cy="646331"/>
           </a:xfrm>
           <a:prstGeom prst="rect">
             <a:avLst/>
@@ -11768,20 +12001,87 @@
               </a:defRPr>
             </a:pPr>
             <a:r>
+              <a:rPr dirty="0"/>
               <a:t>DATA</a:t>
             </a:r>
-            <a:br/>
-            <a:r>
+            <a:br>
+              <a:rPr dirty="0"/>
+            </a:br>
+            <a:r>
+              <a:rPr dirty="0"/>
               <a:t>COLLECTION</a:t>
             </a:r>
-            <a:br/>
-            <a:r>
-              <a:t>(Classification Categories,</a:t>
-            </a:r>
-            <a:br/>
-            <a:r>
-              <a:t>Codes, Pay Bands, etc.)</a:t>
-            </a:r>
+            <a:br>
+              <a:rPr dirty="0"/>
+            </a:br>
+            <a:r>
+              <a:rPr lang="fr-FR" sz="900" b="1" dirty="0">
+                <a:solidFill>
+                  <a:srgbClr val="C99700"/>
+                </a:solidFill>
+                <a:latin typeface="Calibri"/>
+              </a:rPr>
+              <a:t>Classification </a:t>
+            </a:r>
+            <a:r>
+              <a:rPr lang="fr-FR" sz="900" b="1" dirty="0" err="1">
+                <a:solidFill>
+                  <a:srgbClr val="C99700"/>
+                </a:solidFill>
+                <a:latin typeface="Calibri"/>
+              </a:rPr>
+              <a:t>Categories</a:t>
+            </a:r>
+            <a:r>
+              <a:rPr lang="fr-FR" sz="900" b="1" dirty="0">
+                <a:solidFill>
+                  <a:srgbClr val="C99700"/>
+                </a:solidFill>
+                <a:latin typeface="Calibri"/>
+              </a:rPr>
+              <a:t>,</a:t>
+            </a:r>
+            <a:br>
+              <a:rPr lang="fr-FR" sz="900" b="1" dirty="0">
+                <a:solidFill>
+                  <a:srgbClr val="C99700"/>
+                </a:solidFill>
+                <a:latin typeface="Calibri"/>
+              </a:rPr>
+            </a:br>
+            <a:r>
+              <a:rPr lang="fr-FR" sz="900" b="1" dirty="0">
+                <a:solidFill>
+                  <a:srgbClr val="C99700"/>
+                </a:solidFill>
+                <a:latin typeface="Calibri"/>
+              </a:rPr>
+              <a:t>Codes, </a:t>
+            </a:r>
+            <a:r>
+              <a:rPr lang="fr-FR" sz="900" b="1" dirty="0" err="1">
+                <a:solidFill>
+                  <a:srgbClr val="C99700"/>
+                </a:solidFill>
+                <a:latin typeface="Calibri"/>
+              </a:rPr>
+              <a:t>Pay</a:t>
+            </a:r>
+            <a:r>
+              <a:rPr lang="fr-FR" sz="900" b="1" dirty="0">
+                <a:solidFill>
+                  <a:srgbClr val="C99700"/>
+                </a:solidFill>
+                <a:latin typeface="Calibri"/>
+              </a:rPr>
+              <a:t> Bands, Etc.</a:t>
+            </a:r>
+            <a:endParaRPr sz="900" b="1" dirty="0">
+              <a:solidFill>
+                <a:srgbClr val="C99700"/>
+              </a:solidFill>
+              <a:latin typeface="Calibri"/>
+            </a:endParaRPr>
           </a:p>
         </p:txBody>
       </p:sp>
@@ -11829,6 +12129,7 @@
           <a:lstStyle/>
           <a:p>
             <a:pPr algn="ctr"/>
+            <a:endParaRPr/>
           </a:p>
         </p:txBody>
       </p:sp>
@@ -11969,6 +12270,7 @@
           <a:lstStyle/>
           <a:p>
             <a:pPr algn="ctr"/>
+            <a:endParaRPr/>
           </a:p>
         </p:txBody>
       </p:sp>
@@ -12014,6 +12316,7 @@
           <a:lstStyle/>
           <a:p>
             <a:pPr algn="ctr"/>
+            <a:endParaRPr/>
           </a:p>
         </p:txBody>
       </p:sp>
@@ -12026,7 +12329,7 @@
         <p:spPr>
           <a:xfrm>
             <a:off x="2438247" y="1371600"/>
-            <a:ext cx="1691640" cy="1280160"/>
+            <a:ext cx="1691640" cy="646331"/>
           </a:xfrm>
           <a:prstGeom prst="rect">
             <a:avLst/>
@@ -12048,20 +12351,51 @@
               </a:defRPr>
             </a:pPr>
             <a:r>
+              <a:rPr dirty="0"/>
               <a:t>DATA</a:t>
             </a:r>
-            <a:br/>
-            <a:r>
+            <a:br>
+              <a:rPr dirty="0"/>
+            </a:br>
+            <a:r>
+              <a:rPr dirty="0"/>
               <a:t>STORAGE</a:t>
             </a:r>
-            <a:br/>
-            <a:r>
-              <a:t>(Put it all in a</a:t>
-            </a:r>
-            <a:br/>
-            <a:r>
-              <a:t>central location)</a:t>
-            </a:r>
+            <a:br>
+              <a:rPr dirty="0"/>
+            </a:br>
+            <a:r>
+              <a:rPr lang="en-US" sz="900" b="1" dirty="0">
+                <a:solidFill>
+                  <a:srgbClr val="C99700"/>
+                </a:solidFill>
+                <a:latin typeface="Calibri"/>
+              </a:rPr>
+              <a:t>Put It All In A</a:t>
+            </a:r>
+            <a:br>
+              <a:rPr lang="en-US" sz="900" b="1" dirty="0">
+                <a:solidFill>
+                  <a:srgbClr val="C99700"/>
+                </a:solidFill>
+                <a:latin typeface="Calibri"/>
+              </a:rPr>
+            </a:br>
+            <a:r>
+              <a:rPr lang="en-US" sz="900" b="1" dirty="0">
+                <a:solidFill>
+                  <a:srgbClr val="C99700"/>
+                </a:solidFill>
+                <a:latin typeface="Calibri"/>
+              </a:rPr>
+              <a:t>Central Location</a:t>
+            </a:r>
+            <a:endParaRPr sz="900" b="1" dirty="0">
+              <a:solidFill>
+                <a:srgbClr val="C99700"/>
+              </a:solidFill>
+              <a:latin typeface="Calibri"/>
+            </a:endParaRPr>
           </a:p>
         </p:txBody>
       </p:sp>
@@ -12109,6 +12443,7 @@
           <a:lstStyle/>
           <a:p>
             <a:pPr algn="ctr"/>
+            <a:endParaRPr/>
           </a:p>
         </p:txBody>
       </p:sp>
@@ -12230,6 +12565,7 @@
           <a:lstStyle/>
           <a:p>
             <a:pPr algn="ctr"/>
+            <a:endParaRPr/>
           </a:p>
         </p:txBody>
       </p:sp>
@@ -12275,6 +12611,7 @@
           <a:lstStyle/>
           <a:p>
             <a:pPr algn="ctr"/>
+            <a:endParaRPr/>
           </a:p>
         </p:txBody>
       </p:sp>
@@ -12287,7 +12624,7 @@
         <p:spPr>
           <a:xfrm>
             <a:off x="4312767" y="1371600"/>
-            <a:ext cx="1691640" cy="1280160"/>
+            <a:ext cx="1691640" cy="646331"/>
           </a:xfrm>
           <a:prstGeom prst="rect">
             <a:avLst/>
@@ -12309,20 +12646,51 @@
               </a:defRPr>
             </a:pPr>
             <a:r>
+              <a:rPr dirty="0"/>
               <a:t>DATA</a:t>
             </a:r>
-            <a:br/>
-            <a:r>
+            <a:br>
+              <a:rPr dirty="0"/>
+            </a:br>
+            <a:r>
+              <a:rPr dirty="0"/>
               <a:t>PROCESSING</a:t>
             </a:r>
-            <a:br/>
-            <a:r>
-              <a:t>(Clean it up, Separate test</a:t>
-            </a:r>
-            <a:br/>
-            <a:r>
-              <a:t>version vs. answer key)</a:t>
-            </a:r>
+            <a:br>
+              <a:rPr dirty="0"/>
+            </a:br>
+            <a:r>
+              <a:rPr lang="en-US" sz="900" b="1" dirty="0">
+                <a:solidFill>
+                  <a:srgbClr val="C99700"/>
+                </a:solidFill>
+                <a:latin typeface="Calibri"/>
+              </a:rPr>
+              <a:t>Clean It Up, Separate Test</a:t>
+            </a:r>
+            <a:br>
+              <a:rPr lang="en-US" sz="900" b="1" dirty="0">
+                <a:solidFill>
+                  <a:srgbClr val="C99700"/>
+                </a:solidFill>
+                <a:latin typeface="Calibri"/>
+              </a:rPr>
+            </a:br>
+            <a:r>
+              <a:rPr lang="en-US" sz="900" b="1" dirty="0">
+                <a:solidFill>
+                  <a:srgbClr val="C99700"/>
+                </a:solidFill>
+                <a:latin typeface="Calibri"/>
+              </a:rPr>
+              <a:t>Version Vs. Answer Key</a:t>
+            </a:r>
+            <a:endParaRPr sz="900" b="1" dirty="0">
+              <a:solidFill>
+                <a:srgbClr val="C99700"/>
+              </a:solidFill>
+              <a:latin typeface="Calibri"/>
+            </a:endParaRPr>
           </a:p>
         </p:txBody>
       </p:sp>
@@ -12370,6 +12738,7 @@
           <a:lstStyle/>
           <a:p>
             <a:pPr algn="ctr"/>
+            <a:endParaRPr/>
           </a:p>
         </p:txBody>
       </p:sp>
@@ -12491,6 +12860,7 @@
           <a:lstStyle/>
           <a:p>
             <a:pPr algn="ctr"/>
+            <a:endParaRPr/>
           </a:p>
         </p:txBody>
       </p:sp>
@@ -12536,6 +12906,7 @@
           <a:lstStyle/>
           <a:p>
             <a:pPr algn="ctr"/>
+            <a:endParaRPr/>
           </a:p>
         </p:txBody>
       </p:sp>
@@ -12548,7 +12919,7 @@
         <p:spPr>
           <a:xfrm>
             <a:off x="6187287" y="1371600"/>
-            <a:ext cx="1691640" cy="1280160"/>
+            <a:ext cx="1691640" cy="646331"/>
           </a:xfrm>
           <a:prstGeom prst="rect">
             <a:avLst/>
@@ -12570,20 +12941,47 @@
               </a:defRPr>
             </a:pPr>
             <a:r>
+              <a:rPr dirty="0"/>
               <a:t>ML</a:t>
             </a:r>
-            <a:br/>
-            <a:r>
+            <a:br>
+              <a:rPr dirty="0"/>
+            </a:br>
+            <a:r>
+              <a:rPr dirty="0"/>
               <a:t>TRAINING</a:t>
             </a:r>
-            <a:br/>
-            <a:r>
-              <a:t>(Let the Machine take the</a:t>
-            </a:r>
-            <a:br/>
-            <a:r>
-              <a:t>test and 'learn')</a:t>
-            </a:r>
+            <a:br>
+              <a:rPr dirty="0"/>
+            </a:br>
+            <a:r>
+              <a:rPr lang="en-US" dirty="0">
+                <a:solidFill>
+                  <a:srgbClr val="C99700"/>
+                </a:solidFill>
+              </a:rPr>
+              <a:t>Let The Machine Take The</a:t>
+            </a:r>
+            <a:br>
+              <a:rPr lang="en-US" dirty="0">
+                <a:solidFill>
+                  <a:srgbClr val="C99700"/>
+                </a:solidFill>
+              </a:rPr>
+            </a:br>
+            <a:r>
+              <a:rPr lang="en-US" dirty="0">
+                <a:solidFill>
+                  <a:srgbClr val="C99700"/>
+                </a:solidFill>
+              </a:rPr>
+              <a:t>Test And 'Learn'</a:t>
+            </a:r>
+            <a:endParaRPr dirty="0">
+              <a:solidFill>
+                <a:srgbClr val="C99700"/>
+              </a:solidFill>
+            </a:endParaRPr>
           </a:p>
         </p:txBody>
       </p:sp>
@@ -12631,6 +13029,7 @@
           <a:lstStyle/>
           <a:p>
             <a:pPr algn="ctr"/>
+            <a:endParaRPr/>
           </a:p>
         </p:txBody>
       </p:sp>
@@ -12767,6 +13166,7 @@
           <a:lstStyle/>
           <a:p>
             <a:pPr algn="ctr"/>
+            <a:endParaRPr/>
           </a:p>
         </p:txBody>
       </p:sp>
@@ -12812,6 +13212,7 @@
           <a:lstStyle/>
           <a:p>
             <a:pPr algn="ctr"/>
+            <a:endParaRPr/>
           </a:p>
         </p:txBody>
       </p:sp>
@@ -12824,7 +13225,7 @@
         <p:spPr>
           <a:xfrm>
             <a:off x="8061807" y="1371600"/>
-            <a:ext cx="1691640" cy="1280160"/>
+            <a:ext cx="1691640" cy="646331"/>
           </a:xfrm>
           <a:prstGeom prst="rect">
             <a:avLst/>
@@ -12846,20 +13247,47 @@
               </a:defRPr>
             </a:pPr>
             <a:r>
+              <a:rPr dirty="0"/>
               <a:t>LLM</a:t>
             </a:r>
-            <a:br/>
-            <a:r>
+            <a:br>
+              <a:rPr dirty="0"/>
+            </a:br>
+            <a:r>
+              <a:rPr dirty="0"/>
               <a:t>CLASSIFICATION</a:t>
             </a:r>
-            <a:br/>
-            <a:r>
-              <a:t>(Parallel look</a:t>
-            </a:r>
-            <a:br/>
-            <a:r>
-              <a:t>using AI)</a:t>
-            </a:r>
+            <a:br>
+              <a:rPr dirty="0"/>
+            </a:br>
+            <a:r>
+              <a:rPr lang="en-US" dirty="0">
+                <a:solidFill>
+                  <a:srgbClr val="C99700"/>
+                </a:solidFill>
+              </a:rPr>
+              <a:t>Parallel Look</a:t>
+            </a:r>
+            <a:br>
+              <a:rPr lang="en-US" dirty="0">
+                <a:solidFill>
+                  <a:srgbClr val="C99700"/>
+                </a:solidFill>
+              </a:rPr>
+            </a:br>
+            <a:r>
+              <a:rPr lang="en-US" dirty="0">
+                <a:solidFill>
+                  <a:srgbClr val="C99700"/>
+                </a:solidFill>
+              </a:rPr>
+              <a:t>Using AI</a:t>
+            </a:r>
+            <a:endParaRPr dirty="0">
+              <a:solidFill>
+                <a:srgbClr val="C99700"/>
+              </a:solidFill>
+            </a:endParaRPr>
           </a:p>
         </p:txBody>
       </p:sp>
@@ -12907,6 +13335,7 @@
           <a:lstStyle/>
           <a:p>
             <a:pPr algn="ctr"/>
+            <a:endParaRPr/>
           </a:p>
         </p:txBody>
       </p:sp>
@@ -13028,6 +13457,7 @@
           <a:lstStyle/>
           <a:p>
             <a:pPr algn="ctr"/>
+            <a:endParaRPr/>
           </a:p>
         </p:txBody>
       </p:sp>
@@ -13073,6 +13503,7 @@
           <a:lstStyle/>
           <a:p>
             <a:pPr algn="ctr"/>
+            <a:endParaRPr/>
           </a:p>
         </p:txBody>
       </p:sp>
@@ -13085,7 +13516,7 @@
         <p:spPr>
           <a:xfrm>
             <a:off x="9936327" y="1371600"/>
-            <a:ext cx="1691640" cy="1280160"/>
+            <a:ext cx="1691640" cy="646331"/>
           </a:xfrm>
           <a:prstGeom prst="rect">
             <a:avLst/>
@@ -13107,20 +13538,47 @@
               </a:defRPr>
             </a:pPr>
             <a:r>
+              <a:rPr dirty="0"/>
               <a:t>WEB</a:t>
             </a:r>
-            <a:br/>
-            <a:r>
+            <a:br>
+              <a:rPr dirty="0"/>
+            </a:br>
+            <a:r>
+              <a:rPr dirty="0"/>
               <a:t>APPLICATION</a:t>
             </a:r>
-            <a:br/>
-            <a:r>
-              <a:t>(Human tailored</a:t>
-            </a:r>
-            <a:br/>
-            <a:r>
-              <a:t>results)</a:t>
-            </a:r>
+            <a:br>
+              <a:rPr dirty="0"/>
+            </a:br>
+            <a:r>
+              <a:rPr lang="en-US" dirty="0">
+                <a:solidFill>
+                  <a:srgbClr val="C99700"/>
+                </a:solidFill>
+              </a:rPr>
+              <a:t>Human Tailored</a:t>
+            </a:r>
+            <a:br>
+              <a:rPr lang="en-US" dirty="0">
+                <a:solidFill>
+                  <a:srgbClr val="C99700"/>
+                </a:solidFill>
+              </a:rPr>
+            </a:br>
+            <a:r>
+              <a:rPr lang="en-US" dirty="0">
+                <a:solidFill>
+                  <a:srgbClr val="C99700"/>
+                </a:solidFill>
+              </a:rPr>
+              <a:t>Results</a:t>
+            </a:r>
+            <a:endParaRPr dirty="0">
+              <a:solidFill>
+                <a:srgbClr val="C99700"/>
+              </a:solidFill>
+            </a:endParaRPr>
           </a:p>
         </p:txBody>
       </p:sp>
@@ -13168,6 +13626,7 @@
           <a:lstStyle/>
           <a:p>
             <a:pPr algn="ctr"/>
+            <a:endParaRPr/>
           </a:p>
         </p:txBody>
       </p:sp>
@@ -13293,6 +13752,7 @@
           <a:lstStyle/>
           <a:p>
             <a:pPr algn="ctr"/>
+            <a:endParaRPr/>
           </a:p>
         </p:txBody>
       </p:sp>
@@ -13449,7 +13909,7 @@
 </file>
 
 <file path=ppt/slides/slide5.xml><?xml version="1.0" encoding="utf-8"?>
-<p:sld xmlns:a="http://schemas.openxmlformats.org/drawingml/2006/main" xmlns:p="http://schemas.openxmlformats.org/presentationml/2006/main" xmlns:r="http://schemas.openxmlformats.org/officeDocument/2006/relationships">
+<p:sld xmlns:a="http://schemas.openxmlformats.org/drawingml/2006/main" xmlns:r="http://schemas.openxmlformats.org/officeDocument/2006/relationships" xmlns:p="http://schemas.openxmlformats.org/presentationml/2006/main">
   <p:cSld>
     <p:bg>
       <p:bgPr>
@@ -13465,7 +13925,14 @@
         <p:cNvGrpSpPr/>
         <p:nvPr/>
       </p:nvGrpSpPr>
-      <p:grpSpPr/>
+      <p:grpSpPr>
+        <a:xfrm>
+          <a:off x="0" y="0"/>
+          <a:ext cx="0" cy="0"/>
+          <a:chOff x="0" y="0"/>
+          <a:chExt cx="0" cy="0"/>
+        </a:xfrm>
+      </p:grpSpPr>
       <p:sp>
         <p:nvSpPr>
           <p:cNvPr id="2" name="TextBox 1"/>
@@ -13542,6 +14009,7 @@
           <a:lstStyle/>
           <a:p>
             <a:pPr algn="ctr"/>
+            <a:endParaRPr/>
           </a:p>
         </p:txBody>
       </p:sp>
@@ -13589,6 +14057,7 @@
           <a:lstStyle/>
           <a:p>
             <a:pPr algn="ctr"/>
+            <a:endParaRPr/>
           </a:p>
         </p:txBody>
       </p:sp>
@@ -13677,6 +14146,7 @@
                 <a:latin typeface="Calibri"/>
               </a:defRPr>
             </a:pPr>
+            <a:endParaRPr/>
           </a:p>
           <a:p>
             <a:pPr algn="l">
@@ -13750,6 +14220,7 @@
                 <a:latin typeface="Calibri"/>
               </a:defRPr>
             </a:pPr>
+            <a:endParaRPr/>
           </a:p>
           <a:p>
             <a:pPr algn="l">
@@ -13816,6 +14287,7 @@
           <a:lstStyle/>
           <a:p>
             <a:pPr algn="ctr"/>
+            <a:endParaRPr/>
           </a:p>
         </p:txBody>
       </p:sp>
@@ -13904,6 +14376,7 @@
                 <a:latin typeface="Calibri"/>
               </a:defRPr>
             </a:pPr>
+            <a:endParaRPr/>
           </a:p>
           <a:p>
             <a:pPr algn="l">
@@ -14015,6 +14488,7 @@
                 <a:latin typeface="Calibri"/>
               </a:defRPr>
             </a:pPr>
+            <a:endParaRPr/>
           </a:p>
           <a:p>
             <a:pPr algn="l">
@@ -14081,6 +14555,7 @@
           <a:lstStyle/>
           <a:p>
             <a:pPr algn="ctr"/>
+            <a:endParaRPr/>
           </a:p>
         </p:txBody>
       </p:sp>
@@ -14169,6 +14644,7 @@
                 <a:latin typeface="Calibri"/>
               </a:defRPr>
             </a:pPr>
+            <a:endParaRPr/>
           </a:p>
           <a:p>
             <a:pPr algn="l">
@@ -14223,6 +14699,7 @@
                 <a:latin typeface="Calibri"/>
               </a:defRPr>
             </a:pPr>
+            <a:endParaRPr/>
           </a:p>
           <a:p>
             <a:pPr algn="l">
@@ -14296,6 +14773,7 @@
                 <a:latin typeface="Calibri"/>
               </a:defRPr>
             </a:pPr>
+            <a:endParaRPr/>
           </a:p>
           <a:p>
             <a:pPr algn="l">
@@ -14399,7 +14877,7 @@
 </file>
 
 <file path=ppt/slides/slide6.xml><?xml version="1.0" encoding="utf-8"?>
-<p:sld xmlns:a="http://schemas.openxmlformats.org/drawingml/2006/main" xmlns:p="http://schemas.openxmlformats.org/presentationml/2006/main" xmlns:r="http://schemas.openxmlformats.org/officeDocument/2006/relationships">
+<p:sld xmlns:a="http://schemas.openxmlformats.org/drawingml/2006/main" xmlns:r="http://schemas.openxmlformats.org/officeDocument/2006/relationships" xmlns:p="http://schemas.openxmlformats.org/presentationml/2006/main">
   <p:cSld>
     <p:bg>
       <p:bgPr>
@@ -14415,7 +14893,14 @@
         <p:cNvGrpSpPr/>
         <p:nvPr/>
       </p:nvGrpSpPr>
-      <p:grpSpPr/>
+      <p:grpSpPr>
+        <a:xfrm>
+          <a:off x="0" y="0"/>
+          <a:ext cx="0" cy="0"/>
+          <a:chOff x="0" y="0"/>
+          <a:chExt cx="0" cy="0"/>
+        </a:xfrm>
+      </p:grpSpPr>
       <p:sp>
         <p:nvSpPr>
           <p:cNvPr id="2" name="TextBox 1"/>
@@ -14492,6 +14977,7 @@
           <a:lstStyle/>
           <a:p>
             <a:pPr algn="ctr"/>
+            <a:endParaRPr/>
           </a:p>
         </p:txBody>
       </p:sp>
@@ -14539,6 +15025,7 @@
           <a:lstStyle/>
           <a:p>
             <a:pPr algn="ctr"/>
+            <a:endParaRPr/>
           </a:p>
         </p:txBody>
       </p:sp>
@@ -14627,6 +15114,7 @@
                 <a:latin typeface="Calibri"/>
               </a:defRPr>
             </a:pPr>
+            <a:endParaRPr/>
           </a:p>
           <a:p>
             <a:pPr algn="l">
@@ -14738,6 +15226,7 @@
                 <a:latin typeface="Calibri"/>
               </a:defRPr>
             </a:pPr>
+            <a:endParaRPr/>
           </a:p>
           <a:p>
             <a:pPr algn="l">
@@ -14842,6 +15331,7 @@
           <a:lstStyle/>
           <a:p>
             <a:pPr algn="ctr"/>
+            <a:endParaRPr/>
           </a:p>
         </p:txBody>
       </p:sp>
@@ -14949,6 +15439,7 @@
                 <a:latin typeface="Calibri"/>
               </a:defRPr>
             </a:pPr>
+            <a:endParaRPr/>
           </a:p>
           <a:p>
             <a:pPr algn="l">
@@ -15079,6 +15570,7 @@
                 <a:latin typeface="Calibri"/>
               </a:defRPr>
             </a:pPr>
+            <a:endParaRPr/>
           </a:p>
           <a:p>
             <a:pPr algn="l">
@@ -15165,7 +15657,7 @@
 </file>
 
 <file path=ppt/slides/slide7.xml><?xml version="1.0" encoding="utf-8"?>
-<p:sld xmlns:a="http://schemas.openxmlformats.org/drawingml/2006/main" xmlns:p="http://schemas.openxmlformats.org/presentationml/2006/main" xmlns:r="http://schemas.openxmlformats.org/officeDocument/2006/relationships">
+<p:sld xmlns:a="http://schemas.openxmlformats.org/drawingml/2006/main" xmlns:r="http://schemas.openxmlformats.org/officeDocument/2006/relationships" xmlns:p="http://schemas.openxmlformats.org/presentationml/2006/main">
   <p:cSld>
     <p:bg>
       <p:bgPr>
@@ -15181,7 +15673,14 @@
         <p:cNvGrpSpPr/>
         <p:nvPr/>
       </p:nvGrpSpPr>
-      <p:grpSpPr/>
+      <p:grpSpPr>
+        <a:xfrm>
+          <a:off x="0" y="0"/>
+          <a:ext cx="0" cy="0"/>
+          <a:chOff x="0" y="0"/>
+          <a:chExt cx="0" cy="0"/>
+        </a:xfrm>
+      </p:grpSpPr>
       <p:sp>
         <p:nvSpPr>
           <p:cNvPr id="2" name="TextBox 1"/>
@@ -15258,6 +15757,7 @@
           <a:lstStyle/>
           <a:p>
             <a:pPr algn="ctr"/>
+            <a:endParaRPr/>
           </a:p>
         </p:txBody>
       </p:sp>
@@ -15341,6 +15841,7 @@
           <a:lstStyle/>
           <a:p>
             <a:pPr algn="ctr"/>
+            <a:endParaRPr/>
           </a:p>
         </p:txBody>
       </p:sp>
@@ -15448,6 +15949,7 @@
                 <a:latin typeface="Calibri"/>
               </a:defRPr>
             </a:pPr>
+            <a:endParaRPr/>
           </a:p>
           <a:p>
             <a:pPr algn="l">
@@ -15540,6 +16042,7 @@
                 <a:latin typeface="Calibri"/>
               </a:defRPr>
             </a:pPr>
+            <a:endParaRPr/>
           </a:p>
           <a:p>
             <a:pPr algn="l">
@@ -15594,6 +16097,7 @@
                 <a:latin typeface="Calibri"/>
               </a:defRPr>
             </a:pPr>
+            <a:endParaRPr/>
           </a:p>
           <a:p>
             <a:pPr algn="l">
@@ -15660,6 +16164,7 @@
           <a:lstStyle/>
           <a:p>
             <a:pPr algn="ctr"/>
+            <a:endParaRPr/>
           </a:p>
         </p:txBody>
       </p:sp>
@@ -15748,6 +16253,7 @@
                 <a:latin typeface="Calibri"/>
               </a:defRPr>
             </a:pPr>
+            <a:endParaRPr/>
           </a:p>
           <a:p>
             <a:pPr algn="l">
@@ -15840,6 +16346,7 @@
                 <a:latin typeface="Calibri"/>
               </a:defRPr>
             </a:pPr>
+            <a:endParaRPr/>
           </a:p>
           <a:p>
             <a:pPr algn="l">
@@ -15982,6 +16489,7 @@
           <a:lstStyle/>
           <a:p>
             <a:pPr algn="ctr"/>
+            <a:endParaRPr/>
           </a:p>
         </p:txBody>
       </p:sp>
@@ -16127,6 +16635,7 @@
                 <a:latin typeface="Calibri"/>
               </a:defRPr>
             </a:pPr>
+            <a:endParaRPr/>
           </a:p>
           <a:p>
             <a:pPr algn="l">
@@ -16200,6 +16709,7 @@
                 <a:latin typeface="Calibri"/>
               </a:defRPr>
             </a:pPr>
+            <a:endParaRPr/>
           </a:p>
           <a:p>
             <a:pPr algn="l">
@@ -16377,7 +16887,7 @@
 </file>
 
 <file path=ppt/slides/slide8.xml><?xml version="1.0" encoding="utf-8"?>
-<p:sld xmlns:a="http://schemas.openxmlformats.org/drawingml/2006/main" xmlns:p="http://schemas.openxmlformats.org/presentationml/2006/main" xmlns:r="http://schemas.openxmlformats.org/officeDocument/2006/relationships">
+<p:sld xmlns:a="http://schemas.openxmlformats.org/drawingml/2006/main" xmlns:r="http://schemas.openxmlformats.org/officeDocument/2006/relationships" xmlns:p="http://schemas.openxmlformats.org/presentationml/2006/main">
   <p:cSld>
     <p:bg>
       <p:bgPr>
@@ -16393,7 +16903,14 @@
         <p:cNvGrpSpPr/>
         <p:nvPr/>
       </p:nvGrpSpPr>
-      <p:grpSpPr/>
+      <p:grpSpPr>
+        <a:xfrm>
+          <a:off x="0" y="0"/>
+          <a:ext cx="0" cy="0"/>
+          <a:chOff x="0" y="0"/>
+          <a:chExt cx="0" cy="0"/>
+        </a:xfrm>
+      </p:grpSpPr>
       <p:sp>
         <p:nvSpPr>
           <p:cNvPr id="2" name="TextBox 1"/>
@@ -16470,6 +16987,7 @@
           <a:lstStyle/>
           <a:p>
             <a:pPr algn="ctr"/>
+            <a:endParaRPr/>
           </a:p>
         </p:txBody>
       </p:sp>
@@ -16551,6 +17069,7 @@
           <a:lstStyle/>
           <a:p>
             <a:pPr algn="ctr"/>
+            <a:endParaRPr/>
           </a:p>
         </p:txBody>
       </p:sp>
@@ -16594,6 +17113,7 @@
           <a:lstStyle/>
           <a:p>
             <a:pPr algn="ctr"/>
+            <a:endParaRPr/>
           </a:p>
         </p:txBody>
       </p:sp>
@@ -16642,7 +17162,7 @@
         <p:spPr>
           <a:xfrm>
             <a:off x="868680" y="2011680"/>
-            <a:ext cx="3611880" cy="4206240"/>
+            <a:ext cx="3611880" cy="2662267"/>
           </a:xfrm>
           <a:prstGeom prst="rect">
             <a:avLst/>
@@ -16667,7 +17187,24 @@
               </a:defRPr>
             </a:pPr>
             <a:r>
-              <a:t>•  facilities_keywords and research_keywords are the strongest signals — PDs mentioning these terms are most clearly distinguished between job families</a:t>
+              <a:rPr dirty="0"/>
+              <a:t>•  </a:t>
+            </a:r>
+            <a:r>
+              <a:rPr dirty="0" err="1"/>
+              <a:t>facilities_keywords</a:t>
+            </a:r>
+            <a:r>
+              <a:rPr dirty="0"/>
+              <a:t> and </a:t>
+            </a:r>
+            <a:r>
+              <a:rPr dirty="0" err="1"/>
+              <a:t>research_keywords</a:t>
+            </a:r>
+            <a:r>
+              <a:rPr dirty="0"/>
+              <a:t> are the strongest signals — PDs mentioning these terms are most clearly distinguished between job families</a:t>
             </a:r>
           </a:p>
           <a:p>
@@ -16686,7 +17223,16 @@
               </a:defRPr>
             </a:pPr>
             <a:r>
-              <a:t>•  text_length matters — longer, more detailed position descriptions give the model more information to work with</a:t>
+              <a:rPr dirty="0"/>
+              <a:t>•  </a:t>
+            </a:r>
+            <a:r>
+              <a:rPr dirty="0" err="1"/>
+              <a:t>text_length</a:t>
+            </a:r>
+            <a:r>
+              <a:rPr dirty="0"/>
+              <a:t> matters — longer, more detailed position descriptions give the model more information to work with</a:t>
             </a:r>
           </a:p>
           <a:p>
@@ -16705,25 +17251,48 @@
               </a:defRPr>
             </a:pPr>
             <a:r>
-              <a:t>•  budget_mentioned and supervision_count have minimal impact — these appear across many job families and don’t help differentiate</a:t>
-            </a:r>
-          </a:p>
-          <a:p>
-            <a:pPr algn="l">
+              <a:rPr dirty="0"/>
+              <a:t>•  </a:t>
+            </a:r>
+            <a:r>
+              <a:rPr dirty="0" err="1"/>
+              <a:t>budget_mentioned</a:t>
+            </a:r>
+            <a:r>
+              <a:rPr dirty="0"/>
+              <a:t> and </a:t>
+            </a:r>
+            <a:r>
+              <a:rPr dirty="0" err="1"/>
+              <a:t>supervision_count</a:t>
+            </a:r>
+            <a:r>
+              <a:rPr dirty="0"/>
+              <a:t> have minimal impact — these appear across many job families and don’t help differentiate</a:t>
+            </a:r>
+          </a:p>
+          <a:p>
+            <a:pPr>
               <a:spcBef>
                 <a:spcPts val="600"/>
               </a:spcBef>
               <a:spcAft>
-                <a:spcPts val="400"/>
+                <a:spcPts val="800"/>
               </a:spcAft>
               <a:defRPr sz="1100" b="0">
                 <a:solidFill>
-                  <a:srgbClr val="5A5A5A"/>
-                </a:solidFill>
-                <a:latin typeface="Calibri"/>
-              </a:defRPr>
-            </a:pPr>
-            <a:r>
+                  <a:srgbClr val="2D2D2D"/>
+                </a:solidFill>
+                <a:latin typeface="Calibri"/>
+              </a:defRPr>
+            </a:pPr>
+            <a:r>
+              <a:rPr sz="1100" dirty="0">
+                <a:solidFill>
+                  <a:srgbClr val="2D2D2D"/>
+                </a:solidFill>
+                <a:latin typeface="Calibri"/>
+              </a:rPr>
               <a:t>•  Each color represents one of the 7 occupational families. The total bar length shows overall influence — longer bars mean the model relies more heavily on that feature when making its classification decision.</a:t>
             </a:r>
           </a:p>
@@ -16798,7 +17367,7 @@
 </file>
 
 <file path=ppt/slides/slide9.xml><?xml version="1.0" encoding="utf-8"?>
-<p:sld xmlns:a="http://schemas.openxmlformats.org/drawingml/2006/main" xmlns:p="http://schemas.openxmlformats.org/presentationml/2006/main" xmlns:r="http://schemas.openxmlformats.org/officeDocument/2006/relationships">
+<p:sld xmlns:a="http://schemas.openxmlformats.org/drawingml/2006/main" xmlns:r="http://schemas.openxmlformats.org/officeDocument/2006/relationships" xmlns:p="http://schemas.openxmlformats.org/presentationml/2006/main">
   <p:cSld>
     <p:bg>
       <p:bgPr>
@@ -16814,7 +17383,14 @@
         <p:cNvGrpSpPr/>
         <p:nvPr/>
       </p:nvGrpSpPr>
-      <p:grpSpPr/>
+      <p:grpSpPr>
+        <a:xfrm>
+          <a:off x="0" y="0"/>
+          <a:ext cx="0" cy="0"/>
+          <a:chOff x="0" y="0"/>
+          <a:chExt cx="0" cy="0"/>
+        </a:xfrm>
+      </p:grpSpPr>
       <p:sp>
         <p:nvSpPr>
           <p:cNvPr id="2" name="TextBox 1"/>
@@ -16891,6 +17467,7 @@
           <a:lstStyle/>
           <a:p>
             <a:pPr algn="ctr"/>
+            <a:endParaRPr/>
           </a:p>
         </p:txBody>
       </p:sp>
@@ -16962,7 +17539,7 @@
         </p:nvSpPr>
         <p:spPr>
           <a:xfrm>
-            <a:off x="3352647" y="1097280"/>
+            <a:off x="5473547" y="1414312"/>
             <a:ext cx="2286000" cy="320040"/>
           </a:xfrm>
           <a:prstGeom prst="rect">
@@ -16976,7 +17553,7 @@
           </a:bodyPr>
           <a:lstStyle/>
           <a:p>
-            <a:pPr algn="l">
+            <a:pPr algn="ctr">
               <a:defRPr sz="1400" b="1">
                 <a:solidFill>
                   <a:srgbClr val="115740"/>
@@ -16985,6 +17562,14 @@
               </a:defRPr>
             </a:pPr>
             <a:r>
+              <a:rPr dirty="0">
+                <a:solidFill>
+                  <a:schemeClr val="tx1">
+                    <a:lumMod val="95000"/>
+                    <a:lumOff val="5000"/>
+                  </a:schemeClr>
+                </a:solidFill>
+              </a:rPr>
               <a:t>Starting Confidence: 55%</a:t>
             </a:r>
           </a:p>
@@ -16998,7 +17583,7 @@
         </p:nvSpPr>
         <p:spPr>
           <a:xfrm>
-            <a:off x="7010247" y="1097280"/>
+            <a:off x="7156297" y="1143334"/>
             <a:ext cx="2286000" cy="320040"/>
           </a:xfrm>
           <a:prstGeom prst="rect">
@@ -17012,7 +17597,7 @@
           </a:bodyPr>
           <a:lstStyle/>
           <a:p>
-            <a:pPr algn="l">
+            <a:pPr algn="ctr">
               <a:defRPr sz="1400" b="1">
                 <a:solidFill>
                   <a:srgbClr val="115740"/>
@@ -17021,6 +17606,11 @@
               </a:defRPr>
             </a:pPr>
             <a:r>
+              <a:rPr dirty="0">
+                <a:solidFill>
+                  <a:srgbClr val="C99700"/>
+                </a:solidFill>
+              </a:rPr>
               <a:t>Final Confidence: 71%</a:t>
             </a:r>
           </a:p>
@@ -17068,6 +17658,7 @@
           <a:lstStyle/>
           <a:p>
             <a:pPr algn="ctr"/>
+            <a:endParaRPr/>
           </a:p>
         </p:txBody>
       </p:sp>
@@ -17111,6 +17702,7 @@
           <a:lstStyle/>
           <a:p>
             <a:pPr algn="ctr"/>
+            <a:endParaRPr/>
           </a:p>
         </p:txBody>
       </p:sp>
@@ -17159,7 +17751,7 @@
         <p:spPr>
           <a:xfrm>
             <a:off x="868680" y="4323882"/>
-            <a:ext cx="10545775" cy="2148840"/>
+            <a:ext cx="10545775" cy="1785104"/>
           </a:xfrm>
           <a:prstGeom prst="rect">
             <a:avLst/>
@@ -17184,8 +17776,38 @@
               </a:defRPr>
             </a:pPr>
             <a:r>
+              <a:rPr dirty="0"/>
               <a:t>Think of this as a debate between features arguing FOR and AGAINST classifying this position as ‘Administrative Services.’</a:t>
             </a:r>
+            <a:endParaRPr lang="en-US" dirty="0"/>
+          </a:p>
+          <a:p>
+            <a:pPr algn="l">
+              <a:spcAft>
+                <a:spcPts val="600"/>
+              </a:spcAft>
+              <a:defRPr sz="1100" b="0">
+                <a:solidFill>
+                  <a:srgbClr val="2D2D2D"/>
+                </a:solidFill>
+                <a:latin typeface="Calibri"/>
+              </a:defRPr>
+            </a:pPr>
+            <a:r>
+              <a:rPr lang="en-US" sz="1100" b="1" dirty="0">
+                <a:latin typeface="Calibri"/>
+              </a:rPr>
+              <a:t>Starting Confidence: </a:t>
+            </a:r>
+            <a:r>
+              <a:rPr lang="en-US" dirty="0"/>
+              <a:t>Initial guess based on class distribution. </a:t>
+            </a:r>
+            <a:r>
+              <a:rPr lang="en-US" u="sng" dirty="0"/>
+              <a:t>“In my experience…”</a:t>
+            </a:r>
+            <a:endParaRPr u="sng" dirty="0"/>
           </a:p>
           <a:p>
             <a:pPr algn="l">
@@ -17203,7 +17825,40 @@
               </a:defRPr>
             </a:pPr>
             <a:r>
-              <a:t>Red features argue IN FAVOR — healthcare_keywords = 0 (no healthcare terms supports Admin), supervises_staff = 1 (supervision duties are common in Admin roles). These push the confidence UP from 55% toward 71%.</a:t>
+              <a:rPr lang="en-US" b="1" dirty="0">
+                <a:solidFill>
+                  <a:srgbClr val="FF0000"/>
+                </a:solidFill>
+              </a:rPr>
+              <a:t>Red Features </a:t>
+            </a:r>
+            <a:r>
+              <a:rPr b="1" dirty="0">
+                <a:solidFill>
+                  <a:srgbClr val="FF0000"/>
+                </a:solidFill>
+              </a:rPr>
+              <a:t>argue IN FAVOR </a:t>
+            </a:r>
+            <a:r>
+              <a:rPr dirty="0"/>
+              <a:t>— </a:t>
+            </a:r>
+            <a:r>
+              <a:rPr dirty="0" err="1"/>
+              <a:t>healthcare_keywords</a:t>
+            </a:r>
+            <a:r>
+              <a:rPr dirty="0"/>
+              <a:t> = 0 (no healthcare terms supports Admin), </a:t>
+            </a:r>
+            <a:r>
+              <a:rPr dirty="0" err="1"/>
+              <a:t>supervises_staff</a:t>
+            </a:r>
+            <a:r>
+              <a:rPr dirty="0"/>
+              <a:t> = 1 (supervision duties are common in Admin roles). These push the confidence UP from 55% toward 71%.</a:t>
             </a:r>
           </a:p>
           <a:p>
@@ -17222,7 +17877,40 @@
               </a:defRPr>
             </a:pPr>
             <a:r>
-              <a:t>Blue features argue AGAINST — finance_keywords and receives_supervision suggest this could be Financial Services instead. These push the confidence DOWN.</a:t>
+              <a:rPr lang="en-US" b="1" dirty="0">
+                <a:solidFill>
+                  <a:srgbClr val="0070C0"/>
+                </a:solidFill>
+              </a:rPr>
+              <a:t>Blue Features </a:t>
+            </a:r>
+            <a:r>
+              <a:rPr b="1" dirty="0">
+                <a:solidFill>
+                  <a:srgbClr val="0070C0"/>
+                </a:solidFill>
+              </a:rPr>
+              <a:t>argue AGAINST </a:t>
+            </a:r>
+            <a:r>
+              <a:rPr dirty="0"/>
+              <a:t>— </a:t>
+            </a:r>
+            <a:r>
+              <a:rPr dirty="0" err="1"/>
+              <a:t>finance_keywords</a:t>
+            </a:r>
+            <a:r>
+              <a:rPr dirty="0"/>
+              <a:t> and </a:t>
+            </a:r>
+            <a:r>
+              <a:rPr dirty="0" err="1"/>
+              <a:t>receives_supervision</a:t>
+            </a:r>
+            <a:r>
+              <a:rPr dirty="0"/>
+              <a:t> suggest this could be Financial Services instead. These push the confidence DOWN.</a:t>
             </a:r>
           </a:p>
           <a:p>
@@ -17241,7 +17929,16 @@
               </a:defRPr>
             </a:pPr>
             <a:r>
-              <a:t>The final verdict: 71% confidence in Administrative Services — the ‘for’ arguments outweigh the ‘against.’ This is explainable AI: every classification traces back to specific, auditable features.</a:t>
+              <a:rPr lang="en-US" b="1" dirty="0">
+                <a:solidFill>
+                  <a:srgbClr val="C99700"/>
+                </a:solidFill>
+              </a:rPr>
+              <a:t>The Final Verdict: </a:t>
+            </a:r>
+            <a:r>
+              <a:rPr dirty="0"/>
+              <a:t>71% confidence in Administrative Services — the ‘for’ arguments outweigh the ‘against.’ This is explainable AI: every classification traces back to specific, auditable features.</a:t>
             </a:r>
           </a:p>
         </p:txBody>

</xml_diff>